<commit_message>
Add the text layout engine, calibrated against PowerPoint
- tools/Fidelity: text-metrics calibration deck (9 fonts, line spacing
  multiples and exact values, sizes, paragraph spacing, anchoring, mixed
  runs, bullets) and a `calibrate` command that renders it at 4x and
  measures every baseline with sub-pixel precision.
- src/Engine/Text: HarfBuzz shaping, line breaking (UAX #14 subset) and
  PowerPoint's vertical line model derived from the measurements. Text is
  emitted as SVG on exact baselines; line positions now match PowerPoint
  within one pixel.
- Headless Chrome renders text without LCD anti-aliasing, like PowerPoint's
  export.

Co-Authored-By: Claude Opus 5.5 <noreply@anthropic.com>
</commit_message>
<xml_diff>
--- a/tests/corpus/pptx/generated/fills.pptx
+++ b/tests/corpus/pptx/generated/fills.pptx
@@ -132,7 +132,7 @@
           <p:cNvPr id="2" name="Titel 1">
             <a:extLst>
               <a:ext uri="{FF2B5EF4-FFF2-40B4-BE49-F238E27FC236}">
-                <a16:creationId xmlns:a16="http://schemas.microsoft.com/office/drawing/2014/main" id="{3E6BAC33-30FA-ABE8-C6CF-28143525CD46}"/>
+                <a16:creationId xmlns:a16="http://schemas.microsoft.com/office/drawing/2014/main" id="{3AB04097-57B5-6A13-0F83-671BEF25A717}"/>
               </a:ext>
             </a:extLst>
           </p:cNvPr>
@@ -169,7 +169,7 @@
           <p:cNvPr id="3" name="Untertitel 2">
             <a:extLst>
               <a:ext uri="{FF2B5EF4-FFF2-40B4-BE49-F238E27FC236}">
-                <a16:creationId xmlns:a16="http://schemas.microsoft.com/office/drawing/2014/main" id="{F6657613-E256-34BD-21F2-50CCC69937B0}"/>
+                <a16:creationId xmlns:a16="http://schemas.microsoft.com/office/drawing/2014/main" id="{D74F7031-F66C-70F4-481A-3E88C27043E1}"/>
               </a:ext>
             </a:extLst>
           </p:cNvPr>
@@ -239,7 +239,7 @@
           <p:cNvPr id="4" name="Datumsplatzhalter 3">
             <a:extLst>
               <a:ext uri="{FF2B5EF4-FFF2-40B4-BE49-F238E27FC236}">
-                <a16:creationId xmlns:a16="http://schemas.microsoft.com/office/drawing/2014/main" id="{9F0441F4-BE59-402C-7774-90B4858D7AFB}"/>
+                <a16:creationId xmlns:a16="http://schemas.microsoft.com/office/drawing/2014/main" id="{5B9C3A28-4734-9EEB-0E0C-6E8931794E96}"/>
               </a:ext>
             </a:extLst>
           </p:cNvPr>
@@ -255,7 +255,7 @@
           <a:bodyPr/>
           <a:lstStyle/>
           <a:p>
-            <a:fld id="{BEE8B028-C60C-46BB-9FC8-7AE2B990A964}" type="datetimeFigureOut">
+            <a:fld id="{F5072598-430D-43E6-AA52-E0B716F765A9}" type="datetimeFigureOut">
               <a:rPr lang="de-DE" smtClean="0"/>
               <a:t>08.10.2026</a:t>
             </a:fld>
@@ -268,7 +268,7 @@
           <p:cNvPr id="5" name="Fußzeilenplatzhalter 4">
             <a:extLst>
               <a:ext uri="{FF2B5EF4-FFF2-40B4-BE49-F238E27FC236}">
-                <a16:creationId xmlns:a16="http://schemas.microsoft.com/office/drawing/2014/main" id="{34C21399-1848-E400-DE59-63FCCB443887}"/>
+                <a16:creationId xmlns:a16="http://schemas.microsoft.com/office/drawing/2014/main" id="{ACE5226A-ACE8-661D-736A-F098B2CCA993}"/>
               </a:ext>
             </a:extLst>
           </p:cNvPr>
@@ -293,7 +293,7 @@
           <p:cNvPr id="6" name="Foliennummernplatzhalter 5">
             <a:extLst>
               <a:ext uri="{FF2B5EF4-FFF2-40B4-BE49-F238E27FC236}">
-                <a16:creationId xmlns:a16="http://schemas.microsoft.com/office/drawing/2014/main" id="{F635A82A-22AE-FE7F-B0F2-A0E8A5903F28}"/>
+                <a16:creationId xmlns:a16="http://schemas.microsoft.com/office/drawing/2014/main" id="{E644E323-7F50-159D-47BF-28A48D6A370B}"/>
               </a:ext>
             </a:extLst>
           </p:cNvPr>
@@ -309,7 +309,7 @@
           <a:bodyPr/>
           <a:lstStyle/>
           <a:p>
-            <a:fld id="{74758E45-F88A-44E4-B551-174347A5E4E7}" type="slidenum">
+            <a:fld id="{EB35F42C-9DAD-4D41-9F5D-E9053B6E5F2F}" type="slidenum">
               <a:rPr lang="de-DE" smtClean="0"/>
               <a:t>‹Nr.›</a:t>
             </a:fld>
@@ -320,7 +320,7 @@
     </p:spTree>
     <p:extLst>
       <p:ext uri="{BB962C8B-B14F-4D97-AF65-F5344CB8AC3E}">
-        <p14:creationId xmlns:p14="http://schemas.microsoft.com/office/powerpoint/2010/main" val="3642650130"/>
+        <p14:creationId xmlns:p14="http://schemas.microsoft.com/office/powerpoint/2010/main" val="3954289103"/>
       </p:ext>
     </p:extLst>
   </p:cSld>
@@ -352,7 +352,7 @@
           <p:cNvPr id="2" name="Titel 1">
             <a:extLst>
               <a:ext uri="{FF2B5EF4-FFF2-40B4-BE49-F238E27FC236}">
-                <a16:creationId xmlns:a16="http://schemas.microsoft.com/office/drawing/2014/main" id="{978B9769-31E2-FE61-9ECF-F0499E860AA4}"/>
+                <a16:creationId xmlns:a16="http://schemas.microsoft.com/office/drawing/2014/main" id="{2A76985C-E24A-F2FB-D172-6E1AD52EAC24}"/>
               </a:ext>
             </a:extLst>
           </p:cNvPr>
@@ -380,7 +380,7 @@
           <p:cNvPr id="3" name="Vertikaler Textplatzhalter 2">
             <a:extLst>
               <a:ext uri="{FF2B5EF4-FFF2-40B4-BE49-F238E27FC236}">
-                <a16:creationId xmlns:a16="http://schemas.microsoft.com/office/drawing/2014/main" id="{0BAD479C-2633-7114-7802-6732B748D790}"/>
+                <a16:creationId xmlns:a16="http://schemas.microsoft.com/office/drawing/2014/main" id="{A372C77B-069A-735C-FE4B-3DA14B2AEDFE}"/>
               </a:ext>
             </a:extLst>
           </p:cNvPr>
@@ -437,7 +437,7 @@
           <p:cNvPr id="4" name="Datumsplatzhalter 3">
             <a:extLst>
               <a:ext uri="{FF2B5EF4-FFF2-40B4-BE49-F238E27FC236}">
-                <a16:creationId xmlns:a16="http://schemas.microsoft.com/office/drawing/2014/main" id="{686E5833-568E-14D7-AC4B-F0554566C2D5}"/>
+                <a16:creationId xmlns:a16="http://schemas.microsoft.com/office/drawing/2014/main" id="{AD73DAB1-AA5E-8337-E6BB-3ED75995770D}"/>
               </a:ext>
             </a:extLst>
           </p:cNvPr>
@@ -453,7 +453,7 @@
           <a:bodyPr/>
           <a:lstStyle/>
           <a:p>
-            <a:fld id="{BEE8B028-C60C-46BB-9FC8-7AE2B990A964}" type="datetimeFigureOut">
+            <a:fld id="{F5072598-430D-43E6-AA52-E0B716F765A9}" type="datetimeFigureOut">
               <a:rPr lang="de-DE" smtClean="0"/>
               <a:t>08.10.2026</a:t>
             </a:fld>
@@ -466,7 +466,7 @@
           <p:cNvPr id="5" name="Fußzeilenplatzhalter 4">
             <a:extLst>
               <a:ext uri="{FF2B5EF4-FFF2-40B4-BE49-F238E27FC236}">
-                <a16:creationId xmlns:a16="http://schemas.microsoft.com/office/drawing/2014/main" id="{D7B9AC47-91EA-0CF5-DD2B-F11B4B53B4AB}"/>
+                <a16:creationId xmlns:a16="http://schemas.microsoft.com/office/drawing/2014/main" id="{90A6F121-1CE9-A53D-9236-0FB6A34506AC}"/>
               </a:ext>
             </a:extLst>
           </p:cNvPr>
@@ -491,7 +491,7 @@
           <p:cNvPr id="6" name="Foliennummernplatzhalter 5">
             <a:extLst>
               <a:ext uri="{FF2B5EF4-FFF2-40B4-BE49-F238E27FC236}">
-                <a16:creationId xmlns:a16="http://schemas.microsoft.com/office/drawing/2014/main" id="{42374E4D-33FC-E588-7288-5C5F515F9B18}"/>
+                <a16:creationId xmlns:a16="http://schemas.microsoft.com/office/drawing/2014/main" id="{ADDCFE97-EF1A-E6DB-26E3-2120DD42D668}"/>
               </a:ext>
             </a:extLst>
           </p:cNvPr>
@@ -507,7 +507,7 @@
           <a:bodyPr/>
           <a:lstStyle/>
           <a:p>
-            <a:fld id="{74758E45-F88A-44E4-B551-174347A5E4E7}" type="slidenum">
+            <a:fld id="{EB35F42C-9DAD-4D41-9F5D-E9053B6E5F2F}" type="slidenum">
               <a:rPr lang="de-DE" smtClean="0"/>
               <a:t>‹Nr.›</a:t>
             </a:fld>
@@ -518,7 +518,7 @@
     </p:spTree>
     <p:extLst>
       <p:ext uri="{BB962C8B-B14F-4D97-AF65-F5344CB8AC3E}">
-        <p14:creationId xmlns:p14="http://schemas.microsoft.com/office/powerpoint/2010/main" val="1051403907"/>
+        <p14:creationId xmlns:p14="http://schemas.microsoft.com/office/powerpoint/2010/main" val="3284997945"/>
       </p:ext>
     </p:extLst>
   </p:cSld>
@@ -550,7 +550,7 @@
           <p:cNvPr id="2" name="Vertikaler Titel 1">
             <a:extLst>
               <a:ext uri="{FF2B5EF4-FFF2-40B4-BE49-F238E27FC236}">
-                <a16:creationId xmlns:a16="http://schemas.microsoft.com/office/drawing/2014/main" id="{A928DC48-46C4-9578-0C98-DCD2547D20F8}"/>
+                <a16:creationId xmlns:a16="http://schemas.microsoft.com/office/drawing/2014/main" id="{FADC2FC2-E526-F747-485A-00A5A9FCDD1C}"/>
               </a:ext>
             </a:extLst>
           </p:cNvPr>
@@ -583,7 +583,7 @@
           <p:cNvPr id="3" name="Vertikaler Textplatzhalter 2">
             <a:extLst>
               <a:ext uri="{FF2B5EF4-FFF2-40B4-BE49-F238E27FC236}">
-                <a16:creationId xmlns:a16="http://schemas.microsoft.com/office/drawing/2014/main" id="{A90E577B-2DFF-8219-DB22-B43A4A9EE580}"/>
+                <a16:creationId xmlns:a16="http://schemas.microsoft.com/office/drawing/2014/main" id="{67EC531E-3EA6-9CE1-87AD-007491B4C78D}"/>
               </a:ext>
             </a:extLst>
           </p:cNvPr>
@@ -645,7 +645,7 @@
           <p:cNvPr id="4" name="Datumsplatzhalter 3">
             <a:extLst>
               <a:ext uri="{FF2B5EF4-FFF2-40B4-BE49-F238E27FC236}">
-                <a16:creationId xmlns:a16="http://schemas.microsoft.com/office/drawing/2014/main" id="{02498017-685A-3A47-E804-016973AA1110}"/>
+                <a16:creationId xmlns:a16="http://schemas.microsoft.com/office/drawing/2014/main" id="{9F035CE3-0C70-6909-BCCB-EFF269376B26}"/>
               </a:ext>
             </a:extLst>
           </p:cNvPr>
@@ -661,7 +661,7 @@
           <a:bodyPr/>
           <a:lstStyle/>
           <a:p>
-            <a:fld id="{BEE8B028-C60C-46BB-9FC8-7AE2B990A964}" type="datetimeFigureOut">
+            <a:fld id="{F5072598-430D-43E6-AA52-E0B716F765A9}" type="datetimeFigureOut">
               <a:rPr lang="de-DE" smtClean="0"/>
               <a:t>08.10.2026</a:t>
             </a:fld>
@@ -674,7 +674,7 @@
           <p:cNvPr id="5" name="Fußzeilenplatzhalter 4">
             <a:extLst>
               <a:ext uri="{FF2B5EF4-FFF2-40B4-BE49-F238E27FC236}">
-                <a16:creationId xmlns:a16="http://schemas.microsoft.com/office/drawing/2014/main" id="{CB6EE525-07B8-7F0D-2482-FB5BFC834BFD}"/>
+                <a16:creationId xmlns:a16="http://schemas.microsoft.com/office/drawing/2014/main" id="{26ACC7D4-DB6E-4A78-ED8C-BC706A2DF7C3}"/>
               </a:ext>
             </a:extLst>
           </p:cNvPr>
@@ -699,7 +699,7 @@
           <p:cNvPr id="6" name="Foliennummernplatzhalter 5">
             <a:extLst>
               <a:ext uri="{FF2B5EF4-FFF2-40B4-BE49-F238E27FC236}">
-                <a16:creationId xmlns:a16="http://schemas.microsoft.com/office/drawing/2014/main" id="{E26718C9-8A6E-08A2-25F6-4A8CE5FD964D}"/>
+                <a16:creationId xmlns:a16="http://schemas.microsoft.com/office/drawing/2014/main" id="{7CBDEB3C-CE12-426C-8101-DFC9DDD85742}"/>
               </a:ext>
             </a:extLst>
           </p:cNvPr>
@@ -715,7 +715,7 @@
           <a:bodyPr/>
           <a:lstStyle/>
           <a:p>
-            <a:fld id="{74758E45-F88A-44E4-B551-174347A5E4E7}" type="slidenum">
+            <a:fld id="{EB35F42C-9DAD-4D41-9F5D-E9053B6E5F2F}" type="slidenum">
               <a:rPr lang="de-DE" smtClean="0"/>
               <a:t>‹Nr.›</a:t>
             </a:fld>
@@ -726,7 +726,7 @@
     </p:spTree>
     <p:extLst>
       <p:ext uri="{BB962C8B-B14F-4D97-AF65-F5344CB8AC3E}">
-        <p14:creationId xmlns:p14="http://schemas.microsoft.com/office/powerpoint/2010/main" val="2611383816"/>
+        <p14:creationId xmlns:p14="http://schemas.microsoft.com/office/powerpoint/2010/main" val="865606643"/>
       </p:ext>
     </p:extLst>
   </p:cSld>
@@ -758,7 +758,7 @@
           <p:cNvPr id="2" name="Titel 1">
             <a:extLst>
               <a:ext uri="{FF2B5EF4-FFF2-40B4-BE49-F238E27FC236}">
-                <a16:creationId xmlns:a16="http://schemas.microsoft.com/office/drawing/2014/main" id="{9B129A45-9D7E-9FDA-51C5-C162C5A23149}"/>
+                <a16:creationId xmlns:a16="http://schemas.microsoft.com/office/drawing/2014/main" id="{0DB44C4B-336A-ACA2-825C-25626F3C7077}"/>
               </a:ext>
             </a:extLst>
           </p:cNvPr>
@@ -786,7 +786,7 @@
           <p:cNvPr id="3" name="Inhaltsplatzhalter 2">
             <a:extLst>
               <a:ext uri="{FF2B5EF4-FFF2-40B4-BE49-F238E27FC236}">
-                <a16:creationId xmlns:a16="http://schemas.microsoft.com/office/drawing/2014/main" id="{85339F79-F8B8-A8C9-4B66-69DE20D83459}"/>
+                <a16:creationId xmlns:a16="http://schemas.microsoft.com/office/drawing/2014/main" id="{DB6AFE55-0193-3035-ECF6-9509D61FF424}"/>
               </a:ext>
             </a:extLst>
           </p:cNvPr>
@@ -843,7 +843,7 @@
           <p:cNvPr id="4" name="Datumsplatzhalter 3">
             <a:extLst>
               <a:ext uri="{FF2B5EF4-FFF2-40B4-BE49-F238E27FC236}">
-                <a16:creationId xmlns:a16="http://schemas.microsoft.com/office/drawing/2014/main" id="{0AE8E703-85C7-9D38-9A64-BDA0A79D2E4B}"/>
+                <a16:creationId xmlns:a16="http://schemas.microsoft.com/office/drawing/2014/main" id="{C39E9FD7-45ED-6978-5566-1995AD6C489D}"/>
               </a:ext>
             </a:extLst>
           </p:cNvPr>
@@ -859,7 +859,7 @@
           <a:bodyPr/>
           <a:lstStyle/>
           <a:p>
-            <a:fld id="{BEE8B028-C60C-46BB-9FC8-7AE2B990A964}" type="datetimeFigureOut">
+            <a:fld id="{F5072598-430D-43E6-AA52-E0B716F765A9}" type="datetimeFigureOut">
               <a:rPr lang="de-DE" smtClean="0"/>
               <a:t>08.10.2026</a:t>
             </a:fld>
@@ -872,7 +872,7 @@
           <p:cNvPr id="5" name="Fußzeilenplatzhalter 4">
             <a:extLst>
               <a:ext uri="{FF2B5EF4-FFF2-40B4-BE49-F238E27FC236}">
-                <a16:creationId xmlns:a16="http://schemas.microsoft.com/office/drawing/2014/main" id="{A1C5DB37-C724-4AA3-E14F-BBA8AD6C066E}"/>
+                <a16:creationId xmlns:a16="http://schemas.microsoft.com/office/drawing/2014/main" id="{BA0FA797-B534-A635-BD9F-A7966A46DFC2}"/>
               </a:ext>
             </a:extLst>
           </p:cNvPr>
@@ -897,7 +897,7 @@
           <p:cNvPr id="6" name="Foliennummernplatzhalter 5">
             <a:extLst>
               <a:ext uri="{FF2B5EF4-FFF2-40B4-BE49-F238E27FC236}">
-                <a16:creationId xmlns:a16="http://schemas.microsoft.com/office/drawing/2014/main" id="{21C64202-DBCB-DCDA-9CBE-1887936C3648}"/>
+                <a16:creationId xmlns:a16="http://schemas.microsoft.com/office/drawing/2014/main" id="{2BF85DE7-B81E-C7CA-B23C-630AFBDF110B}"/>
               </a:ext>
             </a:extLst>
           </p:cNvPr>
@@ -913,7 +913,7 @@
           <a:bodyPr/>
           <a:lstStyle/>
           <a:p>
-            <a:fld id="{74758E45-F88A-44E4-B551-174347A5E4E7}" type="slidenum">
+            <a:fld id="{EB35F42C-9DAD-4D41-9F5D-E9053B6E5F2F}" type="slidenum">
               <a:rPr lang="de-DE" smtClean="0"/>
               <a:t>‹Nr.›</a:t>
             </a:fld>
@@ -924,7 +924,7 @@
     </p:spTree>
     <p:extLst>
       <p:ext uri="{BB962C8B-B14F-4D97-AF65-F5344CB8AC3E}">
-        <p14:creationId xmlns:p14="http://schemas.microsoft.com/office/powerpoint/2010/main" val="3282184196"/>
+        <p14:creationId xmlns:p14="http://schemas.microsoft.com/office/powerpoint/2010/main" val="1658704705"/>
       </p:ext>
     </p:extLst>
   </p:cSld>
@@ -956,7 +956,7 @@
           <p:cNvPr id="2" name="Titel 1">
             <a:extLst>
               <a:ext uri="{FF2B5EF4-FFF2-40B4-BE49-F238E27FC236}">
-                <a16:creationId xmlns:a16="http://schemas.microsoft.com/office/drawing/2014/main" id="{3280E4E4-B212-D327-2731-4321C5697395}"/>
+                <a16:creationId xmlns:a16="http://schemas.microsoft.com/office/drawing/2014/main" id="{1AFCA4C5-75BA-5308-9AD1-14F74112B195}"/>
               </a:ext>
             </a:extLst>
           </p:cNvPr>
@@ -993,7 +993,7 @@
           <p:cNvPr id="3" name="Textplatzhalter 2">
             <a:extLst>
               <a:ext uri="{FF2B5EF4-FFF2-40B4-BE49-F238E27FC236}">
-                <a16:creationId xmlns:a16="http://schemas.microsoft.com/office/drawing/2014/main" id="{4B958BBB-7F93-2F12-3018-C22C2FC9D644}"/>
+                <a16:creationId xmlns:a16="http://schemas.microsoft.com/office/drawing/2014/main" id="{38F1917C-A157-7D42-166E-0ED817D822CB}"/>
               </a:ext>
             </a:extLst>
           </p:cNvPr>
@@ -1118,7 +1118,7 @@
           <p:cNvPr id="4" name="Datumsplatzhalter 3">
             <a:extLst>
               <a:ext uri="{FF2B5EF4-FFF2-40B4-BE49-F238E27FC236}">
-                <a16:creationId xmlns:a16="http://schemas.microsoft.com/office/drawing/2014/main" id="{C7FC65DC-DF05-A262-99A2-F80C9AA20B8A}"/>
+                <a16:creationId xmlns:a16="http://schemas.microsoft.com/office/drawing/2014/main" id="{5438CF50-DE10-2296-4695-76502F1F877B}"/>
               </a:ext>
             </a:extLst>
           </p:cNvPr>
@@ -1134,7 +1134,7 @@
           <a:bodyPr/>
           <a:lstStyle/>
           <a:p>
-            <a:fld id="{BEE8B028-C60C-46BB-9FC8-7AE2B990A964}" type="datetimeFigureOut">
+            <a:fld id="{F5072598-430D-43E6-AA52-E0B716F765A9}" type="datetimeFigureOut">
               <a:rPr lang="de-DE" smtClean="0"/>
               <a:t>08.10.2026</a:t>
             </a:fld>
@@ -1147,7 +1147,7 @@
           <p:cNvPr id="5" name="Fußzeilenplatzhalter 4">
             <a:extLst>
               <a:ext uri="{FF2B5EF4-FFF2-40B4-BE49-F238E27FC236}">
-                <a16:creationId xmlns:a16="http://schemas.microsoft.com/office/drawing/2014/main" id="{252B324C-BCDF-C9E9-572D-08D638EC1B3A}"/>
+                <a16:creationId xmlns:a16="http://schemas.microsoft.com/office/drawing/2014/main" id="{4DDF99FB-A8D6-F04B-9997-797557A0A802}"/>
               </a:ext>
             </a:extLst>
           </p:cNvPr>
@@ -1172,7 +1172,7 @@
           <p:cNvPr id="6" name="Foliennummernplatzhalter 5">
             <a:extLst>
               <a:ext uri="{FF2B5EF4-FFF2-40B4-BE49-F238E27FC236}">
-                <a16:creationId xmlns:a16="http://schemas.microsoft.com/office/drawing/2014/main" id="{46780639-1FC0-EC23-717F-301209BE6AA5}"/>
+                <a16:creationId xmlns:a16="http://schemas.microsoft.com/office/drawing/2014/main" id="{E1D6617C-69E9-51D8-064A-06953106F05C}"/>
               </a:ext>
             </a:extLst>
           </p:cNvPr>
@@ -1188,7 +1188,7 @@
           <a:bodyPr/>
           <a:lstStyle/>
           <a:p>
-            <a:fld id="{74758E45-F88A-44E4-B551-174347A5E4E7}" type="slidenum">
+            <a:fld id="{EB35F42C-9DAD-4D41-9F5D-E9053B6E5F2F}" type="slidenum">
               <a:rPr lang="de-DE" smtClean="0"/>
               <a:t>‹Nr.›</a:t>
             </a:fld>
@@ -1199,7 +1199,7 @@
     </p:spTree>
     <p:extLst>
       <p:ext uri="{BB962C8B-B14F-4D97-AF65-F5344CB8AC3E}">
-        <p14:creationId xmlns:p14="http://schemas.microsoft.com/office/powerpoint/2010/main" val="953195238"/>
+        <p14:creationId xmlns:p14="http://schemas.microsoft.com/office/powerpoint/2010/main" val="1153455536"/>
       </p:ext>
     </p:extLst>
   </p:cSld>
@@ -1231,7 +1231,7 @@
           <p:cNvPr id="2" name="Titel 1">
             <a:extLst>
               <a:ext uri="{FF2B5EF4-FFF2-40B4-BE49-F238E27FC236}">
-                <a16:creationId xmlns:a16="http://schemas.microsoft.com/office/drawing/2014/main" id="{FD139675-34C0-C749-61FC-A954743C6294}"/>
+                <a16:creationId xmlns:a16="http://schemas.microsoft.com/office/drawing/2014/main" id="{B91FBA49-BF6B-1C02-27C5-A8D52AAF005E}"/>
               </a:ext>
             </a:extLst>
           </p:cNvPr>
@@ -1259,7 +1259,7 @@
           <p:cNvPr id="3" name="Inhaltsplatzhalter 2">
             <a:extLst>
               <a:ext uri="{FF2B5EF4-FFF2-40B4-BE49-F238E27FC236}">
-                <a16:creationId xmlns:a16="http://schemas.microsoft.com/office/drawing/2014/main" id="{CF2ED479-A373-D578-46A1-C5D7885273C0}"/>
+                <a16:creationId xmlns:a16="http://schemas.microsoft.com/office/drawing/2014/main" id="{5692D161-E41A-EBEE-029A-907F2CDD14CC}"/>
               </a:ext>
             </a:extLst>
           </p:cNvPr>
@@ -1321,7 +1321,7 @@
           <p:cNvPr id="4" name="Inhaltsplatzhalter 3">
             <a:extLst>
               <a:ext uri="{FF2B5EF4-FFF2-40B4-BE49-F238E27FC236}">
-                <a16:creationId xmlns:a16="http://schemas.microsoft.com/office/drawing/2014/main" id="{7F4E4DD1-18A1-3D93-C206-0E2D7605E9C2}"/>
+                <a16:creationId xmlns:a16="http://schemas.microsoft.com/office/drawing/2014/main" id="{35D386B5-6A0A-7751-4B5A-314D01D235C2}"/>
               </a:ext>
             </a:extLst>
           </p:cNvPr>
@@ -1383,7 +1383,7 @@
           <p:cNvPr id="5" name="Datumsplatzhalter 4">
             <a:extLst>
               <a:ext uri="{FF2B5EF4-FFF2-40B4-BE49-F238E27FC236}">
-                <a16:creationId xmlns:a16="http://schemas.microsoft.com/office/drawing/2014/main" id="{64502860-F646-F75C-0F09-6E6030893FD4}"/>
+                <a16:creationId xmlns:a16="http://schemas.microsoft.com/office/drawing/2014/main" id="{8AFFEC28-0EAF-586A-3760-BFBFD75BA48F}"/>
               </a:ext>
             </a:extLst>
           </p:cNvPr>
@@ -1399,7 +1399,7 @@
           <a:bodyPr/>
           <a:lstStyle/>
           <a:p>
-            <a:fld id="{BEE8B028-C60C-46BB-9FC8-7AE2B990A964}" type="datetimeFigureOut">
+            <a:fld id="{F5072598-430D-43E6-AA52-E0B716F765A9}" type="datetimeFigureOut">
               <a:rPr lang="de-DE" smtClean="0"/>
               <a:t>08.10.2026</a:t>
             </a:fld>
@@ -1412,7 +1412,7 @@
           <p:cNvPr id="6" name="Fußzeilenplatzhalter 5">
             <a:extLst>
               <a:ext uri="{FF2B5EF4-FFF2-40B4-BE49-F238E27FC236}">
-                <a16:creationId xmlns:a16="http://schemas.microsoft.com/office/drawing/2014/main" id="{023FB498-0AF5-1E60-3DEC-CFBDABA26F8F}"/>
+                <a16:creationId xmlns:a16="http://schemas.microsoft.com/office/drawing/2014/main" id="{1D9B9488-C810-C5C0-4B14-3466B7F1A5CC}"/>
               </a:ext>
             </a:extLst>
           </p:cNvPr>
@@ -1437,7 +1437,7 @@
           <p:cNvPr id="7" name="Foliennummernplatzhalter 6">
             <a:extLst>
               <a:ext uri="{FF2B5EF4-FFF2-40B4-BE49-F238E27FC236}">
-                <a16:creationId xmlns:a16="http://schemas.microsoft.com/office/drawing/2014/main" id="{ACD3C276-B45C-93CA-19D1-C66E21DEA48D}"/>
+                <a16:creationId xmlns:a16="http://schemas.microsoft.com/office/drawing/2014/main" id="{134E4137-8D31-4B6C-CB41-88F82FE53316}"/>
               </a:ext>
             </a:extLst>
           </p:cNvPr>
@@ -1453,7 +1453,7 @@
           <a:bodyPr/>
           <a:lstStyle/>
           <a:p>
-            <a:fld id="{74758E45-F88A-44E4-B551-174347A5E4E7}" type="slidenum">
+            <a:fld id="{EB35F42C-9DAD-4D41-9F5D-E9053B6E5F2F}" type="slidenum">
               <a:rPr lang="de-DE" smtClean="0"/>
               <a:t>‹Nr.›</a:t>
             </a:fld>
@@ -1464,7 +1464,7 @@
     </p:spTree>
     <p:extLst>
       <p:ext uri="{BB962C8B-B14F-4D97-AF65-F5344CB8AC3E}">
-        <p14:creationId xmlns:p14="http://schemas.microsoft.com/office/powerpoint/2010/main" val="2067812296"/>
+        <p14:creationId xmlns:p14="http://schemas.microsoft.com/office/powerpoint/2010/main" val="1503416305"/>
       </p:ext>
     </p:extLst>
   </p:cSld>
@@ -1496,7 +1496,7 @@
           <p:cNvPr id="2" name="Titel 1">
             <a:extLst>
               <a:ext uri="{FF2B5EF4-FFF2-40B4-BE49-F238E27FC236}">
-                <a16:creationId xmlns:a16="http://schemas.microsoft.com/office/drawing/2014/main" id="{024013E2-CFBD-439C-8DF2-4040C3351F69}"/>
+                <a16:creationId xmlns:a16="http://schemas.microsoft.com/office/drawing/2014/main" id="{0B827AC7-A126-83A2-6942-DC486D051DA3}"/>
               </a:ext>
             </a:extLst>
           </p:cNvPr>
@@ -1529,7 +1529,7 @@
           <p:cNvPr id="3" name="Textplatzhalter 2">
             <a:extLst>
               <a:ext uri="{FF2B5EF4-FFF2-40B4-BE49-F238E27FC236}">
-                <a16:creationId xmlns:a16="http://schemas.microsoft.com/office/drawing/2014/main" id="{F65B703F-EA65-BF65-3A44-A6BFA9433810}"/>
+                <a16:creationId xmlns:a16="http://schemas.microsoft.com/office/drawing/2014/main" id="{215B52BE-E790-B4A4-977C-EA50EB01FC3F}"/>
               </a:ext>
             </a:extLst>
           </p:cNvPr>
@@ -1600,7 +1600,7 @@
           <p:cNvPr id="4" name="Inhaltsplatzhalter 3">
             <a:extLst>
               <a:ext uri="{FF2B5EF4-FFF2-40B4-BE49-F238E27FC236}">
-                <a16:creationId xmlns:a16="http://schemas.microsoft.com/office/drawing/2014/main" id="{7F67C47B-770E-57BC-FC9A-E28D32B3E833}"/>
+                <a16:creationId xmlns:a16="http://schemas.microsoft.com/office/drawing/2014/main" id="{87AAA49C-6FB5-2CE3-1C2C-8C94DD69A44C}"/>
               </a:ext>
             </a:extLst>
           </p:cNvPr>
@@ -1662,7 +1662,7 @@
           <p:cNvPr id="5" name="Textplatzhalter 4">
             <a:extLst>
               <a:ext uri="{FF2B5EF4-FFF2-40B4-BE49-F238E27FC236}">
-                <a16:creationId xmlns:a16="http://schemas.microsoft.com/office/drawing/2014/main" id="{CDDC3FDF-7F48-10D1-8D81-58AE1EC9C660}"/>
+                <a16:creationId xmlns:a16="http://schemas.microsoft.com/office/drawing/2014/main" id="{330397E9-0874-F179-B19E-4611B48A1ADB}"/>
               </a:ext>
             </a:extLst>
           </p:cNvPr>
@@ -1733,7 +1733,7 @@
           <p:cNvPr id="6" name="Inhaltsplatzhalter 5">
             <a:extLst>
               <a:ext uri="{FF2B5EF4-FFF2-40B4-BE49-F238E27FC236}">
-                <a16:creationId xmlns:a16="http://schemas.microsoft.com/office/drawing/2014/main" id="{6D71DB11-12D7-1962-5C86-A7976EE4AB3A}"/>
+                <a16:creationId xmlns:a16="http://schemas.microsoft.com/office/drawing/2014/main" id="{DB643786-5E2F-9663-97CA-EE14A6724888}"/>
               </a:ext>
             </a:extLst>
           </p:cNvPr>
@@ -1795,7 +1795,7 @@
           <p:cNvPr id="7" name="Datumsplatzhalter 6">
             <a:extLst>
               <a:ext uri="{FF2B5EF4-FFF2-40B4-BE49-F238E27FC236}">
-                <a16:creationId xmlns:a16="http://schemas.microsoft.com/office/drawing/2014/main" id="{FD42DD2C-4482-E118-4173-805F81112629}"/>
+                <a16:creationId xmlns:a16="http://schemas.microsoft.com/office/drawing/2014/main" id="{F8C36917-E6D0-22F8-F4F9-6AF7FD3AD7A4}"/>
               </a:ext>
             </a:extLst>
           </p:cNvPr>
@@ -1811,7 +1811,7 @@
           <a:bodyPr/>
           <a:lstStyle/>
           <a:p>
-            <a:fld id="{BEE8B028-C60C-46BB-9FC8-7AE2B990A964}" type="datetimeFigureOut">
+            <a:fld id="{F5072598-430D-43E6-AA52-E0B716F765A9}" type="datetimeFigureOut">
               <a:rPr lang="de-DE" smtClean="0"/>
               <a:t>08.10.2026</a:t>
             </a:fld>
@@ -1824,7 +1824,7 @@
           <p:cNvPr id="8" name="Fußzeilenplatzhalter 7">
             <a:extLst>
               <a:ext uri="{FF2B5EF4-FFF2-40B4-BE49-F238E27FC236}">
-                <a16:creationId xmlns:a16="http://schemas.microsoft.com/office/drawing/2014/main" id="{64FFD75C-AC4A-CDC3-3EB7-9ACD37770009}"/>
+                <a16:creationId xmlns:a16="http://schemas.microsoft.com/office/drawing/2014/main" id="{6C845D4D-BD28-44CE-0168-C71D8B3C60A1}"/>
               </a:ext>
             </a:extLst>
           </p:cNvPr>
@@ -1849,7 +1849,7 @@
           <p:cNvPr id="9" name="Foliennummernplatzhalter 8">
             <a:extLst>
               <a:ext uri="{FF2B5EF4-FFF2-40B4-BE49-F238E27FC236}">
-                <a16:creationId xmlns:a16="http://schemas.microsoft.com/office/drawing/2014/main" id="{27198FC1-ACEF-0E38-F21E-EB66F0E38F24}"/>
+                <a16:creationId xmlns:a16="http://schemas.microsoft.com/office/drawing/2014/main" id="{5E5E94F7-F826-6C48-444A-4C3EA0539A89}"/>
               </a:ext>
             </a:extLst>
           </p:cNvPr>
@@ -1865,7 +1865,7 @@
           <a:bodyPr/>
           <a:lstStyle/>
           <a:p>
-            <a:fld id="{74758E45-F88A-44E4-B551-174347A5E4E7}" type="slidenum">
+            <a:fld id="{EB35F42C-9DAD-4D41-9F5D-E9053B6E5F2F}" type="slidenum">
               <a:rPr lang="de-DE" smtClean="0"/>
               <a:t>‹Nr.›</a:t>
             </a:fld>
@@ -1876,7 +1876,7 @@
     </p:spTree>
     <p:extLst>
       <p:ext uri="{BB962C8B-B14F-4D97-AF65-F5344CB8AC3E}">
-        <p14:creationId xmlns:p14="http://schemas.microsoft.com/office/powerpoint/2010/main" val="3853984377"/>
+        <p14:creationId xmlns:p14="http://schemas.microsoft.com/office/powerpoint/2010/main" val="3195820291"/>
       </p:ext>
     </p:extLst>
   </p:cSld>
@@ -1908,7 +1908,7 @@
           <p:cNvPr id="2" name="Titel 1">
             <a:extLst>
               <a:ext uri="{FF2B5EF4-FFF2-40B4-BE49-F238E27FC236}">
-                <a16:creationId xmlns:a16="http://schemas.microsoft.com/office/drawing/2014/main" id="{7CCD8839-A255-B997-EDB4-631D1D45CBA3}"/>
+                <a16:creationId xmlns:a16="http://schemas.microsoft.com/office/drawing/2014/main" id="{50AFC8B6-7A3B-A951-C815-2B47BB313A11}"/>
               </a:ext>
             </a:extLst>
           </p:cNvPr>
@@ -1936,7 +1936,7 @@
           <p:cNvPr id="3" name="Datumsplatzhalter 2">
             <a:extLst>
               <a:ext uri="{FF2B5EF4-FFF2-40B4-BE49-F238E27FC236}">
-                <a16:creationId xmlns:a16="http://schemas.microsoft.com/office/drawing/2014/main" id="{C88A5E5C-5DC2-186D-0C53-AA1B0AA01F5C}"/>
+                <a16:creationId xmlns:a16="http://schemas.microsoft.com/office/drawing/2014/main" id="{39F274F7-4537-CE4A-EF8E-E4E528E901C4}"/>
               </a:ext>
             </a:extLst>
           </p:cNvPr>
@@ -1952,7 +1952,7 @@
           <a:bodyPr/>
           <a:lstStyle/>
           <a:p>
-            <a:fld id="{BEE8B028-C60C-46BB-9FC8-7AE2B990A964}" type="datetimeFigureOut">
+            <a:fld id="{F5072598-430D-43E6-AA52-E0B716F765A9}" type="datetimeFigureOut">
               <a:rPr lang="de-DE" smtClean="0"/>
               <a:t>08.10.2026</a:t>
             </a:fld>
@@ -1965,7 +1965,7 @@
           <p:cNvPr id="4" name="Fußzeilenplatzhalter 3">
             <a:extLst>
               <a:ext uri="{FF2B5EF4-FFF2-40B4-BE49-F238E27FC236}">
-                <a16:creationId xmlns:a16="http://schemas.microsoft.com/office/drawing/2014/main" id="{045DB377-4EE2-8D0C-5AEB-18A09020B6C8}"/>
+                <a16:creationId xmlns:a16="http://schemas.microsoft.com/office/drawing/2014/main" id="{6C1B7DAC-8073-1771-7531-E1B8506CBED7}"/>
               </a:ext>
             </a:extLst>
           </p:cNvPr>
@@ -1990,7 +1990,7 @@
           <p:cNvPr id="5" name="Foliennummernplatzhalter 4">
             <a:extLst>
               <a:ext uri="{FF2B5EF4-FFF2-40B4-BE49-F238E27FC236}">
-                <a16:creationId xmlns:a16="http://schemas.microsoft.com/office/drawing/2014/main" id="{266AF807-21B5-4646-3004-E1C46BD0539A}"/>
+                <a16:creationId xmlns:a16="http://schemas.microsoft.com/office/drawing/2014/main" id="{60A6D5D2-9970-EBD1-FA50-FE6495AA5585}"/>
               </a:ext>
             </a:extLst>
           </p:cNvPr>
@@ -2006,7 +2006,7 @@
           <a:bodyPr/>
           <a:lstStyle/>
           <a:p>
-            <a:fld id="{74758E45-F88A-44E4-B551-174347A5E4E7}" type="slidenum">
+            <a:fld id="{EB35F42C-9DAD-4D41-9F5D-E9053B6E5F2F}" type="slidenum">
               <a:rPr lang="de-DE" smtClean="0"/>
               <a:t>‹Nr.›</a:t>
             </a:fld>
@@ -2017,7 +2017,7 @@
     </p:spTree>
     <p:extLst>
       <p:ext uri="{BB962C8B-B14F-4D97-AF65-F5344CB8AC3E}">
-        <p14:creationId xmlns:p14="http://schemas.microsoft.com/office/powerpoint/2010/main" val="292298971"/>
+        <p14:creationId xmlns:p14="http://schemas.microsoft.com/office/powerpoint/2010/main" val="1637842565"/>
       </p:ext>
     </p:extLst>
   </p:cSld>
@@ -2049,7 +2049,7 @@
           <p:cNvPr id="2" name="Datumsplatzhalter 1">
             <a:extLst>
               <a:ext uri="{FF2B5EF4-FFF2-40B4-BE49-F238E27FC236}">
-                <a16:creationId xmlns:a16="http://schemas.microsoft.com/office/drawing/2014/main" id="{D526E5F4-B602-0520-B07F-8AE77E650168}"/>
+                <a16:creationId xmlns:a16="http://schemas.microsoft.com/office/drawing/2014/main" id="{551FBADE-BCE5-6AEF-FF9B-60E8A302A8CE}"/>
               </a:ext>
             </a:extLst>
           </p:cNvPr>
@@ -2065,7 +2065,7 @@
           <a:bodyPr/>
           <a:lstStyle/>
           <a:p>
-            <a:fld id="{BEE8B028-C60C-46BB-9FC8-7AE2B990A964}" type="datetimeFigureOut">
+            <a:fld id="{F5072598-430D-43E6-AA52-E0B716F765A9}" type="datetimeFigureOut">
               <a:rPr lang="de-DE" smtClean="0"/>
               <a:t>08.10.2026</a:t>
             </a:fld>
@@ -2078,7 +2078,7 @@
           <p:cNvPr id="3" name="Fußzeilenplatzhalter 2">
             <a:extLst>
               <a:ext uri="{FF2B5EF4-FFF2-40B4-BE49-F238E27FC236}">
-                <a16:creationId xmlns:a16="http://schemas.microsoft.com/office/drawing/2014/main" id="{AD1E542A-095A-2367-99F1-6FB0B6DC09FF}"/>
+                <a16:creationId xmlns:a16="http://schemas.microsoft.com/office/drawing/2014/main" id="{76B3BF7C-68BD-2325-AF1E-801F9ABEB94D}"/>
               </a:ext>
             </a:extLst>
           </p:cNvPr>
@@ -2103,7 +2103,7 @@
           <p:cNvPr id="4" name="Foliennummernplatzhalter 3">
             <a:extLst>
               <a:ext uri="{FF2B5EF4-FFF2-40B4-BE49-F238E27FC236}">
-                <a16:creationId xmlns:a16="http://schemas.microsoft.com/office/drawing/2014/main" id="{60A3094A-7F0C-C8F2-BC85-CE659864F676}"/>
+                <a16:creationId xmlns:a16="http://schemas.microsoft.com/office/drawing/2014/main" id="{96AF1BD5-B538-525D-D530-50E054D29955}"/>
               </a:ext>
             </a:extLst>
           </p:cNvPr>
@@ -2119,7 +2119,7 @@
           <a:bodyPr/>
           <a:lstStyle/>
           <a:p>
-            <a:fld id="{74758E45-F88A-44E4-B551-174347A5E4E7}" type="slidenum">
+            <a:fld id="{EB35F42C-9DAD-4D41-9F5D-E9053B6E5F2F}" type="slidenum">
               <a:rPr lang="de-DE" smtClean="0"/>
               <a:t>‹Nr.›</a:t>
             </a:fld>
@@ -2130,7 +2130,7 @@
     </p:spTree>
     <p:extLst>
       <p:ext uri="{BB962C8B-B14F-4D97-AF65-F5344CB8AC3E}">
-        <p14:creationId xmlns:p14="http://schemas.microsoft.com/office/powerpoint/2010/main" val="2245046629"/>
+        <p14:creationId xmlns:p14="http://schemas.microsoft.com/office/powerpoint/2010/main" val="4083061739"/>
       </p:ext>
     </p:extLst>
   </p:cSld>
@@ -2162,7 +2162,7 @@
           <p:cNvPr id="2" name="Titel 1">
             <a:extLst>
               <a:ext uri="{FF2B5EF4-FFF2-40B4-BE49-F238E27FC236}">
-                <a16:creationId xmlns:a16="http://schemas.microsoft.com/office/drawing/2014/main" id="{B08BA1DB-D9B3-E4FA-C50A-A86DD9355725}"/>
+                <a16:creationId xmlns:a16="http://schemas.microsoft.com/office/drawing/2014/main" id="{1E41079A-D16A-A04F-C858-AC3B96C9735E}"/>
               </a:ext>
             </a:extLst>
           </p:cNvPr>
@@ -2199,7 +2199,7 @@
           <p:cNvPr id="3" name="Inhaltsplatzhalter 2">
             <a:extLst>
               <a:ext uri="{FF2B5EF4-FFF2-40B4-BE49-F238E27FC236}">
-                <a16:creationId xmlns:a16="http://schemas.microsoft.com/office/drawing/2014/main" id="{64AA0810-D91E-FAE0-8221-B55E7BA00873}"/>
+                <a16:creationId xmlns:a16="http://schemas.microsoft.com/office/drawing/2014/main" id="{06074ABE-1208-9C11-E6EA-12A86BCF3EF4}"/>
               </a:ext>
             </a:extLst>
           </p:cNvPr>
@@ -2289,7 +2289,7 @@
           <p:cNvPr id="4" name="Textplatzhalter 3">
             <a:extLst>
               <a:ext uri="{FF2B5EF4-FFF2-40B4-BE49-F238E27FC236}">
-                <a16:creationId xmlns:a16="http://schemas.microsoft.com/office/drawing/2014/main" id="{7E803458-924D-8329-E19A-373DE2BC85D4}"/>
+                <a16:creationId xmlns:a16="http://schemas.microsoft.com/office/drawing/2014/main" id="{880181EF-8731-8B43-08CF-A8D35E214A3B}"/>
               </a:ext>
             </a:extLst>
           </p:cNvPr>
@@ -2360,7 +2360,7 @@
           <p:cNvPr id="5" name="Datumsplatzhalter 4">
             <a:extLst>
               <a:ext uri="{FF2B5EF4-FFF2-40B4-BE49-F238E27FC236}">
-                <a16:creationId xmlns:a16="http://schemas.microsoft.com/office/drawing/2014/main" id="{A9CFB225-D5E6-B927-469D-C91EAA824411}"/>
+                <a16:creationId xmlns:a16="http://schemas.microsoft.com/office/drawing/2014/main" id="{41B9C2FD-64D3-C15D-6788-B660C58C31AB}"/>
               </a:ext>
             </a:extLst>
           </p:cNvPr>
@@ -2376,7 +2376,7 @@
           <a:bodyPr/>
           <a:lstStyle/>
           <a:p>
-            <a:fld id="{BEE8B028-C60C-46BB-9FC8-7AE2B990A964}" type="datetimeFigureOut">
+            <a:fld id="{F5072598-430D-43E6-AA52-E0B716F765A9}" type="datetimeFigureOut">
               <a:rPr lang="de-DE" smtClean="0"/>
               <a:t>08.10.2026</a:t>
             </a:fld>
@@ -2389,7 +2389,7 @@
           <p:cNvPr id="6" name="Fußzeilenplatzhalter 5">
             <a:extLst>
               <a:ext uri="{FF2B5EF4-FFF2-40B4-BE49-F238E27FC236}">
-                <a16:creationId xmlns:a16="http://schemas.microsoft.com/office/drawing/2014/main" id="{1A3C1B9E-C516-9F9A-861E-5C3A48E246EC}"/>
+                <a16:creationId xmlns:a16="http://schemas.microsoft.com/office/drawing/2014/main" id="{DB351D56-416F-AF47-C9AD-D7E255262ABA}"/>
               </a:ext>
             </a:extLst>
           </p:cNvPr>
@@ -2414,7 +2414,7 @@
           <p:cNvPr id="7" name="Foliennummernplatzhalter 6">
             <a:extLst>
               <a:ext uri="{FF2B5EF4-FFF2-40B4-BE49-F238E27FC236}">
-                <a16:creationId xmlns:a16="http://schemas.microsoft.com/office/drawing/2014/main" id="{D62D4449-8625-0000-9090-2A7F09D3976F}"/>
+                <a16:creationId xmlns:a16="http://schemas.microsoft.com/office/drawing/2014/main" id="{7F0C1B8F-D9C9-AEC8-82FB-4935C524C4FF}"/>
               </a:ext>
             </a:extLst>
           </p:cNvPr>
@@ -2430,7 +2430,7 @@
           <a:bodyPr/>
           <a:lstStyle/>
           <a:p>
-            <a:fld id="{74758E45-F88A-44E4-B551-174347A5E4E7}" type="slidenum">
+            <a:fld id="{EB35F42C-9DAD-4D41-9F5D-E9053B6E5F2F}" type="slidenum">
               <a:rPr lang="de-DE" smtClean="0"/>
               <a:t>‹Nr.›</a:t>
             </a:fld>
@@ -2441,7 +2441,7 @@
     </p:spTree>
     <p:extLst>
       <p:ext uri="{BB962C8B-B14F-4D97-AF65-F5344CB8AC3E}">
-        <p14:creationId xmlns:p14="http://schemas.microsoft.com/office/powerpoint/2010/main" val="2038552801"/>
+        <p14:creationId xmlns:p14="http://schemas.microsoft.com/office/powerpoint/2010/main" val="3889121641"/>
       </p:ext>
     </p:extLst>
   </p:cSld>
@@ -2473,7 +2473,7 @@
           <p:cNvPr id="2" name="Titel 1">
             <a:extLst>
               <a:ext uri="{FF2B5EF4-FFF2-40B4-BE49-F238E27FC236}">
-                <a16:creationId xmlns:a16="http://schemas.microsoft.com/office/drawing/2014/main" id="{C106B355-8B99-C7C3-63AA-9533525B8195}"/>
+                <a16:creationId xmlns:a16="http://schemas.microsoft.com/office/drawing/2014/main" id="{0B8E6AF2-3E2A-759E-EDD6-89AA79021F3A}"/>
               </a:ext>
             </a:extLst>
           </p:cNvPr>
@@ -2510,7 +2510,7 @@
           <p:cNvPr id="3" name="Bildplatzhalter 2">
             <a:extLst>
               <a:ext uri="{FF2B5EF4-FFF2-40B4-BE49-F238E27FC236}">
-                <a16:creationId xmlns:a16="http://schemas.microsoft.com/office/drawing/2014/main" id="{06684AF6-7021-4727-D1F6-0F2160FC0E49}"/>
+                <a16:creationId xmlns:a16="http://schemas.microsoft.com/office/drawing/2014/main" id="{83EC6B1E-F7BF-9379-888F-0E434B70DC7C}"/>
               </a:ext>
             </a:extLst>
           </p:cNvPr>
@@ -2577,7 +2577,7 @@
           <p:cNvPr id="4" name="Textplatzhalter 3">
             <a:extLst>
               <a:ext uri="{FF2B5EF4-FFF2-40B4-BE49-F238E27FC236}">
-                <a16:creationId xmlns:a16="http://schemas.microsoft.com/office/drawing/2014/main" id="{B5817E93-E27E-BF49-2FF2-2128F2D52A96}"/>
+                <a16:creationId xmlns:a16="http://schemas.microsoft.com/office/drawing/2014/main" id="{C420D423-EA40-6AA0-8940-F203CBE0AFAC}"/>
               </a:ext>
             </a:extLst>
           </p:cNvPr>
@@ -2648,7 +2648,7 @@
           <p:cNvPr id="5" name="Datumsplatzhalter 4">
             <a:extLst>
               <a:ext uri="{FF2B5EF4-FFF2-40B4-BE49-F238E27FC236}">
-                <a16:creationId xmlns:a16="http://schemas.microsoft.com/office/drawing/2014/main" id="{00737088-C267-3DFB-5DE2-8C715AEE2FC3}"/>
+                <a16:creationId xmlns:a16="http://schemas.microsoft.com/office/drawing/2014/main" id="{B6DAB1D0-9861-6216-5FDC-5C3096D4D710}"/>
               </a:ext>
             </a:extLst>
           </p:cNvPr>
@@ -2664,7 +2664,7 @@
           <a:bodyPr/>
           <a:lstStyle/>
           <a:p>
-            <a:fld id="{BEE8B028-C60C-46BB-9FC8-7AE2B990A964}" type="datetimeFigureOut">
+            <a:fld id="{F5072598-430D-43E6-AA52-E0B716F765A9}" type="datetimeFigureOut">
               <a:rPr lang="de-DE" smtClean="0"/>
               <a:t>08.10.2026</a:t>
             </a:fld>
@@ -2677,7 +2677,7 @@
           <p:cNvPr id="6" name="Fußzeilenplatzhalter 5">
             <a:extLst>
               <a:ext uri="{FF2B5EF4-FFF2-40B4-BE49-F238E27FC236}">
-                <a16:creationId xmlns:a16="http://schemas.microsoft.com/office/drawing/2014/main" id="{590C5CB9-8FFA-B9A9-AB13-5213DDFDA989}"/>
+                <a16:creationId xmlns:a16="http://schemas.microsoft.com/office/drawing/2014/main" id="{68201A82-74D1-2F95-7B81-700234818CAA}"/>
               </a:ext>
             </a:extLst>
           </p:cNvPr>
@@ -2702,7 +2702,7 @@
           <p:cNvPr id="7" name="Foliennummernplatzhalter 6">
             <a:extLst>
               <a:ext uri="{FF2B5EF4-FFF2-40B4-BE49-F238E27FC236}">
-                <a16:creationId xmlns:a16="http://schemas.microsoft.com/office/drawing/2014/main" id="{E4B61698-BB3F-B2FF-8932-AF3E4CC3F5F1}"/>
+                <a16:creationId xmlns:a16="http://schemas.microsoft.com/office/drawing/2014/main" id="{ACF2F4C8-CA1F-E13D-FE25-4D3D561038C2}"/>
               </a:ext>
             </a:extLst>
           </p:cNvPr>
@@ -2718,7 +2718,7 @@
           <a:bodyPr/>
           <a:lstStyle/>
           <a:p>
-            <a:fld id="{74758E45-F88A-44E4-B551-174347A5E4E7}" type="slidenum">
+            <a:fld id="{EB35F42C-9DAD-4D41-9F5D-E9053B6E5F2F}" type="slidenum">
               <a:rPr lang="de-DE" smtClean="0"/>
               <a:t>‹Nr.›</a:t>
             </a:fld>
@@ -2729,7 +2729,7 @@
     </p:spTree>
     <p:extLst>
       <p:ext uri="{BB962C8B-B14F-4D97-AF65-F5344CB8AC3E}">
-        <p14:creationId xmlns:p14="http://schemas.microsoft.com/office/powerpoint/2010/main" val="368684126"/>
+        <p14:creationId xmlns:p14="http://schemas.microsoft.com/office/powerpoint/2010/main" val="1228771686"/>
       </p:ext>
     </p:extLst>
   </p:cSld>
@@ -2766,7 +2766,7 @@
           <p:cNvPr id="2" name="Titelplatzhalter 1">
             <a:extLst>
               <a:ext uri="{FF2B5EF4-FFF2-40B4-BE49-F238E27FC236}">
-                <a16:creationId xmlns:a16="http://schemas.microsoft.com/office/drawing/2014/main" id="{FD837E1D-687D-8C4B-BBBF-96631C7656A4}"/>
+                <a16:creationId xmlns:a16="http://schemas.microsoft.com/office/drawing/2014/main" id="{48AF7574-F46A-19AC-BE96-209B888A0BBE}"/>
               </a:ext>
             </a:extLst>
           </p:cNvPr>
@@ -2804,7 +2804,7 @@
           <p:cNvPr id="3" name="Textplatzhalter 2">
             <a:extLst>
               <a:ext uri="{FF2B5EF4-FFF2-40B4-BE49-F238E27FC236}">
-                <a16:creationId xmlns:a16="http://schemas.microsoft.com/office/drawing/2014/main" id="{CD17A5D3-3E07-6396-4E23-CFD17261B383}"/>
+                <a16:creationId xmlns:a16="http://schemas.microsoft.com/office/drawing/2014/main" id="{7BC986A7-9FB5-8DA3-6ADE-FBC3CD3A5F28}"/>
               </a:ext>
             </a:extLst>
           </p:cNvPr>
@@ -2871,7 +2871,7 @@
           <p:cNvPr id="4" name="Datumsplatzhalter 3">
             <a:extLst>
               <a:ext uri="{FF2B5EF4-FFF2-40B4-BE49-F238E27FC236}">
-                <a16:creationId xmlns:a16="http://schemas.microsoft.com/office/drawing/2014/main" id="{0155BF6F-6D76-CE73-04D4-EBA8205ABFF7}"/>
+                <a16:creationId xmlns:a16="http://schemas.microsoft.com/office/drawing/2014/main" id="{4F465A70-7247-9B3A-C0A8-0E4576E38596}"/>
               </a:ext>
             </a:extLst>
           </p:cNvPr>
@@ -2905,7 +2905,7 @@
             </a:lvl1pPr>
           </a:lstStyle>
           <a:p>
-            <a:fld id="{BEE8B028-C60C-46BB-9FC8-7AE2B990A964}" type="datetimeFigureOut">
+            <a:fld id="{F5072598-430D-43E6-AA52-E0B716F765A9}" type="datetimeFigureOut">
               <a:rPr lang="de-DE" smtClean="0"/>
               <a:t>08.10.2026</a:t>
             </a:fld>
@@ -2918,7 +2918,7 @@
           <p:cNvPr id="5" name="Fußzeilenplatzhalter 4">
             <a:extLst>
               <a:ext uri="{FF2B5EF4-FFF2-40B4-BE49-F238E27FC236}">
-                <a16:creationId xmlns:a16="http://schemas.microsoft.com/office/drawing/2014/main" id="{CB077CED-F3C6-1210-3B16-1EF395BBE29C}"/>
+                <a16:creationId xmlns:a16="http://schemas.microsoft.com/office/drawing/2014/main" id="{2BC66E4C-A908-CE7C-5DE3-452F308276C5}"/>
               </a:ext>
             </a:extLst>
           </p:cNvPr>
@@ -2961,7 +2961,7 @@
           <p:cNvPr id="6" name="Foliennummernplatzhalter 5">
             <a:extLst>
               <a:ext uri="{FF2B5EF4-FFF2-40B4-BE49-F238E27FC236}">
-                <a16:creationId xmlns:a16="http://schemas.microsoft.com/office/drawing/2014/main" id="{2B0CA6E6-759B-C3B8-01D4-20F622CD3D94}"/>
+                <a16:creationId xmlns:a16="http://schemas.microsoft.com/office/drawing/2014/main" id="{DE5843DB-4FAD-ACFD-C4C8-265AC2FD9EB9}"/>
               </a:ext>
             </a:extLst>
           </p:cNvPr>
@@ -2995,7 +2995,7 @@
             </a:lvl1pPr>
           </a:lstStyle>
           <a:p>
-            <a:fld id="{74758E45-F88A-44E4-B551-174347A5E4E7}" type="slidenum">
+            <a:fld id="{EB35F42C-9DAD-4D41-9F5D-E9053B6E5F2F}" type="slidenum">
               <a:rPr lang="de-DE" smtClean="0"/>
               <a:t>‹Nr.›</a:t>
             </a:fld>
@@ -3006,7 +3006,7 @@
     </p:spTree>
     <p:extLst>
       <p:ext uri="{BB962C8B-B14F-4D97-AF65-F5344CB8AC3E}">
-        <p14:creationId xmlns:p14="http://schemas.microsoft.com/office/powerpoint/2010/main" val="1935652893"/>
+        <p14:creationId xmlns:p14="http://schemas.microsoft.com/office/powerpoint/2010/main" val="3780293227"/>
       </p:ext>
     </p:extLst>
   </p:cSld>
@@ -3329,7 +3329,7 @@
           <p:cNvPr id="2" name="Rechteck 1">
             <a:extLst>
               <a:ext uri="{FF2B5EF4-FFF2-40B4-BE49-F238E27FC236}">
-                <a16:creationId xmlns:a16="http://schemas.microsoft.com/office/drawing/2014/main" id="{A58FBF4F-8CE0-CB45-A53E-C75FCE69D5CF}"/>
+                <a16:creationId xmlns:a16="http://schemas.microsoft.com/office/drawing/2014/main" id="{69912014-C66A-E42D-6FE2-5E248A8047EA}"/>
               </a:ext>
             </a:extLst>
           </p:cNvPr>
@@ -3397,7 +3397,7 @@
           <p:cNvPr id="3" name="Rechteck 2">
             <a:extLst>
               <a:ext uri="{FF2B5EF4-FFF2-40B4-BE49-F238E27FC236}">
-                <a16:creationId xmlns:a16="http://schemas.microsoft.com/office/drawing/2014/main" id="{F897D4AA-0808-DD62-C44D-6C05CCC0C70E}"/>
+                <a16:creationId xmlns:a16="http://schemas.microsoft.com/office/drawing/2014/main" id="{F5F4E805-9DB8-767B-71CB-719452240A71}"/>
               </a:ext>
             </a:extLst>
           </p:cNvPr>
@@ -3467,7 +3467,7 @@
           <p:cNvPr id="4" name="Rechteck 3">
             <a:extLst>
               <a:ext uri="{FF2B5EF4-FFF2-40B4-BE49-F238E27FC236}">
-                <a16:creationId xmlns:a16="http://schemas.microsoft.com/office/drawing/2014/main" id="{1F054122-5B01-CDC5-1D94-4460326E6415}"/>
+                <a16:creationId xmlns:a16="http://schemas.microsoft.com/office/drawing/2014/main" id="{8751AC45-0BB3-9D4F-2269-83EAE07DA2C7}"/>
               </a:ext>
             </a:extLst>
           </p:cNvPr>
@@ -3537,7 +3537,7 @@
           <p:cNvPr id="5" name="Rechteck 4">
             <a:extLst>
               <a:ext uri="{FF2B5EF4-FFF2-40B4-BE49-F238E27FC236}">
-                <a16:creationId xmlns:a16="http://schemas.microsoft.com/office/drawing/2014/main" id="{2684AE02-F8BB-F4A6-FD54-504A63FAD1FD}"/>
+                <a16:creationId xmlns:a16="http://schemas.microsoft.com/office/drawing/2014/main" id="{F4C51BED-AD1A-7D57-7A23-64FC68C421CA}"/>
               </a:ext>
             </a:extLst>
           </p:cNvPr>
@@ -3605,7 +3605,7 @@
           <p:cNvPr id="6" name="Rechteck 5">
             <a:extLst>
               <a:ext uri="{FF2B5EF4-FFF2-40B4-BE49-F238E27FC236}">
-                <a16:creationId xmlns:a16="http://schemas.microsoft.com/office/drawing/2014/main" id="{A7A6664F-F0C6-3113-B8CF-E5E337145349}"/>
+                <a16:creationId xmlns:a16="http://schemas.microsoft.com/office/drawing/2014/main" id="{CE34F84C-EEDE-5DF4-7E1F-06128D5F30D0}"/>
               </a:ext>
             </a:extLst>
           </p:cNvPr>
@@ -3675,7 +3675,7 @@
           <p:cNvPr id="7" name="Rechteck 6">
             <a:extLst>
               <a:ext uri="{FF2B5EF4-FFF2-40B4-BE49-F238E27FC236}">
-                <a16:creationId xmlns:a16="http://schemas.microsoft.com/office/drawing/2014/main" id="{8D323B91-3027-EEC0-D96F-7E25BD6DDD49}"/>
+                <a16:creationId xmlns:a16="http://schemas.microsoft.com/office/drawing/2014/main" id="{194C8ABD-0374-C66E-8102-A48EA217F629}"/>
               </a:ext>
             </a:extLst>
           </p:cNvPr>
@@ -3745,7 +3745,7 @@
           <p:cNvPr id="8" name="Rechteck 7">
             <a:extLst>
               <a:ext uri="{FF2B5EF4-FFF2-40B4-BE49-F238E27FC236}">
-                <a16:creationId xmlns:a16="http://schemas.microsoft.com/office/drawing/2014/main" id="{A897F1D0-2547-11BB-CF37-EA61155A7D00}"/>
+                <a16:creationId xmlns:a16="http://schemas.microsoft.com/office/drawing/2014/main" id="{E1B3D4DF-1909-C016-B355-1CDF9960F7D1}"/>
               </a:ext>
             </a:extLst>
           </p:cNvPr>
@@ -3813,7 +3813,7 @@
           <p:cNvPr id="9" name="Rechteck 8">
             <a:extLst>
               <a:ext uri="{FF2B5EF4-FFF2-40B4-BE49-F238E27FC236}">
-                <a16:creationId xmlns:a16="http://schemas.microsoft.com/office/drawing/2014/main" id="{67942A75-F0E6-DCB5-186A-D05085298873}"/>
+                <a16:creationId xmlns:a16="http://schemas.microsoft.com/office/drawing/2014/main" id="{89EE277D-51EE-237F-2039-3B74FFDF0536}"/>
               </a:ext>
             </a:extLst>
           </p:cNvPr>
@@ -3883,7 +3883,7 @@
           <p:cNvPr id="10" name="Rechteck 9">
             <a:extLst>
               <a:ext uri="{FF2B5EF4-FFF2-40B4-BE49-F238E27FC236}">
-                <a16:creationId xmlns:a16="http://schemas.microsoft.com/office/drawing/2014/main" id="{14AEA050-B8BA-30D2-4062-23A26FF6A221}"/>
+                <a16:creationId xmlns:a16="http://schemas.microsoft.com/office/drawing/2014/main" id="{CC40CDCC-C55D-037D-B1DC-CE9C7F8D75CE}"/>
               </a:ext>
             </a:extLst>
           </p:cNvPr>
@@ -3953,7 +3953,7 @@
           <p:cNvPr id="11" name="Rechteck 10">
             <a:extLst>
               <a:ext uri="{FF2B5EF4-FFF2-40B4-BE49-F238E27FC236}">
-                <a16:creationId xmlns:a16="http://schemas.microsoft.com/office/drawing/2014/main" id="{35687053-7184-9169-4349-576896ADD8FE}"/>
+                <a16:creationId xmlns:a16="http://schemas.microsoft.com/office/drawing/2014/main" id="{B6CD41A6-9D60-DE3D-727E-0B216D8C3DD2}"/>
               </a:ext>
             </a:extLst>
           </p:cNvPr>
@@ -4021,7 +4021,7 @@
           <p:cNvPr id="12" name="Rechteck 11">
             <a:extLst>
               <a:ext uri="{FF2B5EF4-FFF2-40B4-BE49-F238E27FC236}">
-                <a16:creationId xmlns:a16="http://schemas.microsoft.com/office/drawing/2014/main" id="{5D2672E9-4DF1-5354-29BC-AB414CB0127D}"/>
+                <a16:creationId xmlns:a16="http://schemas.microsoft.com/office/drawing/2014/main" id="{67F493F8-51A4-B164-B967-410080B87AEE}"/>
               </a:ext>
             </a:extLst>
           </p:cNvPr>
@@ -4091,7 +4091,7 @@
           <p:cNvPr id="13" name="Rechteck 12">
             <a:extLst>
               <a:ext uri="{FF2B5EF4-FFF2-40B4-BE49-F238E27FC236}">
-                <a16:creationId xmlns:a16="http://schemas.microsoft.com/office/drawing/2014/main" id="{8804B15C-0324-C604-27B5-527D4F378152}"/>
+                <a16:creationId xmlns:a16="http://schemas.microsoft.com/office/drawing/2014/main" id="{71E12F1F-1A6B-5122-0E32-369CAAAEAD9F}"/>
               </a:ext>
             </a:extLst>
           </p:cNvPr>
@@ -4161,7 +4161,7 @@
           <p:cNvPr id="14" name="Rechteck 13">
             <a:extLst>
               <a:ext uri="{FF2B5EF4-FFF2-40B4-BE49-F238E27FC236}">
-                <a16:creationId xmlns:a16="http://schemas.microsoft.com/office/drawing/2014/main" id="{AF5C9A7A-1A4C-56AB-10F7-5B0D839E2B50}"/>
+                <a16:creationId xmlns:a16="http://schemas.microsoft.com/office/drawing/2014/main" id="{56C01E74-2A34-7ABA-7316-E16C19497EB6}"/>
               </a:ext>
             </a:extLst>
           </p:cNvPr>
@@ -4229,7 +4229,7 @@
           <p:cNvPr id="15" name="Rechteck 14">
             <a:extLst>
               <a:ext uri="{FF2B5EF4-FFF2-40B4-BE49-F238E27FC236}">
-                <a16:creationId xmlns:a16="http://schemas.microsoft.com/office/drawing/2014/main" id="{9994F7F6-6658-C58D-C079-C60F639E9D44}"/>
+                <a16:creationId xmlns:a16="http://schemas.microsoft.com/office/drawing/2014/main" id="{1739CE3A-4F92-1EBE-A2E4-F9A870D785E6}"/>
               </a:ext>
             </a:extLst>
           </p:cNvPr>
@@ -4299,7 +4299,7 @@
           <p:cNvPr id="16" name="Rechteck 15">
             <a:extLst>
               <a:ext uri="{FF2B5EF4-FFF2-40B4-BE49-F238E27FC236}">
-                <a16:creationId xmlns:a16="http://schemas.microsoft.com/office/drawing/2014/main" id="{D0EA2EA2-0275-F0EF-267A-DB09D52879A1}"/>
+                <a16:creationId xmlns:a16="http://schemas.microsoft.com/office/drawing/2014/main" id="{8F3D64DF-7EF2-1391-40D2-F8EC6197BB4B}"/>
               </a:ext>
             </a:extLst>
           </p:cNvPr>
@@ -4369,7 +4369,7 @@
           <p:cNvPr id="17" name="Rechteck 16">
             <a:extLst>
               <a:ext uri="{FF2B5EF4-FFF2-40B4-BE49-F238E27FC236}">
-                <a16:creationId xmlns:a16="http://schemas.microsoft.com/office/drawing/2014/main" id="{E665D23C-55BF-F799-6B13-B17A1E8F5EC2}"/>
+                <a16:creationId xmlns:a16="http://schemas.microsoft.com/office/drawing/2014/main" id="{34D639AC-3D0C-1CD4-42D3-A15777AB749C}"/>
               </a:ext>
             </a:extLst>
           </p:cNvPr>
@@ -4437,7 +4437,7 @@
           <p:cNvPr id="18" name="Rechteck 17">
             <a:extLst>
               <a:ext uri="{FF2B5EF4-FFF2-40B4-BE49-F238E27FC236}">
-                <a16:creationId xmlns:a16="http://schemas.microsoft.com/office/drawing/2014/main" id="{D24FF86C-06F9-22BC-FDAA-2CDAD8D81EB5}"/>
+                <a16:creationId xmlns:a16="http://schemas.microsoft.com/office/drawing/2014/main" id="{DA06C3CA-7926-28DB-8C0B-51F4165238FA}"/>
               </a:ext>
             </a:extLst>
           </p:cNvPr>
@@ -4507,7 +4507,7 @@
           <p:cNvPr id="19" name="Rechteck 18">
             <a:extLst>
               <a:ext uri="{FF2B5EF4-FFF2-40B4-BE49-F238E27FC236}">
-                <a16:creationId xmlns:a16="http://schemas.microsoft.com/office/drawing/2014/main" id="{6C60B97A-7AE6-0639-0788-B98C79290B20}"/>
+                <a16:creationId xmlns:a16="http://schemas.microsoft.com/office/drawing/2014/main" id="{D84E0660-AF9C-8A96-0A5A-F1B7BD9FC482}"/>
               </a:ext>
             </a:extLst>
           </p:cNvPr>
@@ -4575,7 +4575,7 @@
     </p:spTree>
     <p:extLst>
       <p:ext uri="{BB962C8B-B14F-4D97-AF65-F5344CB8AC3E}">
-        <p14:creationId xmlns:p14="http://schemas.microsoft.com/office/powerpoint/2010/main" val="2580831842"/>
+        <p14:creationId xmlns:p14="http://schemas.microsoft.com/office/powerpoint/2010/main" val="3097456307"/>
       </p:ext>
     </p:extLst>
   </p:cSld>
@@ -4607,7 +4607,7 @@
           <p:cNvPr id="2" name="Rechteck 1">
             <a:extLst>
               <a:ext uri="{FF2B5EF4-FFF2-40B4-BE49-F238E27FC236}">
-                <a16:creationId xmlns:a16="http://schemas.microsoft.com/office/drawing/2014/main" id="{93A46117-D105-2E28-78EB-7DD38EA69D53}"/>
+                <a16:creationId xmlns:a16="http://schemas.microsoft.com/office/drawing/2014/main" id="{3D7541C8-A703-16F4-0D15-3B6FA4419D1D}"/>
               </a:ext>
             </a:extLst>
           </p:cNvPr>
@@ -4678,7 +4678,7 @@
           <p:cNvPr id="3" name="Rechteck 2">
             <a:extLst>
               <a:ext uri="{FF2B5EF4-FFF2-40B4-BE49-F238E27FC236}">
-                <a16:creationId xmlns:a16="http://schemas.microsoft.com/office/drawing/2014/main" id="{9F9D90DA-7391-D1C8-AC2B-938417D766F7}"/>
+                <a16:creationId xmlns:a16="http://schemas.microsoft.com/office/drawing/2014/main" id="{6DE68054-B756-17E3-5361-F1DF4B6FCD87}"/>
               </a:ext>
             </a:extLst>
           </p:cNvPr>
@@ -4749,7 +4749,7 @@
           <p:cNvPr id="4" name="Rechteck 3">
             <a:extLst>
               <a:ext uri="{FF2B5EF4-FFF2-40B4-BE49-F238E27FC236}">
-                <a16:creationId xmlns:a16="http://schemas.microsoft.com/office/drawing/2014/main" id="{C635EBDB-3BCB-7588-D190-BDE55AFADAAC}"/>
+                <a16:creationId xmlns:a16="http://schemas.microsoft.com/office/drawing/2014/main" id="{C45564DC-C769-2299-D5A1-44BFE03EFA77}"/>
               </a:ext>
             </a:extLst>
           </p:cNvPr>
@@ -4820,7 +4820,7 @@
           <p:cNvPr id="5" name="Rechteck 4">
             <a:extLst>
               <a:ext uri="{FF2B5EF4-FFF2-40B4-BE49-F238E27FC236}">
-                <a16:creationId xmlns:a16="http://schemas.microsoft.com/office/drawing/2014/main" id="{7F8D75CC-1542-3C2E-2C0E-2FE87B2F9FF2}"/>
+                <a16:creationId xmlns:a16="http://schemas.microsoft.com/office/drawing/2014/main" id="{DD95BCB3-908C-99D7-8913-70D190BB37D6}"/>
               </a:ext>
             </a:extLst>
           </p:cNvPr>
@@ -4890,7 +4890,7 @@
           <p:cNvPr id="6" name="Rechteck 5">
             <a:extLst>
               <a:ext uri="{FF2B5EF4-FFF2-40B4-BE49-F238E27FC236}">
-                <a16:creationId xmlns:a16="http://schemas.microsoft.com/office/drawing/2014/main" id="{B5ACA711-6F77-5825-F0C2-0831F868700D}"/>
+                <a16:creationId xmlns:a16="http://schemas.microsoft.com/office/drawing/2014/main" id="{7E3AB043-4379-9C41-3073-B845F8A54179}"/>
               </a:ext>
             </a:extLst>
           </p:cNvPr>
@@ -4960,7 +4960,7 @@
           <p:cNvPr id="7" name="Rechteck 6">
             <a:extLst>
               <a:ext uri="{FF2B5EF4-FFF2-40B4-BE49-F238E27FC236}">
-                <a16:creationId xmlns:a16="http://schemas.microsoft.com/office/drawing/2014/main" id="{5CF43C96-C539-9122-CF28-0707020B3BD8}"/>
+                <a16:creationId xmlns:a16="http://schemas.microsoft.com/office/drawing/2014/main" id="{DBB31787-F50E-591D-84B7-B5D3CBE331D4}"/>
               </a:ext>
             </a:extLst>
           </p:cNvPr>
@@ -5030,7 +5030,7 @@
           <p:cNvPr id="8" name="Rechteck 7">
             <a:extLst>
               <a:ext uri="{FF2B5EF4-FFF2-40B4-BE49-F238E27FC236}">
-                <a16:creationId xmlns:a16="http://schemas.microsoft.com/office/drawing/2014/main" id="{C4EC90F4-2C7A-CB2B-1ACD-F35B87830063}"/>
+                <a16:creationId xmlns:a16="http://schemas.microsoft.com/office/drawing/2014/main" id="{60E38716-3C78-B8DF-398A-5C340FF62C50}"/>
               </a:ext>
             </a:extLst>
           </p:cNvPr>
@@ -5101,7 +5101,7 @@
           <p:cNvPr id="9" name="Rechteck 8">
             <a:extLst>
               <a:ext uri="{FF2B5EF4-FFF2-40B4-BE49-F238E27FC236}">
-                <a16:creationId xmlns:a16="http://schemas.microsoft.com/office/drawing/2014/main" id="{89316A18-4C09-704C-C884-9DA7C7D6A5D6}"/>
+                <a16:creationId xmlns:a16="http://schemas.microsoft.com/office/drawing/2014/main" id="{E130D017-FC4A-27B0-459A-E30C81C78949}"/>
               </a:ext>
             </a:extLst>
           </p:cNvPr>
@@ -5172,7 +5172,7 @@
           <p:cNvPr id="10" name="Rechteck 9">
             <a:extLst>
               <a:ext uri="{FF2B5EF4-FFF2-40B4-BE49-F238E27FC236}">
-                <a16:creationId xmlns:a16="http://schemas.microsoft.com/office/drawing/2014/main" id="{5E997BA9-FC2F-1DB0-5DD4-05B5AD952D3E}"/>
+                <a16:creationId xmlns:a16="http://schemas.microsoft.com/office/drawing/2014/main" id="{0A14657F-F22E-967D-DEE8-02A5DE3FF94D}"/>
               </a:ext>
             </a:extLst>
           </p:cNvPr>
@@ -5243,7 +5243,7 @@
           <p:cNvPr id="11" name="Rechteck 10">
             <a:extLst>
               <a:ext uri="{FF2B5EF4-FFF2-40B4-BE49-F238E27FC236}">
-                <a16:creationId xmlns:a16="http://schemas.microsoft.com/office/drawing/2014/main" id="{13237E5E-F9CB-93D4-136D-A178FFEB4A13}"/>
+                <a16:creationId xmlns:a16="http://schemas.microsoft.com/office/drawing/2014/main" id="{A8EFE31F-547E-BDC8-1725-5C93E07E3C60}"/>
               </a:ext>
             </a:extLst>
           </p:cNvPr>
@@ -5313,7 +5313,7 @@
           <p:cNvPr id="12" name="Rechteck 11">
             <a:extLst>
               <a:ext uri="{FF2B5EF4-FFF2-40B4-BE49-F238E27FC236}">
-                <a16:creationId xmlns:a16="http://schemas.microsoft.com/office/drawing/2014/main" id="{EC91A011-A20F-BBF8-642C-0E4032A8419E}"/>
+                <a16:creationId xmlns:a16="http://schemas.microsoft.com/office/drawing/2014/main" id="{8B3BA717-C093-7145-91A3-475967965900}"/>
               </a:ext>
             </a:extLst>
           </p:cNvPr>
@@ -5383,7 +5383,7 @@
           <p:cNvPr id="13" name="Rechteck 12">
             <a:extLst>
               <a:ext uri="{FF2B5EF4-FFF2-40B4-BE49-F238E27FC236}">
-                <a16:creationId xmlns:a16="http://schemas.microsoft.com/office/drawing/2014/main" id="{5E2920C3-E2AB-F221-1565-A0A101DA2711}"/>
+                <a16:creationId xmlns:a16="http://schemas.microsoft.com/office/drawing/2014/main" id="{747164A3-011F-86A4-9753-E13B5417C86E}"/>
               </a:ext>
             </a:extLst>
           </p:cNvPr>
@@ -5453,7 +5453,7 @@
           <p:cNvPr id="14" name="Rechteck 13">
             <a:extLst>
               <a:ext uri="{FF2B5EF4-FFF2-40B4-BE49-F238E27FC236}">
-                <a16:creationId xmlns:a16="http://schemas.microsoft.com/office/drawing/2014/main" id="{94FD2C8A-92DC-F059-804F-85FB33154260}"/>
+                <a16:creationId xmlns:a16="http://schemas.microsoft.com/office/drawing/2014/main" id="{832259FB-BC5F-1350-3A3A-92DC5B17B8B9}"/>
               </a:ext>
             </a:extLst>
           </p:cNvPr>
@@ -5524,7 +5524,7 @@
           <p:cNvPr id="15" name="Rechteck 14">
             <a:extLst>
               <a:ext uri="{FF2B5EF4-FFF2-40B4-BE49-F238E27FC236}">
-                <a16:creationId xmlns:a16="http://schemas.microsoft.com/office/drawing/2014/main" id="{9147437D-8B48-4454-E02F-65C2CA225F91}"/>
+                <a16:creationId xmlns:a16="http://schemas.microsoft.com/office/drawing/2014/main" id="{4775DD23-487C-3B93-1A93-79BA6A0A0155}"/>
               </a:ext>
             </a:extLst>
           </p:cNvPr>
@@ -5595,7 +5595,7 @@
           <p:cNvPr id="16" name="Rechteck 15">
             <a:extLst>
               <a:ext uri="{FF2B5EF4-FFF2-40B4-BE49-F238E27FC236}">
-                <a16:creationId xmlns:a16="http://schemas.microsoft.com/office/drawing/2014/main" id="{98C9D70D-99C1-4819-03C3-88263AF65F97}"/>
+                <a16:creationId xmlns:a16="http://schemas.microsoft.com/office/drawing/2014/main" id="{63288A62-B50A-565B-53A5-16B83A5139D9}"/>
               </a:ext>
             </a:extLst>
           </p:cNvPr>
@@ -5666,7 +5666,7 @@
           <p:cNvPr id="17" name="Rechteck 16">
             <a:extLst>
               <a:ext uri="{FF2B5EF4-FFF2-40B4-BE49-F238E27FC236}">
-                <a16:creationId xmlns:a16="http://schemas.microsoft.com/office/drawing/2014/main" id="{E113931D-74C2-E158-0A57-9CD7605AEB53}"/>
+                <a16:creationId xmlns:a16="http://schemas.microsoft.com/office/drawing/2014/main" id="{DB90219F-D456-A2D8-EC31-1D942DDBE754}"/>
               </a:ext>
             </a:extLst>
           </p:cNvPr>
@@ -5736,7 +5736,7 @@
           <p:cNvPr id="18" name="Rechteck 17">
             <a:extLst>
               <a:ext uri="{FF2B5EF4-FFF2-40B4-BE49-F238E27FC236}">
-                <a16:creationId xmlns:a16="http://schemas.microsoft.com/office/drawing/2014/main" id="{3566BDE7-2C5B-FEEF-3D9B-777D91898AAE}"/>
+                <a16:creationId xmlns:a16="http://schemas.microsoft.com/office/drawing/2014/main" id="{C255E622-3C6C-2905-ABF2-31148A77B4B4}"/>
               </a:ext>
             </a:extLst>
           </p:cNvPr>
@@ -5806,7 +5806,7 @@
           <p:cNvPr id="19" name="Rechteck 18">
             <a:extLst>
               <a:ext uri="{FF2B5EF4-FFF2-40B4-BE49-F238E27FC236}">
-                <a16:creationId xmlns:a16="http://schemas.microsoft.com/office/drawing/2014/main" id="{C0236EE4-B884-7887-1DBE-EEC7F5AB26AC}"/>
+                <a16:creationId xmlns:a16="http://schemas.microsoft.com/office/drawing/2014/main" id="{256D6596-56C7-ED49-F8D6-5E609D329490}"/>
               </a:ext>
             </a:extLst>
           </p:cNvPr>
@@ -5876,7 +5876,7 @@
           <p:cNvPr id="20" name="Rechteck 19">
             <a:extLst>
               <a:ext uri="{FF2B5EF4-FFF2-40B4-BE49-F238E27FC236}">
-                <a16:creationId xmlns:a16="http://schemas.microsoft.com/office/drawing/2014/main" id="{AF26BF1D-54F5-294D-0E9D-C8D5893875B3}"/>
+                <a16:creationId xmlns:a16="http://schemas.microsoft.com/office/drawing/2014/main" id="{9A003C4D-4AA8-AB7E-29C9-455F6A1A79DA}"/>
               </a:ext>
             </a:extLst>
           </p:cNvPr>
@@ -5947,7 +5947,7 @@
           <p:cNvPr id="21" name="Rechteck 20">
             <a:extLst>
               <a:ext uri="{FF2B5EF4-FFF2-40B4-BE49-F238E27FC236}">
-                <a16:creationId xmlns:a16="http://schemas.microsoft.com/office/drawing/2014/main" id="{66C47590-2E37-A56F-90BC-FB3FBB9F1149}"/>
+                <a16:creationId xmlns:a16="http://schemas.microsoft.com/office/drawing/2014/main" id="{C80BFBFC-E262-ACEE-F200-28F552925E5F}"/>
               </a:ext>
             </a:extLst>
           </p:cNvPr>
@@ -6018,7 +6018,7 @@
           <p:cNvPr id="22" name="Rechteck 21">
             <a:extLst>
               <a:ext uri="{FF2B5EF4-FFF2-40B4-BE49-F238E27FC236}">
-                <a16:creationId xmlns:a16="http://schemas.microsoft.com/office/drawing/2014/main" id="{707E8679-F64C-5A23-6AA9-C44827EADF0A}"/>
+                <a16:creationId xmlns:a16="http://schemas.microsoft.com/office/drawing/2014/main" id="{7130B1A7-BAA6-920B-B3AE-1C8CC3408429}"/>
               </a:ext>
             </a:extLst>
           </p:cNvPr>
@@ -6089,7 +6089,7 @@
           <p:cNvPr id="23" name="Rechteck 22">
             <a:extLst>
               <a:ext uri="{FF2B5EF4-FFF2-40B4-BE49-F238E27FC236}">
-                <a16:creationId xmlns:a16="http://schemas.microsoft.com/office/drawing/2014/main" id="{180DD57E-53FD-4B1C-3AB2-A08C8E1D1036}"/>
+                <a16:creationId xmlns:a16="http://schemas.microsoft.com/office/drawing/2014/main" id="{1B74F856-FD41-19C6-9C5F-7942459FDA71}"/>
               </a:ext>
             </a:extLst>
           </p:cNvPr>
@@ -6159,7 +6159,7 @@
           <p:cNvPr id="24" name="Rechteck 23">
             <a:extLst>
               <a:ext uri="{FF2B5EF4-FFF2-40B4-BE49-F238E27FC236}">
-                <a16:creationId xmlns:a16="http://schemas.microsoft.com/office/drawing/2014/main" id="{A066CDAA-441E-3E46-54ED-3F342DCEC9C0}"/>
+                <a16:creationId xmlns:a16="http://schemas.microsoft.com/office/drawing/2014/main" id="{560B5951-AA0D-BB26-E254-080D076617AD}"/>
               </a:ext>
             </a:extLst>
           </p:cNvPr>
@@ -6229,7 +6229,7 @@
           <p:cNvPr id="25" name="Rechteck 24">
             <a:extLst>
               <a:ext uri="{FF2B5EF4-FFF2-40B4-BE49-F238E27FC236}">
-                <a16:creationId xmlns:a16="http://schemas.microsoft.com/office/drawing/2014/main" id="{7524ACE5-5EB3-345B-9D55-207330186AB3}"/>
+                <a16:creationId xmlns:a16="http://schemas.microsoft.com/office/drawing/2014/main" id="{1CB770C2-E877-7894-B80E-5B9BA95C6AE6}"/>
               </a:ext>
             </a:extLst>
           </p:cNvPr>
@@ -6299,7 +6299,7 @@
           <p:cNvPr id="26" name="Rechteck 25">
             <a:extLst>
               <a:ext uri="{FF2B5EF4-FFF2-40B4-BE49-F238E27FC236}">
-                <a16:creationId xmlns:a16="http://schemas.microsoft.com/office/drawing/2014/main" id="{C6DE780F-C90D-A51A-860F-803CC9F95519}"/>
+                <a16:creationId xmlns:a16="http://schemas.microsoft.com/office/drawing/2014/main" id="{48F6C901-CAB2-098A-6F3E-B5AB01F5040F}"/>
               </a:ext>
             </a:extLst>
           </p:cNvPr>
@@ -6370,7 +6370,7 @@
           <p:cNvPr id="27" name="Rechteck 26">
             <a:extLst>
               <a:ext uri="{FF2B5EF4-FFF2-40B4-BE49-F238E27FC236}">
-                <a16:creationId xmlns:a16="http://schemas.microsoft.com/office/drawing/2014/main" id="{D185DEF2-D8B0-54A4-2ACC-25465F36FD1C}"/>
+                <a16:creationId xmlns:a16="http://schemas.microsoft.com/office/drawing/2014/main" id="{C52A0B2E-E48E-B8B9-AA2F-D8E16DD1577F}"/>
               </a:ext>
             </a:extLst>
           </p:cNvPr>
@@ -6441,7 +6441,7 @@
           <p:cNvPr id="28" name="Rechteck 27">
             <a:extLst>
               <a:ext uri="{FF2B5EF4-FFF2-40B4-BE49-F238E27FC236}">
-                <a16:creationId xmlns:a16="http://schemas.microsoft.com/office/drawing/2014/main" id="{8D443E39-4298-3E52-5E0B-884F59C01ADD}"/>
+                <a16:creationId xmlns:a16="http://schemas.microsoft.com/office/drawing/2014/main" id="{5DA6B469-B41A-3938-5FEC-9A0A5177C4F2}"/>
               </a:ext>
             </a:extLst>
           </p:cNvPr>
@@ -6512,7 +6512,7 @@
           <p:cNvPr id="29" name="Rechteck 28">
             <a:extLst>
               <a:ext uri="{FF2B5EF4-FFF2-40B4-BE49-F238E27FC236}">
-                <a16:creationId xmlns:a16="http://schemas.microsoft.com/office/drawing/2014/main" id="{57CB5045-5D2C-118E-7641-359541A3078A}"/>
+                <a16:creationId xmlns:a16="http://schemas.microsoft.com/office/drawing/2014/main" id="{1C6A5B18-664A-0E30-852A-527BF0530145}"/>
               </a:ext>
             </a:extLst>
           </p:cNvPr>
@@ -6582,7 +6582,7 @@
           <p:cNvPr id="30" name="Rechteck 29">
             <a:extLst>
               <a:ext uri="{FF2B5EF4-FFF2-40B4-BE49-F238E27FC236}">
-                <a16:creationId xmlns:a16="http://schemas.microsoft.com/office/drawing/2014/main" id="{C4243B50-85A6-5A65-3D00-BFCE46227639}"/>
+                <a16:creationId xmlns:a16="http://schemas.microsoft.com/office/drawing/2014/main" id="{B04CC59F-0E95-DDB3-759B-CB9A696667FE}"/>
               </a:ext>
             </a:extLst>
           </p:cNvPr>
@@ -6652,7 +6652,7 @@
           <p:cNvPr id="31" name="Rechteck 30">
             <a:extLst>
               <a:ext uri="{FF2B5EF4-FFF2-40B4-BE49-F238E27FC236}">
-                <a16:creationId xmlns:a16="http://schemas.microsoft.com/office/drawing/2014/main" id="{C53CB755-A982-6DFF-EAE6-06BB2EB17F43}"/>
+                <a16:creationId xmlns:a16="http://schemas.microsoft.com/office/drawing/2014/main" id="{BC0CBB7A-E235-E39A-247F-AD6627663C12}"/>
               </a:ext>
             </a:extLst>
           </p:cNvPr>
@@ -6722,7 +6722,7 @@
           <p:cNvPr id="32" name="Rechteck 31">
             <a:extLst>
               <a:ext uri="{FF2B5EF4-FFF2-40B4-BE49-F238E27FC236}">
-                <a16:creationId xmlns:a16="http://schemas.microsoft.com/office/drawing/2014/main" id="{A3F33B78-CDC7-B392-EA35-262F6487BC47}"/>
+                <a16:creationId xmlns:a16="http://schemas.microsoft.com/office/drawing/2014/main" id="{AEBA3BCA-4F59-A8F8-32C9-CEDD81ABB055}"/>
               </a:ext>
             </a:extLst>
           </p:cNvPr>
@@ -6793,7 +6793,7 @@
           <p:cNvPr id="33" name="Rechteck 32">
             <a:extLst>
               <a:ext uri="{FF2B5EF4-FFF2-40B4-BE49-F238E27FC236}">
-                <a16:creationId xmlns:a16="http://schemas.microsoft.com/office/drawing/2014/main" id="{D481A992-14A5-25A2-226C-19D0DCF26DD7}"/>
+                <a16:creationId xmlns:a16="http://schemas.microsoft.com/office/drawing/2014/main" id="{844F317F-C5AF-735E-C556-4BD1D4E55C51}"/>
               </a:ext>
             </a:extLst>
           </p:cNvPr>
@@ -6864,7 +6864,7 @@
           <p:cNvPr id="34" name="Rechteck 33">
             <a:extLst>
               <a:ext uri="{FF2B5EF4-FFF2-40B4-BE49-F238E27FC236}">
-                <a16:creationId xmlns:a16="http://schemas.microsoft.com/office/drawing/2014/main" id="{72CD3A6A-54DC-D68B-8EB1-2EBC1ADB4FB4}"/>
+                <a16:creationId xmlns:a16="http://schemas.microsoft.com/office/drawing/2014/main" id="{92707D0D-CDDD-8331-941F-836DD7BA5EC0}"/>
               </a:ext>
             </a:extLst>
           </p:cNvPr>
@@ -6935,7 +6935,7 @@
           <p:cNvPr id="35" name="Rechteck 34">
             <a:extLst>
               <a:ext uri="{FF2B5EF4-FFF2-40B4-BE49-F238E27FC236}">
-                <a16:creationId xmlns:a16="http://schemas.microsoft.com/office/drawing/2014/main" id="{4F52FF60-98CA-CAAE-30A6-8B94AC25AA2C}"/>
+                <a16:creationId xmlns:a16="http://schemas.microsoft.com/office/drawing/2014/main" id="{BA0DE56B-3510-0772-1CE9-3D21CFA6BA17}"/>
               </a:ext>
             </a:extLst>
           </p:cNvPr>
@@ -7005,7 +7005,7 @@
           <p:cNvPr id="36" name="Rechteck 35">
             <a:extLst>
               <a:ext uri="{FF2B5EF4-FFF2-40B4-BE49-F238E27FC236}">
-                <a16:creationId xmlns:a16="http://schemas.microsoft.com/office/drawing/2014/main" id="{FCA14B44-800D-E915-EAFE-42202EB0A2C4}"/>
+                <a16:creationId xmlns:a16="http://schemas.microsoft.com/office/drawing/2014/main" id="{FC55F63F-A7A5-61AA-096B-B30E3B70763E}"/>
               </a:ext>
             </a:extLst>
           </p:cNvPr>
@@ -7075,7 +7075,7 @@
           <p:cNvPr id="37" name="Rechteck 36">
             <a:extLst>
               <a:ext uri="{FF2B5EF4-FFF2-40B4-BE49-F238E27FC236}">
-                <a16:creationId xmlns:a16="http://schemas.microsoft.com/office/drawing/2014/main" id="{D1191EF6-1A3B-F1BD-682A-65CEB7DB9B8C}"/>
+                <a16:creationId xmlns:a16="http://schemas.microsoft.com/office/drawing/2014/main" id="{C24F9ADC-7483-0EBA-5E9D-95159842088E}"/>
               </a:ext>
             </a:extLst>
           </p:cNvPr>
@@ -7143,7 +7143,7 @@
     </p:spTree>
     <p:extLst>
       <p:ext uri="{BB962C8B-B14F-4D97-AF65-F5344CB8AC3E}">
-        <p14:creationId xmlns:p14="http://schemas.microsoft.com/office/powerpoint/2010/main" val="3247419854"/>
+        <p14:creationId xmlns:p14="http://schemas.microsoft.com/office/powerpoint/2010/main" val="1205324171"/>
       </p:ext>
     </p:extLst>
   </p:cSld>
@@ -7175,7 +7175,7 @@
           <p:cNvPr id="2" name="Rechteck: abgerundete Ecken 1">
             <a:extLst>
               <a:ext uri="{FF2B5EF4-FFF2-40B4-BE49-F238E27FC236}">
-                <a16:creationId xmlns:a16="http://schemas.microsoft.com/office/drawing/2014/main" id="{B7934C4C-2780-BB34-F8C9-99112E97E07D}"/>
+                <a16:creationId xmlns:a16="http://schemas.microsoft.com/office/drawing/2014/main" id="{9A168628-29AB-F793-FAA2-44596302A4C3}"/>
               </a:ext>
             </a:extLst>
           </p:cNvPr>
@@ -7233,7 +7233,7 @@
           <p:cNvPr id="3" name="Rechteck: abgerundete Ecken 2">
             <a:extLst>
               <a:ext uri="{FF2B5EF4-FFF2-40B4-BE49-F238E27FC236}">
-                <a16:creationId xmlns:a16="http://schemas.microsoft.com/office/drawing/2014/main" id="{0B454885-15E9-95A5-859E-3016AC1B73B3}"/>
+                <a16:creationId xmlns:a16="http://schemas.microsoft.com/office/drawing/2014/main" id="{BF53D694-80C8-070C-B224-61133FF08CDC}"/>
               </a:ext>
             </a:extLst>
           </p:cNvPr>
@@ -7291,7 +7291,7 @@
           <p:cNvPr id="4" name="Rechteck: abgerundete Ecken 3">
             <a:extLst>
               <a:ext uri="{FF2B5EF4-FFF2-40B4-BE49-F238E27FC236}">
-                <a16:creationId xmlns:a16="http://schemas.microsoft.com/office/drawing/2014/main" id="{FC501DEB-D841-A836-7793-2590D8AF472E}"/>
+                <a16:creationId xmlns:a16="http://schemas.microsoft.com/office/drawing/2014/main" id="{6A6F9DD7-07F2-0641-4096-3E716A69016A}"/>
               </a:ext>
             </a:extLst>
           </p:cNvPr>
@@ -7352,7 +7352,7 @@
           <p:cNvPr id="5" name="Rechteck: abgerundete Ecken 4">
             <a:extLst>
               <a:ext uri="{FF2B5EF4-FFF2-40B4-BE49-F238E27FC236}">
-                <a16:creationId xmlns:a16="http://schemas.microsoft.com/office/drawing/2014/main" id="{EE31D437-06E1-50A1-534E-809BA132D16A}"/>
+                <a16:creationId xmlns:a16="http://schemas.microsoft.com/office/drawing/2014/main" id="{74D4494E-4F50-066A-A3C2-9F48C926740D}"/>
               </a:ext>
             </a:extLst>
           </p:cNvPr>
@@ -7413,7 +7413,7 @@
           <p:cNvPr id="6" name="Rechteck: abgerundete Ecken 5">
             <a:extLst>
               <a:ext uri="{FF2B5EF4-FFF2-40B4-BE49-F238E27FC236}">
-                <a16:creationId xmlns:a16="http://schemas.microsoft.com/office/drawing/2014/main" id="{B7893DA2-2002-8FF8-5CAF-667F811F76D9}"/>
+                <a16:creationId xmlns:a16="http://schemas.microsoft.com/office/drawing/2014/main" id="{C7F039A9-F77C-7F02-5E46-9A4FD52E58FC}"/>
               </a:ext>
             </a:extLst>
           </p:cNvPr>
@@ -7471,7 +7471,7 @@
           <p:cNvPr id="7" name="Rechteck: abgerundete Ecken 6">
             <a:extLst>
               <a:ext uri="{FF2B5EF4-FFF2-40B4-BE49-F238E27FC236}">
-                <a16:creationId xmlns:a16="http://schemas.microsoft.com/office/drawing/2014/main" id="{F623A686-4D7C-977C-5EC3-01BFF07710D8}"/>
+                <a16:creationId xmlns:a16="http://schemas.microsoft.com/office/drawing/2014/main" id="{864BA547-49CD-9BD0-F23D-B701C18BCF7D}"/>
               </a:ext>
             </a:extLst>
           </p:cNvPr>
@@ -7529,7 +7529,7 @@
           <p:cNvPr id="8" name="Rechteck: abgerundete Ecken 7">
             <a:extLst>
               <a:ext uri="{FF2B5EF4-FFF2-40B4-BE49-F238E27FC236}">
-                <a16:creationId xmlns:a16="http://schemas.microsoft.com/office/drawing/2014/main" id="{408FA753-E7B6-1CF7-C2E5-D64028B2BD20}"/>
+                <a16:creationId xmlns:a16="http://schemas.microsoft.com/office/drawing/2014/main" id="{6417B6A8-3BE9-122A-1070-4ADBC0F9732E}"/>
               </a:ext>
             </a:extLst>
           </p:cNvPr>
@@ -7590,7 +7590,7 @@
           <p:cNvPr id="9" name="Rechteck: abgerundete Ecken 8">
             <a:extLst>
               <a:ext uri="{FF2B5EF4-FFF2-40B4-BE49-F238E27FC236}">
-                <a16:creationId xmlns:a16="http://schemas.microsoft.com/office/drawing/2014/main" id="{C68C591F-24A3-F2C9-C7AC-C60F7D6E665F}"/>
+                <a16:creationId xmlns:a16="http://schemas.microsoft.com/office/drawing/2014/main" id="{6B61A4D2-2EEF-A5BF-898A-23325EE1F557}"/>
               </a:ext>
             </a:extLst>
           </p:cNvPr>
@@ -7651,7 +7651,7 @@
           <p:cNvPr id="10" name="Rechteck: abgerundete Ecken 9">
             <a:extLst>
               <a:ext uri="{FF2B5EF4-FFF2-40B4-BE49-F238E27FC236}">
-                <a16:creationId xmlns:a16="http://schemas.microsoft.com/office/drawing/2014/main" id="{866EBC11-9BAF-0B9B-324F-02668FA5BE46}"/>
+                <a16:creationId xmlns:a16="http://schemas.microsoft.com/office/drawing/2014/main" id="{5826BB52-6414-A001-C69E-0DB9A16B70A9}"/>
               </a:ext>
             </a:extLst>
           </p:cNvPr>
@@ -7709,7 +7709,7 @@
           <p:cNvPr id="11" name="Rechteck: abgerundete Ecken 10">
             <a:extLst>
               <a:ext uri="{FF2B5EF4-FFF2-40B4-BE49-F238E27FC236}">
-                <a16:creationId xmlns:a16="http://schemas.microsoft.com/office/drawing/2014/main" id="{9B3B01EB-4CCE-8DED-EF77-288D4C769301}"/>
+                <a16:creationId xmlns:a16="http://schemas.microsoft.com/office/drawing/2014/main" id="{176C9209-4210-0E1F-7332-A12AD2774E29}"/>
               </a:ext>
             </a:extLst>
           </p:cNvPr>
@@ -7767,7 +7767,7 @@
           <p:cNvPr id="12" name="Rechteck: abgerundete Ecken 11">
             <a:extLst>
               <a:ext uri="{FF2B5EF4-FFF2-40B4-BE49-F238E27FC236}">
-                <a16:creationId xmlns:a16="http://schemas.microsoft.com/office/drawing/2014/main" id="{09C01245-3232-1172-2BB6-296B9F59EFFF}"/>
+                <a16:creationId xmlns:a16="http://schemas.microsoft.com/office/drawing/2014/main" id="{9936F452-D083-6A0C-C35F-4ED8632A9A3B}"/>
               </a:ext>
             </a:extLst>
           </p:cNvPr>
@@ -7828,7 +7828,7 @@
           <p:cNvPr id="13" name="Rechteck: abgerundete Ecken 12">
             <a:extLst>
               <a:ext uri="{FF2B5EF4-FFF2-40B4-BE49-F238E27FC236}">
-                <a16:creationId xmlns:a16="http://schemas.microsoft.com/office/drawing/2014/main" id="{642D302F-3759-C80C-45D9-C0E8CE931847}"/>
+                <a16:creationId xmlns:a16="http://schemas.microsoft.com/office/drawing/2014/main" id="{6B90CA09-0425-BA08-4349-818C09C1F345}"/>
               </a:ext>
             </a:extLst>
           </p:cNvPr>
@@ -7889,7 +7889,7 @@
           <p:cNvPr id="14" name="Rechteck: abgerundete Ecken 13">
             <a:extLst>
               <a:ext uri="{FF2B5EF4-FFF2-40B4-BE49-F238E27FC236}">
-                <a16:creationId xmlns:a16="http://schemas.microsoft.com/office/drawing/2014/main" id="{41701F12-8D51-7F34-8AB8-09931405A675}"/>
+                <a16:creationId xmlns:a16="http://schemas.microsoft.com/office/drawing/2014/main" id="{CA335A42-1521-900E-75EE-7A29E194A4F1}"/>
               </a:ext>
             </a:extLst>
           </p:cNvPr>
@@ -7947,7 +7947,7 @@
           <p:cNvPr id="15" name="Rechteck: abgerundete Ecken 14">
             <a:extLst>
               <a:ext uri="{FF2B5EF4-FFF2-40B4-BE49-F238E27FC236}">
-                <a16:creationId xmlns:a16="http://schemas.microsoft.com/office/drawing/2014/main" id="{9FE5E229-C43C-8CE3-2B99-166A229A4644}"/>
+                <a16:creationId xmlns:a16="http://schemas.microsoft.com/office/drawing/2014/main" id="{670AB89F-AD45-9518-7181-FC02FD7752D5}"/>
               </a:ext>
             </a:extLst>
           </p:cNvPr>
@@ -8005,7 +8005,7 @@
           <p:cNvPr id="16" name="Rechteck: abgerundete Ecken 15">
             <a:extLst>
               <a:ext uri="{FF2B5EF4-FFF2-40B4-BE49-F238E27FC236}">
-                <a16:creationId xmlns:a16="http://schemas.microsoft.com/office/drawing/2014/main" id="{C67DD2AA-3446-856F-CC95-024C87002F37}"/>
+                <a16:creationId xmlns:a16="http://schemas.microsoft.com/office/drawing/2014/main" id="{819DC429-2606-FDD6-7583-D594297E8C88}"/>
               </a:ext>
             </a:extLst>
           </p:cNvPr>
@@ -8066,7 +8066,7 @@
           <p:cNvPr id="17" name="Rechteck: abgerundete Ecken 16">
             <a:extLst>
               <a:ext uri="{FF2B5EF4-FFF2-40B4-BE49-F238E27FC236}">
-                <a16:creationId xmlns:a16="http://schemas.microsoft.com/office/drawing/2014/main" id="{EC67A072-3955-C3FC-6B98-10E3B5073429}"/>
+                <a16:creationId xmlns:a16="http://schemas.microsoft.com/office/drawing/2014/main" id="{0291C00A-2B71-A404-8C5A-4FE5535B53C6}"/>
               </a:ext>
             </a:extLst>
           </p:cNvPr>
@@ -8127,7 +8127,7 @@
           <p:cNvPr id="18" name="Rechteck: abgerundete Ecken 17">
             <a:extLst>
               <a:ext uri="{FF2B5EF4-FFF2-40B4-BE49-F238E27FC236}">
-                <a16:creationId xmlns:a16="http://schemas.microsoft.com/office/drawing/2014/main" id="{75CED04E-2F0A-FBF0-3759-B2299DCEEA95}"/>
+                <a16:creationId xmlns:a16="http://schemas.microsoft.com/office/drawing/2014/main" id="{0830144D-E7CC-6F72-B671-88CEBA944D44}"/>
               </a:ext>
             </a:extLst>
           </p:cNvPr>
@@ -8187,7 +8187,7 @@
           <p:cNvPr id="19" name="Rechteck: abgerundete Ecken 18">
             <a:extLst>
               <a:ext uri="{FF2B5EF4-FFF2-40B4-BE49-F238E27FC236}">
-                <a16:creationId xmlns:a16="http://schemas.microsoft.com/office/drawing/2014/main" id="{9DCC68F9-F4F9-4B91-402D-1E81969943CA}"/>
+                <a16:creationId xmlns:a16="http://schemas.microsoft.com/office/drawing/2014/main" id="{AE3ACB41-E585-B67E-5746-702EC2B59C4E}"/>
               </a:ext>
             </a:extLst>
           </p:cNvPr>
@@ -8247,7 +8247,7 @@
           <p:cNvPr id="20" name="Rechteck: abgerundete Ecken 19">
             <a:extLst>
               <a:ext uri="{FF2B5EF4-FFF2-40B4-BE49-F238E27FC236}">
-                <a16:creationId xmlns:a16="http://schemas.microsoft.com/office/drawing/2014/main" id="{3A8DB770-A2C5-D431-ECE7-5B53C172C9DC}"/>
+                <a16:creationId xmlns:a16="http://schemas.microsoft.com/office/drawing/2014/main" id="{B5E4B626-FB78-67D6-E949-2641F374DEEC}"/>
               </a:ext>
             </a:extLst>
           </p:cNvPr>
@@ -8307,7 +8307,7 @@
           <p:cNvPr id="21" name="Rechteck: abgerundete Ecken 20">
             <a:extLst>
               <a:ext uri="{FF2B5EF4-FFF2-40B4-BE49-F238E27FC236}">
-                <a16:creationId xmlns:a16="http://schemas.microsoft.com/office/drawing/2014/main" id="{45B3FC8F-328D-72D1-D58A-7A5B898F22BB}"/>
+                <a16:creationId xmlns:a16="http://schemas.microsoft.com/office/drawing/2014/main" id="{0E253C66-87D8-3EEE-381C-082F10227409}"/>
               </a:ext>
             </a:extLst>
           </p:cNvPr>
@@ -8367,7 +8367,7 @@
           <p:cNvPr id="22" name="Rechteck: abgerundete Ecken 21">
             <a:extLst>
               <a:ext uri="{FF2B5EF4-FFF2-40B4-BE49-F238E27FC236}">
-                <a16:creationId xmlns:a16="http://schemas.microsoft.com/office/drawing/2014/main" id="{5B686462-7FF7-F2A0-773E-4B1C258BF563}"/>
+                <a16:creationId xmlns:a16="http://schemas.microsoft.com/office/drawing/2014/main" id="{18DE3797-890B-3196-A55B-75E8B2037F38}"/>
               </a:ext>
             </a:extLst>
           </p:cNvPr>
@@ -8413,7 +8413,7 @@
           <p:cNvPr id="23" name="Rechteck: abgerundete Ecken 22">
             <a:extLst>
               <a:ext uri="{FF2B5EF4-FFF2-40B4-BE49-F238E27FC236}">
-                <a16:creationId xmlns:a16="http://schemas.microsoft.com/office/drawing/2014/main" id="{E1FFD65D-5B7C-9034-50C5-8BC06FD97F6F}"/>
+                <a16:creationId xmlns:a16="http://schemas.microsoft.com/office/drawing/2014/main" id="{5E367CE6-31B4-C7D0-560E-767931A410E6}"/>
               </a:ext>
             </a:extLst>
           </p:cNvPr>
@@ -8459,7 +8459,7 @@
           <p:cNvPr id="24" name="Rechteck: abgerundete Ecken 23">
             <a:extLst>
               <a:ext uri="{FF2B5EF4-FFF2-40B4-BE49-F238E27FC236}">
-                <a16:creationId xmlns:a16="http://schemas.microsoft.com/office/drawing/2014/main" id="{BE1AA219-C4AD-7610-087D-52488A6311A3}"/>
+                <a16:creationId xmlns:a16="http://schemas.microsoft.com/office/drawing/2014/main" id="{19D4AA17-9BD3-CCF9-97C5-93C0A1AF810C}"/>
               </a:ext>
             </a:extLst>
           </p:cNvPr>
@@ -8505,7 +8505,7 @@
           <p:cNvPr id="25" name="Rechteck: abgerundete Ecken 24">
             <a:extLst>
               <a:ext uri="{FF2B5EF4-FFF2-40B4-BE49-F238E27FC236}">
-                <a16:creationId xmlns:a16="http://schemas.microsoft.com/office/drawing/2014/main" id="{F143CE09-32B6-EAB5-7672-A38D07079DF5}"/>
+                <a16:creationId xmlns:a16="http://schemas.microsoft.com/office/drawing/2014/main" id="{CBF16376-1470-FB46-8D68-C30D1DC83D1B}"/>
               </a:ext>
             </a:extLst>
           </p:cNvPr>
@@ -8551,7 +8551,7 @@
           <p:cNvPr id="26" name="Rechteck: abgerundete Ecken 25">
             <a:extLst>
               <a:ext uri="{FF2B5EF4-FFF2-40B4-BE49-F238E27FC236}">
-                <a16:creationId xmlns:a16="http://schemas.microsoft.com/office/drawing/2014/main" id="{B863EC0F-4873-D345-2107-3FAF73D49DEC}"/>
+                <a16:creationId xmlns:a16="http://schemas.microsoft.com/office/drawing/2014/main" id="{7443ED0A-4403-B87D-5D8E-E53E84E84FDC}"/>
               </a:ext>
             </a:extLst>
           </p:cNvPr>
@@ -8611,7 +8611,7 @@
           <p:cNvPr id="27" name="Rechteck: abgerundete Ecken 26">
             <a:extLst>
               <a:ext uri="{FF2B5EF4-FFF2-40B4-BE49-F238E27FC236}">
-                <a16:creationId xmlns:a16="http://schemas.microsoft.com/office/drawing/2014/main" id="{7158B4DA-B71D-998A-EF15-70FB244D4CFA}"/>
+                <a16:creationId xmlns:a16="http://schemas.microsoft.com/office/drawing/2014/main" id="{9D7EABAD-848D-A062-EE08-26CA73BC30F1}"/>
               </a:ext>
             </a:extLst>
           </p:cNvPr>
@@ -8671,7 +8671,7 @@
           <p:cNvPr id="28" name="Rechteck: abgerundete Ecken 27">
             <a:extLst>
               <a:ext uri="{FF2B5EF4-FFF2-40B4-BE49-F238E27FC236}">
-                <a16:creationId xmlns:a16="http://schemas.microsoft.com/office/drawing/2014/main" id="{FEAD1386-0102-4090-4D95-4608606FDDCE}"/>
+                <a16:creationId xmlns:a16="http://schemas.microsoft.com/office/drawing/2014/main" id="{01311C00-0653-B3FF-D843-89EDA706C96B}"/>
               </a:ext>
             </a:extLst>
           </p:cNvPr>
@@ -8734,7 +8734,7 @@
           <p:cNvPr id="29" name="Rechteck: abgerundete Ecken 28">
             <a:extLst>
               <a:ext uri="{FF2B5EF4-FFF2-40B4-BE49-F238E27FC236}">
-                <a16:creationId xmlns:a16="http://schemas.microsoft.com/office/drawing/2014/main" id="{156A87DB-7D4A-A17C-2372-B4E99A538A0D}"/>
+                <a16:creationId xmlns:a16="http://schemas.microsoft.com/office/drawing/2014/main" id="{7169077C-708C-CD89-3B25-A3A055814737}"/>
               </a:ext>
             </a:extLst>
           </p:cNvPr>
@@ -8795,7 +8795,7 @@
     </p:spTree>
     <p:extLst>
       <p:ext uri="{BB962C8B-B14F-4D97-AF65-F5344CB8AC3E}">
-        <p14:creationId xmlns:p14="http://schemas.microsoft.com/office/powerpoint/2010/main" val="78198717"/>
+        <p14:creationId xmlns:p14="http://schemas.microsoft.com/office/powerpoint/2010/main" val="4125390728"/>
       </p:ext>
     </p:extLst>
   </p:cSld>
@@ -8827,7 +8827,7 @@
           <p:cNvPr id="2" name="Rechteck 1">
             <a:extLst>
               <a:ext uri="{FF2B5EF4-FFF2-40B4-BE49-F238E27FC236}">
-                <a16:creationId xmlns:a16="http://schemas.microsoft.com/office/drawing/2014/main" id="{548C4E1B-257A-CEF1-80EE-77E4D63013F7}"/>
+                <a16:creationId xmlns:a16="http://schemas.microsoft.com/office/drawing/2014/main" id="{0DD59215-6CC2-4A56-5F51-1C7A0564890E}"/>
               </a:ext>
             </a:extLst>
           </p:cNvPr>
@@ -8881,7 +8881,7 @@
           <p:cNvPr id="3" name="Rechteck 2">
             <a:extLst>
               <a:ext uri="{FF2B5EF4-FFF2-40B4-BE49-F238E27FC236}">
-                <a16:creationId xmlns:a16="http://schemas.microsoft.com/office/drawing/2014/main" id="{24DD16ED-555A-70AD-FFF0-F0F3CFED7C95}"/>
+                <a16:creationId xmlns:a16="http://schemas.microsoft.com/office/drawing/2014/main" id="{F3D71174-142A-C343-037E-DEE2FC634CB0}"/>
               </a:ext>
             </a:extLst>
           </p:cNvPr>
@@ -8935,7 +8935,7 @@
           <p:cNvPr id="4" name="Rechteck 3">
             <a:extLst>
               <a:ext uri="{FF2B5EF4-FFF2-40B4-BE49-F238E27FC236}">
-                <a16:creationId xmlns:a16="http://schemas.microsoft.com/office/drawing/2014/main" id="{3728943C-FE02-8B23-D64A-1C52AB80F4DF}"/>
+                <a16:creationId xmlns:a16="http://schemas.microsoft.com/office/drawing/2014/main" id="{C5B2531F-D1F8-DA44-4CF4-9F0F8081E22C}"/>
               </a:ext>
             </a:extLst>
           </p:cNvPr>
@@ -8989,7 +8989,7 @@
           <p:cNvPr id="5" name="Rechteck 4">
             <a:extLst>
               <a:ext uri="{FF2B5EF4-FFF2-40B4-BE49-F238E27FC236}">
-                <a16:creationId xmlns:a16="http://schemas.microsoft.com/office/drawing/2014/main" id="{2AEB33C5-BE7F-0F5F-CA2B-F1C03134CE85}"/>
+                <a16:creationId xmlns:a16="http://schemas.microsoft.com/office/drawing/2014/main" id="{B2CBC482-8B3F-2144-A767-F3CFB64FCAEC}"/>
               </a:ext>
             </a:extLst>
           </p:cNvPr>
@@ -9043,7 +9043,7 @@
           <p:cNvPr id="6" name="Rechteck 5">
             <a:extLst>
               <a:ext uri="{FF2B5EF4-FFF2-40B4-BE49-F238E27FC236}">
-                <a16:creationId xmlns:a16="http://schemas.microsoft.com/office/drawing/2014/main" id="{DBF64EC4-346B-4283-87C6-175E814C3AAA}"/>
+                <a16:creationId xmlns:a16="http://schemas.microsoft.com/office/drawing/2014/main" id="{14ECBC87-A7CB-D87D-7CF8-04F592F7C24D}"/>
               </a:ext>
             </a:extLst>
           </p:cNvPr>
@@ -9097,7 +9097,7 @@
           <p:cNvPr id="7" name="Rechteck 6">
             <a:extLst>
               <a:ext uri="{FF2B5EF4-FFF2-40B4-BE49-F238E27FC236}">
-                <a16:creationId xmlns:a16="http://schemas.microsoft.com/office/drawing/2014/main" id="{2C829A46-0188-57DB-CAF3-86FEC228AE19}"/>
+                <a16:creationId xmlns:a16="http://schemas.microsoft.com/office/drawing/2014/main" id="{5F12181D-45BC-0044-F062-F578B99051CD}"/>
               </a:ext>
             </a:extLst>
           </p:cNvPr>
@@ -9151,7 +9151,7 @@
           <p:cNvPr id="8" name="Rechteck 7">
             <a:extLst>
               <a:ext uri="{FF2B5EF4-FFF2-40B4-BE49-F238E27FC236}">
-                <a16:creationId xmlns:a16="http://schemas.microsoft.com/office/drawing/2014/main" id="{5EEFBC64-6D50-090F-2646-F74CEF88A8A2}"/>
+                <a16:creationId xmlns:a16="http://schemas.microsoft.com/office/drawing/2014/main" id="{7E748E70-FC29-45AE-3457-28618A166CD4}"/>
               </a:ext>
             </a:extLst>
           </p:cNvPr>
@@ -9205,7 +9205,7 @@
           <p:cNvPr id="9" name="Rechteck 8">
             <a:extLst>
               <a:ext uri="{FF2B5EF4-FFF2-40B4-BE49-F238E27FC236}">
-                <a16:creationId xmlns:a16="http://schemas.microsoft.com/office/drawing/2014/main" id="{1BF944B9-3CED-D989-4816-8C90D579E2FE}"/>
+                <a16:creationId xmlns:a16="http://schemas.microsoft.com/office/drawing/2014/main" id="{1BECB6E0-F599-CCAF-8D22-8A4EFA686F74}"/>
               </a:ext>
             </a:extLst>
           </p:cNvPr>
@@ -9259,7 +9259,7 @@
           <p:cNvPr id="10" name="Rechteck 9">
             <a:extLst>
               <a:ext uri="{FF2B5EF4-FFF2-40B4-BE49-F238E27FC236}">
-                <a16:creationId xmlns:a16="http://schemas.microsoft.com/office/drawing/2014/main" id="{9F6EC275-ABBE-2044-9C9C-A5C1441047B6}"/>
+                <a16:creationId xmlns:a16="http://schemas.microsoft.com/office/drawing/2014/main" id="{EE13B57F-695E-6D2E-6AD7-AC1453B6AD49}"/>
               </a:ext>
             </a:extLst>
           </p:cNvPr>
@@ -9313,7 +9313,7 @@
           <p:cNvPr id="11" name="Rechteck 10">
             <a:extLst>
               <a:ext uri="{FF2B5EF4-FFF2-40B4-BE49-F238E27FC236}">
-                <a16:creationId xmlns:a16="http://schemas.microsoft.com/office/drawing/2014/main" id="{74A8EB7E-FD01-D4E1-7C22-9012245499EA}"/>
+                <a16:creationId xmlns:a16="http://schemas.microsoft.com/office/drawing/2014/main" id="{F6DF12B7-0C14-843A-FB0B-BED453DA9534}"/>
               </a:ext>
             </a:extLst>
           </p:cNvPr>
@@ -9367,7 +9367,7 @@
           <p:cNvPr id="12" name="Rechteck 11">
             <a:extLst>
               <a:ext uri="{FF2B5EF4-FFF2-40B4-BE49-F238E27FC236}">
-                <a16:creationId xmlns:a16="http://schemas.microsoft.com/office/drawing/2014/main" id="{9F9DF840-5783-4CB6-957D-3EE0EEBFA0DA}"/>
+                <a16:creationId xmlns:a16="http://schemas.microsoft.com/office/drawing/2014/main" id="{7051ECF8-D776-11D8-817C-273FA62F3B5F}"/>
               </a:ext>
             </a:extLst>
           </p:cNvPr>
@@ -9421,7 +9421,7 @@
           <p:cNvPr id="13" name="Rechteck 12">
             <a:extLst>
               <a:ext uri="{FF2B5EF4-FFF2-40B4-BE49-F238E27FC236}">
-                <a16:creationId xmlns:a16="http://schemas.microsoft.com/office/drawing/2014/main" id="{245FAC60-C01F-68C6-B025-C026BA3C9EDF}"/>
+                <a16:creationId xmlns:a16="http://schemas.microsoft.com/office/drawing/2014/main" id="{740DD3CB-67E2-6B6A-A3E4-90C3FF8F4909}"/>
               </a:ext>
             </a:extLst>
           </p:cNvPr>
@@ -9475,7 +9475,7 @@
           <p:cNvPr id="14" name="Rechteck 13">
             <a:extLst>
               <a:ext uri="{FF2B5EF4-FFF2-40B4-BE49-F238E27FC236}">
-                <a16:creationId xmlns:a16="http://schemas.microsoft.com/office/drawing/2014/main" id="{D066F953-CD16-5DCD-8279-57451AA145AB}"/>
+                <a16:creationId xmlns:a16="http://schemas.microsoft.com/office/drawing/2014/main" id="{354A0A7F-B1D2-3E6E-3F86-062C47206948}"/>
               </a:ext>
             </a:extLst>
           </p:cNvPr>
@@ -9529,7 +9529,7 @@
           <p:cNvPr id="15" name="Rechteck 14">
             <a:extLst>
               <a:ext uri="{FF2B5EF4-FFF2-40B4-BE49-F238E27FC236}">
-                <a16:creationId xmlns:a16="http://schemas.microsoft.com/office/drawing/2014/main" id="{EAA6DEFC-9137-8789-7CEE-067C2D40EE7E}"/>
+                <a16:creationId xmlns:a16="http://schemas.microsoft.com/office/drawing/2014/main" id="{D45CCF24-BB3C-5F67-E2C9-1F5EAC127FA8}"/>
               </a:ext>
             </a:extLst>
           </p:cNvPr>
@@ -9583,7 +9583,7 @@
           <p:cNvPr id="16" name="Rechteck 15">
             <a:extLst>
               <a:ext uri="{FF2B5EF4-FFF2-40B4-BE49-F238E27FC236}">
-                <a16:creationId xmlns:a16="http://schemas.microsoft.com/office/drawing/2014/main" id="{F11EEB29-AFFF-2B28-E4D8-90D485B85A2C}"/>
+                <a16:creationId xmlns:a16="http://schemas.microsoft.com/office/drawing/2014/main" id="{76C5A887-C7BC-C40F-D99A-C6EBEA736C11}"/>
               </a:ext>
             </a:extLst>
           </p:cNvPr>
@@ -9637,7 +9637,7 @@
           <p:cNvPr id="17" name="Rechteck 16">
             <a:extLst>
               <a:ext uri="{FF2B5EF4-FFF2-40B4-BE49-F238E27FC236}">
-                <a16:creationId xmlns:a16="http://schemas.microsoft.com/office/drawing/2014/main" id="{290E7173-BA38-E8C1-843E-ED58B6825690}"/>
+                <a16:creationId xmlns:a16="http://schemas.microsoft.com/office/drawing/2014/main" id="{F675AE4E-1D16-E3B9-BBD7-FCB5108BF1A4}"/>
               </a:ext>
             </a:extLst>
           </p:cNvPr>
@@ -9691,7 +9691,7 @@
           <p:cNvPr id="18" name="Rechteck 17">
             <a:extLst>
               <a:ext uri="{FF2B5EF4-FFF2-40B4-BE49-F238E27FC236}">
-                <a16:creationId xmlns:a16="http://schemas.microsoft.com/office/drawing/2014/main" id="{EFA66FDC-A030-ADA9-072D-CBF68A38394A}"/>
+                <a16:creationId xmlns:a16="http://schemas.microsoft.com/office/drawing/2014/main" id="{9BE93EA4-E3D9-69D0-A54F-06359CEB19AA}"/>
               </a:ext>
             </a:extLst>
           </p:cNvPr>
@@ -9745,7 +9745,7 @@
           <p:cNvPr id="19" name="Rechteck 18">
             <a:extLst>
               <a:ext uri="{FF2B5EF4-FFF2-40B4-BE49-F238E27FC236}">
-                <a16:creationId xmlns:a16="http://schemas.microsoft.com/office/drawing/2014/main" id="{5806E4C6-0B43-21D8-8823-327DEAAEA662}"/>
+                <a16:creationId xmlns:a16="http://schemas.microsoft.com/office/drawing/2014/main" id="{81E69DBE-36D4-5E17-D6BE-FFEBE0F8BA7C}"/>
               </a:ext>
             </a:extLst>
           </p:cNvPr>
@@ -9799,7 +9799,7 @@
           <p:cNvPr id="20" name="Rechteck 19">
             <a:extLst>
               <a:ext uri="{FF2B5EF4-FFF2-40B4-BE49-F238E27FC236}">
-                <a16:creationId xmlns:a16="http://schemas.microsoft.com/office/drawing/2014/main" id="{58227C07-9868-9B89-8007-8BCC146963BE}"/>
+                <a16:creationId xmlns:a16="http://schemas.microsoft.com/office/drawing/2014/main" id="{B7BFD877-785C-A804-11C7-BB2164C784F8}"/>
               </a:ext>
             </a:extLst>
           </p:cNvPr>
@@ -9853,7 +9853,7 @@
           <p:cNvPr id="21" name="Rechteck 20">
             <a:extLst>
               <a:ext uri="{FF2B5EF4-FFF2-40B4-BE49-F238E27FC236}">
-                <a16:creationId xmlns:a16="http://schemas.microsoft.com/office/drawing/2014/main" id="{9BF626B5-6312-3B48-20EE-990E68B35A78}"/>
+                <a16:creationId xmlns:a16="http://schemas.microsoft.com/office/drawing/2014/main" id="{7577F613-786C-5730-A83F-50609809F5BD}"/>
               </a:ext>
             </a:extLst>
           </p:cNvPr>
@@ -9907,7 +9907,7 @@
           <p:cNvPr id="22" name="Rechteck 21">
             <a:extLst>
               <a:ext uri="{FF2B5EF4-FFF2-40B4-BE49-F238E27FC236}">
-                <a16:creationId xmlns:a16="http://schemas.microsoft.com/office/drawing/2014/main" id="{A010D4EA-7B66-C76B-20A0-6FDAE7BCCD52}"/>
+                <a16:creationId xmlns:a16="http://schemas.microsoft.com/office/drawing/2014/main" id="{37E5BD3F-ABA7-3A2D-C01C-504AF1F4D600}"/>
               </a:ext>
             </a:extLst>
           </p:cNvPr>
@@ -9961,7 +9961,7 @@
           <p:cNvPr id="23" name="Rechteck 22">
             <a:extLst>
               <a:ext uri="{FF2B5EF4-FFF2-40B4-BE49-F238E27FC236}">
-                <a16:creationId xmlns:a16="http://schemas.microsoft.com/office/drawing/2014/main" id="{1722F2F1-F526-B75A-8C8D-F4A84856275F}"/>
+                <a16:creationId xmlns:a16="http://schemas.microsoft.com/office/drawing/2014/main" id="{8357A44F-742B-889D-F395-136518630D7A}"/>
               </a:ext>
             </a:extLst>
           </p:cNvPr>
@@ -10015,7 +10015,7 @@
           <p:cNvPr id="24" name="Rechteck 23">
             <a:extLst>
               <a:ext uri="{FF2B5EF4-FFF2-40B4-BE49-F238E27FC236}">
-                <a16:creationId xmlns:a16="http://schemas.microsoft.com/office/drawing/2014/main" id="{4A843B42-D67F-DF04-9F97-0C71286ECA37}"/>
+                <a16:creationId xmlns:a16="http://schemas.microsoft.com/office/drawing/2014/main" id="{57705D47-6413-BE7D-3A80-3F47F0F60609}"/>
               </a:ext>
             </a:extLst>
           </p:cNvPr>
@@ -10069,7 +10069,7 @@
           <p:cNvPr id="25" name="Rechteck 24">
             <a:extLst>
               <a:ext uri="{FF2B5EF4-FFF2-40B4-BE49-F238E27FC236}">
-                <a16:creationId xmlns:a16="http://schemas.microsoft.com/office/drawing/2014/main" id="{15C340BD-8AAA-D7D5-CCA4-32DD030F5553}"/>
+                <a16:creationId xmlns:a16="http://schemas.microsoft.com/office/drawing/2014/main" id="{9E3FB5E9-3770-15A5-5423-57DEAB81466A}"/>
               </a:ext>
             </a:extLst>
           </p:cNvPr>
@@ -10123,7 +10123,7 @@
           <p:cNvPr id="26" name="Rechteck 25">
             <a:extLst>
               <a:ext uri="{FF2B5EF4-FFF2-40B4-BE49-F238E27FC236}">
-                <a16:creationId xmlns:a16="http://schemas.microsoft.com/office/drawing/2014/main" id="{47EA8F5B-5BFD-F257-EDB0-A05252030EB6}"/>
+                <a16:creationId xmlns:a16="http://schemas.microsoft.com/office/drawing/2014/main" id="{4E67E647-0686-4F58-53EB-FC329A2368B3}"/>
               </a:ext>
             </a:extLst>
           </p:cNvPr>
@@ -10177,7 +10177,7 @@
           <p:cNvPr id="27" name="Rechteck 26">
             <a:extLst>
               <a:ext uri="{FF2B5EF4-FFF2-40B4-BE49-F238E27FC236}">
-                <a16:creationId xmlns:a16="http://schemas.microsoft.com/office/drawing/2014/main" id="{123F93D7-5BA8-2D55-A446-2B5F5A35871A}"/>
+                <a16:creationId xmlns:a16="http://schemas.microsoft.com/office/drawing/2014/main" id="{2A667062-EA58-D764-896A-DABB5DE53348}"/>
               </a:ext>
             </a:extLst>
           </p:cNvPr>
@@ -10231,7 +10231,7 @@
           <p:cNvPr id="28" name="Rechteck 27">
             <a:extLst>
               <a:ext uri="{FF2B5EF4-FFF2-40B4-BE49-F238E27FC236}">
-                <a16:creationId xmlns:a16="http://schemas.microsoft.com/office/drawing/2014/main" id="{7DDD226F-FDBF-F5E0-57D2-1C63D6C07C94}"/>
+                <a16:creationId xmlns:a16="http://schemas.microsoft.com/office/drawing/2014/main" id="{121710C8-A7F1-6228-DF76-B37F3BB14123}"/>
               </a:ext>
             </a:extLst>
           </p:cNvPr>
@@ -10285,7 +10285,7 @@
           <p:cNvPr id="29" name="Rechteck 28">
             <a:extLst>
               <a:ext uri="{FF2B5EF4-FFF2-40B4-BE49-F238E27FC236}">
-                <a16:creationId xmlns:a16="http://schemas.microsoft.com/office/drawing/2014/main" id="{727EC87C-1B5C-0273-21DB-9806DD6EF665}"/>
+                <a16:creationId xmlns:a16="http://schemas.microsoft.com/office/drawing/2014/main" id="{E4DA01BE-AECA-4A99-3DDF-1D098CA735E4}"/>
               </a:ext>
             </a:extLst>
           </p:cNvPr>
@@ -10339,7 +10339,7 @@
           <p:cNvPr id="30" name="Rechteck 29">
             <a:extLst>
               <a:ext uri="{FF2B5EF4-FFF2-40B4-BE49-F238E27FC236}">
-                <a16:creationId xmlns:a16="http://schemas.microsoft.com/office/drawing/2014/main" id="{2864970D-22B6-5D39-CBC2-3BBF82D0E0D6}"/>
+                <a16:creationId xmlns:a16="http://schemas.microsoft.com/office/drawing/2014/main" id="{535FAA6F-B631-2C7C-30C3-95C281F94C8E}"/>
               </a:ext>
             </a:extLst>
           </p:cNvPr>
@@ -10393,7 +10393,7 @@
           <p:cNvPr id="31" name="Rechteck 30">
             <a:extLst>
               <a:ext uri="{FF2B5EF4-FFF2-40B4-BE49-F238E27FC236}">
-                <a16:creationId xmlns:a16="http://schemas.microsoft.com/office/drawing/2014/main" id="{7AFDDB99-591A-8E4B-EF86-787E7A65401D}"/>
+                <a16:creationId xmlns:a16="http://schemas.microsoft.com/office/drawing/2014/main" id="{AF4743D5-F7BB-56F3-1AF4-55632A0CFA63}"/>
               </a:ext>
             </a:extLst>
           </p:cNvPr>
@@ -10447,7 +10447,7 @@
           <p:cNvPr id="32" name="Rechteck 31">
             <a:extLst>
               <a:ext uri="{FF2B5EF4-FFF2-40B4-BE49-F238E27FC236}">
-                <a16:creationId xmlns:a16="http://schemas.microsoft.com/office/drawing/2014/main" id="{E144ACBE-59D4-842D-D1AF-B50FE6D73A81}"/>
+                <a16:creationId xmlns:a16="http://schemas.microsoft.com/office/drawing/2014/main" id="{AA75C936-428C-062C-C5E3-3C9611911A98}"/>
               </a:ext>
             </a:extLst>
           </p:cNvPr>
@@ -10501,7 +10501,7 @@
           <p:cNvPr id="33" name="Rechteck 32">
             <a:extLst>
               <a:ext uri="{FF2B5EF4-FFF2-40B4-BE49-F238E27FC236}">
-                <a16:creationId xmlns:a16="http://schemas.microsoft.com/office/drawing/2014/main" id="{41C84E77-D443-5A34-3336-95EE24EC9D5C}"/>
+                <a16:creationId xmlns:a16="http://schemas.microsoft.com/office/drawing/2014/main" id="{B8ADC72E-B5F5-C98A-4886-4FE8EB645076}"/>
               </a:ext>
             </a:extLst>
           </p:cNvPr>
@@ -10555,7 +10555,7 @@
           <p:cNvPr id="34" name="Rechteck 33">
             <a:extLst>
               <a:ext uri="{FF2B5EF4-FFF2-40B4-BE49-F238E27FC236}">
-                <a16:creationId xmlns:a16="http://schemas.microsoft.com/office/drawing/2014/main" id="{D6009FB0-FE17-DB10-6A4A-C90B951A3A49}"/>
+                <a16:creationId xmlns:a16="http://schemas.microsoft.com/office/drawing/2014/main" id="{6F7F9A40-601C-C0E3-B373-86B19E004533}"/>
               </a:ext>
             </a:extLst>
           </p:cNvPr>
@@ -10609,7 +10609,7 @@
           <p:cNvPr id="35" name="Rechteck 34">
             <a:extLst>
               <a:ext uri="{FF2B5EF4-FFF2-40B4-BE49-F238E27FC236}">
-                <a16:creationId xmlns:a16="http://schemas.microsoft.com/office/drawing/2014/main" id="{DBF80D92-9BDE-6A36-19CA-4B077943E030}"/>
+                <a16:creationId xmlns:a16="http://schemas.microsoft.com/office/drawing/2014/main" id="{7935D33B-50F6-AA68-32E1-660E2F48B279}"/>
               </a:ext>
             </a:extLst>
           </p:cNvPr>
@@ -10663,7 +10663,7 @@
           <p:cNvPr id="36" name="Rechteck 35">
             <a:extLst>
               <a:ext uri="{FF2B5EF4-FFF2-40B4-BE49-F238E27FC236}">
-                <a16:creationId xmlns:a16="http://schemas.microsoft.com/office/drawing/2014/main" id="{7B2AD1F6-BD7C-57DD-9E66-1096B181354A}"/>
+                <a16:creationId xmlns:a16="http://schemas.microsoft.com/office/drawing/2014/main" id="{559A5A61-FBDD-BF6E-4213-4966A381394F}"/>
               </a:ext>
             </a:extLst>
           </p:cNvPr>
@@ -10717,7 +10717,7 @@
           <p:cNvPr id="37" name="Rechteck 36">
             <a:extLst>
               <a:ext uri="{FF2B5EF4-FFF2-40B4-BE49-F238E27FC236}">
-                <a16:creationId xmlns:a16="http://schemas.microsoft.com/office/drawing/2014/main" id="{93A768D8-DF71-B7D7-0B1C-A9394D3F743B}"/>
+                <a16:creationId xmlns:a16="http://schemas.microsoft.com/office/drawing/2014/main" id="{59EC625E-BB41-6AC0-5854-6D3090EBBC38}"/>
               </a:ext>
             </a:extLst>
           </p:cNvPr>
@@ -10771,7 +10771,7 @@
           <p:cNvPr id="38" name="Rechteck 37">
             <a:extLst>
               <a:ext uri="{FF2B5EF4-FFF2-40B4-BE49-F238E27FC236}">
-                <a16:creationId xmlns:a16="http://schemas.microsoft.com/office/drawing/2014/main" id="{716CEA1B-5A07-A507-4ECE-2FC9057CFF0E}"/>
+                <a16:creationId xmlns:a16="http://schemas.microsoft.com/office/drawing/2014/main" id="{B9A18B94-D335-B21D-FC1C-4DEB3D63A4A7}"/>
               </a:ext>
             </a:extLst>
           </p:cNvPr>
@@ -10825,7 +10825,7 @@
           <p:cNvPr id="39" name="Rechteck 38">
             <a:extLst>
               <a:ext uri="{FF2B5EF4-FFF2-40B4-BE49-F238E27FC236}">
-                <a16:creationId xmlns:a16="http://schemas.microsoft.com/office/drawing/2014/main" id="{9FED3313-7D89-E578-860D-611E8838F1EC}"/>
+                <a16:creationId xmlns:a16="http://schemas.microsoft.com/office/drawing/2014/main" id="{B53E340C-0402-440A-A1FC-4920428A8A6B}"/>
               </a:ext>
             </a:extLst>
           </p:cNvPr>
@@ -10879,7 +10879,7 @@
           <p:cNvPr id="40" name="Rechteck 39">
             <a:extLst>
               <a:ext uri="{FF2B5EF4-FFF2-40B4-BE49-F238E27FC236}">
-                <a16:creationId xmlns:a16="http://schemas.microsoft.com/office/drawing/2014/main" id="{9F060CAA-DF6A-8F28-857E-C40F112A4CA8}"/>
+                <a16:creationId xmlns:a16="http://schemas.microsoft.com/office/drawing/2014/main" id="{1871D4AE-CD3A-370D-2D59-2652BD08694E}"/>
               </a:ext>
             </a:extLst>
           </p:cNvPr>
@@ -10933,7 +10933,7 @@
           <p:cNvPr id="41" name="Rechteck 40">
             <a:extLst>
               <a:ext uri="{FF2B5EF4-FFF2-40B4-BE49-F238E27FC236}">
-                <a16:creationId xmlns:a16="http://schemas.microsoft.com/office/drawing/2014/main" id="{29755262-7FC6-1D89-B4A6-0316E867A01F}"/>
+                <a16:creationId xmlns:a16="http://schemas.microsoft.com/office/drawing/2014/main" id="{66B6BAB7-9002-00E7-130C-FB1882498882}"/>
               </a:ext>
             </a:extLst>
           </p:cNvPr>
@@ -10987,7 +10987,7 @@
           <p:cNvPr id="42" name="Rechteck 41">
             <a:extLst>
               <a:ext uri="{FF2B5EF4-FFF2-40B4-BE49-F238E27FC236}">
-                <a16:creationId xmlns:a16="http://schemas.microsoft.com/office/drawing/2014/main" id="{3FC19285-68C3-43D3-6861-C90F2094CB18}"/>
+                <a16:creationId xmlns:a16="http://schemas.microsoft.com/office/drawing/2014/main" id="{69FD3C13-148F-7408-4ACD-5B0EC8DACA47}"/>
               </a:ext>
             </a:extLst>
           </p:cNvPr>
@@ -11041,7 +11041,7 @@
           <p:cNvPr id="43" name="Rechteck 42">
             <a:extLst>
               <a:ext uri="{FF2B5EF4-FFF2-40B4-BE49-F238E27FC236}">
-                <a16:creationId xmlns:a16="http://schemas.microsoft.com/office/drawing/2014/main" id="{359A3679-14A5-D54E-63FA-0D80A3518B0D}"/>
+                <a16:creationId xmlns:a16="http://schemas.microsoft.com/office/drawing/2014/main" id="{93C6F8C5-8AFA-19D1-4A26-2158D123AF7A}"/>
               </a:ext>
             </a:extLst>
           </p:cNvPr>
@@ -11095,7 +11095,7 @@
           <p:cNvPr id="44" name="Rechteck 43">
             <a:extLst>
               <a:ext uri="{FF2B5EF4-FFF2-40B4-BE49-F238E27FC236}">
-                <a16:creationId xmlns:a16="http://schemas.microsoft.com/office/drawing/2014/main" id="{77753684-1E6C-D40F-FF48-073661B09241}"/>
+                <a16:creationId xmlns:a16="http://schemas.microsoft.com/office/drawing/2014/main" id="{0D7BEEF3-586A-10C6-E762-BE62BDDECCE4}"/>
               </a:ext>
             </a:extLst>
           </p:cNvPr>
@@ -11149,7 +11149,7 @@
           <p:cNvPr id="45" name="Rechteck 44">
             <a:extLst>
               <a:ext uri="{FF2B5EF4-FFF2-40B4-BE49-F238E27FC236}">
-                <a16:creationId xmlns:a16="http://schemas.microsoft.com/office/drawing/2014/main" id="{4F944923-FD47-27E0-624A-F03FF1695F1E}"/>
+                <a16:creationId xmlns:a16="http://schemas.microsoft.com/office/drawing/2014/main" id="{647616C8-9E6D-083F-8BED-4E97D033B8EF}"/>
               </a:ext>
             </a:extLst>
           </p:cNvPr>
@@ -11203,7 +11203,7 @@
           <p:cNvPr id="46" name="Rechteck 45">
             <a:extLst>
               <a:ext uri="{FF2B5EF4-FFF2-40B4-BE49-F238E27FC236}">
-                <a16:creationId xmlns:a16="http://schemas.microsoft.com/office/drawing/2014/main" id="{CE8F211A-2A0D-73E8-5DE1-81D5054FA1FB}"/>
+                <a16:creationId xmlns:a16="http://schemas.microsoft.com/office/drawing/2014/main" id="{B2E92038-7B35-A27A-812B-DCAA6C241E2A}"/>
               </a:ext>
             </a:extLst>
           </p:cNvPr>
@@ -11257,7 +11257,7 @@
           <p:cNvPr id="47" name="Rechteck 46">
             <a:extLst>
               <a:ext uri="{FF2B5EF4-FFF2-40B4-BE49-F238E27FC236}">
-                <a16:creationId xmlns:a16="http://schemas.microsoft.com/office/drawing/2014/main" id="{2D106B52-AB46-9F99-54F4-B3308CDB3293}"/>
+                <a16:creationId xmlns:a16="http://schemas.microsoft.com/office/drawing/2014/main" id="{0B1B5149-161F-4AC3-C461-C392D28B77AE}"/>
               </a:ext>
             </a:extLst>
           </p:cNvPr>
@@ -11311,7 +11311,7 @@
           <p:cNvPr id="48" name="Rechteck 47">
             <a:extLst>
               <a:ext uri="{FF2B5EF4-FFF2-40B4-BE49-F238E27FC236}">
-                <a16:creationId xmlns:a16="http://schemas.microsoft.com/office/drawing/2014/main" id="{D2A64FA5-FEE6-5642-879D-8ABB79A47969}"/>
+                <a16:creationId xmlns:a16="http://schemas.microsoft.com/office/drawing/2014/main" id="{72772527-DAE0-8B7B-0BA2-A56BBF25D66A}"/>
               </a:ext>
             </a:extLst>
           </p:cNvPr>
@@ -11365,7 +11365,7 @@
           <p:cNvPr id="49" name="Rechteck 48">
             <a:extLst>
               <a:ext uri="{FF2B5EF4-FFF2-40B4-BE49-F238E27FC236}">
-                <a16:creationId xmlns:a16="http://schemas.microsoft.com/office/drawing/2014/main" id="{82339278-156A-B6B1-B5EE-1AA18703FA17}"/>
+                <a16:creationId xmlns:a16="http://schemas.microsoft.com/office/drawing/2014/main" id="{9319254C-24D9-8390-25BB-89CFA4F04C78}"/>
               </a:ext>
             </a:extLst>
           </p:cNvPr>
@@ -11419,7 +11419,7 @@
           <p:cNvPr id="50" name="Rechteck 49">
             <a:extLst>
               <a:ext uri="{FF2B5EF4-FFF2-40B4-BE49-F238E27FC236}">
-                <a16:creationId xmlns:a16="http://schemas.microsoft.com/office/drawing/2014/main" id="{68548425-BF07-D349-5DF9-F2ADCF1C98F4}"/>
+                <a16:creationId xmlns:a16="http://schemas.microsoft.com/office/drawing/2014/main" id="{5FAA4020-6841-3B5C-9BCD-54C33AF61C66}"/>
               </a:ext>
             </a:extLst>
           </p:cNvPr>
@@ -11473,7 +11473,7 @@
           <p:cNvPr id="51" name="Rechteck 50">
             <a:extLst>
               <a:ext uri="{FF2B5EF4-FFF2-40B4-BE49-F238E27FC236}">
-                <a16:creationId xmlns:a16="http://schemas.microsoft.com/office/drawing/2014/main" id="{E78ABF27-1685-213E-130F-F8655BABBACC}"/>
+                <a16:creationId xmlns:a16="http://schemas.microsoft.com/office/drawing/2014/main" id="{C361CA68-259C-10EC-5362-E1261F43257F}"/>
               </a:ext>
             </a:extLst>
           </p:cNvPr>
@@ -11527,7 +11527,7 @@
           <p:cNvPr id="52" name="Rechteck 51">
             <a:extLst>
               <a:ext uri="{FF2B5EF4-FFF2-40B4-BE49-F238E27FC236}">
-                <a16:creationId xmlns:a16="http://schemas.microsoft.com/office/drawing/2014/main" id="{F7BF2701-686F-EBBF-6C43-A278342CC4AA}"/>
+                <a16:creationId xmlns:a16="http://schemas.microsoft.com/office/drawing/2014/main" id="{3270C2A2-161E-9102-5A40-B54FAF375A13}"/>
               </a:ext>
             </a:extLst>
           </p:cNvPr>
@@ -11581,7 +11581,7 @@
           <p:cNvPr id="53" name="Rechteck 52">
             <a:extLst>
               <a:ext uri="{FF2B5EF4-FFF2-40B4-BE49-F238E27FC236}">
-                <a16:creationId xmlns:a16="http://schemas.microsoft.com/office/drawing/2014/main" id="{8B9D2B1C-451E-D54C-E971-A6A52463E545}"/>
+                <a16:creationId xmlns:a16="http://schemas.microsoft.com/office/drawing/2014/main" id="{57FD3F57-261F-0400-4E35-D1251EEFDE13}"/>
               </a:ext>
             </a:extLst>
           </p:cNvPr>
@@ -11635,7 +11635,7 @@
           <p:cNvPr id="54" name="Rechteck 53">
             <a:extLst>
               <a:ext uri="{FF2B5EF4-FFF2-40B4-BE49-F238E27FC236}">
-                <a16:creationId xmlns:a16="http://schemas.microsoft.com/office/drawing/2014/main" id="{2D49FF7B-8EC7-BFD3-7A24-5A3571ADF84B}"/>
+                <a16:creationId xmlns:a16="http://schemas.microsoft.com/office/drawing/2014/main" id="{8722DFAD-70E1-7326-1CEA-864C0CEC1058}"/>
               </a:ext>
             </a:extLst>
           </p:cNvPr>
@@ -11689,7 +11689,7 @@
           <p:cNvPr id="55" name="Rechteck 54">
             <a:extLst>
               <a:ext uri="{FF2B5EF4-FFF2-40B4-BE49-F238E27FC236}">
-                <a16:creationId xmlns:a16="http://schemas.microsoft.com/office/drawing/2014/main" id="{4339004D-7D99-F280-9E33-6CBCA5DCB2DD}"/>
+                <a16:creationId xmlns:a16="http://schemas.microsoft.com/office/drawing/2014/main" id="{23128A7F-7845-DE64-ACA8-FE11847E33F3}"/>
               </a:ext>
             </a:extLst>
           </p:cNvPr>
@@ -11741,7 +11741,7 @@
     </p:spTree>
     <p:extLst>
       <p:ext uri="{BB962C8B-B14F-4D97-AF65-F5344CB8AC3E}">
-        <p14:creationId xmlns:p14="http://schemas.microsoft.com/office/powerpoint/2010/main" val="1097850850"/>
+        <p14:creationId xmlns:p14="http://schemas.microsoft.com/office/powerpoint/2010/main" val="3333149842"/>
       </p:ext>
     </p:extLst>
   </p:cSld>

</xml_diff>

<commit_message>
Render tables, effects and pictures; add the objects test deck
- Tables: grid layout with rows growing to fit their text, merged cells,
  cell fills and borders, table style parts (whole table, banding, first and
  last row/column, corner cells) from ppt/tableStyles.xml and their text
  styles.
- Effects: outer shadow, glow and soft edges as SVG filters, calibrated
  against radial profiles measured in PowerPoint renderings; shadows on text
  runs.
- tools/Fidelity: objects deck with pictures (PNG with alpha, JPEG, SVG, crop,
  outline, rotation), tables, effects; test images are generated.

Co-Authored-By: Claude Opus 5.5 <noreply@anthropic.com>
</commit_message>
<xml_diff>
--- a/tests/corpus/pptx/generated/fills.pptx
+++ b/tests/corpus/pptx/generated/fills.pptx
@@ -132,7 +132,7 @@
           <p:cNvPr id="2" name="Titel 1">
             <a:extLst>
               <a:ext uri="{FF2B5EF4-FFF2-40B4-BE49-F238E27FC236}">
-                <a16:creationId xmlns:a16="http://schemas.microsoft.com/office/drawing/2014/main" id="{3AB04097-57B5-6A13-0F83-671BEF25A717}"/>
+                <a16:creationId xmlns:a16="http://schemas.microsoft.com/office/drawing/2014/main" id="{66191F4E-AEA4-6B06-0DD5-572D705A449E}"/>
               </a:ext>
             </a:extLst>
           </p:cNvPr>
@@ -169,7 +169,7 @@
           <p:cNvPr id="3" name="Untertitel 2">
             <a:extLst>
               <a:ext uri="{FF2B5EF4-FFF2-40B4-BE49-F238E27FC236}">
-                <a16:creationId xmlns:a16="http://schemas.microsoft.com/office/drawing/2014/main" id="{D74F7031-F66C-70F4-481A-3E88C27043E1}"/>
+                <a16:creationId xmlns:a16="http://schemas.microsoft.com/office/drawing/2014/main" id="{AD650281-78FF-2630-E427-21843544B329}"/>
               </a:ext>
             </a:extLst>
           </p:cNvPr>
@@ -239,7 +239,7 @@
           <p:cNvPr id="4" name="Datumsplatzhalter 3">
             <a:extLst>
               <a:ext uri="{FF2B5EF4-FFF2-40B4-BE49-F238E27FC236}">
-                <a16:creationId xmlns:a16="http://schemas.microsoft.com/office/drawing/2014/main" id="{5B9C3A28-4734-9EEB-0E0C-6E8931794E96}"/>
+                <a16:creationId xmlns:a16="http://schemas.microsoft.com/office/drawing/2014/main" id="{929A6C3B-8D1A-E4DB-0617-636EF69FCFC8}"/>
               </a:ext>
             </a:extLst>
           </p:cNvPr>
@@ -255,7 +255,7 @@
           <a:bodyPr/>
           <a:lstStyle/>
           <a:p>
-            <a:fld id="{F5072598-430D-43E6-AA52-E0B716F765A9}" type="datetimeFigureOut">
+            <a:fld id="{4C7194E1-7AB7-4C19-9A54-266CF35DBFE8}" type="datetimeFigureOut">
               <a:rPr lang="de-DE" smtClean="0"/>
               <a:t>08.10.2026</a:t>
             </a:fld>
@@ -268,7 +268,7 @@
           <p:cNvPr id="5" name="Fußzeilenplatzhalter 4">
             <a:extLst>
               <a:ext uri="{FF2B5EF4-FFF2-40B4-BE49-F238E27FC236}">
-                <a16:creationId xmlns:a16="http://schemas.microsoft.com/office/drawing/2014/main" id="{ACE5226A-ACE8-661D-736A-F098B2CCA993}"/>
+                <a16:creationId xmlns:a16="http://schemas.microsoft.com/office/drawing/2014/main" id="{12E627DC-B86B-8CA2-7C32-AE8AF5A1DF06}"/>
               </a:ext>
             </a:extLst>
           </p:cNvPr>
@@ -293,7 +293,7 @@
           <p:cNvPr id="6" name="Foliennummernplatzhalter 5">
             <a:extLst>
               <a:ext uri="{FF2B5EF4-FFF2-40B4-BE49-F238E27FC236}">
-                <a16:creationId xmlns:a16="http://schemas.microsoft.com/office/drawing/2014/main" id="{E644E323-7F50-159D-47BF-28A48D6A370B}"/>
+                <a16:creationId xmlns:a16="http://schemas.microsoft.com/office/drawing/2014/main" id="{7266DEBF-C742-8962-AA55-0BCE42860EF4}"/>
               </a:ext>
             </a:extLst>
           </p:cNvPr>
@@ -309,7 +309,7 @@
           <a:bodyPr/>
           <a:lstStyle/>
           <a:p>
-            <a:fld id="{EB35F42C-9DAD-4D41-9F5D-E9053B6E5F2F}" type="slidenum">
+            <a:fld id="{3F5CA287-20CA-4900-B098-91820305D6F1}" type="slidenum">
               <a:rPr lang="de-DE" smtClean="0"/>
               <a:t>‹Nr.›</a:t>
             </a:fld>
@@ -320,7 +320,7 @@
     </p:spTree>
     <p:extLst>
       <p:ext uri="{BB962C8B-B14F-4D97-AF65-F5344CB8AC3E}">
-        <p14:creationId xmlns:p14="http://schemas.microsoft.com/office/powerpoint/2010/main" val="3954289103"/>
+        <p14:creationId xmlns:p14="http://schemas.microsoft.com/office/powerpoint/2010/main" val="2110307179"/>
       </p:ext>
     </p:extLst>
   </p:cSld>
@@ -352,7 +352,7 @@
           <p:cNvPr id="2" name="Titel 1">
             <a:extLst>
               <a:ext uri="{FF2B5EF4-FFF2-40B4-BE49-F238E27FC236}">
-                <a16:creationId xmlns:a16="http://schemas.microsoft.com/office/drawing/2014/main" id="{2A76985C-E24A-F2FB-D172-6E1AD52EAC24}"/>
+                <a16:creationId xmlns:a16="http://schemas.microsoft.com/office/drawing/2014/main" id="{BBFCF058-0656-252B-D878-008054076483}"/>
               </a:ext>
             </a:extLst>
           </p:cNvPr>
@@ -380,7 +380,7 @@
           <p:cNvPr id="3" name="Vertikaler Textplatzhalter 2">
             <a:extLst>
               <a:ext uri="{FF2B5EF4-FFF2-40B4-BE49-F238E27FC236}">
-                <a16:creationId xmlns:a16="http://schemas.microsoft.com/office/drawing/2014/main" id="{A372C77B-069A-735C-FE4B-3DA14B2AEDFE}"/>
+                <a16:creationId xmlns:a16="http://schemas.microsoft.com/office/drawing/2014/main" id="{27CAF2AE-8C4C-AC5D-677A-0923A19DBC9A}"/>
               </a:ext>
             </a:extLst>
           </p:cNvPr>
@@ -437,7 +437,7 @@
           <p:cNvPr id="4" name="Datumsplatzhalter 3">
             <a:extLst>
               <a:ext uri="{FF2B5EF4-FFF2-40B4-BE49-F238E27FC236}">
-                <a16:creationId xmlns:a16="http://schemas.microsoft.com/office/drawing/2014/main" id="{AD73DAB1-AA5E-8337-E6BB-3ED75995770D}"/>
+                <a16:creationId xmlns:a16="http://schemas.microsoft.com/office/drawing/2014/main" id="{13CCC13B-F52D-C413-D759-8911217D94B6}"/>
               </a:ext>
             </a:extLst>
           </p:cNvPr>
@@ -453,7 +453,7 @@
           <a:bodyPr/>
           <a:lstStyle/>
           <a:p>
-            <a:fld id="{F5072598-430D-43E6-AA52-E0B716F765A9}" type="datetimeFigureOut">
+            <a:fld id="{4C7194E1-7AB7-4C19-9A54-266CF35DBFE8}" type="datetimeFigureOut">
               <a:rPr lang="de-DE" smtClean="0"/>
               <a:t>08.10.2026</a:t>
             </a:fld>
@@ -466,7 +466,7 @@
           <p:cNvPr id="5" name="Fußzeilenplatzhalter 4">
             <a:extLst>
               <a:ext uri="{FF2B5EF4-FFF2-40B4-BE49-F238E27FC236}">
-                <a16:creationId xmlns:a16="http://schemas.microsoft.com/office/drawing/2014/main" id="{90A6F121-1CE9-A53D-9236-0FB6A34506AC}"/>
+                <a16:creationId xmlns:a16="http://schemas.microsoft.com/office/drawing/2014/main" id="{8FC1F807-D362-FCE2-FD31-9AEB6A936B22}"/>
               </a:ext>
             </a:extLst>
           </p:cNvPr>
@@ -491,7 +491,7 @@
           <p:cNvPr id="6" name="Foliennummernplatzhalter 5">
             <a:extLst>
               <a:ext uri="{FF2B5EF4-FFF2-40B4-BE49-F238E27FC236}">
-                <a16:creationId xmlns:a16="http://schemas.microsoft.com/office/drawing/2014/main" id="{ADDCFE97-EF1A-E6DB-26E3-2120DD42D668}"/>
+                <a16:creationId xmlns:a16="http://schemas.microsoft.com/office/drawing/2014/main" id="{2DB1AD06-37F2-4BD3-38EE-3934E27D3649}"/>
               </a:ext>
             </a:extLst>
           </p:cNvPr>
@@ -507,7 +507,7 @@
           <a:bodyPr/>
           <a:lstStyle/>
           <a:p>
-            <a:fld id="{EB35F42C-9DAD-4D41-9F5D-E9053B6E5F2F}" type="slidenum">
+            <a:fld id="{3F5CA287-20CA-4900-B098-91820305D6F1}" type="slidenum">
               <a:rPr lang="de-DE" smtClean="0"/>
               <a:t>‹Nr.›</a:t>
             </a:fld>
@@ -518,7 +518,7 @@
     </p:spTree>
     <p:extLst>
       <p:ext uri="{BB962C8B-B14F-4D97-AF65-F5344CB8AC3E}">
-        <p14:creationId xmlns:p14="http://schemas.microsoft.com/office/powerpoint/2010/main" val="3284997945"/>
+        <p14:creationId xmlns:p14="http://schemas.microsoft.com/office/powerpoint/2010/main" val="1364106735"/>
       </p:ext>
     </p:extLst>
   </p:cSld>
@@ -550,7 +550,7 @@
           <p:cNvPr id="2" name="Vertikaler Titel 1">
             <a:extLst>
               <a:ext uri="{FF2B5EF4-FFF2-40B4-BE49-F238E27FC236}">
-                <a16:creationId xmlns:a16="http://schemas.microsoft.com/office/drawing/2014/main" id="{FADC2FC2-E526-F747-485A-00A5A9FCDD1C}"/>
+                <a16:creationId xmlns:a16="http://schemas.microsoft.com/office/drawing/2014/main" id="{1A214DEF-5C24-AF5C-DBA3-2CB1431CEDA3}"/>
               </a:ext>
             </a:extLst>
           </p:cNvPr>
@@ -583,7 +583,7 @@
           <p:cNvPr id="3" name="Vertikaler Textplatzhalter 2">
             <a:extLst>
               <a:ext uri="{FF2B5EF4-FFF2-40B4-BE49-F238E27FC236}">
-                <a16:creationId xmlns:a16="http://schemas.microsoft.com/office/drawing/2014/main" id="{67EC531E-3EA6-9CE1-87AD-007491B4C78D}"/>
+                <a16:creationId xmlns:a16="http://schemas.microsoft.com/office/drawing/2014/main" id="{D8ADF3C7-7424-2462-10EA-55DEA9D8ABC1}"/>
               </a:ext>
             </a:extLst>
           </p:cNvPr>
@@ -645,7 +645,7 @@
           <p:cNvPr id="4" name="Datumsplatzhalter 3">
             <a:extLst>
               <a:ext uri="{FF2B5EF4-FFF2-40B4-BE49-F238E27FC236}">
-                <a16:creationId xmlns:a16="http://schemas.microsoft.com/office/drawing/2014/main" id="{9F035CE3-0C70-6909-BCCB-EFF269376B26}"/>
+                <a16:creationId xmlns:a16="http://schemas.microsoft.com/office/drawing/2014/main" id="{B7968A58-B3F4-0B6B-9746-A6DF9EEEA50B}"/>
               </a:ext>
             </a:extLst>
           </p:cNvPr>
@@ -661,7 +661,7 @@
           <a:bodyPr/>
           <a:lstStyle/>
           <a:p>
-            <a:fld id="{F5072598-430D-43E6-AA52-E0B716F765A9}" type="datetimeFigureOut">
+            <a:fld id="{4C7194E1-7AB7-4C19-9A54-266CF35DBFE8}" type="datetimeFigureOut">
               <a:rPr lang="de-DE" smtClean="0"/>
               <a:t>08.10.2026</a:t>
             </a:fld>
@@ -674,7 +674,7 @@
           <p:cNvPr id="5" name="Fußzeilenplatzhalter 4">
             <a:extLst>
               <a:ext uri="{FF2B5EF4-FFF2-40B4-BE49-F238E27FC236}">
-                <a16:creationId xmlns:a16="http://schemas.microsoft.com/office/drawing/2014/main" id="{26ACC7D4-DB6E-4A78-ED8C-BC706A2DF7C3}"/>
+                <a16:creationId xmlns:a16="http://schemas.microsoft.com/office/drawing/2014/main" id="{81B033E5-33AE-4316-5615-91D6C931DC64}"/>
               </a:ext>
             </a:extLst>
           </p:cNvPr>
@@ -699,7 +699,7 @@
           <p:cNvPr id="6" name="Foliennummernplatzhalter 5">
             <a:extLst>
               <a:ext uri="{FF2B5EF4-FFF2-40B4-BE49-F238E27FC236}">
-                <a16:creationId xmlns:a16="http://schemas.microsoft.com/office/drawing/2014/main" id="{7CBDEB3C-CE12-426C-8101-DFC9DDD85742}"/>
+                <a16:creationId xmlns:a16="http://schemas.microsoft.com/office/drawing/2014/main" id="{C65DFAF6-84CE-4462-DB2A-3A819102CD1A}"/>
               </a:ext>
             </a:extLst>
           </p:cNvPr>
@@ -715,7 +715,7 @@
           <a:bodyPr/>
           <a:lstStyle/>
           <a:p>
-            <a:fld id="{EB35F42C-9DAD-4D41-9F5D-E9053B6E5F2F}" type="slidenum">
+            <a:fld id="{3F5CA287-20CA-4900-B098-91820305D6F1}" type="slidenum">
               <a:rPr lang="de-DE" smtClean="0"/>
               <a:t>‹Nr.›</a:t>
             </a:fld>
@@ -726,7 +726,7 @@
     </p:spTree>
     <p:extLst>
       <p:ext uri="{BB962C8B-B14F-4D97-AF65-F5344CB8AC3E}">
-        <p14:creationId xmlns:p14="http://schemas.microsoft.com/office/powerpoint/2010/main" val="865606643"/>
+        <p14:creationId xmlns:p14="http://schemas.microsoft.com/office/powerpoint/2010/main" val="1790565892"/>
       </p:ext>
     </p:extLst>
   </p:cSld>
@@ -758,7 +758,7 @@
           <p:cNvPr id="2" name="Titel 1">
             <a:extLst>
               <a:ext uri="{FF2B5EF4-FFF2-40B4-BE49-F238E27FC236}">
-                <a16:creationId xmlns:a16="http://schemas.microsoft.com/office/drawing/2014/main" id="{0DB44C4B-336A-ACA2-825C-25626F3C7077}"/>
+                <a16:creationId xmlns:a16="http://schemas.microsoft.com/office/drawing/2014/main" id="{A0A7E916-8FB0-A648-D8C4-DA5A7F36A9DC}"/>
               </a:ext>
             </a:extLst>
           </p:cNvPr>
@@ -786,7 +786,7 @@
           <p:cNvPr id="3" name="Inhaltsplatzhalter 2">
             <a:extLst>
               <a:ext uri="{FF2B5EF4-FFF2-40B4-BE49-F238E27FC236}">
-                <a16:creationId xmlns:a16="http://schemas.microsoft.com/office/drawing/2014/main" id="{DB6AFE55-0193-3035-ECF6-9509D61FF424}"/>
+                <a16:creationId xmlns:a16="http://schemas.microsoft.com/office/drawing/2014/main" id="{0355CB40-6B0B-6774-06BC-F4819C3A7996}"/>
               </a:ext>
             </a:extLst>
           </p:cNvPr>
@@ -843,7 +843,7 @@
           <p:cNvPr id="4" name="Datumsplatzhalter 3">
             <a:extLst>
               <a:ext uri="{FF2B5EF4-FFF2-40B4-BE49-F238E27FC236}">
-                <a16:creationId xmlns:a16="http://schemas.microsoft.com/office/drawing/2014/main" id="{C39E9FD7-45ED-6978-5566-1995AD6C489D}"/>
+                <a16:creationId xmlns:a16="http://schemas.microsoft.com/office/drawing/2014/main" id="{858CA0B2-7330-23CC-5C38-81F798721680}"/>
               </a:ext>
             </a:extLst>
           </p:cNvPr>
@@ -859,7 +859,7 @@
           <a:bodyPr/>
           <a:lstStyle/>
           <a:p>
-            <a:fld id="{F5072598-430D-43E6-AA52-E0B716F765A9}" type="datetimeFigureOut">
+            <a:fld id="{4C7194E1-7AB7-4C19-9A54-266CF35DBFE8}" type="datetimeFigureOut">
               <a:rPr lang="de-DE" smtClean="0"/>
               <a:t>08.10.2026</a:t>
             </a:fld>
@@ -872,7 +872,7 @@
           <p:cNvPr id="5" name="Fußzeilenplatzhalter 4">
             <a:extLst>
               <a:ext uri="{FF2B5EF4-FFF2-40B4-BE49-F238E27FC236}">
-                <a16:creationId xmlns:a16="http://schemas.microsoft.com/office/drawing/2014/main" id="{BA0FA797-B534-A635-BD9F-A7966A46DFC2}"/>
+                <a16:creationId xmlns:a16="http://schemas.microsoft.com/office/drawing/2014/main" id="{6B66A987-0CE1-3923-3EAB-4ECF96A69EB6}"/>
               </a:ext>
             </a:extLst>
           </p:cNvPr>
@@ -897,7 +897,7 @@
           <p:cNvPr id="6" name="Foliennummernplatzhalter 5">
             <a:extLst>
               <a:ext uri="{FF2B5EF4-FFF2-40B4-BE49-F238E27FC236}">
-                <a16:creationId xmlns:a16="http://schemas.microsoft.com/office/drawing/2014/main" id="{2BF85DE7-B81E-C7CA-B23C-630AFBDF110B}"/>
+                <a16:creationId xmlns:a16="http://schemas.microsoft.com/office/drawing/2014/main" id="{E6F50F90-F197-2506-6836-37666C556924}"/>
               </a:ext>
             </a:extLst>
           </p:cNvPr>
@@ -913,7 +913,7 @@
           <a:bodyPr/>
           <a:lstStyle/>
           <a:p>
-            <a:fld id="{EB35F42C-9DAD-4D41-9F5D-E9053B6E5F2F}" type="slidenum">
+            <a:fld id="{3F5CA287-20CA-4900-B098-91820305D6F1}" type="slidenum">
               <a:rPr lang="de-DE" smtClean="0"/>
               <a:t>‹Nr.›</a:t>
             </a:fld>
@@ -924,7 +924,7 @@
     </p:spTree>
     <p:extLst>
       <p:ext uri="{BB962C8B-B14F-4D97-AF65-F5344CB8AC3E}">
-        <p14:creationId xmlns:p14="http://schemas.microsoft.com/office/powerpoint/2010/main" val="1658704705"/>
+        <p14:creationId xmlns:p14="http://schemas.microsoft.com/office/powerpoint/2010/main" val="2322048722"/>
       </p:ext>
     </p:extLst>
   </p:cSld>
@@ -956,7 +956,7 @@
           <p:cNvPr id="2" name="Titel 1">
             <a:extLst>
               <a:ext uri="{FF2B5EF4-FFF2-40B4-BE49-F238E27FC236}">
-                <a16:creationId xmlns:a16="http://schemas.microsoft.com/office/drawing/2014/main" id="{1AFCA4C5-75BA-5308-9AD1-14F74112B195}"/>
+                <a16:creationId xmlns:a16="http://schemas.microsoft.com/office/drawing/2014/main" id="{A81DC526-F238-A986-B453-67F6B9C36670}"/>
               </a:ext>
             </a:extLst>
           </p:cNvPr>
@@ -993,7 +993,7 @@
           <p:cNvPr id="3" name="Textplatzhalter 2">
             <a:extLst>
               <a:ext uri="{FF2B5EF4-FFF2-40B4-BE49-F238E27FC236}">
-                <a16:creationId xmlns:a16="http://schemas.microsoft.com/office/drawing/2014/main" id="{38F1917C-A157-7D42-166E-0ED817D822CB}"/>
+                <a16:creationId xmlns:a16="http://schemas.microsoft.com/office/drawing/2014/main" id="{923362D9-2472-6956-F2E4-6260A8CF61A8}"/>
               </a:ext>
             </a:extLst>
           </p:cNvPr>
@@ -1118,7 +1118,7 @@
           <p:cNvPr id="4" name="Datumsplatzhalter 3">
             <a:extLst>
               <a:ext uri="{FF2B5EF4-FFF2-40B4-BE49-F238E27FC236}">
-                <a16:creationId xmlns:a16="http://schemas.microsoft.com/office/drawing/2014/main" id="{5438CF50-DE10-2296-4695-76502F1F877B}"/>
+                <a16:creationId xmlns:a16="http://schemas.microsoft.com/office/drawing/2014/main" id="{0D4EF427-15C4-896E-29A8-9C6A780CA2CD}"/>
               </a:ext>
             </a:extLst>
           </p:cNvPr>
@@ -1134,7 +1134,7 @@
           <a:bodyPr/>
           <a:lstStyle/>
           <a:p>
-            <a:fld id="{F5072598-430D-43E6-AA52-E0B716F765A9}" type="datetimeFigureOut">
+            <a:fld id="{4C7194E1-7AB7-4C19-9A54-266CF35DBFE8}" type="datetimeFigureOut">
               <a:rPr lang="de-DE" smtClean="0"/>
               <a:t>08.10.2026</a:t>
             </a:fld>
@@ -1147,7 +1147,7 @@
           <p:cNvPr id="5" name="Fußzeilenplatzhalter 4">
             <a:extLst>
               <a:ext uri="{FF2B5EF4-FFF2-40B4-BE49-F238E27FC236}">
-                <a16:creationId xmlns:a16="http://schemas.microsoft.com/office/drawing/2014/main" id="{4DDF99FB-A8D6-F04B-9997-797557A0A802}"/>
+                <a16:creationId xmlns:a16="http://schemas.microsoft.com/office/drawing/2014/main" id="{5AA2E6B4-7F4A-0942-1C5D-68B2F01DDB23}"/>
               </a:ext>
             </a:extLst>
           </p:cNvPr>
@@ -1172,7 +1172,7 @@
           <p:cNvPr id="6" name="Foliennummernplatzhalter 5">
             <a:extLst>
               <a:ext uri="{FF2B5EF4-FFF2-40B4-BE49-F238E27FC236}">
-                <a16:creationId xmlns:a16="http://schemas.microsoft.com/office/drawing/2014/main" id="{E1D6617C-69E9-51D8-064A-06953106F05C}"/>
+                <a16:creationId xmlns:a16="http://schemas.microsoft.com/office/drawing/2014/main" id="{6BDADBC9-B5BB-3DA4-DB1A-EE63F69DF62C}"/>
               </a:ext>
             </a:extLst>
           </p:cNvPr>
@@ -1188,7 +1188,7 @@
           <a:bodyPr/>
           <a:lstStyle/>
           <a:p>
-            <a:fld id="{EB35F42C-9DAD-4D41-9F5D-E9053B6E5F2F}" type="slidenum">
+            <a:fld id="{3F5CA287-20CA-4900-B098-91820305D6F1}" type="slidenum">
               <a:rPr lang="de-DE" smtClean="0"/>
               <a:t>‹Nr.›</a:t>
             </a:fld>
@@ -1199,7 +1199,7 @@
     </p:spTree>
     <p:extLst>
       <p:ext uri="{BB962C8B-B14F-4D97-AF65-F5344CB8AC3E}">
-        <p14:creationId xmlns:p14="http://schemas.microsoft.com/office/powerpoint/2010/main" val="1153455536"/>
+        <p14:creationId xmlns:p14="http://schemas.microsoft.com/office/powerpoint/2010/main" val="1125983611"/>
       </p:ext>
     </p:extLst>
   </p:cSld>
@@ -1231,7 +1231,7 @@
           <p:cNvPr id="2" name="Titel 1">
             <a:extLst>
               <a:ext uri="{FF2B5EF4-FFF2-40B4-BE49-F238E27FC236}">
-                <a16:creationId xmlns:a16="http://schemas.microsoft.com/office/drawing/2014/main" id="{B91FBA49-BF6B-1C02-27C5-A8D52AAF005E}"/>
+                <a16:creationId xmlns:a16="http://schemas.microsoft.com/office/drawing/2014/main" id="{E4567FCA-D5CE-286A-557C-418E5B5221A5}"/>
               </a:ext>
             </a:extLst>
           </p:cNvPr>
@@ -1259,7 +1259,7 @@
           <p:cNvPr id="3" name="Inhaltsplatzhalter 2">
             <a:extLst>
               <a:ext uri="{FF2B5EF4-FFF2-40B4-BE49-F238E27FC236}">
-                <a16:creationId xmlns:a16="http://schemas.microsoft.com/office/drawing/2014/main" id="{5692D161-E41A-EBEE-029A-907F2CDD14CC}"/>
+                <a16:creationId xmlns:a16="http://schemas.microsoft.com/office/drawing/2014/main" id="{89981859-22DC-3806-8A5B-136140EE1F57}"/>
               </a:ext>
             </a:extLst>
           </p:cNvPr>
@@ -1321,7 +1321,7 @@
           <p:cNvPr id="4" name="Inhaltsplatzhalter 3">
             <a:extLst>
               <a:ext uri="{FF2B5EF4-FFF2-40B4-BE49-F238E27FC236}">
-                <a16:creationId xmlns:a16="http://schemas.microsoft.com/office/drawing/2014/main" id="{35D386B5-6A0A-7751-4B5A-314D01D235C2}"/>
+                <a16:creationId xmlns:a16="http://schemas.microsoft.com/office/drawing/2014/main" id="{0A8B5ABB-3E75-91FE-A52C-823EEF76D1E8}"/>
               </a:ext>
             </a:extLst>
           </p:cNvPr>
@@ -1383,7 +1383,7 @@
           <p:cNvPr id="5" name="Datumsplatzhalter 4">
             <a:extLst>
               <a:ext uri="{FF2B5EF4-FFF2-40B4-BE49-F238E27FC236}">
-                <a16:creationId xmlns:a16="http://schemas.microsoft.com/office/drawing/2014/main" id="{8AFFEC28-0EAF-586A-3760-BFBFD75BA48F}"/>
+                <a16:creationId xmlns:a16="http://schemas.microsoft.com/office/drawing/2014/main" id="{FD8DADF6-7C1A-AF0F-D5A0-9624340B6210}"/>
               </a:ext>
             </a:extLst>
           </p:cNvPr>
@@ -1399,7 +1399,7 @@
           <a:bodyPr/>
           <a:lstStyle/>
           <a:p>
-            <a:fld id="{F5072598-430D-43E6-AA52-E0B716F765A9}" type="datetimeFigureOut">
+            <a:fld id="{4C7194E1-7AB7-4C19-9A54-266CF35DBFE8}" type="datetimeFigureOut">
               <a:rPr lang="de-DE" smtClean="0"/>
               <a:t>08.10.2026</a:t>
             </a:fld>
@@ -1412,7 +1412,7 @@
           <p:cNvPr id="6" name="Fußzeilenplatzhalter 5">
             <a:extLst>
               <a:ext uri="{FF2B5EF4-FFF2-40B4-BE49-F238E27FC236}">
-                <a16:creationId xmlns:a16="http://schemas.microsoft.com/office/drawing/2014/main" id="{1D9B9488-C810-C5C0-4B14-3466B7F1A5CC}"/>
+                <a16:creationId xmlns:a16="http://schemas.microsoft.com/office/drawing/2014/main" id="{E8B3AE04-8F35-836C-34A5-C313EFC83E5A}"/>
               </a:ext>
             </a:extLst>
           </p:cNvPr>
@@ -1437,7 +1437,7 @@
           <p:cNvPr id="7" name="Foliennummernplatzhalter 6">
             <a:extLst>
               <a:ext uri="{FF2B5EF4-FFF2-40B4-BE49-F238E27FC236}">
-                <a16:creationId xmlns:a16="http://schemas.microsoft.com/office/drawing/2014/main" id="{134E4137-8D31-4B6C-CB41-88F82FE53316}"/>
+                <a16:creationId xmlns:a16="http://schemas.microsoft.com/office/drawing/2014/main" id="{35132FB6-4631-3F6C-4A21-BDD7EACCF6CF}"/>
               </a:ext>
             </a:extLst>
           </p:cNvPr>
@@ -1453,7 +1453,7 @@
           <a:bodyPr/>
           <a:lstStyle/>
           <a:p>
-            <a:fld id="{EB35F42C-9DAD-4D41-9F5D-E9053B6E5F2F}" type="slidenum">
+            <a:fld id="{3F5CA287-20CA-4900-B098-91820305D6F1}" type="slidenum">
               <a:rPr lang="de-DE" smtClean="0"/>
               <a:t>‹Nr.›</a:t>
             </a:fld>
@@ -1464,7 +1464,7 @@
     </p:spTree>
     <p:extLst>
       <p:ext uri="{BB962C8B-B14F-4D97-AF65-F5344CB8AC3E}">
-        <p14:creationId xmlns:p14="http://schemas.microsoft.com/office/powerpoint/2010/main" val="1503416305"/>
+        <p14:creationId xmlns:p14="http://schemas.microsoft.com/office/powerpoint/2010/main" val="3709209841"/>
       </p:ext>
     </p:extLst>
   </p:cSld>
@@ -1496,7 +1496,7 @@
           <p:cNvPr id="2" name="Titel 1">
             <a:extLst>
               <a:ext uri="{FF2B5EF4-FFF2-40B4-BE49-F238E27FC236}">
-                <a16:creationId xmlns:a16="http://schemas.microsoft.com/office/drawing/2014/main" id="{0B827AC7-A126-83A2-6942-DC486D051DA3}"/>
+                <a16:creationId xmlns:a16="http://schemas.microsoft.com/office/drawing/2014/main" id="{23448C9D-B356-DEFD-5133-0D6C1EADB275}"/>
               </a:ext>
             </a:extLst>
           </p:cNvPr>
@@ -1529,7 +1529,7 @@
           <p:cNvPr id="3" name="Textplatzhalter 2">
             <a:extLst>
               <a:ext uri="{FF2B5EF4-FFF2-40B4-BE49-F238E27FC236}">
-                <a16:creationId xmlns:a16="http://schemas.microsoft.com/office/drawing/2014/main" id="{215B52BE-E790-B4A4-977C-EA50EB01FC3F}"/>
+                <a16:creationId xmlns:a16="http://schemas.microsoft.com/office/drawing/2014/main" id="{1306E3BF-F263-4A70-5366-867174FF5B9D}"/>
               </a:ext>
             </a:extLst>
           </p:cNvPr>
@@ -1600,7 +1600,7 @@
           <p:cNvPr id="4" name="Inhaltsplatzhalter 3">
             <a:extLst>
               <a:ext uri="{FF2B5EF4-FFF2-40B4-BE49-F238E27FC236}">
-                <a16:creationId xmlns:a16="http://schemas.microsoft.com/office/drawing/2014/main" id="{87AAA49C-6FB5-2CE3-1C2C-8C94DD69A44C}"/>
+                <a16:creationId xmlns:a16="http://schemas.microsoft.com/office/drawing/2014/main" id="{5FE20B62-2967-C117-D603-ADF109A5BFB0}"/>
               </a:ext>
             </a:extLst>
           </p:cNvPr>
@@ -1662,7 +1662,7 @@
           <p:cNvPr id="5" name="Textplatzhalter 4">
             <a:extLst>
               <a:ext uri="{FF2B5EF4-FFF2-40B4-BE49-F238E27FC236}">
-                <a16:creationId xmlns:a16="http://schemas.microsoft.com/office/drawing/2014/main" id="{330397E9-0874-F179-B19E-4611B48A1ADB}"/>
+                <a16:creationId xmlns:a16="http://schemas.microsoft.com/office/drawing/2014/main" id="{E4244A20-C60D-4B11-D588-1D7EFC05247D}"/>
               </a:ext>
             </a:extLst>
           </p:cNvPr>
@@ -1733,7 +1733,7 @@
           <p:cNvPr id="6" name="Inhaltsplatzhalter 5">
             <a:extLst>
               <a:ext uri="{FF2B5EF4-FFF2-40B4-BE49-F238E27FC236}">
-                <a16:creationId xmlns:a16="http://schemas.microsoft.com/office/drawing/2014/main" id="{DB643786-5E2F-9663-97CA-EE14A6724888}"/>
+                <a16:creationId xmlns:a16="http://schemas.microsoft.com/office/drawing/2014/main" id="{8143390E-8AF8-9ED9-A3DC-84A273BCF1F2}"/>
               </a:ext>
             </a:extLst>
           </p:cNvPr>
@@ -1795,7 +1795,7 @@
           <p:cNvPr id="7" name="Datumsplatzhalter 6">
             <a:extLst>
               <a:ext uri="{FF2B5EF4-FFF2-40B4-BE49-F238E27FC236}">
-                <a16:creationId xmlns:a16="http://schemas.microsoft.com/office/drawing/2014/main" id="{F8C36917-E6D0-22F8-F4F9-6AF7FD3AD7A4}"/>
+                <a16:creationId xmlns:a16="http://schemas.microsoft.com/office/drawing/2014/main" id="{F3019029-9CBF-8AFA-7B6E-75BA63B9D4AA}"/>
               </a:ext>
             </a:extLst>
           </p:cNvPr>
@@ -1811,7 +1811,7 @@
           <a:bodyPr/>
           <a:lstStyle/>
           <a:p>
-            <a:fld id="{F5072598-430D-43E6-AA52-E0B716F765A9}" type="datetimeFigureOut">
+            <a:fld id="{4C7194E1-7AB7-4C19-9A54-266CF35DBFE8}" type="datetimeFigureOut">
               <a:rPr lang="de-DE" smtClean="0"/>
               <a:t>08.10.2026</a:t>
             </a:fld>
@@ -1824,7 +1824,7 @@
           <p:cNvPr id="8" name="Fußzeilenplatzhalter 7">
             <a:extLst>
               <a:ext uri="{FF2B5EF4-FFF2-40B4-BE49-F238E27FC236}">
-                <a16:creationId xmlns:a16="http://schemas.microsoft.com/office/drawing/2014/main" id="{6C845D4D-BD28-44CE-0168-C71D8B3C60A1}"/>
+                <a16:creationId xmlns:a16="http://schemas.microsoft.com/office/drawing/2014/main" id="{4DC5B713-77E6-EA4A-5EB8-675429042654}"/>
               </a:ext>
             </a:extLst>
           </p:cNvPr>
@@ -1849,7 +1849,7 @@
           <p:cNvPr id="9" name="Foliennummernplatzhalter 8">
             <a:extLst>
               <a:ext uri="{FF2B5EF4-FFF2-40B4-BE49-F238E27FC236}">
-                <a16:creationId xmlns:a16="http://schemas.microsoft.com/office/drawing/2014/main" id="{5E5E94F7-F826-6C48-444A-4C3EA0539A89}"/>
+                <a16:creationId xmlns:a16="http://schemas.microsoft.com/office/drawing/2014/main" id="{BDA722E5-9343-4BB5-BD63-D853F02201BC}"/>
               </a:ext>
             </a:extLst>
           </p:cNvPr>
@@ -1865,7 +1865,7 @@
           <a:bodyPr/>
           <a:lstStyle/>
           <a:p>
-            <a:fld id="{EB35F42C-9DAD-4D41-9F5D-E9053B6E5F2F}" type="slidenum">
+            <a:fld id="{3F5CA287-20CA-4900-B098-91820305D6F1}" type="slidenum">
               <a:rPr lang="de-DE" smtClean="0"/>
               <a:t>‹Nr.›</a:t>
             </a:fld>
@@ -1876,7 +1876,7 @@
     </p:spTree>
     <p:extLst>
       <p:ext uri="{BB962C8B-B14F-4D97-AF65-F5344CB8AC3E}">
-        <p14:creationId xmlns:p14="http://schemas.microsoft.com/office/powerpoint/2010/main" val="3195820291"/>
+        <p14:creationId xmlns:p14="http://schemas.microsoft.com/office/powerpoint/2010/main" val="1377641394"/>
       </p:ext>
     </p:extLst>
   </p:cSld>
@@ -1908,7 +1908,7 @@
           <p:cNvPr id="2" name="Titel 1">
             <a:extLst>
               <a:ext uri="{FF2B5EF4-FFF2-40B4-BE49-F238E27FC236}">
-                <a16:creationId xmlns:a16="http://schemas.microsoft.com/office/drawing/2014/main" id="{50AFC8B6-7A3B-A951-C815-2B47BB313A11}"/>
+                <a16:creationId xmlns:a16="http://schemas.microsoft.com/office/drawing/2014/main" id="{E2D4B9F7-D593-D2A4-8D80-904722150FB7}"/>
               </a:ext>
             </a:extLst>
           </p:cNvPr>
@@ -1936,7 +1936,7 @@
           <p:cNvPr id="3" name="Datumsplatzhalter 2">
             <a:extLst>
               <a:ext uri="{FF2B5EF4-FFF2-40B4-BE49-F238E27FC236}">
-                <a16:creationId xmlns:a16="http://schemas.microsoft.com/office/drawing/2014/main" id="{39F274F7-4537-CE4A-EF8E-E4E528E901C4}"/>
+                <a16:creationId xmlns:a16="http://schemas.microsoft.com/office/drawing/2014/main" id="{C6D4F4E5-EDFC-56C5-4520-5D12D7DBA581}"/>
               </a:ext>
             </a:extLst>
           </p:cNvPr>
@@ -1952,7 +1952,7 @@
           <a:bodyPr/>
           <a:lstStyle/>
           <a:p>
-            <a:fld id="{F5072598-430D-43E6-AA52-E0B716F765A9}" type="datetimeFigureOut">
+            <a:fld id="{4C7194E1-7AB7-4C19-9A54-266CF35DBFE8}" type="datetimeFigureOut">
               <a:rPr lang="de-DE" smtClean="0"/>
               <a:t>08.10.2026</a:t>
             </a:fld>
@@ -1965,7 +1965,7 @@
           <p:cNvPr id="4" name="Fußzeilenplatzhalter 3">
             <a:extLst>
               <a:ext uri="{FF2B5EF4-FFF2-40B4-BE49-F238E27FC236}">
-                <a16:creationId xmlns:a16="http://schemas.microsoft.com/office/drawing/2014/main" id="{6C1B7DAC-8073-1771-7531-E1B8506CBED7}"/>
+                <a16:creationId xmlns:a16="http://schemas.microsoft.com/office/drawing/2014/main" id="{EC6D54C4-81AD-55E2-54E0-F7A3A3D71CC0}"/>
               </a:ext>
             </a:extLst>
           </p:cNvPr>
@@ -1990,7 +1990,7 @@
           <p:cNvPr id="5" name="Foliennummernplatzhalter 4">
             <a:extLst>
               <a:ext uri="{FF2B5EF4-FFF2-40B4-BE49-F238E27FC236}">
-                <a16:creationId xmlns:a16="http://schemas.microsoft.com/office/drawing/2014/main" id="{60A6D5D2-9970-EBD1-FA50-FE6495AA5585}"/>
+                <a16:creationId xmlns:a16="http://schemas.microsoft.com/office/drawing/2014/main" id="{EA089E82-E86D-CB27-5B48-D704A87225B8}"/>
               </a:ext>
             </a:extLst>
           </p:cNvPr>
@@ -2006,7 +2006,7 @@
           <a:bodyPr/>
           <a:lstStyle/>
           <a:p>
-            <a:fld id="{EB35F42C-9DAD-4D41-9F5D-E9053B6E5F2F}" type="slidenum">
+            <a:fld id="{3F5CA287-20CA-4900-B098-91820305D6F1}" type="slidenum">
               <a:rPr lang="de-DE" smtClean="0"/>
               <a:t>‹Nr.›</a:t>
             </a:fld>
@@ -2017,7 +2017,7 @@
     </p:spTree>
     <p:extLst>
       <p:ext uri="{BB962C8B-B14F-4D97-AF65-F5344CB8AC3E}">
-        <p14:creationId xmlns:p14="http://schemas.microsoft.com/office/powerpoint/2010/main" val="1637842565"/>
+        <p14:creationId xmlns:p14="http://schemas.microsoft.com/office/powerpoint/2010/main" val="2151551906"/>
       </p:ext>
     </p:extLst>
   </p:cSld>
@@ -2049,7 +2049,7 @@
           <p:cNvPr id="2" name="Datumsplatzhalter 1">
             <a:extLst>
               <a:ext uri="{FF2B5EF4-FFF2-40B4-BE49-F238E27FC236}">
-                <a16:creationId xmlns:a16="http://schemas.microsoft.com/office/drawing/2014/main" id="{551FBADE-BCE5-6AEF-FF9B-60E8A302A8CE}"/>
+                <a16:creationId xmlns:a16="http://schemas.microsoft.com/office/drawing/2014/main" id="{7588B3F3-3DD7-91D1-D2F6-986A52646E90}"/>
               </a:ext>
             </a:extLst>
           </p:cNvPr>
@@ -2065,7 +2065,7 @@
           <a:bodyPr/>
           <a:lstStyle/>
           <a:p>
-            <a:fld id="{F5072598-430D-43E6-AA52-E0B716F765A9}" type="datetimeFigureOut">
+            <a:fld id="{4C7194E1-7AB7-4C19-9A54-266CF35DBFE8}" type="datetimeFigureOut">
               <a:rPr lang="de-DE" smtClean="0"/>
               <a:t>08.10.2026</a:t>
             </a:fld>
@@ -2078,7 +2078,7 @@
           <p:cNvPr id="3" name="Fußzeilenplatzhalter 2">
             <a:extLst>
               <a:ext uri="{FF2B5EF4-FFF2-40B4-BE49-F238E27FC236}">
-                <a16:creationId xmlns:a16="http://schemas.microsoft.com/office/drawing/2014/main" id="{76B3BF7C-68BD-2325-AF1E-801F9ABEB94D}"/>
+                <a16:creationId xmlns:a16="http://schemas.microsoft.com/office/drawing/2014/main" id="{14825694-2935-D4B1-A058-E909CA0D17CE}"/>
               </a:ext>
             </a:extLst>
           </p:cNvPr>
@@ -2103,7 +2103,7 @@
           <p:cNvPr id="4" name="Foliennummernplatzhalter 3">
             <a:extLst>
               <a:ext uri="{FF2B5EF4-FFF2-40B4-BE49-F238E27FC236}">
-                <a16:creationId xmlns:a16="http://schemas.microsoft.com/office/drawing/2014/main" id="{96AF1BD5-B538-525D-D530-50E054D29955}"/>
+                <a16:creationId xmlns:a16="http://schemas.microsoft.com/office/drawing/2014/main" id="{C7BDB84E-0880-137E-3203-DD2CDD4DA66B}"/>
               </a:ext>
             </a:extLst>
           </p:cNvPr>
@@ -2119,7 +2119,7 @@
           <a:bodyPr/>
           <a:lstStyle/>
           <a:p>
-            <a:fld id="{EB35F42C-9DAD-4D41-9F5D-E9053B6E5F2F}" type="slidenum">
+            <a:fld id="{3F5CA287-20CA-4900-B098-91820305D6F1}" type="slidenum">
               <a:rPr lang="de-DE" smtClean="0"/>
               <a:t>‹Nr.›</a:t>
             </a:fld>
@@ -2130,7 +2130,7 @@
     </p:spTree>
     <p:extLst>
       <p:ext uri="{BB962C8B-B14F-4D97-AF65-F5344CB8AC3E}">
-        <p14:creationId xmlns:p14="http://schemas.microsoft.com/office/powerpoint/2010/main" val="4083061739"/>
+        <p14:creationId xmlns:p14="http://schemas.microsoft.com/office/powerpoint/2010/main" val="117301101"/>
       </p:ext>
     </p:extLst>
   </p:cSld>
@@ -2162,7 +2162,7 @@
           <p:cNvPr id="2" name="Titel 1">
             <a:extLst>
               <a:ext uri="{FF2B5EF4-FFF2-40B4-BE49-F238E27FC236}">
-                <a16:creationId xmlns:a16="http://schemas.microsoft.com/office/drawing/2014/main" id="{1E41079A-D16A-A04F-C858-AC3B96C9735E}"/>
+                <a16:creationId xmlns:a16="http://schemas.microsoft.com/office/drawing/2014/main" id="{DB5250B2-63E9-6D3C-AAB1-0E0B797D6980}"/>
               </a:ext>
             </a:extLst>
           </p:cNvPr>
@@ -2199,7 +2199,7 @@
           <p:cNvPr id="3" name="Inhaltsplatzhalter 2">
             <a:extLst>
               <a:ext uri="{FF2B5EF4-FFF2-40B4-BE49-F238E27FC236}">
-                <a16:creationId xmlns:a16="http://schemas.microsoft.com/office/drawing/2014/main" id="{06074ABE-1208-9C11-E6EA-12A86BCF3EF4}"/>
+                <a16:creationId xmlns:a16="http://schemas.microsoft.com/office/drawing/2014/main" id="{286CA438-D308-2054-8BDB-418017F1AD9D}"/>
               </a:ext>
             </a:extLst>
           </p:cNvPr>
@@ -2289,7 +2289,7 @@
           <p:cNvPr id="4" name="Textplatzhalter 3">
             <a:extLst>
               <a:ext uri="{FF2B5EF4-FFF2-40B4-BE49-F238E27FC236}">
-                <a16:creationId xmlns:a16="http://schemas.microsoft.com/office/drawing/2014/main" id="{880181EF-8731-8B43-08CF-A8D35E214A3B}"/>
+                <a16:creationId xmlns:a16="http://schemas.microsoft.com/office/drawing/2014/main" id="{43EB7E59-D303-4087-13D4-FA60DC70685B}"/>
               </a:ext>
             </a:extLst>
           </p:cNvPr>
@@ -2360,7 +2360,7 @@
           <p:cNvPr id="5" name="Datumsplatzhalter 4">
             <a:extLst>
               <a:ext uri="{FF2B5EF4-FFF2-40B4-BE49-F238E27FC236}">
-                <a16:creationId xmlns:a16="http://schemas.microsoft.com/office/drawing/2014/main" id="{41B9C2FD-64D3-C15D-6788-B660C58C31AB}"/>
+                <a16:creationId xmlns:a16="http://schemas.microsoft.com/office/drawing/2014/main" id="{F881A944-B2F2-D039-07F8-48FEECA56AD1}"/>
               </a:ext>
             </a:extLst>
           </p:cNvPr>
@@ -2376,7 +2376,7 @@
           <a:bodyPr/>
           <a:lstStyle/>
           <a:p>
-            <a:fld id="{F5072598-430D-43E6-AA52-E0B716F765A9}" type="datetimeFigureOut">
+            <a:fld id="{4C7194E1-7AB7-4C19-9A54-266CF35DBFE8}" type="datetimeFigureOut">
               <a:rPr lang="de-DE" smtClean="0"/>
               <a:t>08.10.2026</a:t>
             </a:fld>
@@ -2389,7 +2389,7 @@
           <p:cNvPr id="6" name="Fußzeilenplatzhalter 5">
             <a:extLst>
               <a:ext uri="{FF2B5EF4-FFF2-40B4-BE49-F238E27FC236}">
-                <a16:creationId xmlns:a16="http://schemas.microsoft.com/office/drawing/2014/main" id="{DB351D56-416F-AF47-C9AD-D7E255262ABA}"/>
+                <a16:creationId xmlns:a16="http://schemas.microsoft.com/office/drawing/2014/main" id="{B6214B85-A1DD-35BF-607F-019A45BE7D7A}"/>
               </a:ext>
             </a:extLst>
           </p:cNvPr>
@@ -2414,7 +2414,7 @@
           <p:cNvPr id="7" name="Foliennummernplatzhalter 6">
             <a:extLst>
               <a:ext uri="{FF2B5EF4-FFF2-40B4-BE49-F238E27FC236}">
-                <a16:creationId xmlns:a16="http://schemas.microsoft.com/office/drawing/2014/main" id="{7F0C1B8F-D9C9-AEC8-82FB-4935C524C4FF}"/>
+                <a16:creationId xmlns:a16="http://schemas.microsoft.com/office/drawing/2014/main" id="{4321588B-AB77-7BDA-5D63-F57390D12210}"/>
               </a:ext>
             </a:extLst>
           </p:cNvPr>
@@ -2430,7 +2430,7 @@
           <a:bodyPr/>
           <a:lstStyle/>
           <a:p>
-            <a:fld id="{EB35F42C-9DAD-4D41-9F5D-E9053B6E5F2F}" type="slidenum">
+            <a:fld id="{3F5CA287-20CA-4900-B098-91820305D6F1}" type="slidenum">
               <a:rPr lang="de-DE" smtClean="0"/>
               <a:t>‹Nr.›</a:t>
             </a:fld>
@@ -2441,7 +2441,7 @@
     </p:spTree>
     <p:extLst>
       <p:ext uri="{BB962C8B-B14F-4D97-AF65-F5344CB8AC3E}">
-        <p14:creationId xmlns:p14="http://schemas.microsoft.com/office/powerpoint/2010/main" val="3889121641"/>
+        <p14:creationId xmlns:p14="http://schemas.microsoft.com/office/powerpoint/2010/main" val="1478921003"/>
       </p:ext>
     </p:extLst>
   </p:cSld>
@@ -2473,7 +2473,7 @@
           <p:cNvPr id="2" name="Titel 1">
             <a:extLst>
               <a:ext uri="{FF2B5EF4-FFF2-40B4-BE49-F238E27FC236}">
-                <a16:creationId xmlns:a16="http://schemas.microsoft.com/office/drawing/2014/main" id="{0B8E6AF2-3E2A-759E-EDD6-89AA79021F3A}"/>
+                <a16:creationId xmlns:a16="http://schemas.microsoft.com/office/drawing/2014/main" id="{B07376AC-F71E-7450-0C91-5866CDA6815C}"/>
               </a:ext>
             </a:extLst>
           </p:cNvPr>
@@ -2510,7 +2510,7 @@
           <p:cNvPr id="3" name="Bildplatzhalter 2">
             <a:extLst>
               <a:ext uri="{FF2B5EF4-FFF2-40B4-BE49-F238E27FC236}">
-                <a16:creationId xmlns:a16="http://schemas.microsoft.com/office/drawing/2014/main" id="{83EC6B1E-F7BF-9379-888F-0E434B70DC7C}"/>
+                <a16:creationId xmlns:a16="http://schemas.microsoft.com/office/drawing/2014/main" id="{B23E7106-85D4-C19C-CC5C-E269B354906A}"/>
               </a:ext>
             </a:extLst>
           </p:cNvPr>
@@ -2577,7 +2577,7 @@
           <p:cNvPr id="4" name="Textplatzhalter 3">
             <a:extLst>
               <a:ext uri="{FF2B5EF4-FFF2-40B4-BE49-F238E27FC236}">
-                <a16:creationId xmlns:a16="http://schemas.microsoft.com/office/drawing/2014/main" id="{C420D423-EA40-6AA0-8940-F203CBE0AFAC}"/>
+                <a16:creationId xmlns:a16="http://schemas.microsoft.com/office/drawing/2014/main" id="{C03F093B-9B76-167E-571B-C0B352B77D00}"/>
               </a:ext>
             </a:extLst>
           </p:cNvPr>
@@ -2648,7 +2648,7 @@
           <p:cNvPr id="5" name="Datumsplatzhalter 4">
             <a:extLst>
               <a:ext uri="{FF2B5EF4-FFF2-40B4-BE49-F238E27FC236}">
-                <a16:creationId xmlns:a16="http://schemas.microsoft.com/office/drawing/2014/main" id="{B6DAB1D0-9861-6216-5FDC-5C3096D4D710}"/>
+                <a16:creationId xmlns:a16="http://schemas.microsoft.com/office/drawing/2014/main" id="{3B510934-46D6-F719-BE9C-24E88B50F5EE}"/>
               </a:ext>
             </a:extLst>
           </p:cNvPr>
@@ -2664,7 +2664,7 @@
           <a:bodyPr/>
           <a:lstStyle/>
           <a:p>
-            <a:fld id="{F5072598-430D-43E6-AA52-E0B716F765A9}" type="datetimeFigureOut">
+            <a:fld id="{4C7194E1-7AB7-4C19-9A54-266CF35DBFE8}" type="datetimeFigureOut">
               <a:rPr lang="de-DE" smtClean="0"/>
               <a:t>08.10.2026</a:t>
             </a:fld>
@@ -2677,7 +2677,7 @@
           <p:cNvPr id="6" name="Fußzeilenplatzhalter 5">
             <a:extLst>
               <a:ext uri="{FF2B5EF4-FFF2-40B4-BE49-F238E27FC236}">
-                <a16:creationId xmlns:a16="http://schemas.microsoft.com/office/drawing/2014/main" id="{68201A82-74D1-2F95-7B81-700234818CAA}"/>
+                <a16:creationId xmlns:a16="http://schemas.microsoft.com/office/drawing/2014/main" id="{7D2E9DD9-99CD-D5C7-1AE9-C8C7481EA48F}"/>
               </a:ext>
             </a:extLst>
           </p:cNvPr>
@@ -2702,7 +2702,7 @@
           <p:cNvPr id="7" name="Foliennummernplatzhalter 6">
             <a:extLst>
               <a:ext uri="{FF2B5EF4-FFF2-40B4-BE49-F238E27FC236}">
-                <a16:creationId xmlns:a16="http://schemas.microsoft.com/office/drawing/2014/main" id="{ACF2F4C8-CA1F-E13D-FE25-4D3D561038C2}"/>
+                <a16:creationId xmlns:a16="http://schemas.microsoft.com/office/drawing/2014/main" id="{3BAFCF1E-7892-3153-A89A-59BE395B4847}"/>
               </a:ext>
             </a:extLst>
           </p:cNvPr>
@@ -2718,7 +2718,7 @@
           <a:bodyPr/>
           <a:lstStyle/>
           <a:p>
-            <a:fld id="{EB35F42C-9DAD-4D41-9F5D-E9053B6E5F2F}" type="slidenum">
+            <a:fld id="{3F5CA287-20CA-4900-B098-91820305D6F1}" type="slidenum">
               <a:rPr lang="de-DE" smtClean="0"/>
               <a:t>‹Nr.›</a:t>
             </a:fld>
@@ -2729,7 +2729,7 @@
     </p:spTree>
     <p:extLst>
       <p:ext uri="{BB962C8B-B14F-4D97-AF65-F5344CB8AC3E}">
-        <p14:creationId xmlns:p14="http://schemas.microsoft.com/office/powerpoint/2010/main" val="1228771686"/>
+        <p14:creationId xmlns:p14="http://schemas.microsoft.com/office/powerpoint/2010/main" val="1485586642"/>
       </p:ext>
     </p:extLst>
   </p:cSld>
@@ -2766,7 +2766,7 @@
           <p:cNvPr id="2" name="Titelplatzhalter 1">
             <a:extLst>
               <a:ext uri="{FF2B5EF4-FFF2-40B4-BE49-F238E27FC236}">
-                <a16:creationId xmlns:a16="http://schemas.microsoft.com/office/drawing/2014/main" id="{48AF7574-F46A-19AC-BE96-209B888A0BBE}"/>
+                <a16:creationId xmlns:a16="http://schemas.microsoft.com/office/drawing/2014/main" id="{8A9D3CE0-41A1-AAC8-2DFD-428C5FD72D80}"/>
               </a:ext>
             </a:extLst>
           </p:cNvPr>
@@ -2804,7 +2804,7 @@
           <p:cNvPr id="3" name="Textplatzhalter 2">
             <a:extLst>
               <a:ext uri="{FF2B5EF4-FFF2-40B4-BE49-F238E27FC236}">
-                <a16:creationId xmlns:a16="http://schemas.microsoft.com/office/drawing/2014/main" id="{7BC986A7-9FB5-8DA3-6ADE-FBC3CD3A5F28}"/>
+                <a16:creationId xmlns:a16="http://schemas.microsoft.com/office/drawing/2014/main" id="{658014A1-2E03-B14E-C29F-D9D8C2C270E4}"/>
               </a:ext>
             </a:extLst>
           </p:cNvPr>
@@ -2871,7 +2871,7 @@
           <p:cNvPr id="4" name="Datumsplatzhalter 3">
             <a:extLst>
               <a:ext uri="{FF2B5EF4-FFF2-40B4-BE49-F238E27FC236}">
-                <a16:creationId xmlns:a16="http://schemas.microsoft.com/office/drawing/2014/main" id="{4F465A70-7247-9B3A-C0A8-0E4576E38596}"/>
+                <a16:creationId xmlns:a16="http://schemas.microsoft.com/office/drawing/2014/main" id="{41F3F565-9B4B-960E-6683-EEECF87A2961}"/>
               </a:ext>
             </a:extLst>
           </p:cNvPr>
@@ -2905,7 +2905,7 @@
             </a:lvl1pPr>
           </a:lstStyle>
           <a:p>
-            <a:fld id="{F5072598-430D-43E6-AA52-E0B716F765A9}" type="datetimeFigureOut">
+            <a:fld id="{4C7194E1-7AB7-4C19-9A54-266CF35DBFE8}" type="datetimeFigureOut">
               <a:rPr lang="de-DE" smtClean="0"/>
               <a:t>08.10.2026</a:t>
             </a:fld>
@@ -2918,7 +2918,7 @@
           <p:cNvPr id="5" name="Fußzeilenplatzhalter 4">
             <a:extLst>
               <a:ext uri="{FF2B5EF4-FFF2-40B4-BE49-F238E27FC236}">
-                <a16:creationId xmlns:a16="http://schemas.microsoft.com/office/drawing/2014/main" id="{2BC66E4C-A908-CE7C-5DE3-452F308276C5}"/>
+                <a16:creationId xmlns:a16="http://schemas.microsoft.com/office/drawing/2014/main" id="{C8995E8F-B409-8A80-5B3E-41F1997EBEEA}"/>
               </a:ext>
             </a:extLst>
           </p:cNvPr>
@@ -2961,7 +2961,7 @@
           <p:cNvPr id="6" name="Foliennummernplatzhalter 5">
             <a:extLst>
               <a:ext uri="{FF2B5EF4-FFF2-40B4-BE49-F238E27FC236}">
-                <a16:creationId xmlns:a16="http://schemas.microsoft.com/office/drawing/2014/main" id="{DE5843DB-4FAD-ACFD-C4C8-265AC2FD9EB9}"/>
+                <a16:creationId xmlns:a16="http://schemas.microsoft.com/office/drawing/2014/main" id="{3028A04F-EF09-6982-8287-1A4B22FF74D1}"/>
               </a:ext>
             </a:extLst>
           </p:cNvPr>
@@ -2995,7 +2995,7 @@
             </a:lvl1pPr>
           </a:lstStyle>
           <a:p>
-            <a:fld id="{EB35F42C-9DAD-4D41-9F5D-E9053B6E5F2F}" type="slidenum">
+            <a:fld id="{3F5CA287-20CA-4900-B098-91820305D6F1}" type="slidenum">
               <a:rPr lang="de-DE" smtClean="0"/>
               <a:t>‹Nr.›</a:t>
             </a:fld>
@@ -3006,7 +3006,7 @@
     </p:spTree>
     <p:extLst>
       <p:ext uri="{BB962C8B-B14F-4D97-AF65-F5344CB8AC3E}">
-        <p14:creationId xmlns:p14="http://schemas.microsoft.com/office/powerpoint/2010/main" val="3780293227"/>
+        <p14:creationId xmlns:p14="http://schemas.microsoft.com/office/powerpoint/2010/main" val="313370484"/>
       </p:ext>
     </p:extLst>
   </p:cSld>
@@ -3329,7 +3329,7 @@
           <p:cNvPr id="2" name="Rechteck 1">
             <a:extLst>
               <a:ext uri="{FF2B5EF4-FFF2-40B4-BE49-F238E27FC236}">
-                <a16:creationId xmlns:a16="http://schemas.microsoft.com/office/drawing/2014/main" id="{69912014-C66A-E42D-6FE2-5E248A8047EA}"/>
+                <a16:creationId xmlns:a16="http://schemas.microsoft.com/office/drawing/2014/main" id="{5A6374CB-B874-C460-080E-93964B6A84C8}"/>
               </a:ext>
             </a:extLst>
           </p:cNvPr>
@@ -3397,7 +3397,7 @@
           <p:cNvPr id="3" name="Rechteck 2">
             <a:extLst>
               <a:ext uri="{FF2B5EF4-FFF2-40B4-BE49-F238E27FC236}">
-                <a16:creationId xmlns:a16="http://schemas.microsoft.com/office/drawing/2014/main" id="{F5F4E805-9DB8-767B-71CB-719452240A71}"/>
+                <a16:creationId xmlns:a16="http://schemas.microsoft.com/office/drawing/2014/main" id="{EE2AD4AF-7DB0-7E43-4749-5172F4F0C9B5}"/>
               </a:ext>
             </a:extLst>
           </p:cNvPr>
@@ -3467,7 +3467,7 @@
           <p:cNvPr id="4" name="Rechteck 3">
             <a:extLst>
               <a:ext uri="{FF2B5EF4-FFF2-40B4-BE49-F238E27FC236}">
-                <a16:creationId xmlns:a16="http://schemas.microsoft.com/office/drawing/2014/main" id="{8751AC45-0BB3-9D4F-2269-83EAE07DA2C7}"/>
+                <a16:creationId xmlns:a16="http://schemas.microsoft.com/office/drawing/2014/main" id="{C158243E-6EDC-6780-4F88-05C26CB631FA}"/>
               </a:ext>
             </a:extLst>
           </p:cNvPr>
@@ -3537,7 +3537,7 @@
           <p:cNvPr id="5" name="Rechteck 4">
             <a:extLst>
               <a:ext uri="{FF2B5EF4-FFF2-40B4-BE49-F238E27FC236}">
-                <a16:creationId xmlns:a16="http://schemas.microsoft.com/office/drawing/2014/main" id="{F4C51BED-AD1A-7D57-7A23-64FC68C421CA}"/>
+                <a16:creationId xmlns:a16="http://schemas.microsoft.com/office/drawing/2014/main" id="{3A87D0EB-CB4B-0D7D-7012-CAAA2B59FF0E}"/>
               </a:ext>
             </a:extLst>
           </p:cNvPr>
@@ -3605,7 +3605,7 @@
           <p:cNvPr id="6" name="Rechteck 5">
             <a:extLst>
               <a:ext uri="{FF2B5EF4-FFF2-40B4-BE49-F238E27FC236}">
-                <a16:creationId xmlns:a16="http://schemas.microsoft.com/office/drawing/2014/main" id="{CE34F84C-EEDE-5DF4-7E1F-06128D5F30D0}"/>
+                <a16:creationId xmlns:a16="http://schemas.microsoft.com/office/drawing/2014/main" id="{F950A7EC-D584-18FF-8463-29618EF41ABC}"/>
               </a:ext>
             </a:extLst>
           </p:cNvPr>
@@ -3675,7 +3675,7 @@
           <p:cNvPr id="7" name="Rechteck 6">
             <a:extLst>
               <a:ext uri="{FF2B5EF4-FFF2-40B4-BE49-F238E27FC236}">
-                <a16:creationId xmlns:a16="http://schemas.microsoft.com/office/drawing/2014/main" id="{194C8ABD-0374-C66E-8102-A48EA217F629}"/>
+                <a16:creationId xmlns:a16="http://schemas.microsoft.com/office/drawing/2014/main" id="{19463504-17D4-8C85-9848-EC9115ACABF6}"/>
               </a:ext>
             </a:extLst>
           </p:cNvPr>
@@ -3745,7 +3745,7 @@
           <p:cNvPr id="8" name="Rechteck 7">
             <a:extLst>
               <a:ext uri="{FF2B5EF4-FFF2-40B4-BE49-F238E27FC236}">
-                <a16:creationId xmlns:a16="http://schemas.microsoft.com/office/drawing/2014/main" id="{E1B3D4DF-1909-C016-B355-1CDF9960F7D1}"/>
+                <a16:creationId xmlns:a16="http://schemas.microsoft.com/office/drawing/2014/main" id="{B49EE488-BCCD-E143-8B5E-4D1B187BDCC2}"/>
               </a:ext>
             </a:extLst>
           </p:cNvPr>
@@ -3813,7 +3813,7 @@
           <p:cNvPr id="9" name="Rechteck 8">
             <a:extLst>
               <a:ext uri="{FF2B5EF4-FFF2-40B4-BE49-F238E27FC236}">
-                <a16:creationId xmlns:a16="http://schemas.microsoft.com/office/drawing/2014/main" id="{89EE277D-51EE-237F-2039-3B74FFDF0536}"/>
+                <a16:creationId xmlns:a16="http://schemas.microsoft.com/office/drawing/2014/main" id="{A7499CDF-6BF9-E5E5-C654-A395034FCE1B}"/>
               </a:ext>
             </a:extLst>
           </p:cNvPr>
@@ -3883,7 +3883,7 @@
           <p:cNvPr id="10" name="Rechteck 9">
             <a:extLst>
               <a:ext uri="{FF2B5EF4-FFF2-40B4-BE49-F238E27FC236}">
-                <a16:creationId xmlns:a16="http://schemas.microsoft.com/office/drawing/2014/main" id="{CC40CDCC-C55D-037D-B1DC-CE9C7F8D75CE}"/>
+                <a16:creationId xmlns:a16="http://schemas.microsoft.com/office/drawing/2014/main" id="{C15AF360-BEE9-7769-415C-CF3ADDAF8FF6}"/>
               </a:ext>
             </a:extLst>
           </p:cNvPr>
@@ -3953,7 +3953,7 @@
           <p:cNvPr id="11" name="Rechteck 10">
             <a:extLst>
               <a:ext uri="{FF2B5EF4-FFF2-40B4-BE49-F238E27FC236}">
-                <a16:creationId xmlns:a16="http://schemas.microsoft.com/office/drawing/2014/main" id="{B6CD41A6-9D60-DE3D-727E-0B216D8C3DD2}"/>
+                <a16:creationId xmlns:a16="http://schemas.microsoft.com/office/drawing/2014/main" id="{08B82BB4-1B8E-3485-74C5-05AD3455CEE8}"/>
               </a:ext>
             </a:extLst>
           </p:cNvPr>
@@ -4021,7 +4021,7 @@
           <p:cNvPr id="12" name="Rechteck 11">
             <a:extLst>
               <a:ext uri="{FF2B5EF4-FFF2-40B4-BE49-F238E27FC236}">
-                <a16:creationId xmlns:a16="http://schemas.microsoft.com/office/drawing/2014/main" id="{67F493F8-51A4-B164-B967-410080B87AEE}"/>
+                <a16:creationId xmlns:a16="http://schemas.microsoft.com/office/drawing/2014/main" id="{B05F71BA-F12C-F7DB-7060-722C6604195F}"/>
               </a:ext>
             </a:extLst>
           </p:cNvPr>
@@ -4091,7 +4091,7 @@
           <p:cNvPr id="13" name="Rechteck 12">
             <a:extLst>
               <a:ext uri="{FF2B5EF4-FFF2-40B4-BE49-F238E27FC236}">
-                <a16:creationId xmlns:a16="http://schemas.microsoft.com/office/drawing/2014/main" id="{71E12F1F-1A6B-5122-0E32-369CAAAEAD9F}"/>
+                <a16:creationId xmlns:a16="http://schemas.microsoft.com/office/drawing/2014/main" id="{A3FEF94F-09EA-73E9-C9A9-836E101573B3}"/>
               </a:ext>
             </a:extLst>
           </p:cNvPr>
@@ -4161,7 +4161,7 @@
           <p:cNvPr id="14" name="Rechteck 13">
             <a:extLst>
               <a:ext uri="{FF2B5EF4-FFF2-40B4-BE49-F238E27FC236}">
-                <a16:creationId xmlns:a16="http://schemas.microsoft.com/office/drawing/2014/main" id="{56C01E74-2A34-7ABA-7316-E16C19497EB6}"/>
+                <a16:creationId xmlns:a16="http://schemas.microsoft.com/office/drawing/2014/main" id="{C6C49BF5-22D8-C3C4-0F38-8EACA4131039}"/>
               </a:ext>
             </a:extLst>
           </p:cNvPr>
@@ -4229,7 +4229,7 @@
           <p:cNvPr id="15" name="Rechteck 14">
             <a:extLst>
               <a:ext uri="{FF2B5EF4-FFF2-40B4-BE49-F238E27FC236}">
-                <a16:creationId xmlns:a16="http://schemas.microsoft.com/office/drawing/2014/main" id="{1739CE3A-4F92-1EBE-A2E4-F9A870D785E6}"/>
+                <a16:creationId xmlns:a16="http://schemas.microsoft.com/office/drawing/2014/main" id="{817872A3-8A5D-7631-9125-B2B7735EF9BA}"/>
               </a:ext>
             </a:extLst>
           </p:cNvPr>
@@ -4299,7 +4299,7 @@
           <p:cNvPr id="16" name="Rechteck 15">
             <a:extLst>
               <a:ext uri="{FF2B5EF4-FFF2-40B4-BE49-F238E27FC236}">
-                <a16:creationId xmlns:a16="http://schemas.microsoft.com/office/drawing/2014/main" id="{8F3D64DF-7EF2-1391-40D2-F8EC6197BB4B}"/>
+                <a16:creationId xmlns:a16="http://schemas.microsoft.com/office/drawing/2014/main" id="{4EBD3402-0505-AB66-CFE5-33CCA5502169}"/>
               </a:ext>
             </a:extLst>
           </p:cNvPr>
@@ -4369,7 +4369,7 @@
           <p:cNvPr id="17" name="Rechteck 16">
             <a:extLst>
               <a:ext uri="{FF2B5EF4-FFF2-40B4-BE49-F238E27FC236}">
-                <a16:creationId xmlns:a16="http://schemas.microsoft.com/office/drawing/2014/main" id="{34D639AC-3D0C-1CD4-42D3-A15777AB749C}"/>
+                <a16:creationId xmlns:a16="http://schemas.microsoft.com/office/drawing/2014/main" id="{88EC17CF-106D-FD60-548E-42CD006E2CF7}"/>
               </a:ext>
             </a:extLst>
           </p:cNvPr>
@@ -4437,7 +4437,7 @@
           <p:cNvPr id="18" name="Rechteck 17">
             <a:extLst>
               <a:ext uri="{FF2B5EF4-FFF2-40B4-BE49-F238E27FC236}">
-                <a16:creationId xmlns:a16="http://schemas.microsoft.com/office/drawing/2014/main" id="{DA06C3CA-7926-28DB-8C0B-51F4165238FA}"/>
+                <a16:creationId xmlns:a16="http://schemas.microsoft.com/office/drawing/2014/main" id="{EC780F75-5AA9-531D-AC61-0951E3BB4485}"/>
               </a:ext>
             </a:extLst>
           </p:cNvPr>
@@ -4507,7 +4507,7 @@
           <p:cNvPr id="19" name="Rechteck 18">
             <a:extLst>
               <a:ext uri="{FF2B5EF4-FFF2-40B4-BE49-F238E27FC236}">
-                <a16:creationId xmlns:a16="http://schemas.microsoft.com/office/drawing/2014/main" id="{D84E0660-AF9C-8A96-0A5A-F1B7BD9FC482}"/>
+                <a16:creationId xmlns:a16="http://schemas.microsoft.com/office/drawing/2014/main" id="{B9A2EE3A-293C-12AE-27EF-C68553683751}"/>
               </a:ext>
             </a:extLst>
           </p:cNvPr>
@@ -4575,7 +4575,7 @@
     </p:spTree>
     <p:extLst>
       <p:ext uri="{BB962C8B-B14F-4D97-AF65-F5344CB8AC3E}">
-        <p14:creationId xmlns:p14="http://schemas.microsoft.com/office/powerpoint/2010/main" val="3097456307"/>
+        <p14:creationId xmlns:p14="http://schemas.microsoft.com/office/powerpoint/2010/main" val="692897751"/>
       </p:ext>
     </p:extLst>
   </p:cSld>
@@ -4607,7 +4607,7 @@
           <p:cNvPr id="2" name="Rechteck 1">
             <a:extLst>
               <a:ext uri="{FF2B5EF4-FFF2-40B4-BE49-F238E27FC236}">
-                <a16:creationId xmlns:a16="http://schemas.microsoft.com/office/drawing/2014/main" id="{3D7541C8-A703-16F4-0D15-3B6FA4419D1D}"/>
+                <a16:creationId xmlns:a16="http://schemas.microsoft.com/office/drawing/2014/main" id="{72BB98C7-09E6-CEC6-5CD3-E425B40F23AF}"/>
               </a:ext>
             </a:extLst>
           </p:cNvPr>
@@ -4678,7 +4678,7 @@
           <p:cNvPr id="3" name="Rechteck 2">
             <a:extLst>
               <a:ext uri="{FF2B5EF4-FFF2-40B4-BE49-F238E27FC236}">
-                <a16:creationId xmlns:a16="http://schemas.microsoft.com/office/drawing/2014/main" id="{6DE68054-B756-17E3-5361-F1DF4B6FCD87}"/>
+                <a16:creationId xmlns:a16="http://schemas.microsoft.com/office/drawing/2014/main" id="{F3116453-E5CD-6A19-1637-280AC20090AF}"/>
               </a:ext>
             </a:extLst>
           </p:cNvPr>
@@ -4749,7 +4749,7 @@
           <p:cNvPr id="4" name="Rechteck 3">
             <a:extLst>
               <a:ext uri="{FF2B5EF4-FFF2-40B4-BE49-F238E27FC236}">
-                <a16:creationId xmlns:a16="http://schemas.microsoft.com/office/drawing/2014/main" id="{C45564DC-C769-2299-D5A1-44BFE03EFA77}"/>
+                <a16:creationId xmlns:a16="http://schemas.microsoft.com/office/drawing/2014/main" id="{51901BE3-5FED-4B2D-4489-AD5766BD50EC}"/>
               </a:ext>
             </a:extLst>
           </p:cNvPr>
@@ -4820,7 +4820,7 @@
           <p:cNvPr id="5" name="Rechteck 4">
             <a:extLst>
               <a:ext uri="{FF2B5EF4-FFF2-40B4-BE49-F238E27FC236}">
-                <a16:creationId xmlns:a16="http://schemas.microsoft.com/office/drawing/2014/main" id="{DD95BCB3-908C-99D7-8913-70D190BB37D6}"/>
+                <a16:creationId xmlns:a16="http://schemas.microsoft.com/office/drawing/2014/main" id="{495255B3-1BD6-0BF8-2E10-718DF3663B63}"/>
               </a:ext>
             </a:extLst>
           </p:cNvPr>
@@ -4890,7 +4890,7 @@
           <p:cNvPr id="6" name="Rechteck 5">
             <a:extLst>
               <a:ext uri="{FF2B5EF4-FFF2-40B4-BE49-F238E27FC236}">
-                <a16:creationId xmlns:a16="http://schemas.microsoft.com/office/drawing/2014/main" id="{7E3AB043-4379-9C41-3073-B845F8A54179}"/>
+                <a16:creationId xmlns:a16="http://schemas.microsoft.com/office/drawing/2014/main" id="{C7B627CC-7992-F111-A401-1AB07EF3FF5C}"/>
               </a:ext>
             </a:extLst>
           </p:cNvPr>
@@ -4960,7 +4960,7 @@
           <p:cNvPr id="7" name="Rechteck 6">
             <a:extLst>
               <a:ext uri="{FF2B5EF4-FFF2-40B4-BE49-F238E27FC236}">
-                <a16:creationId xmlns:a16="http://schemas.microsoft.com/office/drawing/2014/main" id="{DBB31787-F50E-591D-84B7-B5D3CBE331D4}"/>
+                <a16:creationId xmlns:a16="http://schemas.microsoft.com/office/drawing/2014/main" id="{DA27B403-B258-8895-C6CB-9AEB1ACB1F90}"/>
               </a:ext>
             </a:extLst>
           </p:cNvPr>
@@ -5030,7 +5030,7 @@
           <p:cNvPr id="8" name="Rechteck 7">
             <a:extLst>
               <a:ext uri="{FF2B5EF4-FFF2-40B4-BE49-F238E27FC236}">
-                <a16:creationId xmlns:a16="http://schemas.microsoft.com/office/drawing/2014/main" id="{60E38716-3C78-B8DF-398A-5C340FF62C50}"/>
+                <a16:creationId xmlns:a16="http://schemas.microsoft.com/office/drawing/2014/main" id="{6C127284-6B1E-A38D-F242-643727B81201}"/>
               </a:ext>
             </a:extLst>
           </p:cNvPr>
@@ -5101,7 +5101,7 @@
           <p:cNvPr id="9" name="Rechteck 8">
             <a:extLst>
               <a:ext uri="{FF2B5EF4-FFF2-40B4-BE49-F238E27FC236}">
-                <a16:creationId xmlns:a16="http://schemas.microsoft.com/office/drawing/2014/main" id="{E130D017-FC4A-27B0-459A-E30C81C78949}"/>
+                <a16:creationId xmlns:a16="http://schemas.microsoft.com/office/drawing/2014/main" id="{92B118CE-6F17-8F1B-7A0C-9E1BDA99B46B}"/>
               </a:ext>
             </a:extLst>
           </p:cNvPr>
@@ -5172,7 +5172,7 @@
           <p:cNvPr id="10" name="Rechteck 9">
             <a:extLst>
               <a:ext uri="{FF2B5EF4-FFF2-40B4-BE49-F238E27FC236}">
-                <a16:creationId xmlns:a16="http://schemas.microsoft.com/office/drawing/2014/main" id="{0A14657F-F22E-967D-DEE8-02A5DE3FF94D}"/>
+                <a16:creationId xmlns:a16="http://schemas.microsoft.com/office/drawing/2014/main" id="{381607E7-1B4B-3111-4811-60B329DFE761}"/>
               </a:ext>
             </a:extLst>
           </p:cNvPr>
@@ -5243,7 +5243,7 @@
           <p:cNvPr id="11" name="Rechteck 10">
             <a:extLst>
               <a:ext uri="{FF2B5EF4-FFF2-40B4-BE49-F238E27FC236}">
-                <a16:creationId xmlns:a16="http://schemas.microsoft.com/office/drawing/2014/main" id="{A8EFE31F-547E-BDC8-1725-5C93E07E3C60}"/>
+                <a16:creationId xmlns:a16="http://schemas.microsoft.com/office/drawing/2014/main" id="{38B6C10C-83F5-1B3F-6125-516CBAD63829}"/>
               </a:ext>
             </a:extLst>
           </p:cNvPr>
@@ -5313,7 +5313,7 @@
           <p:cNvPr id="12" name="Rechteck 11">
             <a:extLst>
               <a:ext uri="{FF2B5EF4-FFF2-40B4-BE49-F238E27FC236}">
-                <a16:creationId xmlns:a16="http://schemas.microsoft.com/office/drawing/2014/main" id="{8B3BA717-C093-7145-91A3-475967965900}"/>
+                <a16:creationId xmlns:a16="http://schemas.microsoft.com/office/drawing/2014/main" id="{5138891E-A344-1B60-5F58-D9F32BD4A037}"/>
               </a:ext>
             </a:extLst>
           </p:cNvPr>
@@ -5383,7 +5383,7 @@
           <p:cNvPr id="13" name="Rechteck 12">
             <a:extLst>
               <a:ext uri="{FF2B5EF4-FFF2-40B4-BE49-F238E27FC236}">
-                <a16:creationId xmlns:a16="http://schemas.microsoft.com/office/drawing/2014/main" id="{747164A3-011F-86A4-9753-E13B5417C86E}"/>
+                <a16:creationId xmlns:a16="http://schemas.microsoft.com/office/drawing/2014/main" id="{E74398F3-532E-AE98-CBB1-0364CA363520}"/>
               </a:ext>
             </a:extLst>
           </p:cNvPr>
@@ -5453,7 +5453,7 @@
           <p:cNvPr id="14" name="Rechteck 13">
             <a:extLst>
               <a:ext uri="{FF2B5EF4-FFF2-40B4-BE49-F238E27FC236}">
-                <a16:creationId xmlns:a16="http://schemas.microsoft.com/office/drawing/2014/main" id="{832259FB-BC5F-1350-3A3A-92DC5B17B8B9}"/>
+                <a16:creationId xmlns:a16="http://schemas.microsoft.com/office/drawing/2014/main" id="{03EC4BFD-7A61-898F-7896-3ABBF0615083}"/>
               </a:ext>
             </a:extLst>
           </p:cNvPr>
@@ -5524,7 +5524,7 @@
           <p:cNvPr id="15" name="Rechteck 14">
             <a:extLst>
               <a:ext uri="{FF2B5EF4-FFF2-40B4-BE49-F238E27FC236}">
-                <a16:creationId xmlns:a16="http://schemas.microsoft.com/office/drawing/2014/main" id="{4775DD23-487C-3B93-1A93-79BA6A0A0155}"/>
+                <a16:creationId xmlns:a16="http://schemas.microsoft.com/office/drawing/2014/main" id="{E2707BFD-0DEC-F607-BE6A-8C82E276FCF2}"/>
               </a:ext>
             </a:extLst>
           </p:cNvPr>
@@ -5595,7 +5595,7 @@
           <p:cNvPr id="16" name="Rechteck 15">
             <a:extLst>
               <a:ext uri="{FF2B5EF4-FFF2-40B4-BE49-F238E27FC236}">
-                <a16:creationId xmlns:a16="http://schemas.microsoft.com/office/drawing/2014/main" id="{63288A62-B50A-565B-53A5-16B83A5139D9}"/>
+                <a16:creationId xmlns:a16="http://schemas.microsoft.com/office/drawing/2014/main" id="{911F9591-A8E2-CF99-2F46-5E69FB0C53A6}"/>
               </a:ext>
             </a:extLst>
           </p:cNvPr>
@@ -5666,7 +5666,7 @@
           <p:cNvPr id="17" name="Rechteck 16">
             <a:extLst>
               <a:ext uri="{FF2B5EF4-FFF2-40B4-BE49-F238E27FC236}">
-                <a16:creationId xmlns:a16="http://schemas.microsoft.com/office/drawing/2014/main" id="{DB90219F-D456-A2D8-EC31-1D942DDBE754}"/>
+                <a16:creationId xmlns:a16="http://schemas.microsoft.com/office/drawing/2014/main" id="{3256D3D1-8B00-A2E0-C508-2B824EC44C43}"/>
               </a:ext>
             </a:extLst>
           </p:cNvPr>
@@ -5736,7 +5736,7 @@
           <p:cNvPr id="18" name="Rechteck 17">
             <a:extLst>
               <a:ext uri="{FF2B5EF4-FFF2-40B4-BE49-F238E27FC236}">
-                <a16:creationId xmlns:a16="http://schemas.microsoft.com/office/drawing/2014/main" id="{C255E622-3C6C-2905-ABF2-31148A77B4B4}"/>
+                <a16:creationId xmlns:a16="http://schemas.microsoft.com/office/drawing/2014/main" id="{6CC91CDA-F204-7A95-6814-9FDC17083973}"/>
               </a:ext>
             </a:extLst>
           </p:cNvPr>
@@ -5806,7 +5806,7 @@
           <p:cNvPr id="19" name="Rechteck 18">
             <a:extLst>
               <a:ext uri="{FF2B5EF4-FFF2-40B4-BE49-F238E27FC236}">
-                <a16:creationId xmlns:a16="http://schemas.microsoft.com/office/drawing/2014/main" id="{256D6596-56C7-ED49-F8D6-5E609D329490}"/>
+                <a16:creationId xmlns:a16="http://schemas.microsoft.com/office/drawing/2014/main" id="{BD203CF8-5DB6-D9B7-9EF3-4DDA77686210}"/>
               </a:ext>
             </a:extLst>
           </p:cNvPr>
@@ -5876,7 +5876,7 @@
           <p:cNvPr id="20" name="Rechteck 19">
             <a:extLst>
               <a:ext uri="{FF2B5EF4-FFF2-40B4-BE49-F238E27FC236}">
-                <a16:creationId xmlns:a16="http://schemas.microsoft.com/office/drawing/2014/main" id="{9A003C4D-4AA8-AB7E-29C9-455F6A1A79DA}"/>
+                <a16:creationId xmlns:a16="http://schemas.microsoft.com/office/drawing/2014/main" id="{DD313FFF-FC58-7D25-72F1-284899A4AAC9}"/>
               </a:ext>
             </a:extLst>
           </p:cNvPr>
@@ -5947,7 +5947,7 @@
           <p:cNvPr id="21" name="Rechteck 20">
             <a:extLst>
               <a:ext uri="{FF2B5EF4-FFF2-40B4-BE49-F238E27FC236}">
-                <a16:creationId xmlns:a16="http://schemas.microsoft.com/office/drawing/2014/main" id="{C80BFBFC-E262-ACEE-F200-28F552925E5F}"/>
+                <a16:creationId xmlns:a16="http://schemas.microsoft.com/office/drawing/2014/main" id="{4A5BA1D0-B7CD-B430-15F9-391D95231425}"/>
               </a:ext>
             </a:extLst>
           </p:cNvPr>
@@ -6018,7 +6018,7 @@
           <p:cNvPr id="22" name="Rechteck 21">
             <a:extLst>
               <a:ext uri="{FF2B5EF4-FFF2-40B4-BE49-F238E27FC236}">
-                <a16:creationId xmlns:a16="http://schemas.microsoft.com/office/drawing/2014/main" id="{7130B1A7-BAA6-920B-B3AE-1C8CC3408429}"/>
+                <a16:creationId xmlns:a16="http://schemas.microsoft.com/office/drawing/2014/main" id="{85111CDB-C4F1-FEB9-CFB7-347477661D76}"/>
               </a:ext>
             </a:extLst>
           </p:cNvPr>
@@ -6089,7 +6089,7 @@
           <p:cNvPr id="23" name="Rechteck 22">
             <a:extLst>
               <a:ext uri="{FF2B5EF4-FFF2-40B4-BE49-F238E27FC236}">
-                <a16:creationId xmlns:a16="http://schemas.microsoft.com/office/drawing/2014/main" id="{1B74F856-FD41-19C6-9C5F-7942459FDA71}"/>
+                <a16:creationId xmlns:a16="http://schemas.microsoft.com/office/drawing/2014/main" id="{017A932C-646C-2FDB-8D7B-99D92F49B13C}"/>
               </a:ext>
             </a:extLst>
           </p:cNvPr>
@@ -6159,7 +6159,7 @@
           <p:cNvPr id="24" name="Rechteck 23">
             <a:extLst>
               <a:ext uri="{FF2B5EF4-FFF2-40B4-BE49-F238E27FC236}">
-                <a16:creationId xmlns:a16="http://schemas.microsoft.com/office/drawing/2014/main" id="{560B5951-AA0D-BB26-E254-080D076617AD}"/>
+                <a16:creationId xmlns:a16="http://schemas.microsoft.com/office/drawing/2014/main" id="{9466CE9B-9E6C-8BA0-B8CD-8E3443F7DE9A}"/>
               </a:ext>
             </a:extLst>
           </p:cNvPr>
@@ -6229,7 +6229,7 @@
           <p:cNvPr id="25" name="Rechteck 24">
             <a:extLst>
               <a:ext uri="{FF2B5EF4-FFF2-40B4-BE49-F238E27FC236}">
-                <a16:creationId xmlns:a16="http://schemas.microsoft.com/office/drawing/2014/main" id="{1CB770C2-E877-7894-B80E-5B9BA95C6AE6}"/>
+                <a16:creationId xmlns:a16="http://schemas.microsoft.com/office/drawing/2014/main" id="{2243DD34-6192-5938-790B-584D2FFE11F0}"/>
               </a:ext>
             </a:extLst>
           </p:cNvPr>
@@ -6299,7 +6299,7 @@
           <p:cNvPr id="26" name="Rechteck 25">
             <a:extLst>
               <a:ext uri="{FF2B5EF4-FFF2-40B4-BE49-F238E27FC236}">
-                <a16:creationId xmlns:a16="http://schemas.microsoft.com/office/drawing/2014/main" id="{48F6C901-CAB2-098A-6F3E-B5AB01F5040F}"/>
+                <a16:creationId xmlns:a16="http://schemas.microsoft.com/office/drawing/2014/main" id="{5CEC58A5-BAEC-0BF9-719C-5609758CF055}"/>
               </a:ext>
             </a:extLst>
           </p:cNvPr>
@@ -6370,7 +6370,7 @@
           <p:cNvPr id="27" name="Rechteck 26">
             <a:extLst>
               <a:ext uri="{FF2B5EF4-FFF2-40B4-BE49-F238E27FC236}">
-                <a16:creationId xmlns:a16="http://schemas.microsoft.com/office/drawing/2014/main" id="{C52A0B2E-E48E-B8B9-AA2F-D8E16DD1577F}"/>
+                <a16:creationId xmlns:a16="http://schemas.microsoft.com/office/drawing/2014/main" id="{5FDF7FF8-ECC9-88F3-7E97-AC61F593CB95}"/>
               </a:ext>
             </a:extLst>
           </p:cNvPr>
@@ -6441,7 +6441,7 @@
           <p:cNvPr id="28" name="Rechteck 27">
             <a:extLst>
               <a:ext uri="{FF2B5EF4-FFF2-40B4-BE49-F238E27FC236}">
-                <a16:creationId xmlns:a16="http://schemas.microsoft.com/office/drawing/2014/main" id="{5DA6B469-B41A-3938-5FEC-9A0A5177C4F2}"/>
+                <a16:creationId xmlns:a16="http://schemas.microsoft.com/office/drawing/2014/main" id="{8CDEFAB7-B55F-F01D-782A-678FB81AF763}"/>
               </a:ext>
             </a:extLst>
           </p:cNvPr>
@@ -6512,7 +6512,7 @@
           <p:cNvPr id="29" name="Rechteck 28">
             <a:extLst>
               <a:ext uri="{FF2B5EF4-FFF2-40B4-BE49-F238E27FC236}">
-                <a16:creationId xmlns:a16="http://schemas.microsoft.com/office/drawing/2014/main" id="{1C6A5B18-664A-0E30-852A-527BF0530145}"/>
+                <a16:creationId xmlns:a16="http://schemas.microsoft.com/office/drawing/2014/main" id="{34249420-0FCE-8B40-51A2-43241C0E4ED9}"/>
               </a:ext>
             </a:extLst>
           </p:cNvPr>
@@ -6582,7 +6582,7 @@
           <p:cNvPr id="30" name="Rechteck 29">
             <a:extLst>
               <a:ext uri="{FF2B5EF4-FFF2-40B4-BE49-F238E27FC236}">
-                <a16:creationId xmlns:a16="http://schemas.microsoft.com/office/drawing/2014/main" id="{B04CC59F-0E95-DDB3-759B-CB9A696667FE}"/>
+                <a16:creationId xmlns:a16="http://schemas.microsoft.com/office/drawing/2014/main" id="{5EA6C50D-8F0A-F17A-AF75-C878CC463D75}"/>
               </a:ext>
             </a:extLst>
           </p:cNvPr>
@@ -6652,7 +6652,7 @@
           <p:cNvPr id="31" name="Rechteck 30">
             <a:extLst>
               <a:ext uri="{FF2B5EF4-FFF2-40B4-BE49-F238E27FC236}">
-                <a16:creationId xmlns:a16="http://schemas.microsoft.com/office/drawing/2014/main" id="{BC0CBB7A-E235-E39A-247F-AD6627663C12}"/>
+                <a16:creationId xmlns:a16="http://schemas.microsoft.com/office/drawing/2014/main" id="{21801ED0-AB86-5949-72E0-01E4FDA450FB}"/>
               </a:ext>
             </a:extLst>
           </p:cNvPr>
@@ -6722,7 +6722,7 @@
           <p:cNvPr id="32" name="Rechteck 31">
             <a:extLst>
               <a:ext uri="{FF2B5EF4-FFF2-40B4-BE49-F238E27FC236}">
-                <a16:creationId xmlns:a16="http://schemas.microsoft.com/office/drawing/2014/main" id="{AEBA3BCA-4F59-A8F8-32C9-CEDD81ABB055}"/>
+                <a16:creationId xmlns:a16="http://schemas.microsoft.com/office/drawing/2014/main" id="{ED0BBBB8-450D-7440-208C-1AE5AA86A710}"/>
               </a:ext>
             </a:extLst>
           </p:cNvPr>
@@ -6793,7 +6793,7 @@
           <p:cNvPr id="33" name="Rechteck 32">
             <a:extLst>
               <a:ext uri="{FF2B5EF4-FFF2-40B4-BE49-F238E27FC236}">
-                <a16:creationId xmlns:a16="http://schemas.microsoft.com/office/drawing/2014/main" id="{844F317F-C5AF-735E-C556-4BD1D4E55C51}"/>
+                <a16:creationId xmlns:a16="http://schemas.microsoft.com/office/drawing/2014/main" id="{D422DCA4-3296-C03D-A29A-932F89669006}"/>
               </a:ext>
             </a:extLst>
           </p:cNvPr>
@@ -6864,7 +6864,7 @@
           <p:cNvPr id="34" name="Rechteck 33">
             <a:extLst>
               <a:ext uri="{FF2B5EF4-FFF2-40B4-BE49-F238E27FC236}">
-                <a16:creationId xmlns:a16="http://schemas.microsoft.com/office/drawing/2014/main" id="{92707D0D-CDDD-8331-941F-836DD7BA5EC0}"/>
+                <a16:creationId xmlns:a16="http://schemas.microsoft.com/office/drawing/2014/main" id="{678B4879-80DC-5387-BE13-2486C34AA827}"/>
               </a:ext>
             </a:extLst>
           </p:cNvPr>
@@ -6935,7 +6935,7 @@
           <p:cNvPr id="35" name="Rechteck 34">
             <a:extLst>
               <a:ext uri="{FF2B5EF4-FFF2-40B4-BE49-F238E27FC236}">
-                <a16:creationId xmlns:a16="http://schemas.microsoft.com/office/drawing/2014/main" id="{BA0DE56B-3510-0772-1CE9-3D21CFA6BA17}"/>
+                <a16:creationId xmlns:a16="http://schemas.microsoft.com/office/drawing/2014/main" id="{7982CD38-40BB-9C8F-E11D-FC268B45DCE8}"/>
               </a:ext>
             </a:extLst>
           </p:cNvPr>
@@ -7005,7 +7005,7 @@
           <p:cNvPr id="36" name="Rechteck 35">
             <a:extLst>
               <a:ext uri="{FF2B5EF4-FFF2-40B4-BE49-F238E27FC236}">
-                <a16:creationId xmlns:a16="http://schemas.microsoft.com/office/drawing/2014/main" id="{FC55F63F-A7A5-61AA-096B-B30E3B70763E}"/>
+                <a16:creationId xmlns:a16="http://schemas.microsoft.com/office/drawing/2014/main" id="{B5A6F445-5335-8015-DC06-30475CBD70A0}"/>
               </a:ext>
             </a:extLst>
           </p:cNvPr>
@@ -7075,7 +7075,7 @@
           <p:cNvPr id="37" name="Rechteck 36">
             <a:extLst>
               <a:ext uri="{FF2B5EF4-FFF2-40B4-BE49-F238E27FC236}">
-                <a16:creationId xmlns:a16="http://schemas.microsoft.com/office/drawing/2014/main" id="{C24F9ADC-7483-0EBA-5E9D-95159842088E}"/>
+                <a16:creationId xmlns:a16="http://schemas.microsoft.com/office/drawing/2014/main" id="{33D255CA-141B-C08A-3787-1B56602F8434}"/>
               </a:ext>
             </a:extLst>
           </p:cNvPr>
@@ -7143,7 +7143,7 @@
     </p:spTree>
     <p:extLst>
       <p:ext uri="{BB962C8B-B14F-4D97-AF65-F5344CB8AC3E}">
-        <p14:creationId xmlns:p14="http://schemas.microsoft.com/office/powerpoint/2010/main" val="1205324171"/>
+        <p14:creationId xmlns:p14="http://schemas.microsoft.com/office/powerpoint/2010/main" val="2748066859"/>
       </p:ext>
     </p:extLst>
   </p:cSld>
@@ -7175,7 +7175,7 @@
           <p:cNvPr id="2" name="Rechteck: abgerundete Ecken 1">
             <a:extLst>
               <a:ext uri="{FF2B5EF4-FFF2-40B4-BE49-F238E27FC236}">
-                <a16:creationId xmlns:a16="http://schemas.microsoft.com/office/drawing/2014/main" id="{9A168628-29AB-F793-FAA2-44596302A4C3}"/>
+                <a16:creationId xmlns:a16="http://schemas.microsoft.com/office/drawing/2014/main" id="{965B4740-C325-E0C4-8117-312FCF122B61}"/>
               </a:ext>
             </a:extLst>
           </p:cNvPr>
@@ -7233,7 +7233,7 @@
           <p:cNvPr id="3" name="Rechteck: abgerundete Ecken 2">
             <a:extLst>
               <a:ext uri="{FF2B5EF4-FFF2-40B4-BE49-F238E27FC236}">
-                <a16:creationId xmlns:a16="http://schemas.microsoft.com/office/drawing/2014/main" id="{BF53D694-80C8-070C-B224-61133FF08CDC}"/>
+                <a16:creationId xmlns:a16="http://schemas.microsoft.com/office/drawing/2014/main" id="{8130FCCD-9446-6C4A-A704-396D1B1FC1A7}"/>
               </a:ext>
             </a:extLst>
           </p:cNvPr>
@@ -7291,7 +7291,7 @@
           <p:cNvPr id="4" name="Rechteck: abgerundete Ecken 3">
             <a:extLst>
               <a:ext uri="{FF2B5EF4-FFF2-40B4-BE49-F238E27FC236}">
-                <a16:creationId xmlns:a16="http://schemas.microsoft.com/office/drawing/2014/main" id="{6A6F9DD7-07F2-0641-4096-3E716A69016A}"/>
+                <a16:creationId xmlns:a16="http://schemas.microsoft.com/office/drawing/2014/main" id="{FD05C16F-C8E0-57A9-20EE-F1811393572D}"/>
               </a:ext>
             </a:extLst>
           </p:cNvPr>
@@ -7352,7 +7352,7 @@
           <p:cNvPr id="5" name="Rechteck: abgerundete Ecken 4">
             <a:extLst>
               <a:ext uri="{FF2B5EF4-FFF2-40B4-BE49-F238E27FC236}">
-                <a16:creationId xmlns:a16="http://schemas.microsoft.com/office/drawing/2014/main" id="{74D4494E-4F50-066A-A3C2-9F48C926740D}"/>
+                <a16:creationId xmlns:a16="http://schemas.microsoft.com/office/drawing/2014/main" id="{37A71AD4-B4C2-4C33-BFE9-67138E3FB030}"/>
               </a:ext>
             </a:extLst>
           </p:cNvPr>
@@ -7413,7 +7413,7 @@
           <p:cNvPr id="6" name="Rechteck: abgerundete Ecken 5">
             <a:extLst>
               <a:ext uri="{FF2B5EF4-FFF2-40B4-BE49-F238E27FC236}">
-                <a16:creationId xmlns:a16="http://schemas.microsoft.com/office/drawing/2014/main" id="{C7F039A9-F77C-7F02-5E46-9A4FD52E58FC}"/>
+                <a16:creationId xmlns:a16="http://schemas.microsoft.com/office/drawing/2014/main" id="{C748F408-F8B4-86D9-59B6-3F6DB41D3CE9}"/>
               </a:ext>
             </a:extLst>
           </p:cNvPr>
@@ -7471,7 +7471,7 @@
           <p:cNvPr id="7" name="Rechteck: abgerundete Ecken 6">
             <a:extLst>
               <a:ext uri="{FF2B5EF4-FFF2-40B4-BE49-F238E27FC236}">
-                <a16:creationId xmlns:a16="http://schemas.microsoft.com/office/drawing/2014/main" id="{864BA547-49CD-9BD0-F23D-B701C18BCF7D}"/>
+                <a16:creationId xmlns:a16="http://schemas.microsoft.com/office/drawing/2014/main" id="{28710612-7FDC-28E5-87F2-4AFB9D9FCFD9}"/>
               </a:ext>
             </a:extLst>
           </p:cNvPr>
@@ -7529,7 +7529,7 @@
           <p:cNvPr id="8" name="Rechteck: abgerundete Ecken 7">
             <a:extLst>
               <a:ext uri="{FF2B5EF4-FFF2-40B4-BE49-F238E27FC236}">
-                <a16:creationId xmlns:a16="http://schemas.microsoft.com/office/drawing/2014/main" id="{6417B6A8-3BE9-122A-1070-4ADBC0F9732E}"/>
+                <a16:creationId xmlns:a16="http://schemas.microsoft.com/office/drawing/2014/main" id="{360D890E-9525-B457-FB4B-E1E8B1348D46}"/>
               </a:ext>
             </a:extLst>
           </p:cNvPr>
@@ -7590,7 +7590,7 @@
           <p:cNvPr id="9" name="Rechteck: abgerundete Ecken 8">
             <a:extLst>
               <a:ext uri="{FF2B5EF4-FFF2-40B4-BE49-F238E27FC236}">
-                <a16:creationId xmlns:a16="http://schemas.microsoft.com/office/drawing/2014/main" id="{6B61A4D2-2EEF-A5BF-898A-23325EE1F557}"/>
+                <a16:creationId xmlns:a16="http://schemas.microsoft.com/office/drawing/2014/main" id="{8EBAE1A5-8A89-58E8-F9EC-B18BDF045E2E}"/>
               </a:ext>
             </a:extLst>
           </p:cNvPr>
@@ -7651,7 +7651,7 @@
           <p:cNvPr id="10" name="Rechteck: abgerundete Ecken 9">
             <a:extLst>
               <a:ext uri="{FF2B5EF4-FFF2-40B4-BE49-F238E27FC236}">
-                <a16:creationId xmlns:a16="http://schemas.microsoft.com/office/drawing/2014/main" id="{5826BB52-6414-A001-C69E-0DB9A16B70A9}"/>
+                <a16:creationId xmlns:a16="http://schemas.microsoft.com/office/drawing/2014/main" id="{72143312-966C-CC9F-834F-C4942D6DCA95}"/>
               </a:ext>
             </a:extLst>
           </p:cNvPr>
@@ -7709,7 +7709,7 @@
           <p:cNvPr id="11" name="Rechteck: abgerundete Ecken 10">
             <a:extLst>
               <a:ext uri="{FF2B5EF4-FFF2-40B4-BE49-F238E27FC236}">
-                <a16:creationId xmlns:a16="http://schemas.microsoft.com/office/drawing/2014/main" id="{176C9209-4210-0E1F-7332-A12AD2774E29}"/>
+                <a16:creationId xmlns:a16="http://schemas.microsoft.com/office/drawing/2014/main" id="{6B5A535E-4DB1-B45B-7B15-AC748F9B75BE}"/>
               </a:ext>
             </a:extLst>
           </p:cNvPr>
@@ -7767,7 +7767,7 @@
           <p:cNvPr id="12" name="Rechteck: abgerundete Ecken 11">
             <a:extLst>
               <a:ext uri="{FF2B5EF4-FFF2-40B4-BE49-F238E27FC236}">
-                <a16:creationId xmlns:a16="http://schemas.microsoft.com/office/drawing/2014/main" id="{9936F452-D083-6A0C-C35F-4ED8632A9A3B}"/>
+                <a16:creationId xmlns:a16="http://schemas.microsoft.com/office/drawing/2014/main" id="{8F755D79-F75E-3C6B-ECD3-E7CFBFCBEF52}"/>
               </a:ext>
             </a:extLst>
           </p:cNvPr>
@@ -7828,7 +7828,7 @@
           <p:cNvPr id="13" name="Rechteck: abgerundete Ecken 12">
             <a:extLst>
               <a:ext uri="{FF2B5EF4-FFF2-40B4-BE49-F238E27FC236}">
-                <a16:creationId xmlns:a16="http://schemas.microsoft.com/office/drawing/2014/main" id="{6B90CA09-0425-BA08-4349-818C09C1F345}"/>
+                <a16:creationId xmlns:a16="http://schemas.microsoft.com/office/drawing/2014/main" id="{2F23AAEB-956A-57D1-32B1-518B6B920CB3}"/>
               </a:ext>
             </a:extLst>
           </p:cNvPr>
@@ -7889,7 +7889,7 @@
           <p:cNvPr id="14" name="Rechteck: abgerundete Ecken 13">
             <a:extLst>
               <a:ext uri="{FF2B5EF4-FFF2-40B4-BE49-F238E27FC236}">
-                <a16:creationId xmlns:a16="http://schemas.microsoft.com/office/drawing/2014/main" id="{CA335A42-1521-900E-75EE-7A29E194A4F1}"/>
+                <a16:creationId xmlns:a16="http://schemas.microsoft.com/office/drawing/2014/main" id="{DFC52A8F-13C9-03A2-2000-ECA790460092}"/>
               </a:ext>
             </a:extLst>
           </p:cNvPr>
@@ -7947,7 +7947,7 @@
           <p:cNvPr id="15" name="Rechteck: abgerundete Ecken 14">
             <a:extLst>
               <a:ext uri="{FF2B5EF4-FFF2-40B4-BE49-F238E27FC236}">
-                <a16:creationId xmlns:a16="http://schemas.microsoft.com/office/drawing/2014/main" id="{670AB89F-AD45-9518-7181-FC02FD7752D5}"/>
+                <a16:creationId xmlns:a16="http://schemas.microsoft.com/office/drawing/2014/main" id="{7E268459-9801-70E0-8149-6CC5AC01D3FF}"/>
               </a:ext>
             </a:extLst>
           </p:cNvPr>
@@ -8005,7 +8005,7 @@
           <p:cNvPr id="16" name="Rechteck: abgerundete Ecken 15">
             <a:extLst>
               <a:ext uri="{FF2B5EF4-FFF2-40B4-BE49-F238E27FC236}">
-                <a16:creationId xmlns:a16="http://schemas.microsoft.com/office/drawing/2014/main" id="{819DC429-2606-FDD6-7583-D594297E8C88}"/>
+                <a16:creationId xmlns:a16="http://schemas.microsoft.com/office/drawing/2014/main" id="{790EBA62-A543-C8AF-4566-A405A64A6CE9}"/>
               </a:ext>
             </a:extLst>
           </p:cNvPr>
@@ -8066,7 +8066,7 @@
           <p:cNvPr id="17" name="Rechteck: abgerundete Ecken 16">
             <a:extLst>
               <a:ext uri="{FF2B5EF4-FFF2-40B4-BE49-F238E27FC236}">
-                <a16:creationId xmlns:a16="http://schemas.microsoft.com/office/drawing/2014/main" id="{0291C00A-2B71-A404-8C5A-4FE5535B53C6}"/>
+                <a16:creationId xmlns:a16="http://schemas.microsoft.com/office/drawing/2014/main" id="{CD155B58-14F9-9035-66BF-CA4E38D9E287}"/>
               </a:ext>
             </a:extLst>
           </p:cNvPr>
@@ -8127,7 +8127,7 @@
           <p:cNvPr id="18" name="Rechteck: abgerundete Ecken 17">
             <a:extLst>
               <a:ext uri="{FF2B5EF4-FFF2-40B4-BE49-F238E27FC236}">
-                <a16:creationId xmlns:a16="http://schemas.microsoft.com/office/drawing/2014/main" id="{0830144D-E7CC-6F72-B671-88CEBA944D44}"/>
+                <a16:creationId xmlns:a16="http://schemas.microsoft.com/office/drawing/2014/main" id="{3FF6B052-9390-1C15-BEFA-2548780013C0}"/>
               </a:ext>
             </a:extLst>
           </p:cNvPr>
@@ -8187,7 +8187,7 @@
           <p:cNvPr id="19" name="Rechteck: abgerundete Ecken 18">
             <a:extLst>
               <a:ext uri="{FF2B5EF4-FFF2-40B4-BE49-F238E27FC236}">
-                <a16:creationId xmlns:a16="http://schemas.microsoft.com/office/drawing/2014/main" id="{AE3ACB41-E585-B67E-5746-702EC2B59C4E}"/>
+                <a16:creationId xmlns:a16="http://schemas.microsoft.com/office/drawing/2014/main" id="{8C397B7C-FAD5-9A9F-E257-0A162314E212}"/>
               </a:ext>
             </a:extLst>
           </p:cNvPr>
@@ -8247,7 +8247,7 @@
           <p:cNvPr id="20" name="Rechteck: abgerundete Ecken 19">
             <a:extLst>
               <a:ext uri="{FF2B5EF4-FFF2-40B4-BE49-F238E27FC236}">
-                <a16:creationId xmlns:a16="http://schemas.microsoft.com/office/drawing/2014/main" id="{B5E4B626-FB78-67D6-E949-2641F374DEEC}"/>
+                <a16:creationId xmlns:a16="http://schemas.microsoft.com/office/drawing/2014/main" id="{5E9FE514-0120-E313-B43C-9D8850225EC9}"/>
               </a:ext>
             </a:extLst>
           </p:cNvPr>
@@ -8307,7 +8307,7 @@
           <p:cNvPr id="21" name="Rechteck: abgerundete Ecken 20">
             <a:extLst>
               <a:ext uri="{FF2B5EF4-FFF2-40B4-BE49-F238E27FC236}">
-                <a16:creationId xmlns:a16="http://schemas.microsoft.com/office/drawing/2014/main" id="{0E253C66-87D8-3EEE-381C-082F10227409}"/>
+                <a16:creationId xmlns:a16="http://schemas.microsoft.com/office/drawing/2014/main" id="{1E31A004-22C9-63A4-21DC-92AE91606F6B}"/>
               </a:ext>
             </a:extLst>
           </p:cNvPr>
@@ -8367,7 +8367,7 @@
           <p:cNvPr id="22" name="Rechteck: abgerundete Ecken 21">
             <a:extLst>
               <a:ext uri="{FF2B5EF4-FFF2-40B4-BE49-F238E27FC236}">
-                <a16:creationId xmlns:a16="http://schemas.microsoft.com/office/drawing/2014/main" id="{18DE3797-890B-3196-A55B-75E8B2037F38}"/>
+                <a16:creationId xmlns:a16="http://schemas.microsoft.com/office/drawing/2014/main" id="{9DC09655-10AD-69D5-554E-AE767CCF3D3A}"/>
               </a:ext>
             </a:extLst>
           </p:cNvPr>
@@ -8413,7 +8413,7 @@
           <p:cNvPr id="23" name="Rechteck: abgerundete Ecken 22">
             <a:extLst>
               <a:ext uri="{FF2B5EF4-FFF2-40B4-BE49-F238E27FC236}">
-                <a16:creationId xmlns:a16="http://schemas.microsoft.com/office/drawing/2014/main" id="{5E367CE6-31B4-C7D0-560E-767931A410E6}"/>
+                <a16:creationId xmlns:a16="http://schemas.microsoft.com/office/drawing/2014/main" id="{C9344076-87A0-DB59-1D0D-E1BFE4C6A6A8}"/>
               </a:ext>
             </a:extLst>
           </p:cNvPr>
@@ -8459,7 +8459,7 @@
           <p:cNvPr id="24" name="Rechteck: abgerundete Ecken 23">
             <a:extLst>
               <a:ext uri="{FF2B5EF4-FFF2-40B4-BE49-F238E27FC236}">
-                <a16:creationId xmlns:a16="http://schemas.microsoft.com/office/drawing/2014/main" id="{19D4AA17-9BD3-CCF9-97C5-93C0A1AF810C}"/>
+                <a16:creationId xmlns:a16="http://schemas.microsoft.com/office/drawing/2014/main" id="{EE4637BB-A3FD-8E06-E542-42F98DF4E12B}"/>
               </a:ext>
             </a:extLst>
           </p:cNvPr>
@@ -8505,7 +8505,7 @@
           <p:cNvPr id="25" name="Rechteck: abgerundete Ecken 24">
             <a:extLst>
               <a:ext uri="{FF2B5EF4-FFF2-40B4-BE49-F238E27FC236}">
-                <a16:creationId xmlns:a16="http://schemas.microsoft.com/office/drawing/2014/main" id="{CBF16376-1470-FB46-8D68-C30D1DC83D1B}"/>
+                <a16:creationId xmlns:a16="http://schemas.microsoft.com/office/drawing/2014/main" id="{ACB4F9F1-6E50-3C29-F2FE-85B8BF430C27}"/>
               </a:ext>
             </a:extLst>
           </p:cNvPr>
@@ -8551,7 +8551,7 @@
           <p:cNvPr id="26" name="Rechteck: abgerundete Ecken 25">
             <a:extLst>
               <a:ext uri="{FF2B5EF4-FFF2-40B4-BE49-F238E27FC236}">
-                <a16:creationId xmlns:a16="http://schemas.microsoft.com/office/drawing/2014/main" id="{7443ED0A-4403-B87D-5D8E-E53E84E84FDC}"/>
+                <a16:creationId xmlns:a16="http://schemas.microsoft.com/office/drawing/2014/main" id="{2F2F8925-EF86-E8EB-AE72-5BF42F0E420D}"/>
               </a:ext>
             </a:extLst>
           </p:cNvPr>
@@ -8611,7 +8611,7 @@
           <p:cNvPr id="27" name="Rechteck: abgerundete Ecken 26">
             <a:extLst>
               <a:ext uri="{FF2B5EF4-FFF2-40B4-BE49-F238E27FC236}">
-                <a16:creationId xmlns:a16="http://schemas.microsoft.com/office/drawing/2014/main" id="{9D7EABAD-848D-A062-EE08-26CA73BC30F1}"/>
+                <a16:creationId xmlns:a16="http://schemas.microsoft.com/office/drawing/2014/main" id="{8D0E4132-62F3-BD4A-DE58-E38D27B8A6E7}"/>
               </a:ext>
             </a:extLst>
           </p:cNvPr>
@@ -8671,7 +8671,7 @@
           <p:cNvPr id="28" name="Rechteck: abgerundete Ecken 27">
             <a:extLst>
               <a:ext uri="{FF2B5EF4-FFF2-40B4-BE49-F238E27FC236}">
-                <a16:creationId xmlns:a16="http://schemas.microsoft.com/office/drawing/2014/main" id="{01311C00-0653-B3FF-D843-89EDA706C96B}"/>
+                <a16:creationId xmlns:a16="http://schemas.microsoft.com/office/drawing/2014/main" id="{E7A60B89-07B9-FF65-2C72-ACD985BFA36B}"/>
               </a:ext>
             </a:extLst>
           </p:cNvPr>
@@ -8734,7 +8734,7 @@
           <p:cNvPr id="29" name="Rechteck: abgerundete Ecken 28">
             <a:extLst>
               <a:ext uri="{FF2B5EF4-FFF2-40B4-BE49-F238E27FC236}">
-                <a16:creationId xmlns:a16="http://schemas.microsoft.com/office/drawing/2014/main" id="{7169077C-708C-CD89-3B25-A3A055814737}"/>
+                <a16:creationId xmlns:a16="http://schemas.microsoft.com/office/drawing/2014/main" id="{8A9C39E4-1E41-265D-5D53-0EDD26A1F306}"/>
               </a:ext>
             </a:extLst>
           </p:cNvPr>
@@ -8795,7 +8795,7 @@
     </p:spTree>
     <p:extLst>
       <p:ext uri="{BB962C8B-B14F-4D97-AF65-F5344CB8AC3E}">
-        <p14:creationId xmlns:p14="http://schemas.microsoft.com/office/powerpoint/2010/main" val="4125390728"/>
+        <p14:creationId xmlns:p14="http://schemas.microsoft.com/office/powerpoint/2010/main" val="2047719586"/>
       </p:ext>
     </p:extLst>
   </p:cSld>
@@ -8827,7 +8827,7 @@
           <p:cNvPr id="2" name="Rechteck 1">
             <a:extLst>
               <a:ext uri="{FF2B5EF4-FFF2-40B4-BE49-F238E27FC236}">
-                <a16:creationId xmlns:a16="http://schemas.microsoft.com/office/drawing/2014/main" id="{0DD59215-6CC2-4A56-5F51-1C7A0564890E}"/>
+                <a16:creationId xmlns:a16="http://schemas.microsoft.com/office/drawing/2014/main" id="{17CE2839-21F6-AA76-6F59-916EFD25440D}"/>
               </a:ext>
             </a:extLst>
           </p:cNvPr>
@@ -8881,7 +8881,7 @@
           <p:cNvPr id="3" name="Rechteck 2">
             <a:extLst>
               <a:ext uri="{FF2B5EF4-FFF2-40B4-BE49-F238E27FC236}">
-                <a16:creationId xmlns:a16="http://schemas.microsoft.com/office/drawing/2014/main" id="{F3D71174-142A-C343-037E-DEE2FC634CB0}"/>
+                <a16:creationId xmlns:a16="http://schemas.microsoft.com/office/drawing/2014/main" id="{54CF58CC-8A11-EDF3-CACC-A6BE19BA0A31}"/>
               </a:ext>
             </a:extLst>
           </p:cNvPr>
@@ -8935,7 +8935,7 @@
           <p:cNvPr id="4" name="Rechteck 3">
             <a:extLst>
               <a:ext uri="{FF2B5EF4-FFF2-40B4-BE49-F238E27FC236}">
-                <a16:creationId xmlns:a16="http://schemas.microsoft.com/office/drawing/2014/main" id="{C5B2531F-D1F8-DA44-4CF4-9F0F8081E22C}"/>
+                <a16:creationId xmlns:a16="http://schemas.microsoft.com/office/drawing/2014/main" id="{7E4761C3-4C40-3659-F6A0-B5569A37FED4}"/>
               </a:ext>
             </a:extLst>
           </p:cNvPr>
@@ -8989,7 +8989,7 @@
           <p:cNvPr id="5" name="Rechteck 4">
             <a:extLst>
               <a:ext uri="{FF2B5EF4-FFF2-40B4-BE49-F238E27FC236}">
-                <a16:creationId xmlns:a16="http://schemas.microsoft.com/office/drawing/2014/main" id="{B2CBC482-8B3F-2144-A767-F3CFB64FCAEC}"/>
+                <a16:creationId xmlns:a16="http://schemas.microsoft.com/office/drawing/2014/main" id="{C0FDDFC1-10BA-1FE2-713D-7FCBE6F0FBD2}"/>
               </a:ext>
             </a:extLst>
           </p:cNvPr>
@@ -9043,7 +9043,7 @@
           <p:cNvPr id="6" name="Rechteck 5">
             <a:extLst>
               <a:ext uri="{FF2B5EF4-FFF2-40B4-BE49-F238E27FC236}">
-                <a16:creationId xmlns:a16="http://schemas.microsoft.com/office/drawing/2014/main" id="{14ECBC87-A7CB-D87D-7CF8-04F592F7C24D}"/>
+                <a16:creationId xmlns:a16="http://schemas.microsoft.com/office/drawing/2014/main" id="{7B149127-94CA-749B-4DF6-8A27F2ED423C}"/>
               </a:ext>
             </a:extLst>
           </p:cNvPr>
@@ -9097,7 +9097,7 @@
           <p:cNvPr id="7" name="Rechteck 6">
             <a:extLst>
               <a:ext uri="{FF2B5EF4-FFF2-40B4-BE49-F238E27FC236}">
-                <a16:creationId xmlns:a16="http://schemas.microsoft.com/office/drawing/2014/main" id="{5F12181D-45BC-0044-F062-F578B99051CD}"/>
+                <a16:creationId xmlns:a16="http://schemas.microsoft.com/office/drawing/2014/main" id="{764294BD-7DDD-B4D1-8354-5DB1C2BD3D82}"/>
               </a:ext>
             </a:extLst>
           </p:cNvPr>
@@ -9151,7 +9151,7 @@
           <p:cNvPr id="8" name="Rechteck 7">
             <a:extLst>
               <a:ext uri="{FF2B5EF4-FFF2-40B4-BE49-F238E27FC236}">
-                <a16:creationId xmlns:a16="http://schemas.microsoft.com/office/drawing/2014/main" id="{7E748E70-FC29-45AE-3457-28618A166CD4}"/>
+                <a16:creationId xmlns:a16="http://schemas.microsoft.com/office/drawing/2014/main" id="{BB15CF6B-10AE-9A9C-FFE7-262486003C04}"/>
               </a:ext>
             </a:extLst>
           </p:cNvPr>
@@ -9205,7 +9205,7 @@
           <p:cNvPr id="9" name="Rechteck 8">
             <a:extLst>
               <a:ext uri="{FF2B5EF4-FFF2-40B4-BE49-F238E27FC236}">
-                <a16:creationId xmlns:a16="http://schemas.microsoft.com/office/drawing/2014/main" id="{1BECB6E0-F599-CCAF-8D22-8A4EFA686F74}"/>
+                <a16:creationId xmlns:a16="http://schemas.microsoft.com/office/drawing/2014/main" id="{97C3A57D-2D34-A22D-D0AE-8B127CA55F52}"/>
               </a:ext>
             </a:extLst>
           </p:cNvPr>
@@ -9259,7 +9259,7 @@
           <p:cNvPr id="10" name="Rechteck 9">
             <a:extLst>
               <a:ext uri="{FF2B5EF4-FFF2-40B4-BE49-F238E27FC236}">
-                <a16:creationId xmlns:a16="http://schemas.microsoft.com/office/drawing/2014/main" id="{EE13B57F-695E-6D2E-6AD7-AC1453B6AD49}"/>
+                <a16:creationId xmlns:a16="http://schemas.microsoft.com/office/drawing/2014/main" id="{19E15C73-065D-1D4F-A058-79F84BBC0E91}"/>
               </a:ext>
             </a:extLst>
           </p:cNvPr>
@@ -9313,7 +9313,7 @@
           <p:cNvPr id="11" name="Rechteck 10">
             <a:extLst>
               <a:ext uri="{FF2B5EF4-FFF2-40B4-BE49-F238E27FC236}">
-                <a16:creationId xmlns:a16="http://schemas.microsoft.com/office/drawing/2014/main" id="{F6DF12B7-0C14-843A-FB0B-BED453DA9534}"/>
+                <a16:creationId xmlns:a16="http://schemas.microsoft.com/office/drawing/2014/main" id="{64B2B84F-E64D-04FF-4539-482A3CD9BD9E}"/>
               </a:ext>
             </a:extLst>
           </p:cNvPr>
@@ -9367,7 +9367,7 @@
           <p:cNvPr id="12" name="Rechteck 11">
             <a:extLst>
               <a:ext uri="{FF2B5EF4-FFF2-40B4-BE49-F238E27FC236}">
-                <a16:creationId xmlns:a16="http://schemas.microsoft.com/office/drawing/2014/main" id="{7051ECF8-D776-11D8-817C-273FA62F3B5F}"/>
+                <a16:creationId xmlns:a16="http://schemas.microsoft.com/office/drawing/2014/main" id="{06BAA078-FF18-01C4-CE7E-AF5CB7C265BE}"/>
               </a:ext>
             </a:extLst>
           </p:cNvPr>
@@ -9421,7 +9421,7 @@
           <p:cNvPr id="13" name="Rechteck 12">
             <a:extLst>
               <a:ext uri="{FF2B5EF4-FFF2-40B4-BE49-F238E27FC236}">
-                <a16:creationId xmlns:a16="http://schemas.microsoft.com/office/drawing/2014/main" id="{740DD3CB-67E2-6B6A-A3E4-90C3FF8F4909}"/>
+                <a16:creationId xmlns:a16="http://schemas.microsoft.com/office/drawing/2014/main" id="{B7E616DF-5110-6A78-5A3B-8379015D7923}"/>
               </a:ext>
             </a:extLst>
           </p:cNvPr>
@@ -9475,7 +9475,7 @@
           <p:cNvPr id="14" name="Rechteck 13">
             <a:extLst>
               <a:ext uri="{FF2B5EF4-FFF2-40B4-BE49-F238E27FC236}">
-                <a16:creationId xmlns:a16="http://schemas.microsoft.com/office/drawing/2014/main" id="{354A0A7F-B1D2-3E6E-3F86-062C47206948}"/>
+                <a16:creationId xmlns:a16="http://schemas.microsoft.com/office/drawing/2014/main" id="{98DE7CF8-CA06-1F30-7F55-BDE3946B4320}"/>
               </a:ext>
             </a:extLst>
           </p:cNvPr>
@@ -9529,7 +9529,7 @@
           <p:cNvPr id="15" name="Rechteck 14">
             <a:extLst>
               <a:ext uri="{FF2B5EF4-FFF2-40B4-BE49-F238E27FC236}">
-                <a16:creationId xmlns:a16="http://schemas.microsoft.com/office/drawing/2014/main" id="{D45CCF24-BB3C-5F67-E2C9-1F5EAC127FA8}"/>
+                <a16:creationId xmlns:a16="http://schemas.microsoft.com/office/drawing/2014/main" id="{729322C0-2858-B94C-78C4-8842E7FFF18E}"/>
               </a:ext>
             </a:extLst>
           </p:cNvPr>
@@ -9583,7 +9583,7 @@
           <p:cNvPr id="16" name="Rechteck 15">
             <a:extLst>
               <a:ext uri="{FF2B5EF4-FFF2-40B4-BE49-F238E27FC236}">
-                <a16:creationId xmlns:a16="http://schemas.microsoft.com/office/drawing/2014/main" id="{76C5A887-C7BC-C40F-D99A-C6EBEA736C11}"/>
+                <a16:creationId xmlns:a16="http://schemas.microsoft.com/office/drawing/2014/main" id="{D579CC05-91FB-A61B-8918-7C3AEAB3BF4D}"/>
               </a:ext>
             </a:extLst>
           </p:cNvPr>
@@ -9637,7 +9637,7 @@
           <p:cNvPr id="17" name="Rechteck 16">
             <a:extLst>
               <a:ext uri="{FF2B5EF4-FFF2-40B4-BE49-F238E27FC236}">
-                <a16:creationId xmlns:a16="http://schemas.microsoft.com/office/drawing/2014/main" id="{F675AE4E-1D16-E3B9-BBD7-FCB5108BF1A4}"/>
+                <a16:creationId xmlns:a16="http://schemas.microsoft.com/office/drawing/2014/main" id="{C0F36532-77F0-B18B-38CE-2E89F3065BC3}"/>
               </a:ext>
             </a:extLst>
           </p:cNvPr>
@@ -9691,7 +9691,7 @@
           <p:cNvPr id="18" name="Rechteck 17">
             <a:extLst>
               <a:ext uri="{FF2B5EF4-FFF2-40B4-BE49-F238E27FC236}">
-                <a16:creationId xmlns:a16="http://schemas.microsoft.com/office/drawing/2014/main" id="{9BE93EA4-E3D9-69D0-A54F-06359CEB19AA}"/>
+                <a16:creationId xmlns:a16="http://schemas.microsoft.com/office/drawing/2014/main" id="{554CEB71-4F4B-A309-BBFF-44C03A70D861}"/>
               </a:ext>
             </a:extLst>
           </p:cNvPr>
@@ -9745,7 +9745,7 @@
           <p:cNvPr id="19" name="Rechteck 18">
             <a:extLst>
               <a:ext uri="{FF2B5EF4-FFF2-40B4-BE49-F238E27FC236}">
-                <a16:creationId xmlns:a16="http://schemas.microsoft.com/office/drawing/2014/main" id="{81E69DBE-36D4-5E17-D6BE-FFEBE0F8BA7C}"/>
+                <a16:creationId xmlns:a16="http://schemas.microsoft.com/office/drawing/2014/main" id="{0B7C8B6F-6230-314D-F42D-F9F30496EBA3}"/>
               </a:ext>
             </a:extLst>
           </p:cNvPr>
@@ -9799,7 +9799,7 @@
           <p:cNvPr id="20" name="Rechteck 19">
             <a:extLst>
               <a:ext uri="{FF2B5EF4-FFF2-40B4-BE49-F238E27FC236}">
-                <a16:creationId xmlns:a16="http://schemas.microsoft.com/office/drawing/2014/main" id="{B7BFD877-785C-A804-11C7-BB2164C784F8}"/>
+                <a16:creationId xmlns:a16="http://schemas.microsoft.com/office/drawing/2014/main" id="{114389EB-DAA5-D6B6-1AD7-1DA73F071EDB}"/>
               </a:ext>
             </a:extLst>
           </p:cNvPr>
@@ -9853,7 +9853,7 @@
           <p:cNvPr id="21" name="Rechteck 20">
             <a:extLst>
               <a:ext uri="{FF2B5EF4-FFF2-40B4-BE49-F238E27FC236}">
-                <a16:creationId xmlns:a16="http://schemas.microsoft.com/office/drawing/2014/main" id="{7577F613-786C-5730-A83F-50609809F5BD}"/>
+                <a16:creationId xmlns:a16="http://schemas.microsoft.com/office/drawing/2014/main" id="{81EA858B-02B1-A0F8-E466-BCFBBF10B557}"/>
               </a:ext>
             </a:extLst>
           </p:cNvPr>
@@ -9907,7 +9907,7 @@
           <p:cNvPr id="22" name="Rechteck 21">
             <a:extLst>
               <a:ext uri="{FF2B5EF4-FFF2-40B4-BE49-F238E27FC236}">
-                <a16:creationId xmlns:a16="http://schemas.microsoft.com/office/drawing/2014/main" id="{37E5BD3F-ABA7-3A2D-C01C-504AF1F4D600}"/>
+                <a16:creationId xmlns:a16="http://schemas.microsoft.com/office/drawing/2014/main" id="{3511D160-3DA4-552E-78B7-7005AC5B7418}"/>
               </a:ext>
             </a:extLst>
           </p:cNvPr>
@@ -9961,7 +9961,7 @@
           <p:cNvPr id="23" name="Rechteck 22">
             <a:extLst>
               <a:ext uri="{FF2B5EF4-FFF2-40B4-BE49-F238E27FC236}">
-                <a16:creationId xmlns:a16="http://schemas.microsoft.com/office/drawing/2014/main" id="{8357A44F-742B-889D-F395-136518630D7A}"/>
+                <a16:creationId xmlns:a16="http://schemas.microsoft.com/office/drawing/2014/main" id="{339F25D2-203B-12ED-D103-48A467723884}"/>
               </a:ext>
             </a:extLst>
           </p:cNvPr>
@@ -10015,7 +10015,7 @@
           <p:cNvPr id="24" name="Rechteck 23">
             <a:extLst>
               <a:ext uri="{FF2B5EF4-FFF2-40B4-BE49-F238E27FC236}">
-                <a16:creationId xmlns:a16="http://schemas.microsoft.com/office/drawing/2014/main" id="{57705D47-6413-BE7D-3A80-3F47F0F60609}"/>
+                <a16:creationId xmlns:a16="http://schemas.microsoft.com/office/drawing/2014/main" id="{02B5316B-907C-7FC3-6A8E-6481DE086563}"/>
               </a:ext>
             </a:extLst>
           </p:cNvPr>
@@ -10069,7 +10069,7 @@
           <p:cNvPr id="25" name="Rechteck 24">
             <a:extLst>
               <a:ext uri="{FF2B5EF4-FFF2-40B4-BE49-F238E27FC236}">
-                <a16:creationId xmlns:a16="http://schemas.microsoft.com/office/drawing/2014/main" id="{9E3FB5E9-3770-15A5-5423-57DEAB81466A}"/>
+                <a16:creationId xmlns:a16="http://schemas.microsoft.com/office/drawing/2014/main" id="{45BB7BF7-3262-2BF7-AE02-513BB0A5C50E}"/>
               </a:ext>
             </a:extLst>
           </p:cNvPr>
@@ -10123,7 +10123,7 @@
           <p:cNvPr id="26" name="Rechteck 25">
             <a:extLst>
               <a:ext uri="{FF2B5EF4-FFF2-40B4-BE49-F238E27FC236}">
-                <a16:creationId xmlns:a16="http://schemas.microsoft.com/office/drawing/2014/main" id="{4E67E647-0686-4F58-53EB-FC329A2368B3}"/>
+                <a16:creationId xmlns:a16="http://schemas.microsoft.com/office/drawing/2014/main" id="{15D36BC2-D209-A278-1D4F-E598014BD137}"/>
               </a:ext>
             </a:extLst>
           </p:cNvPr>
@@ -10177,7 +10177,7 @@
           <p:cNvPr id="27" name="Rechteck 26">
             <a:extLst>
               <a:ext uri="{FF2B5EF4-FFF2-40B4-BE49-F238E27FC236}">
-                <a16:creationId xmlns:a16="http://schemas.microsoft.com/office/drawing/2014/main" id="{2A667062-EA58-D764-896A-DABB5DE53348}"/>
+                <a16:creationId xmlns:a16="http://schemas.microsoft.com/office/drawing/2014/main" id="{FAECDDB4-787D-1E6E-9404-BD7EC60C5857}"/>
               </a:ext>
             </a:extLst>
           </p:cNvPr>
@@ -10231,7 +10231,7 @@
           <p:cNvPr id="28" name="Rechteck 27">
             <a:extLst>
               <a:ext uri="{FF2B5EF4-FFF2-40B4-BE49-F238E27FC236}">
-                <a16:creationId xmlns:a16="http://schemas.microsoft.com/office/drawing/2014/main" id="{121710C8-A7F1-6228-DF76-B37F3BB14123}"/>
+                <a16:creationId xmlns:a16="http://schemas.microsoft.com/office/drawing/2014/main" id="{8E4004F9-76B9-16AB-CC11-2479AB1C8D23}"/>
               </a:ext>
             </a:extLst>
           </p:cNvPr>
@@ -10285,7 +10285,7 @@
           <p:cNvPr id="29" name="Rechteck 28">
             <a:extLst>
               <a:ext uri="{FF2B5EF4-FFF2-40B4-BE49-F238E27FC236}">
-                <a16:creationId xmlns:a16="http://schemas.microsoft.com/office/drawing/2014/main" id="{E4DA01BE-AECA-4A99-3DDF-1D098CA735E4}"/>
+                <a16:creationId xmlns:a16="http://schemas.microsoft.com/office/drawing/2014/main" id="{309462DE-4F61-4207-767A-8CAB3974AD36}"/>
               </a:ext>
             </a:extLst>
           </p:cNvPr>
@@ -10339,7 +10339,7 @@
           <p:cNvPr id="30" name="Rechteck 29">
             <a:extLst>
               <a:ext uri="{FF2B5EF4-FFF2-40B4-BE49-F238E27FC236}">
-                <a16:creationId xmlns:a16="http://schemas.microsoft.com/office/drawing/2014/main" id="{535FAA6F-B631-2C7C-30C3-95C281F94C8E}"/>
+                <a16:creationId xmlns:a16="http://schemas.microsoft.com/office/drawing/2014/main" id="{A6DD338B-E610-1C6F-1FD7-D81EEAC94D33}"/>
               </a:ext>
             </a:extLst>
           </p:cNvPr>
@@ -10393,7 +10393,7 @@
           <p:cNvPr id="31" name="Rechteck 30">
             <a:extLst>
               <a:ext uri="{FF2B5EF4-FFF2-40B4-BE49-F238E27FC236}">
-                <a16:creationId xmlns:a16="http://schemas.microsoft.com/office/drawing/2014/main" id="{AF4743D5-F7BB-56F3-1AF4-55632A0CFA63}"/>
+                <a16:creationId xmlns:a16="http://schemas.microsoft.com/office/drawing/2014/main" id="{1CB9D3AD-C14C-24E3-1C61-ECE22A8A481E}"/>
               </a:ext>
             </a:extLst>
           </p:cNvPr>
@@ -10447,7 +10447,7 @@
           <p:cNvPr id="32" name="Rechteck 31">
             <a:extLst>
               <a:ext uri="{FF2B5EF4-FFF2-40B4-BE49-F238E27FC236}">
-                <a16:creationId xmlns:a16="http://schemas.microsoft.com/office/drawing/2014/main" id="{AA75C936-428C-062C-C5E3-3C9611911A98}"/>
+                <a16:creationId xmlns:a16="http://schemas.microsoft.com/office/drawing/2014/main" id="{301385C6-3782-CA66-7148-74879B924026}"/>
               </a:ext>
             </a:extLst>
           </p:cNvPr>
@@ -10501,7 +10501,7 @@
           <p:cNvPr id="33" name="Rechteck 32">
             <a:extLst>
               <a:ext uri="{FF2B5EF4-FFF2-40B4-BE49-F238E27FC236}">
-                <a16:creationId xmlns:a16="http://schemas.microsoft.com/office/drawing/2014/main" id="{B8ADC72E-B5F5-C98A-4886-4FE8EB645076}"/>
+                <a16:creationId xmlns:a16="http://schemas.microsoft.com/office/drawing/2014/main" id="{08AA7338-0BAA-FDA7-1BDE-C8AE87765A03}"/>
               </a:ext>
             </a:extLst>
           </p:cNvPr>
@@ -10555,7 +10555,7 @@
           <p:cNvPr id="34" name="Rechteck 33">
             <a:extLst>
               <a:ext uri="{FF2B5EF4-FFF2-40B4-BE49-F238E27FC236}">
-                <a16:creationId xmlns:a16="http://schemas.microsoft.com/office/drawing/2014/main" id="{6F7F9A40-601C-C0E3-B373-86B19E004533}"/>
+                <a16:creationId xmlns:a16="http://schemas.microsoft.com/office/drawing/2014/main" id="{4B63D2AC-1322-A4C1-9D86-D8A70FDD75E8}"/>
               </a:ext>
             </a:extLst>
           </p:cNvPr>
@@ -10609,7 +10609,7 @@
           <p:cNvPr id="35" name="Rechteck 34">
             <a:extLst>
               <a:ext uri="{FF2B5EF4-FFF2-40B4-BE49-F238E27FC236}">
-                <a16:creationId xmlns:a16="http://schemas.microsoft.com/office/drawing/2014/main" id="{7935D33B-50F6-AA68-32E1-660E2F48B279}"/>
+                <a16:creationId xmlns:a16="http://schemas.microsoft.com/office/drawing/2014/main" id="{BDC0A1FE-0580-0888-71C6-DB23B9B97419}"/>
               </a:ext>
             </a:extLst>
           </p:cNvPr>
@@ -10663,7 +10663,7 @@
           <p:cNvPr id="36" name="Rechteck 35">
             <a:extLst>
               <a:ext uri="{FF2B5EF4-FFF2-40B4-BE49-F238E27FC236}">
-                <a16:creationId xmlns:a16="http://schemas.microsoft.com/office/drawing/2014/main" id="{559A5A61-FBDD-BF6E-4213-4966A381394F}"/>
+                <a16:creationId xmlns:a16="http://schemas.microsoft.com/office/drawing/2014/main" id="{06839C9C-92EC-99BE-ACD5-70B41FEAB143}"/>
               </a:ext>
             </a:extLst>
           </p:cNvPr>
@@ -10717,7 +10717,7 @@
           <p:cNvPr id="37" name="Rechteck 36">
             <a:extLst>
               <a:ext uri="{FF2B5EF4-FFF2-40B4-BE49-F238E27FC236}">
-                <a16:creationId xmlns:a16="http://schemas.microsoft.com/office/drawing/2014/main" id="{59EC625E-BB41-6AC0-5854-6D3090EBBC38}"/>
+                <a16:creationId xmlns:a16="http://schemas.microsoft.com/office/drawing/2014/main" id="{DABBB52B-8B88-588E-8FE5-3970EF61E17F}"/>
               </a:ext>
             </a:extLst>
           </p:cNvPr>
@@ -10771,7 +10771,7 @@
           <p:cNvPr id="38" name="Rechteck 37">
             <a:extLst>
               <a:ext uri="{FF2B5EF4-FFF2-40B4-BE49-F238E27FC236}">
-                <a16:creationId xmlns:a16="http://schemas.microsoft.com/office/drawing/2014/main" id="{B9A18B94-D335-B21D-FC1C-4DEB3D63A4A7}"/>
+                <a16:creationId xmlns:a16="http://schemas.microsoft.com/office/drawing/2014/main" id="{3B7394B7-39DF-FEF1-4F74-77720C2330DD}"/>
               </a:ext>
             </a:extLst>
           </p:cNvPr>
@@ -10825,7 +10825,7 @@
           <p:cNvPr id="39" name="Rechteck 38">
             <a:extLst>
               <a:ext uri="{FF2B5EF4-FFF2-40B4-BE49-F238E27FC236}">
-                <a16:creationId xmlns:a16="http://schemas.microsoft.com/office/drawing/2014/main" id="{B53E340C-0402-440A-A1FC-4920428A8A6B}"/>
+                <a16:creationId xmlns:a16="http://schemas.microsoft.com/office/drawing/2014/main" id="{61B4DEAD-7EBB-033A-769A-38C0416BA911}"/>
               </a:ext>
             </a:extLst>
           </p:cNvPr>
@@ -10879,7 +10879,7 @@
           <p:cNvPr id="40" name="Rechteck 39">
             <a:extLst>
               <a:ext uri="{FF2B5EF4-FFF2-40B4-BE49-F238E27FC236}">
-                <a16:creationId xmlns:a16="http://schemas.microsoft.com/office/drawing/2014/main" id="{1871D4AE-CD3A-370D-2D59-2652BD08694E}"/>
+                <a16:creationId xmlns:a16="http://schemas.microsoft.com/office/drawing/2014/main" id="{8FF61185-5B27-3845-74AC-A4BC790B2337}"/>
               </a:ext>
             </a:extLst>
           </p:cNvPr>
@@ -10933,7 +10933,7 @@
           <p:cNvPr id="41" name="Rechteck 40">
             <a:extLst>
               <a:ext uri="{FF2B5EF4-FFF2-40B4-BE49-F238E27FC236}">
-                <a16:creationId xmlns:a16="http://schemas.microsoft.com/office/drawing/2014/main" id="{66B6BAB7-9002-00E7-130C-FB1882498882}"/>
+                <a16:creationId xmlns:a16="http://schemas.microsoft.com/office/drawing/2014/main" id="{839C9535-E43E-04B9-2374-B0B466C59491}"/>
               </a:ext>
             </a:extLst>
           </p:cNvPr>
@@ -10987,7 +10987,7 @@
           <p:cNvPr id="42" name="Rechteck 41">
             <a:extLst>
               <a:ext uri="{FF2B5EF4-FFF2-40B4-BE49-F238E27FC236}">
-                <a16:creationId xmlns:a16="http://schemas.microsoft.com/office/drawing/2014/main" id="{69FD3C13-148F-7408-4ACD-5B0EC8DACA47}"/>
+                <a16:creationId xmlns:a16="http://schemas.microsoft.com/office/drawing/2014/main" id="{D31F4208-9609-52B0-9A1C-6E4EA706A2DD}"/>
               </a:ext>
             </a:extLst>
           </p:cNvPr>
@@ -11041,7 +11041,7 @@
           <p:cNvPr id="43" name="Rechteck 42">
             <a:extLst>
               <a:ext uri="{FF2B5EF4-FFF2-40B4-BE49-F238E27FC236}">
-                <a16:creationId xmlns:a16="http://schemas.microsoft.com/office/drawing/2014/main" id="{93C6F8C5-8AFA-19D1-4A26-2158D123AF7A}"/>
+                <a16:creationId xmlns:a16="http://schemas.microsoft.com/office/drawing/2014/main" id="{73D02342-D992-9720-5628-5A5E6462DB23}"/>
               </a:ext>
             </a:extLst>
           </p:cNvPr>
@@ -11095,7 +11095,7 @@
           <p:cNvPr id="44" name="Rechteck 43">
             <a:extLst>
               <a:ext uri="{FF2B5EF4-FFF2-40B4-BE49-F238E27FC236}">
-                <a16:creationId xmlns:a16="http://schemas.microsoft.com/office/drawing/2014/main" id="{0D7BEEF3-586A-10C6-E762-BE62BDDECCE4}"/>
+                <a16:creationId xmlns:a16="http://schemas.microsoft.com/office/drawing/2014/main" id="{A741B15A-2203-DC77-BB5F-017B5FCD1691}"/>
               </a:ext>
             </a:extLst>
           </p:cNvPr>
@@ -11149,7 +11149,7 @@
           <p:cNvPr id="45" name="Rechteck 44">
             <a:extLst>
               <a:ext uri="{FF2B5EF4-FFF2-40B4-BE49-F238E27FC236}">
-                <a16:creationId xmlns:a16="http://schemas.microsoft.com/office/drawing/2014/main" id="{647616C8-9E6D-083F-8BED-4E97D033B8EF}"/>
+                <a16:creationId xmlns:a16="http://schemas.microsoft.com/office/drawing/2014/main" id="{F17768AD-CC07-F88A-1D42-2FC21181FC1C}"/>
               </a:ext>
             </a:extLst>
           </p:cNvPr>
@@ -11203,7 +11203,7 @@
           <p:cNvPr id="46" name="Rechteck 45">
             <a:extLst>
               <a:ext uri="{FF2B5EF4-FFF2-40B4-BE49-F238E27FC236}">
-                <a16:creationId xmlns:a16="http://schemas.microsoft.com/office/drawing/2014/main" id="{B2E92038-7B35-A27A-812B-DCAA6C241E2A}"/>
+                <a16:creationId xmlns:a16="http://schemas.microsoft.com/office/drawing/2014/main" id="{85E9D43C-5D49-7E8C-602E-589882F843ED}"/>
               </a:ext>
             </a:extLst>
           </p:cNvPr>
@@ -11257,7 +11257,7 @@
           <p:cNvPr id="47" name="Rechteck 46">
             <a:extLst>
               <a:ext uri="{FF2B5EF4-FFF2-40B4-BE49-F238E27FC236}">
-                <a16:creationId xmlns:a16="http://schemas.microsoft.com/office/drawing/2014/main" id="{0B1B5149-161F-4AC3-C461-C392D28B77AE}"/>
+                <a16:creationId xmlns:a16="http://schemas.microsoft.com/office/drawing/2014/main" id="{F388A2F2-AD77-0C75-D6E5-4196BD49B6FC}"/>
               </a:ext>
             </a:extLst>
           </p:cNvPr>
@@ -11311,7 +11311,7 @@
           <p:cNvPr id="48" name="Rechteck 47">
             <a:extLst>
               <a:ext uri="{FF2B5EF4-FFF2-40B4-BE49-F238E27FC236}">
-                <a16:creationId xmlns:a16="http://schemas.microsoft.com/office/drawing/2014/main" id="{72772527-DAE0-8B7B-0BA2-A56BBF25D66A}"/>
+                <a16:creationId xmlns:a16="http://schemas.microsoft.com/office/drawing/2014/main" id="{FC553382-AE3C-93E7-90E6-7FD98326DB0E}"/>
               </a:ext>
             </a:extLst>
           </p:cNvPr>
@@ -11365,7 +11365,7 @@
           <p:cNvPr id="49" name="Rechteck 48">
             <a:extLst>
               <a:ext uri="{FF2B5EF4-FFF2-40B4-BE49-F238E27FC236}">
-                <a16:creationId xmlns:a16="http://schemas.microsoft.com/office/drawing/2014/main" id="{9319254C-24D9-8390-25BB-89CFA4F04C78}"/>
+                <a16:creationId xmlns:a16="http://schemas.microsoft.com/office/drawing/2014/main" id="{4006DE0B-E893-E61B-9890-0A5240369E74}"/>
               </a:ext>
             </a:extLst>
           </p:cNvPr>
@@ -11419,7 +11419,7 @@
           <p:cNvPr id="50" name="Rechteck 49">
             <a:extLst>
               <a:ext uri="{FF2B5EF4-FFF2-40B4-BE49-F238E27FC236}">
-                <a16:creationId xmlns:a16="http://schemas.microsoft.com/office/drawing/2014/main" id="{5FAA4020-6841-3B5C-9BCD-54C33AF61C66}"/>
+                <a16:creationId xmlns:a16="http://schemas.microsoft.com/office/drawing/2014/main" id="{15AB441F-9802-32C4-B8E8-07F6371F53AB}"/>
               </a:ext>
             </a:extLst>
           </p:cNvPr>
@@ -11473,7 +11473,7 @@
           <p:cNvPr id="51" name="Rechteck 50">
             <a:extLst>
               <a:ext uri="{FF2B5EF4-FFF2-40B4-BE49-F238E27FC236}">
-                <a16:creationId xmlns:a16="http://schemas.microsoft.com/office/drawing/2014/main" id="{C361CA68-259C-10EC-5362-E1261F43257F}"/>
+                <a16:creationId xmlns:a16="http://schemas.microsoft.com/office/drawing/2014/main" id="{4090E9B5-2DB1-785C-284F-A3864B91E931}"/>
               </a:ext>
             </a:extLst>
           </p:cNvPr>
@@ -11527,7 +11527,7 @@
           <p:cNvPr id="52" name="Rechteck 51">
             <a:extLst>
               <a:ext uri="{FF2B5EF4-FFF2-40B4-BE49-F238E27FC236}">
-                <a16:creationId xmlns:a16="http://schemas.microsoft.com/office/drawing/2014/main" id="{3270C2A2-161E-9102-5A40-B54FAF375A13}"/>
+                <a16:creationId xmlns:a16="http://schemas.microsoft.com/office/drawing/2014/main" id="{D19EA74C-4802-2E14-A66E-5DB5B86557B7}"/>
               </a:ext>
             </a:extLst>
           </p:cNvPr>
@@ -11581,7 +11581,7 @@
           <p:cNvPr id="53" name="Rechteck 52">
             <a:extLst>
               <a:ext uri="{FF2B5EF4-FFF2-40B4-BE49-F238E27FC236}">
-                <a16:creationId xmlns:a16="http://schemas.microsoft.com/office/drawing/2014/main" id="{57FD3F57-261F-0400-4E35-D1251EEFDE13}"/>
+                <a16:creationId xmlns:a16="http://schemas.microsoft.com/office/drawing/2014/main" id="{B4B14F7B-73D0-246E-BFD5-4198F105D712}"/>
               </a:ext>
             </a:extLst>
           </p:cNvPr>
@@ -11635,7 +11635,7 @@
           <p:cNvPr id="54" name="Rechteck 53">
             <a:extLst>
               <a:ext uri="{FF2B5EF4-FFF2-40B4-BE49-F238E27FC236}">
-                <a16:creationId xmlns:a16="http://schemas.microsoft.com/office/drawing/2014/main" id="{8722DFAD-70E1-7326-1CEA-864C0CEC1058}"/>
+                <a16:creationId xmlns:a16="http://schemas.microsoft.com/office/drawing/2014/main" id="{FCEDAA9C-F3AB-9BB4-7D06-D91C5314B401}"/>
               </a:ext>
             </a:extLst>
           </p:cNvPr>
@@ -11689,7 +11689,7 @@
           <p:cNvPr id="55" name="Rechteck 54">
             <a:extLst>
               <a:ext uri="{FF2B5EF4-FFF2-40B4-BE49-F238E27FC236}">
-                <a16:creationId xmlns:a16="http://schemas.microsoft.com/office/drawing/2014/main" id="{23128A7F-7845-DE64-ACA8-FE11847E33F3}"/>
+                <a16:creationId xmlns:a16="http://schemas.microsoft.com/office/drawing/2014/main" id="{278AFE67-CC9E-E138-DC72-B5F254B4E8B9}"/>
               </a:ext>
             </a:extLst>
           </p:cNvPr>
@@ -11741,7 +11741,7 @@
     </p:spTree>
     <p:extLst>
       <p:ext uri="{BB962C8B-B14F-4D97-AF65-F5344CB8AC3E}">
-        <p14:creationId xmlns:p14="http://schemas.microsoft.com/office/powerpoint/2010/main" val="3333149842"/>
+        <p14:creationId xmlns:p14="http://schemas.microsoft.com/office/powerpoint/2010/main" val="707699369"/>
       </p:ext>
     </p:extLst>
   </p:cSld>

</xml_diff>

<commit_message>
Render SmartArt from its drawing part; add the diagrams test deck
SmartArt graphic frames are rendered from the diagramDrawing part that
PowerPoint stores next to the data model (dsp:dataModelExt relId), using
the shape pipeline including txXfrm text rectangles. The generator opens a
minimized window for galleries that need one and builds a diagrams deck
with SmartArt and four chart types.

Co-Authored-By: Claude Opus 5.5 <noreply@anthropic.com>
</commit_message>
<xml_diff>
--- a/tests/corpus/pptx/generated/fills.pptx
+++ b/tests/corpus/pptx/generated/fills.pptx
@@ -132,7 +132,7 @@
           <p:cNvPr id="2" name="Titel 1">
             <a:extLst>
               <a:ext uri="{FF2B5EF4-FFF2-40B4-BE49-F238E27FC236}">
-                <a16:creationId xmlns:a16="http://schemas.microsoft.com/office/drawing/2014/main" id="{66191F4E-AEA4-6B06-0DD5-572D705A449E}"/>
+                <a16:creationId xmlns:a16="http://schemas.microsoft.com/office/drawing/2014/main" id="{2C166149-2F60-4923-ED1D-F8E40890BE4D}"/>
               </a:ext>
             </a:extLst>
           </p:cNvPr>
@@ -169,7 +169,7 @@
           <p:cNvPr id="3" name="Untertitel 2">
             <a:extLst>
               <a:ext uri="{FF2B5EF4-FFF2-40B4-BE49-F238E27FC236}">
-                <a16:creationId xmlns:a16="http://schemas.microsoft.com/office/drawing/2014/main" id="{AD650281-78FF-2630-E427-21843544B329}"/>
+                <a16:creationId xmlns:a16="http://schemas.microsoft.com/office/drawing/2014/main" id="{A290A0ED-E1A6-27C0-5C64-B62581515FFB}"/>
               </a:ext>
             </a:extLst>
           </p:cNvPr>
@@ -239,7 +239,7 @@
           <p:cNvPr id="4" name="Datumsplatzhalter 3">
             <a:extLst>
               <a:ext uri="{FF2B5EF4-FFF2-40B4-BE49-F238E27FC236}">
-                <a16:creationId xmlns:a16="http://schemas.microsoft.com/office/drawing/2014/main" id="{929A6C3B-8D1A-E4DB-0617-636EF69FCFC8}"/>
+                <a16:creationId xmlns:a16="http://schemas.microsoft.com/office/drawing/2014/main" id="{FA510E59-7922-2182-9557-50BA54BCB619}"/>
               </a:ext>
             </a:extLst>
           </p:cNvPr>
@@ -255,7 +255,7 @@
           <a:bodyPr/>
           <a:lstStyle/>
           <a:p>
-            <a:fld id="{4C7194E1-7AB7-4C19-9A54-266CF35DBFE8}" type="datetimeFigureOut">
+            <a:fld id="{F8AB83D3-BC2C-4CF0-8442-23AD7380E14D}" type="datetimeFigureOut">
               <a:rPr lang="de-DE" smtClean="0"/>
               <a:t>08.10.2026</a:t>
             </a:fld>
@@ -268,7 +268,7 @@
           <p:cNvPr id="5" name="Fußzeilenplatzhalter 4">
             <a:extLst>
               <a:ext uri="{FF2B5EF4-FFF2-40B4-BE49-F238E27FC236}">
-                <a16:creationId xmlns:a16="http://schemas.microsoft.com/office/drawing/2014/main" id="{12E627DC-B86B-8CA2-7C32-AE8AF5A1DF06}"/>
+                <a16:creationId xmlns:a16="http://schemas.microsoft.com/office/drawing/2014/main" id="{9DA9B653-AE66-5AA8-A5B5-206F008BD3FB}"/>
               </a:ext>
             </a:extLst>
           </p:cNvPr>
@@ -293,7 +293,7 @@
           <p:cNvPr id="6" name="Foliennummernplatzhalter 5">
             <a:extLst>
               <a:ext uri="{FF2B5EF4-FFF2-40B4-BE49-F238E27FC236}">
-                <a16:creationId xmlns:a16="http://schemas.microsoft.com/office/drawing/2014/main" id="{7266DEBF-C742-8962-AA55-0BCE42860EF4}"/>
+                <a16:creationId xmlns:a16="http://schemas.microsoft.com/office/drawing/2014/main" id="{26866728-40C0-95D5-563C-D241E62BABDB}"/>
               </a:ext>
             </a:extLst>
           </p:cNvPr>
@@ -309,7 +309,7 @@
           <a:bodyPr/>
           <a:lstStyle/>
           <a:p>
-            <a:fld id="{3F5CA287-20CA-4900-B098-91820305D6F1}" type="slidenum">
+            <a:fld id="{D8A1E73B-8462-46D5-B753-7B8FEC9C3BF8}" type="slidenum">
               <a:rPr lang="de-DE" smtClean="0"/>
               <a:t>‹Nr.›</a:t>
             </a:fld>
@@ -320,7 +320,7 @@
     </p:spTree>
     <p:extLst>
       <p:ext uri="{BB962C8B-B14F-4D97-AF65-F5344CB8AC3E}">
-        <p14:creationId xmlns:p14="http://schemas.microsoft.com/office/powerpoint/2010/main" val="2110307179"/>
+        <p14:creationId xmlns:p14="http://schemas.microsoft.com/office/powerpoint/2010/main" val="1474340614"/>
       </p:ext>
     </p:extLst>
   </p:cSld>
@@ -352,7 +352,7 @@
           <p:cNvPr id="2" name="Titel 1">
             <a:extLst>
               <a:ext uri="{FF2B5EF4-FFF2-40B4-BE49-F238E27FC236}">
-                <a16:creationId xmlns:a16="http://schemas.microsoft.com/office/drawing/2014/main" id="{BBFCF058-0656-252B-D878-008054076483}"/>
+                <a16:creationId xmlns:a16="http://schemas.microsoft.com/office/drawing/2014/main" id="{527B6E20-C379-5EF5-6040-AF30ED0E08A5}"/>
               </a:ext>
             </a:extLst>
           </p:cNvPr>
@@ -380,7 +380,7 @@
           <p:cNvPr id="3" name="Vertikaler Textplatzhalter 2">
             <a:extLst>
               <a:ext uri="{FF2B5EF4-FFF2-40B4-BE49-F238E27FC236}">
-                <a16:creationId xmlns:a16="http://schemas.microsoft.com/office/drawing/2014/main" id="{27CAF2AE-8C4C-AC5D-677A-0923A19DBC9A}"/>
+                <a16:creationId xmlns:a16="http://schemas.microsoft.com/office/drawing/2014/main" id="{F148E1BF-8012-7B35-4894-A97E715A9079}"/>
               </a:ext>
             </a:extLst>
           </p:cNvPr>
@@ -437,7 +437,7 @@
           <p:cNvPr id="4" name="Datumsplatzhalter 3">
             <a:extLst>
               <a:ext uri="{FF2B5EF4-FFF2-40B4-BE49-F238E27FC236}">
-                <a16:creationId xmlns:a16="http://schemas.microsoft.com/office/drawing/2014/main" id="{13CCC13B-F52D-C413-D759-8911217D94B6}"/>
+                <a16:creationId xmlns:a16="http://schemas.microsoft.com/office/drawing/2014/main" id="{374C3F25-313A-5FB0-CB0B-E32934E34AD1}"/>
               </a:ext>
             </a:extLst>
           </p:cNvPr>
@@ -453,7 +453,7 @@
           <a:bodyPr/>
           <a:lstStyle/>
           <a:p>
-            <a:fld id="{4C7194E1-7AB7-4C19-9A54-266CF35DBFE8}" type="datetimeFigureOut">
+            <a:fld id="{F8AB83D3-BC2C-4CF0-8442-23AD7380E14D}" type="datetimeFigureOut">
               <a:rPr lang="de-DE" smtClean="0"/>
               <a:t>08.10.2026</a:t>
             </a:fld>
@@ -466,7 +466,7 @@
           <p:cNvPr id="5" name="Fußzeilenplatzhalter 4">
             <a:extLst>
               <a:ext uri="{FF2B5EF4-FFF2-40B4-BE49-F238E27FC236}">
-                <a16:creationId xmlns:a16="http://schemas.microsoft.com/office/drawing/2014/main" id="{8FC1F807-D362-FCE2-FD31-9AEB6A936B22}"/>
+                <a16:creationId xmlns:a16="http://schemas.microsoft.com/office/drawing/2014/main" id="{4B726185-938C-6197-6607-A14A1FFCBD83}"/>
               </a:ext>
             </a:extLst>
           </p:cNvPr>
@@ -491,7 +491,7 @@
           <p:cNvPr id="6" name="Foliennummernplatzhalter 5">
             <a:extLst>
               <a:ext uri="{FF2B5EF4-FFF2-40B4-BE49-F238E27FC236}">
-                <a16:creationId xmlns:a16="http://schemas.microsoft.com/office/drawing/2014/main" id="{2DB1AD06-37F2-4BD3-38EE-3934E27D3649}"/>
+                <a16:creationId xmlns:a16="http://schemas.microsoft.com/office/drawing/2014/main" id="{DCF89DD4-CDE0-DC77-74A6-A94C91889D0C}"/>
               </a:ext>
             </a:extLst>
           </p:cNvPr>
@@ -507,7 +507,7 @@
           <a:bodyPr/>
           <a:lstStyle/>
           <a:p>
-            <a:fld id="{3F5CA287-20CA-4900-B098-91820305D6F1}" type="slidenum">
+            <a:fld id="{D8A1E73B-8462-46D5-B753-7B8FEC9C3BF8}" type="slidenum">
               <a:rPr lang="de-DE" smtClean="0"/>
               <a:t>‹Nr.›</a:t>
             </a:fld>
@@ -518,7 +518,7 @@
     </p:spTree>
     <p:extLst>
       <p:ext uri="{BB962C8B-B14F-4D97-AF65-F5344CB8AC3E}">
-        <p14:creationId xmlns:p14="http://schemas.microsoft.com/office/powerpoint/2010/main" val="1364106735"/>
+        <p14:creationId xmlns:p14="http://schemas.microsoft.com/office/powerpoint/2010/main" val="355181156"/>
       </p:ext>
     </p:extLst>
   </p:cSld>
@@ -550,7 +550,7 @@
           <p:cNvPr id="2" name="Vertikaler Titel 1">
             <a:extLst>
               <a:ext uri="{FF2B5EF4-FFF2-40B4-BE49-F238E27FC236}">
-                <a16:creationId xmlns:a16="http://schemas.microsoft.com/office/drawing/2014/main" id="{1A214DEF-5C24-AF5C-DBA3-2CB1431CEDA3}"/>
+                <a16:creationId xmlns:a16="http://schemas.microsoft.com/office/drawing/2014/main" id="{9DAE2FE3-9D77-14CE-B17C-E1A7DA49907C}"/>
               </a:ext>
             </a:extLst>
           </p:cNvPr>
@@ -583,7 +583,7 @@
           <p:cNvPr id="3" name="Vertikaler Textplatzhalter 2">
             <a:extLst>
               <a:ext uri="{FF2B5EF4-FFF2-40B4-BE49-F238E27FC236}">
-                <a16:creationId xmlns:a16="http://schemas.microsoft.com/office/drawing/2014/main" id="{D8ADF3C7-7424-2462-10EA-55DEA9D8ABC1}"/>
+                <a16:creationId xmlns:a16="http://schemas.microsoft.com/office/drawing/2014/main" id="{D68302D5-59FC-14A4-7A5C-D07AA1F44F9B}"/>
               </a:ext>
             </a:extLst>
           </p:cNvPr>
@@ -645,7 +645,7 @@
           <p:cNvPr id="4" name="Datumsplatzhalter 3">
             <a:extLst>
               <a:ext uri="{FF2B5EF4-FFF2-40B4-BE49-F238E27FC236}">
-                <a16:creationId xmlns:a16="http://schemas.microsoft.com/office/drawing/2014/main" id="{B7968A58-B3F4-0B6B-9746-A6DF9EEEA50B}"/>
+                <a16:creationId xmlns:a16="http://schemas.microsoft.com/office/drawing/2014/main" id="{A1140C65-1064-5EB5-9C0F-2DB0436B72FF}"/>
               </a:ext>
             </a:extLst>
           </p:cNvPr>
@@ -661,7 +661,7 @@
           <a:bodyPr/>
           <a:lstStyle/>
           <a:p>
-            <a:fld id="{4C7194E1-7AB7-4C19-9A54-266CF35DBFE8}" type="datetimeFigureOut">
+            <a:fld id="{F8AB83D3-BC2C-4CF0-8442-23AD7380E14D}" type="datetimeFigureOut">
               <a:rPr lang="de-DE" smtClean="0"/>
               <a:t>08.10.2026</a:t>
             </a:fld>
@@ -674,7 +674,7 @@
           <p:cNvPr id="5" name="Fußzeilenplatzhalter 4">
             <a:extLst>
               <a:ext uri="{FF2B5EF4-FFF2-40B4-BE49-F238E27FC236}">
-                <a16:creationId xmlns:a16="http://schemas.microsoft.com/office/drawing/2014/main" id="{81B033E5-33AE-4316-5615-91D6C931DC64}"/>
+                <a16:creationId xmlns:a16="http://schemas.microsoft.com/office/drawing/2014/main" id="{991D84E6-C6E6-AAEE-31ED-C11DB9D2A87D}"/>
               </a:ext>
             </a:extLst>
           </p:cNvPr>
@@ -699,7 +699,7 @@
           <p:cNvPr id="6" name="Foliennummernplatzhalter 5">
             <a:extLst>
               <a:ext uri="{FF2B5EF4-FFF2-40B4-BE49-F238E27FC236}">
-                <a16:creationId xmlns:a16="http://schemas.microsoft.com/office/drawing/2014/main" id="{C65DFAF6-84CE-4462-DB2A-3A819102CD1A}"/>
+                <a16:creationId xmlns:a16="http://schemas.microsoft.com/office/drawing/2014/main" id="{1A46B592-01A5-BB1F-B66C-7FA6FCC2DB9B}"/>
               </a:ext>
             </a:extLst>
           </p:cNvPr>
@@ -715,7 +715,7 @@
           <a:bodyPr/>
           <a:lstStyle/>
           <a:p>
-            <a:fld id="{3F5CA287-20CA-4900-B098-91820305D6F1}" type="slidenum">
+            <a:fld id="{D8A1E73B-8462-46D5-B753-7B8FEC9C3BF8}" type="slidenum">
               <a:rPr lang="de-DE" smtClean="0"/>
               <a:t>‹Nr.›</a:t>
             </a:fld>
@@ -726,7 +726,7 @@
     </p:spTree>
     <p:extLst>
       <p:ext uri="{BB962C8B-B14F-4D97-AF65-F5344CB8AC3E}">
-        <p14:creationId xmlns:p14="http://schemas.microsoft.com/office/powerpoint/2010/main" val="1790565892"/>
+        <p14:creationId xmlns:p14="http://schemas.microsoft.com/office/powerpoint/2010/main" val="909784453"/>
       </p:ext>
     </p:extLst>
   </p:cSld>
@@ -758,7 +758,7 @@
           <p:cNvPr id="2" name="Titel 1">
             <a:extLst>
               <a:ext uri="{FF2B5EF4-FFF2-40B4-BE49-F238E27FC236}">
-                <a16:creationId xmlns:a16="http://schemas.microsoft.com/office/drawing/2014/main" id="{A0A7E916-8FB0-A648-D8C4-DA5A7F36A9DC}"/>
+                <a16:creationId xmlns:a16="http://schemas.microsoft.com/office/drawing/2014/main" id="{CD7B1799-F2DC-EFF8-D82C-9E3F029784B3}"/>
               </a:ext>
             </a:extLst>
           </p:cNvPr>
@@ -786,7 +786,7 @@
           <p:cNvPr id="3" name="Inhaltsplatzhalter 2">
             <a:extLst>
               <a:ext uri="{FF2B5EF4-FFF2-40B4-BE49-F238E27FC236}">
-                <a16:creationId xmlns:a16="http://schemas.microsoft.com/office/drawing/2014/main" id="{0355CB40-6B0B-6774-06BC-F4819C3A7996}"/>
+                <a16:creationId xmlns:a16="http://schemas.microsoft.com/office/drawing/2014/main" id="{A40DAA67-F189-B989-1239-2295DA1A4900}"/>
               </a:ext>
             </a:extLst>
           </p:cNvPr>
@@ -843,7 +843,7 @@
           <p:cNvPr id="4" name="Datumsplatzhalter 3">
             <a:extLst>
               <a:ext uri="{FF2B5EF4-FFF2-40B4-BE49-F238E27FC236}">
-                <a16:creationId xmlns:a16="http://schemas.microsoft.com/office/drawing/2014/main" id="{858CA0B2-7330-23CC-5C38-81F798721680}"/>
+                <a16:creationId xmlns:a16="http://schemas.microsoft.com/office/drawing/2014/main" id="{3A05D0D1-6A47-6D49-C8F2-20A7008BFF12}"/>
               </a:ext>
             </a:extLst>
           </p:cNvPr>
@@ -859,7 +859,7 @@
           <a:bodyPr/>
           <a:lstStyle/>
           <a:p>
-            <a:fld id="{4C7194E1-7AB7-4C19-9A54-266CF35DBFE8}" type="datetimeFigureOut">
+            <a:fld id="{F8AB83D3-BC2C-4CF0-8442-23AD7380E14D}" type="datetimeFigureOut">
               <a:rPr lang="de-DE" smtClean="0"/>
               <a:t>08.10.2026</a:t>
             </a:fld>
@@ -872,7 +872,7 @@
           <p:cNvPr id="5" name="Fußzeilenplatzhalter 4">
             <a:extLst>
               <a:ext uri="{FF2B5EF4-FFF2-40B4-BE49-F238E27FC236}">
-                <a16:creationId xmlns:a16="http://schemas.microsoft.com/office/drawing/2014/main" id="{6B66A987-0CE1-3923-3EAB-4ECF96A69EB6}"/>
+                <a16:creationId xmlns:a16="http://schemas.microsoft.com/office/drawing/2014/main" id="{CB295411-D8F5-667B-D8C3-F70703FB2D02}"/>
               </a:ext>
             </a:extLst>
           </p:cNvPr>
@@ -897,7 +897,7 @@
           <p:cNvPr id="6" name="Foliennummernplatzhalter 5">
             <a:extLst>
               <a:ext uri="{FF2B5EF4-FFF2-40B4-BE49-F238E27FC236}">
-                <a16:creationId xmlns:a16="http://schemas.microsoft.com/office/drawing/2014/main" id="{E6F50F90-F197-2506-6836-37666C556924}"/>
+                <a16:creationId xmlns:a16="http://schemas.microsoft.com/office/drawing/2014/main" id="{6E0940B7-5220-5AD0-12C3-F6CF9F891231}"/>
               </a:ext>
             </a:extLst>
           </p:cNvPr>
@@ -913,7 +913,7 @@
           <a:bodyPr/>
           <a:lstStyle/>
           <a:p>
-            <a:fld id="{3F5CA287-20CA-4900-B098-91820305D6F1}" type="slidenum">
+            <a:fld id="{D8A1E73B-8462-46D5-B753-7B8FEC9C3BF8}" type="slidenum">
               <a:rPr lang="de-DE" smtClean="0"/>
               <a:t>‹Nr.›</a:t>
             </a:fld>
@@ -924,7 +924,7 @@
     </p:spTree>
     <p:extLst>
       <p:ext uri="{BB962C8B-B14F-4D97-AF65-F5344CB8AC3E}">
-        <p14:creationId xmlns:p14="http://schemas.microsoft.com/office/powerpoint/2010/main" val="2322048722"/>
+        <p14:creationId xmlns:p14="http://schemas.microsoft.com/office/powerpoint/2010/main" val="1523688311"/>
       </p:ext>
     </p:extLst>
   </p:cSld>
@@ -956,7 +956,7 @@
           <p:cNvPr id="2" name="Titel 1">
             <a:extLst>
               <a:ext uri="{FF2B5EF4-FFF2-40B4-BE49-F238E27FC236}">
-                <a16:creationId xmlns:a16="http://schemas.microsoft.com/office/drawing/2014/main" id="{A81DC526-F238-A986-B453-67F6B9C36670}"/>
+                <a16:creationId xmlns:a16="http://schemas.microsoft.com/office/drawing/2014/main" id="{66EE1524-5DAA-8E45-C289-7F4C75A7E723}"/>
               </a:ext>
             </a:extLst>
           </p:cNvPr>
@@ -993,7 +993,7 @@
           <p:cNvPr id="3" name="Textplatzhalter 2">
             <a:extLst>
               <a:ext uri="{FF2B5EF4-FFF2-40B4-BE49-F238E27FC236}">
-                <a16:creationId xmlns:a16="http://schemas.microsoft.com/office/drawing/2014/main" id="{923362D9-2472-6956-F2E4-6260A8CF61A8}"/>
+                <a16:creationId xmlns:a16="http://schemas.microsoft.com/office/drawing/2014/main" id="{CCD5643B-B0B1-ED87-F586-73090AD69E58}"/>
               </a:ext>
             </a:extLst>
           </p:cNvPr>
@@ -1118,7 +1118,7 @@
           <p:cNvPr id="4" name="Datumsplatzhalter 3">
             <a:extLst>
               <a:ext uri="{FF2B5EF4-FFF2-40B4-BE49-F238E27FC236}">
-                <a16:creationId xmlns:a16="http://schemas.microsoft.com/office/drawing/2014/main" id="{0D4EF427-15C4-896E-29A8-9C6A780CA2CD}"/>
+                <a16:creationId xmlns:a16="http://schemas.microsoft.com/office/drawing/2014/main" id="{0087CAA9-850C-0769-14A2-0040AF33244B}"/>
               </a:ext>
             </a:extLst>
           </p:cNvPr>
@@ -1134,7 +1134,7 @@
           <a:bodyPr/>
           <a:lstStyle/>
           <a:p>
-            <a:fld id="{4C7194E1-7AB7-4C19-9A54-266CF35DBFE8}" type="datetimeFigureOut">
+            <a:fld id="{F8AB83D3-BC2C-4CF0-8442-23AD7380E14D}" type="datetimeFigureOut">
               <a:rPr lang="de-DE" smtClean="0"/>
               <a:t>08.10.2026</a:t>
             </a:fld>
@@ -1147,7 +1147,7 @@
           <p:cNvPr id="5" name="Fußzeilenplatzhalter 4">
             <a:extLst>
               <a:ext uri="{FF2B5EF4-FFF2-40B4-BE49-F238E27FC236}">
-                <a16:creationId xmlns:a16="http://schemas.microsoft.com/office/drawing/2014/main" id="{5AA2E6B4-7F4A-0942-1C5D-68B2F01DDB23}"/>
+                <a16:creationId xmlns:a16="http://schemas.microsoft.com/office/drawing/2014/main" id="{3EE58204-5A50-F8D5-664D-C43056E8BBCB}"/>
               </a:ext>
             </a:extLst>
           </p:cNvPr>
@@ -1172,7 +1172,7 @@
           <p:cNvPr id="6" name="Foliennummernplatzhalter 5">
             <a:extLst>
               <a:ext uri="{FF2B5EF4-FFF2-40B4-BE49-F238E27FC236}">
-                <a16:creationId xmlns:a16="http://schemas.microsoft.com/office/drawing/2014/main" id="{6BDADBC9-B5BB-3DA4-DB1A-EE63F69DF62C}"/>
+                <a16:creationId xmlns:a16="http://schemas.microsoft.com/office/drawing/2014/main" id="{7D5FFFEE-05F3-AB34-30D3-56E177469219}"/>
               </a:ext>
             </a:extLst>
           </p:cNvPr>
@@ -1188,7 +1188,7 @@
           <a:bodyPr/>
           <a:lstStyle/>
           <a:p>
-            <a:fld id="{3F5CA287-20CA-4900-B098-91820305D6F1}" type="slidenum">
+            <a:fld id="{D8A1E73B-8462-46D5-B753-7B8FEC9C3BF8}" type="slidenum">
               <a:rPr lang="de-DE" smtClean="0"/>
               <a:t>‹Nr.›</a:t>
             </a:fld>
@@ -1199,7 +1199,7 @@
     </p:spTree>
     <p:extLst>
       <p:ext uri="{BB962C8B-B14F-4D97-AF65-F5344CB8AC3E}">
-        <p14:creationId xmlns:p14="http://schemas.microsoft.com/office/powerpoint/2010/main" val="1125983611"/>
+        <p14:creationId xmlns:p14="http://schemas.microsoft.com/office/powerpoint/2010/main" val="2684425195"/>
       </p:ext>
     </p:extLst>
   </p:cSld>
@@ -1231,7 +1231,7 @@
           <p:cNvPr id="2" name="Titel 1">
             <a:extLst>
               <a:ext uri="{FF2B5EF4-FFF2-40B4-BE49-F238E27FC236}">
-                <a16:creationId xmlns:a16="http://schemas.microsoft.com/office/drawing/2014/main" id="{E4567FCA-D5CE-286A-557C-418E5B5221A5}"/>
+                <a16:creationId xmlns:a16="http://schemas.microsoft.com/office/drawing/2014/main" id="{C86045C0-FE0A-16AF-5281-BA7B5F1CA3CE}"/>
               </a:ext>
             </a:extLst>
           </p:cNvPr>
@@ -1259,7 +1259,7 @@
           <p:cNvPr id="3" name="Inhaltsplatzhalter 2">
             <a:extLst>
               <a:ext uri="{FF2B5EF4-FFF2-40B4-BE49-F238E27FC236}">
-                <a16:creationId xmlns:a16="http://schemas.microsoft.com/office/drawing/2014/main" id="{89981859-22DC-3806-8A5B-136140EE1F57}"/>
+                <a16:creationId xmlns:a16="http://schemas.microsoft.com/office/drawing/2014/main" id="{001AED2B-C774-0DB0-55FA-DC693C5C3CA4}"/>
               </a:ext>
             </a:extLst>
           </p:cNvPr>
@@ -1321,7 +1321,7 @@
           <p:cNvPr id="4" name="Inhaltsplatzhalter 3">
             <a:extLst>
               <a:ext uri="{FF2B5EF4-FFF2-40B4-BE49-F238E27FC236}">
-                <a16:creationId xmlns:a16="http://schemas.microsoft.com/office/drawing/2014/main" id="{0A8B5ABB-3E75-91FE-A52C-823EEF76D1E8}"/>
+                <a16:creationId xmlns:a16="http://schemas.microsoft.com/office/drawing/2014/main" id="{9BD51BA9-0EAF-0FFC-E754-EFC1FD889311}"/>
               </a:ext>
             </a:extLst>
           </p:cNvPr>
@@ -1383,7 +1383,7 @@
           <p:cNvPr id="5" name="Datumsplatzhalter 4">
             <a:extLst>
               <a:ext uri="{FF2B5EF4-FFF2-40B4-BE49-F238E27FC236}">
-                <a16:creationId xmlns:a16="http://schemas.microsoft.com/office/drawing/2014/main" id="{FD8DADF6-7C1A-AF0F-D5A0-9624340B6210}"/>
+                <a16:creationId xmlns:a16="http://schemas.microsoft.com/office/drawing/2014/main" id="{DAFDA207-8B20-996E-16F6-752BF016C66A}"/>
               </a:ext>
             </a:extLst>
           </p:cNvPr>
@@ -1399,7 +1399,7 @@
           <a:bodyPr/>
           <a:lstStyle/>
           <a:p>
-            <a:fld id="{4C7194E1-7AB7-4C19-9A54-266CF35DBFE8}" type="datetimeFigureOut">
+            <a:fld id="{F8AB83D3-BC2C-4CF0-8442-23AD7380E14D}" type="datetimeFigureOut">
               <a:rPr lang="de-DE" smtClean="0"/>
               <a:t>08.10.2026</a:t>
             </a:fld>
@@ -1412,7 +1412,7 @@
           <p:cNvPr id="6" name="Fußzeilenplatzhalter 5">
             <a:extLst>
               <a:ext uri="{FF2B5EF4-FFF2-40B4-BE49-F238E27FC236}">
-                <a16:creationId xmlns:a16="http://schemas.microsoft.com/office/drawing/2014/main" id="{E8B3AE04-8F35-836C-34A5-C313EFC83E5A}"/>
+                <a16:creationId xmlns:a16="http://schemas.microsoft.com/office/drawing/2014/main" id="{855D57FC-A12D-7D25-CC1D-104B4A376E64}"/>
               </a:ext>
             </a:extLst>
           </p:cNvPr>
@@ -1437,7 +1437,7 @@
           <p:cNvPr id="7" name="Foliennummernplatzhalter 6">
             <a:extLst>
               <a:ext uri="{FF2B5EF4-FFF2-40B4-BE49-F238E27FC236}">
-                <a16:creationId xmlns:a16="http://schemas.microsoft.com/office/drawing/2014/main" id="{35132FB6-4631-3F6C-4A21-BDD7EACCF6CF}"/>
+                <a16:creationId xmlns:a16="http://schemas.microsoft.com/office/drawing/2014/main" id="{3DC45300-C698-1B46-04B0-5942A130046B}"/>
               </a:ext>
             </a:extLst>
           </p:cNvPr>
@@ -1453,7 +1453,7 @@
           <a:bodyPr/>
           <a:lstStyle/>
           <a:p>
-            <a:fld id="{3F5CA287-20CA-4900-B098-91820305D6F1}" type="slidenum">
+            <a:fld id="{D8A1E73B-8462-46D5-B753-7B8FEC9C3BF8}" type="slidenum">
               <a:rPr lang="de-DE" smtClean="0"/>
               <a:t>‹Nr.›</a:t>
             </a:fld>
@@ -1464,7 +1464,7 @@
     </p:spTree>
     <p:extLst>
       <p:ext uri="{BB962C8B-B14F-4D97-AF65-F5344CB8AC3E}">
-        <p14:creationId xmlns:p14="http://schemas.microsoft.com/office/powerpoint/2010/main" val="3709209841"/>
+        <p14:creationId xmlns:p14="http://schemas.microsoft.com/office/powerpoint/2010/main" val="1356790354"/>
       </p:ext>
     </p:extLst>
   </p:cSld>
@@ -1496,7 +1496,7 @@
           <p:cNvPr id="2" name="Titel 1">
             <a:extLst>
               <a:ext uri="{FF2B5EF4-FFF2-40B4-BE49-F238E27FC236}">
-                <a16:creationId xmlns:a16="http://schemas.microsoft.com/office/drawing/2014/main" id="{23448C9D-B356-DEFD-5133-0D6C1EADB275}"/>
+                <a16:creationId xmlns:a16="http://schemas.microsoft.com/office/drawing/2014/main" id="{CFCC3E11-4DDE-61A1-B557-7135F31324BB}"/>
               </a:ext>
             </a:extLst>
           </p:cNvPr>
@@ -1529,7 +1529,7 @@
           <p:cNvPr id="3" name="Textplatzhalter 2">
             <a:extLst>
               <a:ext uri="{FF2B5EF4-FFF2-40B4-BE49-F238E27FC236}">
-                <a16:creationId xmlns:a16="http://schemas.microsoft.com/office/drawing/2014/main" id="{1306E3BF-F263-4A70-5366-867174FF5B9D}"/>
+                <a16:creationId xmlns:a16="http://schemas.microsoft.com/office/drawing/2014/main" id="{36D42721-D6AD-1453-0053-6E9AA1D8AD5D}"/>
               </a:ext>
             </a:extLst>
           </p:cNvPr>
@@ -1600,7 +1600,7 @@
           <p:cNvPr id="4" name="Inhaltsplatzhalter 3">
             <a:extLst>
               <a:ext uri="{FF2B5EF4-FFF2-40B4-BE49-F238E27FC236}">
-                <a16:creationId xmlns:a16="http://schemas.microsoft.com/office/drawing/2014/main" id="{5FE20B62-2967-C117-D603-ADF109A5BFB0}"/>
+                <a16:creationId xmlns:a16="http://schemas.microsoft.com/office/drawing/2014/main" id="{5DA60A22-0266-AE3A-1ACA-255E78D3CA98}"/>
               </a:ext>
             </a:extLst>
           </p:cNvPr>
@@ -1662,7 +1662,7 @@
           <p:cNvPr id="5" name="Textplatzhalter 4">
             <a:extLst>
               <a:ext uri="{FF2B5EF4-FFF2-40B4-BE49-F238E27FC236}">
-                <a16:creationId xmlns:a16="http://schemas.microsoft.com/office/drawing/2014/main" id="{E4244A20-C60D-4B11-D588-1D7EFC05247D}"/>
+                <a16:creationId xmlns:a16="http://schemas.microsoft.com/office/drawing/2014/main" id="{9D97F21F-AAF8-7995-DB93-37221B62CA1B}"/>
               </a:ext>
             </a:extLst>
           </p:cNvPr>
@@ -1733,7 +1733,7 @@
           <p:cNvPr id="6" name="Inhaltsplatzhalter 5">
             <a:extLst>
               <a:ext uri="{FF2B5EF4-FFF2-40B4-BE49-F238E27FC236}">
-                <a16:creationId xmlns:a16="http://schemas.microsoft.com/office/drawing/2014/main" id="{8143390E-8AF8-9ED9-A3DC-84A273BCF1F2}"/>
+                <a16:creationId xmlns:a16="http://schemas.microsoft.com/office/drawing/2014/main" id="{AFDE57A3-68DA-4452-EBAC-E97504C7D634}"/>
               </a:ext>
             </a:extLst>
           </p:cNvPr>
@@ -1795,7 +1795,7 @@
           <p:cNvPr id="7" name="Datumsplatzhalter 6">
             <a:extLst>
               <a:ext uri="{FF2B5EF4-FFF2-40B4-BE49-F238E27FC236}">
-                <a16:creationId xmlns:a16="http://schemas.microsoft.com/office/drawing/2014/main" id="{F3019029-9CBF-8AFA-7B6E-75BA63B9D4AA}"/>
+                <a16:creationId xmlns:a16="http://schemas.microsoft.com/office/drawing/2014/main" id="{8F759CFF-708D-83AC-8E38-47CDE3CF3D6D}"/>
               </a:ext>
             </a:extLst>
           </p:cNvPr>
@@ -1811,7 +1811,7 @@
           <a:bodyPr/>
           <a:lstStyle/>
           <a:p>
-            <a:fld id="{4C7194E1-7AB7-4C19-9A54-266CF35DBFE8}" type="datetimeFigureOut">
+            <a:fld id="{F8AB83D3-BC2C-4CF0-8442-23AD7380E14D}" type="datetimeFigureOut">
               <a:rPr lang="de-DE" smtClean="0"/>
               <a:t>08.10.2026</a:t>
             </a:fld>
@@ -1824,7 +1824,7 @@
           <p:cNvPr id="8" name="Fußzeilenplatzhalter 7">
             <a:extLst>
               <a:ext uri="{FF2B5EF4-FFF2-40B4-BE49-F238E27FC236}">
-                <a16:creationId xmlns:a16="http://schemas.microsoft.com/office/drawing/2014/main" id="{4DC5B713-77E6-EA4A-5EB8-675429042654}"/>
+                <a16:creationId xmlns:a16="http://schemas.microsoft.com/office/drawing/2014/main" id="{5B293E60-765B-598C-0B2E-DE1AB0F73961}"/>
               </a:ext>
             </a:extLst>
           </p:cNvPr>
@@ -1849,7 +1849,7 @@
           <p:cNvPr id="9" name="Foliennummernplatzhalter 8">
             <a:extLst>
               <a:ext uri="{FF2B5EF4-FFF2-40B4-BE49-F238E27FC236}">
-                <a16:creationId xmlns:a16="http://schemas.microsoft.com/office/drawing/2014/main" id="{BDA722E5-9343-4BB5-BD63-D853F02201BC}"/>
+                <a16:creationId xmlns:a16="http://schemas.microsoft.com/office/drawing/2014/main" id="{3CB8C5D7-513A-B329-9491-0C32D971129E}"/>
               </a:ext>
             </a:extLst>
           </p:cNvPr>
@@ -1865,7 +1865,7 @@
           <a:bodyPr/>
           <a:lstStyle/>
           <a:p>
-            <a:fld id="{3F5CA287-20CA-4900-B098-91820305D6F1}" type="slidenum">
+            <a:fld id="{D8A1E73B-8462-46D5-B753-7B8FEC9C3BF8}" type="slidenum">
               <a:rPr lang="de-DE" smtClean="0"/>
               <a:t>‹Nr.›</a:t>
             </a:fld>
@@ -1876,7 +1876,7 @@
     </p:spTree>
     <p:extLst>
       <p:ext uri="{BB962C8B-B14F-4D97-AF65-F5344CB8AC3E}">
-        <p14:creationId xmlns:p14="http://schemas.microsoft.com/office/powerpoint/2010/main" val="1377641394"/>
+        <p14:creationId xmlns:p14="http://schemas.microsoft.com/office/powerpoint/2010/main" val="1720144878"/>
       </p:ext>
     </p:extLst>
   </p:cSld>
@@ -1908,7 +1908,7 @@
           <p:cNvPr id="2" name="Titel 1">
             <a:extLst>
               <a:ext uri="{FF2B5EF4-FFF2-40B4-BE49-F238E27FC236}">
-                <a16:creationId xmlns:a16="http://schemas.microsoft.com/office/drawing/2014/main" id="{E2D4B9F7-D593-D2A4-8D80-904722150FB7}"/>
+                <a16:creationId xmlns:a16="http://schemas.microsoft.com/office/drawing/2014/main" id="{535D97B1-9107-0049-A505-A1C84C2FCB3B}"/>
               </a:ext>
             </a:extLst>
           </p:cNvPr>
@@ -1936,7 +1936,7 @@
           <p:cNvPr id="3" name="Datumsplatzhalter 2">
             <a:extLst>
               <a:ext uri="{FF2B5EF4-FFF2-40B4-BE49-F238E27FC236}">
-                <a16:creationId xmlns:a16="http://schemas.microsoft.com/office/drawing/2014/main" id="{C6D4F4E5-EDFC-56C5-4520-5D12D7DBA581}"/>
+                <a16:creationId xmlns:a16="http://schemas.microsoft.com/office/drawing/2014/main" id="{21FC2A93-C471-2BFB-EA7B-AD987A968D7D}"/>
               </a:ext>
             </a:extLst>
           </p:cNvPr>
@@ -1952,7 +1952,7 @@
           <a:bodyPr/>
           <a:lstStyle/>
           <a:p>
-            <a:fld id="{4C7194E1-7AB7-4C19-9A54-266CF35DBFE8}" type="datetimeFigureOut">
+            <a:fld id="{F8AB83D3-BC2C-4CF0-8442-23AD7380E14D}" type="datetimeFigureOut">
               <a:rPr lang="de-DE" smtClean="0"/>
               <a:t>08.10.2026</a:t>
             </a:fld>
@@ -1965,7 +1965,7 @@
           <p:cNvPr id="4" name="Fußzeilenplatzhalter 3">
             <a:extLst>
               <a:ext uri="{FF2B5EF4-FFF2-40B4-BE49-F238E27FC236}">
-                <a16:creationId xmlns:a16="http://schemas.microsoft.com/office/drawing/2014/main" id="{EC6D54C4-81AD-55E2-54E0-F7A3A3D71CC0}"/>
+                <a16:creationId xmlns:a16="http://schemas.microsoft.com/office/drawing/2014/main" id="{626B7255-3D2A-E460-6B24-BD1C27A15ADF}"/>
               </a:ext>
             </a:extLst>
           </p:cNvPr>
@@ -1990,7 +1990,7 @@
           <p:cNvPr id="5" name="Foliennummernplatzhalter 4">
             <a:extLst>
               <a:ext uri="{FF2B5EF4-FFF2-40B4-BE49-F238E27FC236}">
-                <a16:creationId xmlns:a16="http://schemas.microsoft.com/office/drawing/2014/main" id="{EA089E82-E86D-CB27-5B48-D704A87225B8}"/>
+                <a16:creationId xmlns:a16="http://schemas.microsoft.com/office/drawing/2014/main" id="{B484EED7-2F45-F6DC-7D87-E25F0D7FE631}"/>
               </a:ext>
             </a:extLst>
           </p:cNvPr>
@@ -2006,7 +2006,7 @@
           <a:bodyPr/>
           <a:lstStyle/>
           <a:p>
-            <a:fld id="{3F5CA287-20CA-4900-B098-91820305D6F1}" type="slidenum">
+            <a:fld id="{D8A1E73B-8462-46D5-B753-7B8FEC9C3BF8}" type="slidenum">
               <a:rPr lang="de-DE" smtClean="0"/>
               <a:t>‹Nr.›</a:t>
             </a:fld>
@@ -2017,7 +2017,7 @@
     </p:spTree>
     <p:extLst>
       <p:ext uri="{BB962C8B-B14F-4D97-AF65-F5344CB8AC3E}">
-        <p14:creationId xmlns:p14="http://schemas.microsoft.com/office/powerpoint/2010/main" val="2151551906"/>
+        <p14:creationId xmlns:p14="http://schemas.microsoft.com/office/powerpoint/2010/main" val="1115708081"/>
       </p:ext>
     </p:extLst>
   </p:cSld>
@@ -2049,7 +2049,7 @@
           <p:cNvPr id="2" name="Datumsplatzhalter 1">
             <a:extLst>
               <a:ext uri="{FF2B5EF4-FFF2-40B4-BE49-F238E27FC236}">
-                <a16:creationId xmlns:a16="http://schemas.microsoft.com/office/drawing/2014/main" id="{7588B3F3-3DD7-91D1-D2F6-986A52646E90}"/>
+                <a16:creationId xmlns:a16="http://schemas.microsoft.com/office/drawing/2014/main" id="{E469939C-4735-0251-0D1B-789B5C2887AE}"/>
               </a:ext>
             </a:extLst>
           </p:cNvPr>
@@ -2065,7 +2065,7 @@
           <a:bodyPr/>
           <a:lstStyle/>
           <a:p>
-            <a:fld id="{4C7194E1-7AB7-4C19-9A54-266CF35DBFE8}" type="datetimeFigureOut">
+            <a:fld id="{F8AB83D3-BC2C-4CF0-8442-23AD7380E14D}" type="datetimeFigureOut">
               <a:rPr lang="de-DE" smtClean="0"/>
               <a:t>08.10.2026</a:t>
             </a:fld>
@@ -2078,7 +2078,7 @@
           <p:cNvPr id="3" name="Fußzeilenplatzhalter 2">
             <a:extLst>
               <a:ext uri="{FF2B5EF4-FFF2-40B4-BE49-F238E27FC236}">
-                <a16:creationId xmlns:a16="http://schemas.microsoft.com/office/drawing/2014/main" id="{14825694-2935-D4B1-A058-E909CA0D17CE}"/>
+                <a16:creationId xmlns:a16="http://schemas.microsoft.com/office/drawing/2014/main" id="{6CCA356D-A255-0D21-5BF0-8FDAE9E50BBF}"/>
               </a:ext>
             </a:extLst>
           </p:cNvPr>
@@ -2103,7 +2103,7 @@
           <p:cNvPr id="4" name="Foliennummernplatzhalter 3">
             <a:extLst>
               <a:ext uri="{FF2B5EF4-FFF2-40B4-BE49-F238E27FC236}">
-                <a16:creationId xmlns:a16="http://schemas.microsoft.com/office/drawing/2014/main" id="{C7BDB84E-0880-137E-3203-DD2CDD4DA66B}"/>
+                <a16:creationId xmlns:a16="http://schemas.microsoft.com/office/drawing/2014/main" id="{0F547C47-4936-32F4-3282-DE735E418182}"/>
               </a:ext>
             </a:extLst>
           </p:cNvPr>
@@ -2119,7 +2119,7 @@
           <a:bodyPr/>
           <a:lstStyle/>
           <a:p>
-            <a:fld id="{3F5CA287-20CA-4900-B098-91820305D6F1}" type="slidenum">
+            <a:fld id="{D8A1E73B-8462-46D5-B753-7B8FEC9C3BF8}" type="slidenum">
               <a:rPr lang="de-DE" smtClean="0"/>
               <a:t>‹Nr.›</a:t>
             </a:fld>
@@ -2130,7 +2130,7 @@
     </p:spTree>
     <p:extLst>
       <p:ext uri="{BB962C8B-B14F-4D97-AF65-F5344CB8AC3E}">
-        <p14:creationId xmlns:p14="http://schemas.microsoft.com/office/powerpoint/2010/main" val="117301101"/>
+        <p14:creationId xmlns:p14="http://schemas.microsoft.com/office/powerpoint/2010/main" val="1197738100"/>
       </p:ext>
     </p:extLst>
   </p:cSld>
@@ -2162,7 +2162,7 @@
           <p:cNvPr id="2" name="Titel 1">
             <a:extLst>
               <a:ext uri="{FF2B5EF4-FFF2-40B4-BE49-F238E27FC236}">
-                <a16:creationId xmlns:a16="http://schemas.microsoft.com/office/drawing/2014/main" id="{DB5250B2-63E9-6D3C-AAB1-0E0B797D6980}"/>
+                <a16:creationId xmlns:a16="http://schemas.microsoft.com/office/drawing/2014/main" id="{DD3E2EF6-A0E6-DCB9-B16C-140AA39B7091}"/>
               </a:ext>
             </a:extLst>
           </p:cNvPr>
@@ -2199,7 +2199,7 @@
           <p:cNvPr id="3" name="Inhaltsplatzhalter 2">
             <a:extLst>
               <a:ext uri="{FF2B5EF4-FFF2-40B4-BE49-F238E27FC236}">
-                <a16:creationId xmlns:a16="http://schemas.microsoft.com/office/drawing/2014/main" id="{286CA438-D308-2054-8BDB-418017F1AD9D}"/>
+                <a16:creationId xmlns:a16="http://schemas.microsoft.com/office/drawing/2014/main" id="{1C0374B0-32F0-60A8-9E77-7B67FAB7A086}"/>
               </a:ext>
             </a:extLst>
           </p:cNvPr>
@@ -2289,7 +2289,7 @@
           <p:cNvPr id="4" name="Textplatzhalter 3">
             <a:extLst>
               <a:ext uri="{FF2B5EF4-FFF2-40B4-BE49-F238E27FC236}">
-                <a16:creationId xmlns:a16="http://schemas.microsoft.com/office/drawing/2014/main" id="{43EB7E59-D303-4087-13D4-FA60DC70685B}"/>
+                <a16:creationId xmlns:a16="http://schemas.microsoft.com/office/drawing/2014/main" id="{ED2172B0-A9FA-D170-C863-32EEEF762359}"/>
               </a:ext>
             </a:extLst>
           </p:cNvPr>
@@ -2360,7 +2360,7 @@
           <p:cNvPr id="5" name="Datumsplatzhalter 4">
             <a:extLst>
               <a:ext uri="{FF2B5EF4-FFF2-40B4-BE49-F238E27FC236}">
-                <a16:creationId xmlns:a16="http://schemas.microsoft.com/office/drawing/2014/main" id="{F881A944-B2F2-D039-07F8-48FEECA56AD1}"/>
+                <a16:creationId xmlns:a16="http://schemas.microsoft.com/office/drawing/2014/main" id="{2C74340F-6C8B-6F94-F809-4097A3027CF9}"/>
               </a:ext>
             </a:extLst>
           </p:cNvPr>
@@ -2376,7 +2376,7 @@
           <a:bodyPr/>
           <a:lstStyle/>
           <a:p>
-            <a:fld id="{4C7194E1-7AB7-4C19-9A54-266CF35DBFE8}" type="datetimeFigureOut">
+            <a:fld id="{F8AB83D3-BC2C-4CF0-8442-23AD7380E14D}" type="datetimeFigureOut">
               <a:rPr lang="de-DE" smtClean="0"/>
               <a:t>08.10.2026</a:t>
             </a:fld>
@@ -2389,7 +2389,7 @@
           <p:cNvPr id="6" name="Fußzeilenplatzhalter 5">
             <a:extLst>
               <a:ext uri="{FF2B5EF4-FFF2-40B4-BE49-F238E27FC236}">
-                <a16:creationId xmlns:a16="http://schemas.microsoft.com/office/drawing/2014/main" id="{B6214B85-A1DD-35BF-607F-019A45BE7D7A}"/>
+                <a16:creationId xmlns:a16="http://schemas.microsoft.com/office/drawing/2014/main" id="{BB7B877A-D98C-E185-8E7D-78806FBBC7F4}"/>
               </a:ext>
             </a:extLst>
           </p:cNvPr>
@@ -2414,7 +2414,7 @@
           <p:cNvPr id="7" name="Foliennummernplatzhalter 6">
             <a:extLst>
               <a:ext uri="{FF2B5EF4-FFF2-40B4-BE49-F238E27FC236}">
-                <a16:creationId xmlns:a16="http://schemas.microsoft.com/office/drawing/2014/main" id="{4321588B-AB77-7BDA-5D63-F57390D12210}"/>
+                <a16:creationId xmlns:a16="http://schemas.microsoft.com/office/drawing/2014/main" id="{FEE648E3-FE43-DB1C-11C2-5B700458824C}"/>
               </a:ext>
             </a:extLst>
           </p:cNvPr>
@@ -2430,7 +2430,7 @@
           <a:bodyPr/>
           <a:lstStyle/>
           <a:p>
-            <a:fld id="{3F5CA287-20CA-4900-B098-91820305D6F1}" type="slidenum">
+            <a:fld id="{D8A1E73B-8462-46D5-B753-7B8FEC9C3BF8}" type="slidenum">
               <a:rPr lang="de-DE" smtClean="0"/>
               <a:t>‹Nr.›</a:t>
             </a:fld>
@@ -2441,7 +2441,7 @@
     </p:spTree>
     <p:extLst>
       <p:ext uri="{BB962C8B-B14F-4D97-AF65-F5344CB8AC3E}">
-        <p14:creationId xmlns:p14="http://schemas.microsoft.com/office/powerpoint/2010/main" val="1478921003"/>
+        <p14:creationId xmlns:p14="http://schemas.microsoft.com/office/powerpoint/2010/main" val="2465815018"/>
       </p:ext>
     </p:extLst>
   </p:cSld>
@@ -2473,7 +2473,7 @@
           <p:cNvPr id="2" name="Titel 1">
             <a:extLst>
               <a:ext uri="{FF2B5EF4-FFF2-40B4-BE49-F238E27FC236}">
-                <a16:creationId xmlns:a16="http://schemas.microsoft.com/office/drawing/2014/main" id="{B07376AC-F71E-7450-0C91-5866CDA6815C}"/>
+                <a16:creationId xmlns:a16="http://schemas.microsoft.com/office/drawing/2014/main" id="{BC663A40-679D-B361-4539-D0F90E26D946}"/>
               </a:ext>
             </a:extLst>
           </p:cNvPr>
@@ -2510,7 +2510,7 @@
           <p:cNvPr id="3" name="Bildplatzhalter 2">
             <a:extLst>
               <a:ext uri="{FF2B5EF4-FFF2-40B4-BE49-F238E27FC236}">
-                <a16:creationId xmlns:a16="http://schemas.microsoft.com/office/drawing/2014/main" id="{B23E7106-85D4-C19C-CC5C-E269B354906A}"/>
+                <a16:creationId xmlns:a16="http://schemas.microsoft.com/office/drawing/2014/main" id="{564E3AC2-C6EB-9523-8A23-060388BEF020}"/>
               </a:ext>
             </a:extLst>
           </p:cNvPr>
@@ -2577,7 +2577,7 @@
           <p:cNvPr id="4" name="Textplatzhalter 3">
             <a:extLst>
               <a:ext uri="{FF2B5EF4-FFF2-40B4-BE49-F238E27FC236}">
-                <a16:creationId xmlns:a16="http://schemas.microsoft.com/office/drawing/2014/main" id="{C03F093B-9B76-167E-571B-C0B352B77D00}"/>
+                <a16:creationId xmlns:a16="http://schemas.microsoft.com/office/drawing/2014/main" id="{54F0592F-82F8-B45D-D04C-7E260050E280}"/>
               </a:ext>
             </a:extLst>
           </p:cNvPr>
@@ -2648,7 +2648,7 @@
           <p:cNvPr id="5" name="Datumsplatzhalter 4">
             <a:extLst>
               <a:ext uri="{FF2B5EF4-FFF2-40B4-BE49-F238E27FC236}">
-                <a16:creationId xmlns:a16="http://schemas.microsoft.com/office/drawing/2014/main" id="{3B510934-46D6-F719-BE9C-24E88B50F5EE}"/>
+                <a16:creationId xmlns:a16="http://schemas.microsoft.com/office/drawing/2014/main" id="{52C9E760-F0F7-C60C-4F06-D027E47A96AF}"/>
               </a:ext>
             </a:extLst>
           </p:cNvPr>
@@ -2664,7 +2664,7 @@
           <a:bodyPr/>
           <a:lstStyle/>
           <a:p>
-            <a:fld id="{4C7194E1-7AB7-4C19-9A54-266CF35DBFE8}" type="datetimeFigureOut">
+            <a:fld id="{F8AB83D3-BC2C-4CF0-8442-23AD7380E14D}" type="datetimeFigureOut">
               <a:rPr lang="de-DE" smtClean="0"/>
               <a:t>08.10.2026</a:t>
             </a:fld>
@@ -2677,7 +2677,7 @@
           <p:cNvPr id="6" name="Fußzeilenplatzhalter 5">
             <a:extLst>
               <a:ext uri="{FF2B5EF4-FFF2-40B4-BE49-F238E27FC236}">
-                <a16:creationId xmlns:a16="http://schemas.microsoft.com/office/drawing/2014/main" id="{7D2E9DD9-99CD-D5C7-1AE9-C8C7481EA48F}"/>
+                <a16:creationId xmlns:a16="http://schemas.microsoft.com/office/drawing/2014/main" id="{68C938D2-7C9A-07B7-1114-89371D2A1DFF}"/>
               </a:ext>
             </a:extLst>
           </p:cNvPr>
@@ -2702,7 +2702,7 @@
           <p:cNvPr id="7" name="Foliennummernplatzhalter 6">
             <a:extLst>
               <a:ext uri="{FF2B5EF4-FFF2-40B4-BE49-F238E27FC236}">
-                <a16:creationId xmlns:a16="http://schemas.microsoft.com/office/drawing/2014/main" id="{3BAFCF1E-7892-3153-A89A-59BE395B4847}"/>
+                <a16:creationId xmlns:a16="http://schemas.microsoft.com/office/drawing/2014/main" id="{25C0879F-F50F-4CF9-3EAF-5102DF929611}"/>
               </a:ext>
             </a:extLst>
           </p:cNvPr>
@@ -2718,7 +2718,7 @@
           <a:bodyPr/>
           <a:lstStyle/>
           <a:p>
-            <a:fld id="{3F5CA287-20CA-4900-B098-91820305D6F1}" type="slidenum">
+            <a:fld id="{D8A1E73B-8462-46D5-B753-7B8FEC9C3BF8}" type="slidenum">
               <a:rPr lang="de-DE" smtClean="0"/>
               <a:t>‹Nr.›</a:t>
             </a:fld>
@@ -2729,7 +2729,7 @@
     </p:spTree>
     <p:extLst>
       <p:ext uri="{BB962C8B-B14F-4D97-AF65-F5344CB8AC3E}">
-        <p14:creationId xmlns:p14="http://schemas.microsoft.com/office/powerpoint/2010/main" val="1485586642"/>
+        <p14:creationId xmlns:p14="http://schemas.microsoft.com/office/powerpoint/2010/main" val="2569619025"/>
       </p:ext>
     </p:extLst>
   </p:cSld>
@@ -2766,7 +2766,7 @@
           <p:cNvPr id="2" name="Titelplatzhalter 1">
             <a:extLst>
               <a:ext uri="{FF2B5EF4-FFF2-40B4-BE49-F238E27FC236}">
-                <a16:creationId xmlns:a16="http://schemas.microsoft.com/office/drawing/2014/main" id="{8A9D3CE0-41A1-AAC8-2DFD-428C5FD72D80}"/>
+                <a16:creationId xmlns:a16="http://schemas.microsoft.com/office/drawing/2014/main" id="{A729012F-6749-FBE1-CD82-87CA51B210EC}"/>
               </a:ext>
             </a:extLst>
           </p:cNvPr>
@@ -2804,7 +2804,7 @@
           <p:cNvPr id="3" name="Textplatzhalter 2">
             <a:extLst>
               <a:ext uri="{FF2B5EF4-FFF2-40B4-BE49-F238E27FC236}">
-                <a16:creationId xmlns:a16="http://schemas.microsoft.com/office/drawing/2014/main" id="{658014A1-2E03-B14E-C29F-D9D8C2C270E4}"/>
+                <a16:creationId xmlns:a16="http://schemas.microsoft.com/office/drawing/2014/main" id="{18838E00-3F24-3C6F-6A65-03C25786AD5A}"/>
               </a:ext>
             </a:extLst>
           </p:cNvPr>
@@ -2871,7 +2871,7 @@
           <p:cNvPr id="4" name="Datumsplatzhalter 3">
             <a:extLst>
               <a:ext uri="{FF2B5EF4-FFF2-40B4-BE49-F238E27FC236}">
-                <a16:creationId xmlns:a16="http://schemas.microsoft.com/office/drawing/2014/main" id="{41F3F565-9B4B-960E-6683-EEECF87A2961}"/>
+                <a16:creationId xmlns:a16="http://schemas.microsoft.com/office/drawing/2014/main" id="{0A8EB782-D626-9D0F-A5F2-6999F08A1EF7}"/>
               </a:ext>
             </a:extLst>
           </p:cNvPr>
@@ -2905,7 +2905,7 @@
             </a:lvl1pPr>
           </a:lstStyle>
           <a:p>
-            <a:fld id="{4C7194E1-7AB7-4C19-9A54-266CF35DBFE8}" type="datetimeFigureOut">
+            <a:fld id="{F8AB83D3-BC2C-4CF0-8442-23AD7380E14D}" type="datetimeFigureOut">
               <a:rPr lang="de-DE" smtClean="0"/>
               <a:t>08.10.2026</a:t>
             </a:fld>
@@ -2918,7 +2918,7 @@
           <p:cNvPr id="5" name="Fußzeilenplatzhalter 4">
             <a:extLst>
               <a:ext uri="{FF2B5EF4-FFF2-40B4-BE49-F238E27FC236}">
-                <a16:creationId xmlns:a16="http://schemas.microsoft.com/office/drawing/2014/main" id="{C8995E8F-B409-8A80-5B3E-41F1997EBEEA}"/>
+                <a16:creationId xmlns:a16="http://schemas.microsoft.com/office/drawing/2014/main" id="{39211B3D-C611-B0DC-79FE-471B07FF2C32}"/>
               </a:ext>
             </a:extLst>
           </p:cNvPr>
@@ -2961,7 +2961,7 @@
           <p:cNvPr id="6" name="Foliennummernplatzhalter 5">
             <a:extLst>
               <a:ext uri="{FF2B5EF4-FFF2-40B4-BE49-F238E27FC236}">
-                <a16:creationId xmlns:a16="http://schemas.microsoft.com/office/drawing/2014/main" id="{3028A04F-EF09-6982-8287-1A4B22FF74D1}"/>
+                <a16:creationId xmlns:a16="http://schemas.microsoft.com/office/drawing/2014/main" id="{E89AF69A-0CC7-E8D6-AAC8-B0EB11A905C4}"/>
               </a:ext>
             </a:extLst>
           </p:cNvPr>
@@ -2995,7 +2995,7 @@
             </a:lvl1pPr>
           </a:lstStyle>
           <a:p>
-            <a:fld id="{3F5CA287-20CA-4900-B098-91820305D6F1}" type="slidenum">
+            <a:fld id="{D8A1E73B-8462-46D5-B753-7B8FEC9C3BF8}" type="slidenum">
               <a:rPr lang="de-DE" smtClean="0"/>
               <a:t>‹Nr.›</a:t>
             </a:fld>
@@ -3006,7 +3006,7 @@
     </p:spTree>
     <p:extLst>
       <p:ext uri="{BB962C8B-B14F-4D97-AF65-F5344CB8AC3E}">
-        <p14:creationId xmlns:p14="http://schemas.microsoft.com/office/powerpoint/2010/main" val="313370484"/>
+        <p14:creationId xmlns:p14="http://schemas.microsoft.com/office/powerpoint/2010/main" val="2083804732"/>
       </p:ext>
     </p:extLst>
   </p:cSld>
@@ -3329,7 +3329,7 @@
           <p:cNvPr id="2" name="Rechteck 1">
             <a:extLst>
               <a:ext uri="{FF2B5EF4-FFF2-40B4-BE49-F238E27FC236}">
-                <a16:creationId xmlns:a16="http://schemas.microsoft.com/office/drawing/2014/main" id="{5A6374CB-B874-C460-080E-93964B6A84C8}"/>
+                <a16:creationId xmlns:a16="http://schemas.microsoft.com/office/drawing/2014/main" id="{8F82B67F-664F-1E70-020E-E224EA3FB83F}"/>
               </a:ext>
             </a:extLst>
           </p:cNvPr>
@@ -3397,7 +3397,7 @@
           <p:cNvPr id="3" name="Rechteck 2">
             <a:extLst>
               <a:ext uri="{FF2B5EF4-FFF2-40B4-BE49-F238E27FC236}">
-                <a16:creationId xmlns:a16="http://schemas.microsoft.com/office/drawing/2014/main" id="{EE2AD4AF-7DB0-7E43-4749-5172F4F0C9B5}"/>
+                <a16:creationId xmlns:a16="http://schemas.microsoft.com/office/drawing/2014/main" id="{918331EA-4FEF-7890-000F-3BF68E16E101}"/>
               </a:ext>
             </a:extLst>
           </p:cNvPr>
@@ -3467,7 +3467,7 @@
           <p:cNvPr id="4" name="Rechteck 3">
             <a:extLst>
               <a:ext uri="{FF2B5EF4-FFF2-40B4-BE49-F238E27FC236}">
-                <a16:creationId xmlns:a16="http://schemas.microsoft.com/office/drawing/2014/main" id="{C158243E-6EDC-6780-4F88-05C26CB631FA}"/>
+                <a16:creationId xmlns:a16="http://schemas.microsoft.com/office/drawing/2014/main" id="{2C1CB7F8-012C-A469-E67C-BC3A00D9F61F}"/>
               </a:ext>
             </a:extLst>
           </p:cNvPr>
@@ -3537,7 +3537,7 @@
           <p:cNvPr id="5" name="Rechteck 4">
             <a:extLst>
               <a:ext uri="{FF2B5EF4-FFF2-40B4-BE49-F238E27FC236}">
-                <a16:creationId xmlns:a16="http://schemas.microsoft.com/office/drawing/2014/main" id="{3A87D0EB-CB4B-0D7D-7012-CAAA2B59FF0E}"/>
+                <a16:creationId xmlns:a16="http://schemas.microsoft.com/office/drawing/2014/main" id="{1BCD0FE8-ABEF-D13B-5105-DD87996D8A74}"/>
               </a:ext>
             </a:extLst>
           </p:cNvPr>
@@ -3605,7 +3605,7 @@
           <p:cNvPr id="6" name="Rechteck 5">
             <a:extLst>
               <a:ext uri="{FF2B5EF4-FFF2-40B4-BE49-F238E27FC236}">
-                <a16:creationId xmlns:a16="http://schemas.microsoft.com/office/drawing/2014/main" id="{F950A7EC-D584-18FF-8463-29618EF41ABC}"/>
+                <a16:creationId xmlns:a16="http://schemas.microsoft.com/office/drawing/2014/main" id="{14F36316-9CB9-1593-B094-DC90B473A9F8}"/>
               </a:ext>
             </a:extLst>
           </p:cNvPr>
@@ -3675,7 +3675,7 @@
           <p:cNvPr id="7" name="Rechteck 6">
             <a:extLst>
               <a:ext uri="{FF2B5EF4-FFF2-40B4-BE49-F238E27FC236}">
-                <a16:creationId xmlns:a16="http://schemas.microsoft.com/office/drawing/2014/main" id="{19463504-17D4-8C85-9848-EC9115ACABF6}"/>
+                <a16:creationId xmlns:a16="http://schemas.microsoft.com/office/drawing/2014/main" id="{5D077155-B8EB-94B0-C7BC-36ABAC4E8870}"/>
               </a:ext>
             </a:extLst>
           </p:cNvPr>
@@ -3745,7 +3745,7 @@
           <p:cNvPr id="8" name="Rechteck 7">
             <a:extLst>
               <a:ext uri="{FF2B5EF4-FFF2-40B4-BE49-F238E27FC236}">
-                <a16:creationId xmlns:a16="http://schemas.microsoft.com/office/drawing/2014/main" id="{B49EE488-BCCD-E143-8B5E-4D1B187BDCC2}"/>
+                <a16:creationId xmlns:a16="http://schemas.microsoft.com/office/drawing/2014/main" id="{EEBC623F-3DE9-AA36-A47D-02C23CCAD639}"/>
               </a:ext>
             </a:extLst>
           </p:cNvPr>
@@ -3813,7 +3813,7 @@
           <p:cNvPr id="9" name="Rechteck 8">
             <a:extLst>
               <a:ext uri="{FF2B5EF4-FFF2-40B4-BE49-F238E27FC236}">
-                <a16:creationId xmlns:a16="http://schemas.microsoft.com/office/drawing/2014/main" id="{A7499CDF-6BF9-E5E5-C654-A395034FCE1B}"/>
+                <a16:creationId xmlns:a16="http://schemas.microsoft.com/office/drawing/2014/main" id="{135AA081-CDAA-A6BD-58C5-6198E8D38CEA}"/>
               </a:ext>
             </a:extLst>
           </p:cNvPr>
@@ -3883,7 +3883,7 @@
           <p:cNvPr id="10" name="Rechteck 9">
             <a:extLst>
               <a:ext uri="{FF2B5EF4-FFF2-40B4-BE49-F238E27FC236}">
-                <a16:creationId xmlns:a16="http://schemas.microsoft.com/office/drawing/2014/main" id="{C15AF360-BEE9-7769-415C-CF3ADDAF8FF6}"/>
+                <a16:creationId xmlns:a16="http://schemas.microsoft.com/office/drawing/2014/main" id="{570DF6C1-C263-2BF2-21CF-418584C11FE1}"/>
               </a:ext>
             </a:extLst>
           </p:cNvPr>
@@ -3953,7 +3953,7 @@
           <p:cNvPr id="11" name="Rechteck 10">
             <a:extLst>
               <a:ext uri="{FF2B5EF4-FFF2-40B4-BE49-F238E27FC236}">
-                <a16:creationId xmlns:a16="http://schemas.microsoft.com/office/drawing/2014/main" id="{08B82BB4-1B8E-3485-74C5-05AD3455CEE8}"/>
+                <a16:creationId xmlns:a16="http://schemas.microsoft.com/office/drawing/2014/main" id="{A608A2D8-5157-5CD4-F8B7-19A3793094AD}"/>
               </a:ext>
             </a:extLst>
           </p:cNvPr>
@@ -4021,7 +4021,7 @@
           <p:cNvPr id="12" name="Rechteck 11">
             <a:extLst>
               <a:ext uri="{FF2B5EF4-FFF2-40B4-BE49-F238E27FC236}">
-                <a16:creationId xmlns:a16="http://schemas.microsoft.com/office/drawing/2014/main" id="{B05F71BA-F12C-F7DB-7060-722C6604195F}"/>
+                <a16:creationId xmlns:a16="http://schemas.microsoft.com/office/drawing/2014/main" id="{EEA5F517-A5F5-DCC9-3A65-061663868329}"/>
               </a:ext>
             </a:extLst>
           </p:cNvPr>
@@ -4091,7 +4091,7 @@
           <p:cNvPr id="13" name="Rechteck 12">
             <a:extLst>
               <a:ext uri="{FF2B5EF4-FFF2-40B4-BE49-F238E27FC236}">
-                <a16:creationId xmlns:a16="http://schemas.microsoft.com/office/drawing/2014/main" id="{A3FEF94F-09EA-73E9-C9A9-836E101573B3}"/>
+                <a16:creationId xmlns:a16="http://schemas.microsoft.com/office/drawing/2014/main" id="{4B4808EC-7F30-D900-4212-4680A05D8E33}"/>
               </a:ext>
             </a:extLst>
           </p:cNvPr>
@@ -4161,7 +4161,7 @@
           <p:cNvPr id="14" name="Rechteck 13">
             <a:extLst>
               <a:ext uri="{FF2B5EF4-FFF2-40B4-BE49-F238E27FC236}">
-                <a16:creationId xmlns:a16="http://schemas.microsoft.com/office/drawing/2014/main" id="{C6C49BF5-22D8-C3C4-0F38-8EACA4131039}"/>
+                <a16:creationId xmlns:a16="http://schemas.microsoft.com/office/drawing/2014/main" id="{88B88B33-8144-9C22-66A3-88A17959AA08}"/>
               </a:ext>
             </a:extLst>
           </p:cNvPr>
@@ -4229,7 +4229,7 @@
           <p:cNvPr id="15" name="Rechteck 14">
             <a:extLst>
               <a:ext uri="{FF2B5EF4-FFF2-40B4-BE49-F238E27FC236}">
-                <a16:creationId xmlns:a16="http://schemas.microsoft.com/office/drawing/2014/main" id="{817872A3-8A5D-7631-9125-B2B7735EF9BA}"/>
+                <a16:creationId xmlns:a16="http://schemas.microsoft.com/office/drawing/2014/main" id="{61B97EEB-B792-F1AB-75B9-A195AA8476CB}"/>
               </a:ext>
             </a:extLst>
           </p:cNvPr>
@@ -4299,7 +4299,7 @@
           <p:cNvPr id="16" name="Rechteck 15">
             <a:extLst>
               <a:ext uri="{FF2B5EF4-FFF2-40B4-BE49-F238E27FC236}">
-                <a16:creationId xmlns:a16="http://schemas.microsoft.com/office/drawing/2014/main" id="{4EBD3402-0505-AB66-CFE5-33CCA5502169}"/>
+                <a16:creationId xmlns:a16="http://schemas.microsoft.com/office/drawing/2014/main" id="{FFB37391-9D91-4A67-08D8-BA60CCA4CCAF}"/>
               </a:ext>
             </a:extLst>
           </p:cNvPr>
@@ -4369,7 +4369,7 @@
           <p:cNvPr id="17" name="Rechteck 16">
             <a:extLst>
               <a:ext uri="{FF2B5EF4-FFF2-40B4-BE49-F238E27FC236}">
-                <a16:creationId xmlns:a16="http://schemas.microsoft.com/office/drawing/2014/main" id="{88EC17CF-106D-FD60-548E-42CD006E2CF7}"/>
+                <a16:creationId xmlns:a16="http://schemas.microsoft.com/office/drawing/2014/main" id="{0EE5C8DF-2DD1-575C-B36D-763E4E3DF3B2}"/>
               </a:ext>
             </a:extLst>
           </p:cNvPr>
@@ -4437,7 +4437,7 @@
           <p:cNvPr id="18" name="Rechteck 17">
             <a:extLst>
               <a:ext uri="{FF2B5EF4-FFF2-40B4-BE49-F238E27FC236}">
-                <a16:creationId xmlns:a16="http://schemas.microsoft.com/office/drawing/2014/main" id="{EC780F75-5AA9-531D-AC61-0951E3BB4485}"/>
+                <a16:creationId xmlns:a16="http://schemas.microsoft.com/office/drawing/2014/main" id="{0B7A8A36-C93C-1B8B-8D94-60CECC632936}"/>
               </a:ext>
             </a:extLst>
           </p:cNvPr>
@@ -4507,7 +4507,7 @@
           <p:cNvPr id="19" name="Rechteck 18">
             <a:extLst>
               <a:ext uri="{FF2B5EF4-FFF2-40B4-BE49-F238E27FC236}">
-                <a16:creationId xmlns:a16="http://schemas.microsoft.com/office/drawing/2014/main" id="{B9A2EE3A-293C-12AE-27EF-C68553683751}"/>
+                <a16:creationId xmlns:a16="http://schemas.microsoft.com/office/drawing/2014/main" id="{3E14329B-52FA-C97F-37F4-49477B5C54D6}"/>
               </a:ext>
             </a:extLst>
           </p:cNvPr>
@@ -4575,7 +4575,7 @@
     </p:spTree>
     <p:extLst>
       <p:ext uri="{BB962C8B-B14F-4D97-AF65-F5344CB8AC3E}">
-        <p14:creationId xmlns:p14="http://schemas.microsoft.com/office/powerpoint/2010/main" val="692897751"/>
+        <p14:creationId xmlns:p14="http://schemas.microsoft.com/office/powerpoint/2010/main" val="2503825195"/>
       </p:ext>
     </p:extLst>
   </p:cSld>
@@ -4607,7 +4607,7 @@
           <p:cNvPr id="2" name="Rechteck 1">
             <a:extLst>
               <a:ext uri="{FF2B5EF4-FFF2-40B4-BE49-F238E27FC236}">
-                <a16:creationId xmlns:a16="http://schemas.microsoft.com/office/drawing/2014/main" id="{72BB98C7-09E6-CEC6-5CD3-E425B40F23AF}"/>
+                <a16:creationId xmlns:a16="http://schemas.microsoft.com/office/drawing/2014/main" id="{C35C8A8C-2D6F-5E54-49C6-3F5079C6182E}"/>
               </a:ext>
             </a:extLst>
           </p:cNvPr>
@@ -4678,7 +4678,7 @@
           <p:cNvPr id="3" name="Rechteck 2">
             <a:extLst>
               <a:ext uri="{FF2B5EF4-FFF2-40B4-BE49-F238E27FC236}">
-                <a16:creationId xmlns:a16="http://schemas.microsoft.com/office/drawing/2014/main" id="{F3116453-E5CD-6A19-1637-280AC20090AF}"/>
+                <a16:creationId xmlns:a16="http://schemas.microsoft.com/office/drawing/2014/main" id="{EEDEE84C-CAF1-3968-62E0-2EF38D7692B5}"/>
               </a:ext>
             </a:extLst>
           </p:cNvPr>
@@ -4749,7 +4749,7 @@
           <p:cNvPr id="4" name="Rechteck 3">
             <a:extLst>
               <a:ext uri="{FF2B5EF4-FFF2-40B4-BE49-F238E27FC236}">
-                <a16:creationId xmlns:a16="http://schemas.microsoft.com/office/drawing/2014/main" id="{51901BE3-5FED-4B2D-4489-AD5766BD50EC}"/>
+                <a16:creationId xmlns:a16="http://schemas.microsoft.com/office/drawing/2014/main" id="{50FC29AA-464B-75B3-E96F-CA8E0AE73769}"/>
               </a:ext>
             </a:extLst>
           </p:cNvPr>
@@ -4820,7 +4820,7 @@
           <p:cNvPr id="5" name="Rechteck 4">
             <a:extLst>
               <a:ext uri="{FF2B5EF4-FFF2-40B4-BE49-F238E27FC236}">
-                <a16:creationId xmlns:a16="http://schemas.microsoft.com/office/drawing/2014/main" id="{495255B3-1BD6-0BF8-2E10-718DF3663B63}"/>
+                <a16:creationId xmlns:a16="http://schemas.microsoft.com/office/drawing/2014/main" id="{3AF560B3-179F-3B05-7E77-C41A0F1EEA17}"/>
               </a:ext>
             </a:extLst>
           </p:cNvPr>
@@ -4890,7 +4890,7 @@
           <p:cNvPr id="6" name="Rechteck 5">
             <a:extLst>
               <a:ext uri="{FF2B5EF4-FFF2-40B4-BE49-F238E27FC236}">
-                <a16:creationId xmlns:a16="http://schemas.microsoft.com/office/drawing/2014/main" id="{C7B627CC-7992-F111-A401-1AB07EF3FF5C}"/>
+                <a16:creationId xmlns:a16="http://schemas.microsoft.com/office/drawing/2014/main" id="{D6B9D7A5-265D-312D-6DCC-6DD803D18518}"/>
               </a:ext>
             </a:extLst>
           </p:cNvPr>
@@ -4960,7 +4960,7 @@
           <p:cNvPr id="7" name="Rechteck 6">
             <a:extLst>
               <a:ext uri="{FF2B5EF4-FFF2-40B4-BE49-F238E27FC236}">
-                <a16:creationId xmlns:a16="http://schemas.microsoft.com/office/drawing/2014/main" id="{DA27B403-B258-8895-C6CB-9AEB1ACB1F90}"/>
+                <a16:creationId xmlns:a16="http://schemas.microsoft.com/office/drawing/2014/main" id="{D6989745-6165-F2DD-CFF0-66C329869659}"/>
               </a:ext>
             </a:extLst>
           </p:cNvPr>
@@ -5030,7 +5030,7 @@
           <p:cNvPr id="8" name="Rechteck 7">
             <a:extLst>
               <a:ext uri="{FF2B5EF4-FFF2-40B4-BE49-F238E27FC236}">
-                <a16:creationId xmlns:a16="http://schemas.microsoft.com/office/drawing/2014/main" id="{6C127284-6B1E-A38D-F242-643727B81201}"/>
+                <a16:creationId xmlns:a16="http://schemas.microsoft.com/office/drawing/2014/main" id="{CD5182B4-65E7-E34C-EE02-45A61F6E2457}"/>
               </a:ext>
             </a:extLst>
           </p:cNvPr>
@@ -5101,7 +5101,7 @@
           <p:cNvPr id="9" name="Rechteck 8">
             <a:extLst>
               <a:ext uri="{FF2B5EF4-FFF2-40B4-BE49-F238E27FC236}">
-                <a16:creationId xmlns:a16="http://schemas.microsoft.com/office/drawing/2014/main" id="{92B118CE-6F17-8F1B-7A0C-9E1BDA99B46B}"/>
+                <a16:creationId xmlns:a16="http://schemas.microsoft.com/office/drawing/2014/main" id="{14C8B886-21B4-3EA5-C1FA-E44EA8F86510}"/>
               </a:ext>
             </a:extLst>
           </p:cNvPr>
@@ -5172,7 +5172,7 @@
           <p:cNvPr id="10" name="Rechteck 9">
             <a:extLst>
               <a:ext uri="{FF2B5EF4-FFF2-40B4-BE49-F238E27FC236}">
-                <a16:creationId xmlns:a16="http://schemas.microsoft.com/office/drawing/2014/main" id="{381607E7-1B4B-3111-4811-60B329DFE761}"/>
+                <a16:creationId xmlns:a16="http://schemas.microsoft.com/office/drawing/2014/main" id="{571E9864-5B50-7E6C-000F-A37554AE9D7B}"/>
               </a:ext>
             </a:extLst>
           </p:cNvPr>
@@ -5243,7 +5243,7 @@
           <p:cNvPr id="11" name="Rechteck 10">
             <a:extLst>
               <a:ext uri="{FF2B5EF4-FFF2-40B4-BE49-F238E27FC236}">
-                <a16:creationId xmlns:a16="http://schemas.microsoft.com/office/drawing/2014/main" id="{38B6C10C-83F5-1B3F-6125-516CBAD63829}"/>
+                <a16:creationId xmlns:a16="http://schemas.microsoft.com/office/drawing/2014/main" id="{7BBD5814-F74C-46B8-12F1-01F6E80645BA}"/>
               </a:ext>
             </a:extLst>
           </p:cNvPr>
@@ -5313,7 +5313,7 @@
           <p:cNvPr id="12" name="Rechteck 11">
             <a:extLst>
               <a:ext uri="{FF2B5EF4-FFF2-40B4-BE49-F238E27FC236}">
-                <a16:creationId xmlns:a16="http://schemas.microsoft.com/office/drawing/2014/main" id="{5138891E-A344-1B60-5F58-D9F32BD4A037}"/>
+                <a16:creationId xmlns:a16="http://schemas.microsoft.com/office/drawing/2014/main" id="{15F0F07C-9315-961E-AF5F-347DAB469006}"/>
               </a:ext>
             </a:extLst>
           </p:cNvPr>
@@ -5383,7 +5383,7 @@
           <p:cNvPr id="13" name="Rechteck 12">
             <a:extLst>
               <a:ext uri="{FF2B5EF4-FFF2-40B4-BE49-F238E27FC236}">
-                <a16:creationId xmlns:a16="http://schemas.microsoft.com/office/drawing/2014/main" id="{E74398F3-532E-AE98-CBB1-0364CA363520}"/>
+                <a16:creationId xmlns:a16="http://schemas.microsoft.com/office/drawing/2014/main" id="{F67E846C-1F77-3ACD-B2D9-311A1D108D14}"/>
               </a:ext>
             </a:extLst>
           </p:cNvPr>
@@ -5453,7 +5453,7 @@
           <p:cNvPr id="14" name="Rechteck 13">
             <a:extLst>
               <a:ext uri="{FF2B5EF4-FFF2-40B4-BE49-F238E27FC236}">
-                <a16:creationId xmlns:a16="http://schemas.microsoft.com/office/drawing/2014/main" id="{03EC4BFD-7A61-898F-7896-3ABBF0615083}"/>
+                <a16:creationId xmlns:a16="http://schemas.microsoft.com/office/drawing/2014/main" id="{67D4EBC2-D0BA-B7D6-8028-6ABB97D05D66}"/>
               </a:ext>
             </a:extLst>
           </p:cNvPr>
@@ -5524,7 +5524,7 @@
           <p:cNvPr id="15" name="Rechteck 14">
             <a:extLst>
               <a:ext uri="{FF2B5EF4-FFF2-40B4-BE49-F238E27FC236}">
-                <a16:creationId xmlns:a16="http://schemas.microsoft.com/office/drawing/2014/main" id="{E2707BFD-0DEC-F607-BE6A-8C82E276FCF2}"/>
+                <a16:creationId xmlns:a16="http://schemas.microsoft.com/office/drawing/2014/main" id="{A88EDE90-01C1-61C1-6C16-CECF70CB149D}"/>
               </a:ext>
             </a:extLst>
           </p:cNvPr>
@@ -5595,7 +5595,7 @@
           <p:cNvPr id="16" name="Rechteck 15">
             <a:extLst>
               <a:ext uri="{FF2B5EF4-FFF2-40B4-BE49-F238E27FC236}">
-                <a16:creationId xmlns:a16="http://schemas.microsoft.com/office/drawing/2014/main" id="{911F9591-A8E2-CF99-2F46-5E69FB0C53A6}"/>
+                <a16:creationId xmlns:a16="http://schemas.microsoft.com/office/drawing/2014/main" id="{B168C4BC-A874-0A7A-B762-8651B9E81642}"/>
               </a:ext>
             </a:extLst>
           </p:cNvPr>
@@ -5666,7 +5666,7 @@
           <p:cNvPr id="17" name="Rechteck 16">
             <a:extLst>
               <a:ext uri="{FF2B5EF4-FFF2-40B4-BE49-F238E27FC236}">
-                <a16:creationId xmlns:a16="http://schemas.microsoft.com/office/drawing/2014/main" id="{3256D3D1-8B00-A2E0-C508-2B824EC44C43}"/>
+                <a16:creationId xmlns:a16="http://schemas.microsoft.com/office/drawing/2014/main" id="{570BAA63-95B7-ADAC-452F-992319E36F5D}"/>
               </a:ext>
             </a:extLst>
           </p:cNvPr>
@@ -5736,7 +5736,7 @@
           <p:cNvPr id="18" name="Rechteck 17">
             <a:extLst>
               <a:ext uri="{FF2B5EF4-FFF2-40B4-BE49-F238E27FC236}">
-                <a16:creationId xmlns:a16="http://schemas.microsoft.com/office/drawing/2014/main" id="{6CC91CDA-F204-7A95-6814-9FDC17083973}"/>
+                <a16:creationId xmlns:a16="http://schemas.microsoft.com/office/drawing/2014/main" id="{E7C88D80-A44C-01A6-D0CA-E58CBBE61B3C}"/>
               </a:ext>
             </a:extLst>
           </p:cNvPr>
@@ -5806,7 +5806,7 @@
           <p:cNvPr id="19" name="Rechteck 18">
             <a:extLst>
               <a:ext uri="{FF2B5EF4-FFF2-40B4-BE49-F238E27FC236}">
-                <a16:creationId xmlns:a16="http://schemas.microsoft.com/office/drawing/2014/main" id="{BD203CF8-5DB6-D9B7-9EF3-4DDA77686210}"/>
+                <a16:creationId xmlns:a16="http://schemas.microsoft.com/office/drawing/2014/main" id="{FC070D47-A08A-CD69-C6EC-C05750993C29}"/>
               </a:ext>
             </a:extLst>
           </p:cNvPr>
@@ -5876,7 +5876,7 @@
           <p:cNvPr id="20" name="Rechteck 19">
             <a:extLst>
               <a:ext uri="{FF2B5EF4-FFF2-40B4-BE49-F238E27FC236}">
-                <a16:creationId xmlns:a16="http://schemas.microsoft.com/office/drawing/2014/main" id="{DD313FFF-FC58-7D25-72F1-284899A4AAC9}"/>
+                <a16:creationId xmlns:a16="http://schemas.microsoft.com/office/drawing/2014/main" id="{2CF655F2-EB1E-3A5A-E365-DF9EB7B4F1B7}"/>
               </a:ext>
             </a:extLst>
           </p:cNvPr>
@@ -5947,7 +5947,7 @@
           <p:cNvPr id="21" name="Rechteck 20">
             <a:extLst>
               <a:ext uri="{FF2B5EF4-FFF2-40B4-BE49-F238E27FC236}">
-                <a16:creationId xmlns:a16="http://schemas.microsoft.com/office/drawing/2014/main" id="{4A5BA1D0-B7CD-B430-15F9-391D95231425}"/>
+                <a16:creationId xmlns:a16="http://schemas.microsoft.com/office/drawing/2014/main" id="{8B7AD85D-DD1D-5625-EF43-723FFA89C2FB}"/>
               </a:ext>
             </a:extLst>
           </p:cNvPr>
@@ -6018,7 +6018,7 @@
           <p:cNvPr id="22" name="Rechteck 21">
             <a:extLst>
               <a:ext uri="{FF2B5EF4-FFF2-40B4-BE49-F238E27FC236}">
-                <a16:creationId xmlns:a16="http://schemas.microsoft.com/office/drawing/2014/main" id="{85111CDB-C4F1-FEB9-CFB7-347477661D76}"/>
+                <a16:creationId xmlns:a16="http://schemas.microsoft.com/office/drawing/2014/main" id="{CA4D44EC-37E3-27AB-2188-B70DF9C44102}"/>
               </a:ext>
             </a:extLst>
           </p:cNvPr>
@@ -6089,7 +6089,7 @@
           <p:cNvPr id="23" name="Rechteck 22">
             <a:extLst>
               <a:ext uri="{FF2B5EF4-FFF2-40B4-BE49-F238E27FC236}">
-                <a16:creationId xmlns:a16="http://schemas.microsoft.com/office/drawing/2014/main" id="{017A932C-646C-2FDB-8D7B-99D92F49B13C}"/>
+                <a16:creationId xmlns:a16="http://schemas.microsoft.com/office/drawing/2014/main" id="{83C0741D-BD5D-704D-F726-EFE4AF2AFAB5}"/>
               </a:ext>
             </a:extLst>
           </p:cNvPr>
@@ -6159,7 +6159,7 @@
           <p:cNvPr id="24" name="Rechteck 23">
             <a:extLst>
               <a:ext uri="{FF2B5EF4-FFF2-40B4-BE49-F238E27FC236}">
-                <a16:creationId xmlns:a16="http://schemas.microsoft.com/office/drawing/2014/main" id="{9466CE9B-9E6C-8BA0-B8CD-8E3443F7DE9A}"/>
+                <a16:creationId xmlns:a16="http://schemas.microsoft.com/office/drawing/2014/main" id="{2A1D9C80-AE33-C4B3-894D-DCB74FCAB416}"/>
               </a:ext>
             </a:extLst>
           </p:cNvPr>
@@ -6229,7 +6229,7 @@
           <p:cNvPr id="25" name="Rechteck 24">
             <a:extLst>
               <a:ext uri="{FF2B5EF4-FFF2-40B4-BE49-F238E27FC236}">
-                <a16:creationId xmlns:a16="http://schemas.microsoft.com/office/drawing/2014/main" id="{2243DD34-6192-5938-790B-584D2FFE11F0}"/>
+                <a16:creationId xmlns:a16="http://schemas.microsoft.com/office/drawing/2014/main" id="{90064BED-FC8A-7F22-40E4-24DC5D07E8D8}"/>
               </a:ext>
             </a:extLst>
           </p:cNvPr>
@@ -6299,7 +6299,7 @@
           <p:cNvPr id="26" name="Rechteck 25">
             <a:extLst>
               <a:ext uri="{FF2B5EF4-FFF2-40B4-BE49-F238E27FC236}">
-                <a16:creationId xmlns:a16="http://schemas.microsoft.com/office/drawing/2014/main" id="{5CEC58A5-BAEC-0BF9-719C-5609758CF055}"/>
+                <a16:creationId xmlns:a16="http://schemas.microsoft.com/office/drawing/2014/main" id="{040C01EF-C72E-E8F8-0639-C22B2314DFA2}"/>
               </a:ext>
             </a:extLst>
           </p:cNvPr>
@@ -6370,7 +6370,7 @@
           <p:cNvPr id="27" name="Rechteck 26">
             <a:extLst>
               <a:ext uri="{FF2B5EF4-FFF2-40B4-BE49-F238E27FC236}">
-                <a16:creationId xmlns:a16="http://schemas.microsoft.com/office/drawing/2014/main" id="{5FDF7FF8-ECC9-88F3-7E97-AC61F593CB95}"/>
+                <a16:creationId xmlns:a16="http://schemas.microsoft.com/office/drawing/2014/main" id="{F54F929E-943D-FC65-F0E5-3EB4898509EE}"/>
               </a:ext>
             </a:extLst>
           </p:cNvPr>
@@ -6441,7 +6441,7 @@
           <p:cNvPr id="28" name="Rechteck 27">
             <a:extLst>
               <a:ext uri="{FF2B5EF4-FFF2-40B4-BE49-F238E27FC236}">
-                <a16:creationId xmlns:a16="http://schemas.microsoft.com/office/drawing/2014/main" id="{8CDEFAB7-B55F-F01D-782A-678FB81AF763}"/>
+                <a16:creationId xmlns:a16="http://schemas.microsoft.com/office/drawing/2014/main" id="{660848FE-7EA7-72E6-E393-DB7ED24382D3}"/>
               </a:ext>
             </a:extLst>
           </p:cNvPr>
@@ -6512,7 +6512,7 @@
           <p:cNvPr id="29" name="Rechteck 28">
             <a:extLst>
               <a:ext uri="{FF2B5EF4-FFF2-40B4-BE49-F238E27FC236}">
-                <a16:creationId xmlns:a16="http://schemas.microsoft.com/office/drawing/2014/main" id="{34249420-0FCE-8B40-51A2-43241C0E4ED9}"/>
+                <a16:creationId xmlns:a16="http://schemas.microsoft.com/office/drawing/2014/main" id="{0610E8A3-2816-0CFF-2893-CDD18055A30F}"/>
               </a:ext>
             </a:extLst>
           </p:cNvPr>
@@ -6582,7 +6582,7 @@
           <p:cNvPr id="30" name="Rechteck 29">
             <a:extLst>
               <a:ext uri="{FF2B5EF4-FFF2-40B4-BE49-F238E27FC236}">
-                <a16:creationId xmlns:a16="http://schemas.microsoft.com/office/drawing/2014/main" id="{5EA6C50D-8F0A-F17A-AF75-C878CC463D75}"/>
+                <a16:creationId xmlns:a16="http://schemas.microsoft.com/office/drawing/2014/main" id="{EF9C7E5D-5905-4B6A-4A8C-1B002F7CD1C3}"/>
               </a:ext>
             </a:extLst>
           </p:cNvPr>
@@ -6652,7 +6652,7 @@
           <p:cNvPr id="31" name="Rechteck 30">
             <a:extLst>
               <a:ext uri="{FF2B5EF4-FFF2-40B4-BE49-F238E27FC236}">
-                <a16:creationId xmlns:a16="http://schemas.microsoft.com/office/drawing/2014/main" id="{21801ED0-AB86-5949-72E0-01E4FDA450FB}"/>
+                <a16:creationId xmlns:a16="http://schemas.microsoft.com/office/drawing/2014/main" id="{04739DCA-E96E-3467-5138-A7BEE34C3138}"/>
               </a:ext>
             </a:extLst>
           </p:cNvPr>
@@ -6722,7 +6722,7 @@
           <p:cNvPr id="32" name="Rechteck 31">
             <a:extLst>
               <a:ext uri="{FF2B5EF4-FFF2-40B4-BE49-F238E27FC236}">
-                <a16:creationId xmlns:a16="http://schemas.microsoft.com/office/drawing/2014/main" id="{ED0BBBB8-450D-7440-208C-1AE5AA86A710}"/>
+                <a16:creationId xmlns:a16="http://schemas.microsoft.com/office/drawing/2014/main" id="{D44B2286-3FE9-57D3-7314-798DFDCD67AF}"/>
               </a:ext>
             </a:extLst>
           </p:cNvPr>
@@ -6793,7 +6793,7 @@
           <p:cNvPr id="33" name="Rechteck 32">
             <a:extLst>
               <a:ext uri="{FF2B5EF4-FFF2-40B4-BE49-F238E27FC236}">
-                <a16:creationId xmlns:a16="http://schemas.microsoft.com/office/drawing/2014/main" id="{D422DCA4-3296-C03D-A29A-932F89669006}"/>
+                <a16:creationId xmlns:a16="http://schemas.microsoft.com/office/drawing/2014/main" id="{AA349CCB-ED23-120E-DE5B-2A1ED04C4CA4}"/>
               </a:ext>
             </a:extLst>
           </p:cNvPr>
@@ -6864,7 +6864,7 @@
           <p:cNvPr id="34" name="Rechteck 33">
             <a:extLst>
               <a:ext uri="{FF2B5EF4-FFF2-40B4-BE49-F238E27FC236}">
-                <a16:creationId xmlns:a16="http://schemas.microsoft.com/office/drawing/2014/main" id="{678B4879-80DC-5387-BE13-2486C34AA827}"/>
+                <a16:creationId xmlns:a16="http://schemas.microsoft.com/office/drawing/2014/main" id="{44E5D89A-0446-C081-C279-3071EE8D80CA}"/>
               </a:ext>
             </a:extLst>
           </p:cNvPr>
@@ -6935,7 +6935,7 @@
           <p:cNvPr id="35" name="Rechteck 34">
             <a:extLst>
               <a:ext uri="{FF2B5EF4-FFF2-40B4-BE49-F238E27FC236}">
-                <a16:creationId xmlns:a16="http://schemas.microsoft.com/office/drawing/2014/main" id="{7982CD38-40BB-9C8F-E11D-FC268B45DCE8}"/>
+                <a16:creationId xmlns:a16="http://schemas.microsoft.com/office/drawing/2014/main" id="{765FCFE9-CD1A-8DF9-857D-A428330EFBF5}"/>
               </a:ext>
             </a:extLst>
           </p:cNvPr>
@@ -7005,7 +7005,7 @@
           <p:cNvPr id="36" name="Rechteck 35">
             <a:extLst>
               <a:ext uri="{FF2B5EF4-FFF2-40B4-BE49-F238E27FC236}">
-                <a16:creationId xmlns:a16="http://schemas.microsoft.com/office/drawing/2014/main" id="{B5A6F445-5335-8015-DC06-30475CBD70A0}"/>
+                <a16:creationId xmlns:a16="http://schemas.microsoft.com/office/drawing/2014/main" id="{CDEA24CC-496F-8703-6340-E6561F4FFAA4}"/>
               </a:ext>
             </a:extLst>
           </p:cNvPr>
@@ -7075,7 +7075,7 @@
           <p:cNvPr id="37" name="Rechteck 36">
             <a:extLst>
               <a:ext uri="{FF2B5EF4-FFF2-40B4-BE49-F238E27FC236}">
-                <a16:creationId xmlns:a16="http://schemas.microsoft.com/office/drawing/2014/main" id="{33D255CA-141B-C08A-3787-1B56602F8434}"/>
+                <a16:creationId xmlns:a16="http://schemas.microsoft.com/office/drawing/2014/main" id="{31BCB4C7-06F3-2DB2-2557-DF9B23D13151}"/>
               </a:ext>
             </a:extLst>
           </p:cNvPr>
@@ -7143,7 +7143,7 @@
     </p:spTree>
     <p:extLst>
       <p:ext uri="{BB962C8B-B14F-4D97-AF65-F5344CB8AC3E}">
-        <p14:creationId xmlns:p14="http://schemas.microsoft.com/office/powerpoint/2010/main" val="2748066859"/>
+        <p14:creationId xmlns:p14="http://schemas.microsoft.com/office/powerpoint/2010/main" val="1494924073"/>
       </p:ext>
     </p:extLst>
   </p:cSld>
@@ -7175,7 +7175,7 @@
           <p:cNvPr id="2" name="Rechteck: abgerundete Ecken 1">
             <a:extLst>
               <a:ext uri="{FF2B5EF4-FFF2-40B4-BE49-F238E27FC236}">
-                <a16:creationId xmlns:a16="http://schemas.microsoft.com/office/drawing/2014/main" id="{965B4740-C325-E0C4-8117-312FCF122B61}"/>
+                <a16:creationId xmlns:a16="http://schemas.microsoft.com/office/drawing/2014/main" id="{38C32889-9871-D6C5-D47F-139500FB0151}"/>
               </a:ext>
             </a:extLst>
           </p:cNvPr>
@@ -7233,7 +7233,7 @@
           <p:cNvPr id="3" name="Rechteck: abgerundete Ecken 2">
             <a:extLst>
               <a:ext uri="{FF2B5EF4-FFF2-40B4-BE49-F238E27FC236}">
-                <a16:creationId xmlns:a16="http://schemas.microsoft.com/office/drawing/2014/main" id="{8130FCCD-9446-6C4A-A704-396D1B1FC1A7}"/>
+                <a16:creationId xmlns:a16="http://schemas.microsoft.com/office/drawing/2014/main" id="{B00E661E-BDC9-1CD7-3A4D-2CB2370E122A}"/>
               </a:ext>
             </a:extLst>
           </p:cNvPr>
@@ -7291,7 +7291,7 @@
           <p:cNvPr id="4" name="Rechteck: abgerundete Ecken 3">
             <a:extLst>
               <a:ext uri="{FF2B5EF4-FFF2-40B4-BE49-F238E27FC236}">
-                <a16:creationId xmlns:a16="http://schemas.microsoft.com/office/drawing/2014/main" id="{FD05C16F-C8E0-57A9-20EE-F1811393572D}"/>
+                <a16:creationId xmlns:a16="http://schemas.microsoft.com/office/drawing/2014/main" id="{D6A84BD1-712E-E960-8990-D498BBC2EBFF}"/>
               </a:ext>
             </a:extLst>
           </p:cNvPr>
@@ -7352,7 +7352,7 @@
           <p:cNvPr id="5" name="Rechteck: abgerundete Ecken 4">
             <a:extLst>
               <a:ext uri="{FF2B5EF4-FFF2-40B4-BE49-F238E27FC236}">
-                <a16:creationId xmlns:a16="http://schemas.microsoft.com/office/drawing/2014/main" id="{37A71AD4-B4C2-4C33-BFE9-67138E3FB030}"/>
+                <a16:creationId xmlns:a16="http://schemas.microsoft.com/office/drawing/2014/main" id="{E018CFE2-1218-A288-EB3A-12D3FE777D8E}"/>
               </a:ext>
             </a:extLst>
           </p:cNvPr>
@@ -7413,7 +7413,7 @@
           <p:cNvPr id="6" name="Rechteck: abgerundete Ecken 5">
             <a:extLst>
               <a:ext uri="{FF2B5EF4-FFF2-40B4-BE49-F238E27FC236}">
-                <a16:creationId xmlns:a16="http://schemas.microsoft.com/office/drawing/2014/main" id="{C748F408-F8B4-86D9-59B6-3F6DB41D3CE9}"/>
+                <a16:creationId xmlns:a16="http://schemas.microsoft.com/office/drawing/2014/main" id="{E076E9B1-FAE3-BE84-9237-CC2271A6CE93}"/>
               </a:ext>
             </a:extLst>
           </p:cNvPr>
@@ -7471,7 +7471,7 @@
           <p:cNvPr id="7" name="Rechteck: abgerundete Ecken 6">
             <a:extLst>
               <a:ext uri="{FF2B5EF4-FFF2-40B4-BE49-F238E27FC236}">
-                <a16:creationId xmlns:a16="http://schemas.microsoft.com/office/drawing/2014/main" id="{28710612-7FDC-28E5-87F2-4AFB9D9FCFD9}"/>
+                <a16:creationId xmlns:a16="http://schemas.microsoft.com/office/drawing/2014/main" id="{FBFA0BE6-3840-84A5-AAA1-51DCD314E988}"/>
               </a:ext>
             </a:extLst>
           </p:cNvPr>
@@ -7529,7 +7529,7 @@
           <p:cNvPr id="8" name="Rechteck: abgerundete Ecken 7">
             <a:extLst>
               <a:ext uri="{FF2B5EF4-FFF2-40B4-BE49-F238E27FC236}">
-                <a16:creationId xmlns:a16="http://schemas.microsoft.com/office/drawing/2014/main" id="{360D890E-9525-B457-FB4B-E1E8B1348D46}"/>
+                <a16:creationId xmlns:a16="http://schemas.microsoft.com/office/drawing/2014/main" id="{464670CC-B08A-6F36-0666-D90F5A97ACCE}"/>
               </a:ext>
             </a:extLst>
           </p:cNvPr>
@@ -7590,7 +7590,7 @@
           <p:cNvPr id="9" name="Rechteck: abgerundete Ecken 8">
             <a:extLst>
               <a:ext uri="{FF2B5EF4-FFF2-40B4-BE49-F238E27FC236}">
-                <a16:creationId xmlns:a16="http://schemas.microsoft.com/office/drawing/2014/main" id="{8EBAE1A5-8A89-58E8-F9EC-B18BDF045E2E}"/>
+                <a16:creationId xmlns:a16="http://schemas.microsoft.com/office/drawing/2014/main" id="{7D19F140-895D-B5AE-80C9-53DCF13B66B4}"/>
               </a:ext>
             </a:extLst>
           </p:cNvPr>
@@ -7651,7 +7651,7 @@
           <p:cNvPr id="10" name="Rechteck: abgerundete Ecken 9">
             <a:extLst>
               <a:ext uri="{FF2B5EF4-FFF2-40B4-BE49-F238E27FC236}">
-                <a16:creationId xmlns:a16="http://schemas.microsoft.com/office/drawing/2014/main" id="{72143312-966C-CC9F-834F-C4942D6DCA95}"/>
+                <a16:creationId xmlns:a16="http://schemas.microsoft.com/office/drawing/2014/main" id="{9CF3F088-A685-CE82-D6B5-7238FF12F3DF}"/>
               </a:ext>
             </a:extLst>
           </p:cNvPr>
@@ -7709,7 +7709,7 @@
           <p:cNvPr id="11" name="Rechteck: abgerundete Ecken 10">
             <a:extLst>
               <a:ext uri="{FF2B5EF4-FFF2-40B4-BE49-F238E27FC236}">
-                <a16:creationId xmlns:a16="http://schemas.microsoft.com/office/drawing/2014/main" id="{6B5A535E-4DB1-B45B-7B15-AC748F9B75BE}"/>
+                <a16:creationId xmlns:a16="http://schemas.microsoft.com/office/drawing/2014/main" id="{878D06FE-7C35-640B-3F25-D9AD3D84D494}"/>
               </a:ext>
             </a:extLst>
           </p:cNvPr>
@@ -7767,7 +7767,7 @@
           <p:cNvPr id="12" name="Rechteck: abgerundete Ecken 11">
             <a:extLst>
               <a:ext uri="{FF2B5EF4-FFF2-40B4-BE49-F238E27FC236}">
-                <a16:creationId xmlns:a16="http://schemas.microsoft.com/office/drawing/2014/main" id="{8F755D79-F75E-3C6B-ECD3-E7CFBFCBEF52}"/>
+                <a16:creationId xmlns:a16="http://schemas.microsoft.com/office/drawing/2014/main" id="{324B3A92-735C-55E1-8191-8AD9E4A6358C}"/>
               </a:ext>
             </a:extLst>
           </p:cNvPr>
@@ -7828,7 +7828,7 @@
           <p:cNvPr id="13" name="Rechteck: abgerundete Ecken 12">
             <a:extLst>
               <a:ext uri="{FF2B5EF4-FFF2-40B4-BE49-F238E27FC236}">
-                <a16:creationId xmlns:a16="http://schemas.microsoft.com/office/drawing/2014/main" id="{2F23AAEB-956A-57D1-32B1-518B6B920CB3}"/>
+                <a16:creationId xmlns:a16="http://schemas.microsoft.com/office/drawing/2014/main" id="{546AB96E-BFE8-7CED-A069-9FD50205E918}"/>
               </a:ext>
             </a:extLst>
           </p:cNvPr>
@@ -7889,7 +7889,7 @@
           <p:cNvPr id="14" name="Rechteck: abgerundete Ecken 13">
             <a:extLst>
               <a:ext uri="{FF2B5EF4-FFF2-40B4-BE49-F238E27FC236}">
-                <a16:creationId xmlns:a16="http://schemas.microsoft.com/office/drawing/2014/main" id="{DFC52A8F-13C9-03A2-2000-ECA790460092}"/>
+                <a16:creationId xmlns:a16="http://schemas.microsoft.com/office/drawing/2014/main" id="{5635E62E-6898-B2A3-C9B4-34E556A73563}"/>
               </a:ext>
             </a:extLst>
           </p:cNvPr>
@@ -7947,7 +7947,7 @@
           <p:cNvPr id="15" name="Rechteck: abgerundete Ecken 14">
             <a:extLst>
               <a:ext uri="{FF2B5EF4-FFF2-40B4-BE49-F238E27FC236}">
-                <a16:creationId xmlns:a16="http://schemas.microsoft.com/office/drawing/2014/main" id="{7E268459-9801-70E0-8149-6CC5AC01D3FF}"/>
+                <a16:creationId xmlns:a16="http://schemas.microsoft.com/office/drawing/2014/main" id="{738ECF8D-FC61-4FE7-6E7B-E1CF5DA3CB97}"/>
               </a:ext>
             </a:extLst>
           </p:cNvPr>
@@ -8005,7 +8005,7 @@
           <p:cNvPr id="16" name="Rechteck: abgerundete Ecken 15">
             <a:extLst>
               <a:ext uri="{FF2B5EF4-FFF2-40B4-BE49-F238E27FC236}">
-                <a16:creationId xmlns:a16="http://schemas.microsoft.com/office/drawing/2014/main" id="{790EBA62-A543-C8AF-4566-A405A64A6CE9}"/>
+                <a16:creationId xmlns:a16="http://schemas.microsoft.com/office/drawing/2014/main" id="{1CA01A0B-4DD4-47BC-DAEF-C143C396E06C}"/>
               </a:ext>
             </a:extLst>
           </p:cNvPr>
@@ -8066,7 +8066,7 @@
           <p:cNvPr id="17" name="Rechteck: abgerundete Ecken 16">
             <a:extLst>
               <a:ext uri="{FF2B5EF4-FFF2-40B4-BE49-F238E27FC236}">
-                <a16:creationId xmlns:a16="http://schemas.microsoft.com/office/drawing/2014/main" id="{CD155B58-14F9-9035-66BF-CA4E38D9E287}"/>
+                <a16:creationId xmlns:a16="http://schemas.microsoft.com/office/drawing/2014/main" id="{422C99ED-4055-B919-25A7-AF9C065A28EC}"/>
               </a:ext>
             </a:extLst>
           </p:cNvPr>
@@ -8127,7 +8127,7 @@
           <p:cNvPr id="18" name="Rechteck: abgerundete Ecken 17">
             <a:extLst>
               <a:ext uri="{FF2B5EF4-FFF2-40B4-BE49-F238E27FC236}">
-                <a16:creationId xmlns:a16="http://schemas.microsoft.com/office/drawing/2014/main" id="{3FF6B052-9390-1C15-BEFA-2548780013C0}"/>
+                <a16:creationId xmlns:a16="http://schemas.microsoft.com/office/drawing/2014/main" id="{BB2EC00B-5466-2A61-86B8-E312B7FF38C4}"/>
               </a:ext>
             </a:extLst>
           </p:cNvPr>
@@ -8187,7 +8187,7 @@
           <p:cNvPr id="19" name="Rechteck: abgerundete Ecken 18">
             <a:extLst>
               <a:ext uri="{FF2B5EF4-FFF2-40B4-BE49-F238E27FC236}">
-                <a16:creationId xmlns:a16="http://schemas.microsoft.com/office/drawing/2014/main" id="{8C397B7C-FAD5-9A9F-E257-0A162314E212}"/>
+                <a16:creationId xmlns:a16="http://schemas.microsoft.com/office/drawing/2014/main" id="{4889ADF0-B2DA-1151-1038-5E1CAAD1BC4A}"/>
               </a:ext>
             </a:extLst>
           </p:cNvPr>
@@ -8247,7 +8247,7 @@
           <p:cNvPr id="20" name="Rechteck: abgerundete Ecken 19">
             <a:extLst>
               <a:ext uri="{FF2B5EF4-FFF2-40B4-BE49-F238E27FC236}">
-                <a16:creationId xmlns:a16="http://schemas.microsoft.com/office/drawing/2014/main" id="{5E9FE514-0120-E313-B43C-9D8850225EC9}"/>
+                <a16:creationId xmlns:a16="http://schemas.microsoft.com/office/drawing/2014/main" id="{DE03C3C9-BAFE-2668-BC27-C8A46D516E61}"/>
               </a:ext>
             </a:extLst>
           </p:cNvPr>
@@ -8307,7 +8307,7 @@
           <p:cNvPr id="21" name="Rechteck: abgerundete Ecken 20">
             <a:extLst>
               <a:ext uri="{FF2B5EF4-FFF2-40B4-BE49-F238E27FC236}">
-                <a16:creationId xmlns:a16="http://schemas.microsoft.com/office/drawing/2014/main" id="{1E31A004-22C9-63A4-21DC-92AE91606F6B}"/>
+                <a16:creationId xmlns:a16="http://schemas.microsoft.com/office/drawing/2014/main" id="{9F9A88C7-C4F9-8DFB-7394-768C536FBEA3}"/>
               </a:ext>
             </a:extLst>
           </p:cNvPr>
@@ -8367,7 +8367,7 @@
           <p:cNvPr id="22" name="Rechteck: abgerundete Ecken 21">
             <a:extLst>
               <a:ext uri="{FF2B5EF4-FFF2-40B4-BE49-F238E27FC236}">
-                <a16:creationId xmlns:a16="http://schemas.microsoft.com/office/drawing/2014/main" id="{9DC09655-10AD-69D5-554E-AE767CCF3D3A}"/>
+                <a16:creationId xmlns:a16="http://schemas.microsoft.com/office/drawing/2014/main" id="{63E9CA30-F77D-BAE9-678D-97CA17847808}"/>
               </a:ext>
             </a:extLst>
           </p:cNvPr>
@@ -8413,7 +8413,7 @@
           <p:cNvPr id="23" name="Rechteck: abgerundete Ecken 22">
             <a:extLst>
               <a:ext uri="{FF2B5EF4-FFF2-40B4-BE49-F238E27FC236}">
-                <a16:creationId xmlns:a16="http://schemas.microsoft.com/office/drawing/2014/main" id="{C9344076-87A0-DB59-1D0D-E1BFE4C6A6A8}"/>
+                <a16:creationId xmlns:a16="http://schemas.microsoft.com/office/drawing/2014/main" id="{EF37FD62-062D-A71B-3C2A-68C5E9BE2357}"/>
               </a:ext>
             </a:extLst>
           </p:cNvPr>
@@ -8459,7 +8459,7 @@
           <p:cNvPr id="24" name="Rechteck: abgerundete Ecken 23">
             <a:extLst>
               <a:ext uri="{FF2B5EF4-FFF2-40B4-BE49-F238E27FC236}">
-                <a16:creationId xmlns:a16="http://schemas.microsoft.com/office/drawing/2014/main" id="{EE4637BB-A3FD-8E06-E542-42F98DF4E12B}"/>
+                <a16:creationId xmlns:a16="http://schemas.microsoft.com/office/drawing/2014/main" id="{0F09ACB3-D179-D098-46DD-EE0AB09FAE44}"/>
               </a:ext>
             </a:extLst>
           </p:cNvPr>
@@ -8505,7 +8505,7 @@
           <p:cNvPr id="25" name="Rechteck: abgerundete Ecken 24">
             <a:extLst>
               <a:ext uri="{FF2B5EF4-FFF2-40B4-BE49-F238E27FC236}">
-                <a16:creationId xmlns:a16="http://schemas.microsoft.com/office/drawing/2014/main" id="{ACB4F9F1-6E50-3C29-F2FE-85B8BF430C27}"/>
+                <a16:creationId xmlns:a16="http://schemas.microsoft.com/office/drawing/2014/main" id="{4299440B-3098-EB84-E148-7845A8EE54A6}"/>
               </a:ext>
             </a:extLst>
           </p:cNvPr>
@@ -8551,7 +8551,7 @@
           <p:cNvPr id="26" name="Rechteck: abgerundete Ecken 25">
             <a:extLst>
               <a:ext uri="{FF2B5EF4-FFF2-40B4-BE49-F238E27FC236}">
-                <a16:creationId xmlns:a16="http://schemas.microsoft.com/office/drawing/2014/main" id="{2F2F8925-EF86-E8EB-AE72-5BF42F0E420D}"/>
+                <a16:creationId xmlns:a16="http://schemas.microsoft.com/office/drawing/2014/main" id="{B05CA8A4-6972-F890-97FC-ACA2DEECDA2A}"/>
               </a:ext>
             </a:extLst>
           </p:cNvPr>
@@ -8611,7 +8611,7 @@
           <p:cNvPr id="27" name="Rechteck: abgerundete Ecken 26">
             <a:extLst>
               <a:ext uri="{FF2B5EF4-FFF2-40B4-BE49-F238E27FC236}">
-                <a16:creationId xmlns:a16="http://schemas.microsoft.com/office/drawing/2014/main" id="{8D0E4132-62F3-BD4A-DE58-E38D27B8A6E7}"/>
+                <a16:creationId xmlns:a16="http://schemas.microsoft.com/office/drawing/2014/main" id="{A6A21B09-66C6-18ED-0289-B620522191D1}"/>
               </a:ext>
             </a:extLst>
           </p:cNvPr>
@@ -8671,7 +8671,7 @@
           <p:cNvPr id="28" name="Rechteck: abgerundete Ecken 27">
             <a:extLst>
               <a:ext uri="{FF2B5EF4-FFF2-40B4-BE49-F238E27FC236}">
-                <a16:creationId xmlns:a16="http://schemas.microsoft.com/office/drawing/2014/main" id="{E7A60B89-07B9-FF65-2C72-ACD985BFA36B}"/>
+                <a16:creationId xmlns:a16="http://schemas.microsoft.com/office/drawing/2014/main" id="{6405EF49-329C-7028-31E5-824A2265326A}"/>
               </a:ext>
             </a:extLst>
           </p:cNvPr>
@@ -8734,7 +8734,7 @@
           <p:cNvPr id="29" name="Rechteck: abgerundete Ecken 28">
             <a:extLst>
               <a:ext uri="{FF2B5EF4-FFF2-40B4-BE49-F238E27FC236}">
-                <a16:creationId xmlns:a16="http://schemas.microsoft.com/office/drawing/2014/main" id="{8A9C39E4-1E41-265D-5D53-0EDD26A1F306}"/>
+                <a16:creationId xmlns:a16="http://schemas.microsoft.com/office/drawing/2014/main" id="{AA2DEDBD-48D0-FD80-BA73-817F01704E30}"/>
               </a:ext>
             </a:extLst>
           </p:cNvPr>
@@ -8795,7 +8795,7 @@
     </p:spTree>
     <p:extLst>
       <p:ext uri="{BB962C8B-B14F-4D97-AF65-F5344CB8AC3E}">
-        <p14:creationId xmlns:p14="http://schemas.microsoft.com/office/powerpoint/2010/main" val="2047719586"/>
+        <p14:creationId xmlns:p14="http://schemas.microsoft.com/office/powerpoint/2010/main" val="1954023265"/>
       </p:ext>
     </p:extLst>
   </p:cSld>
@@ -8827,7 +8827,7 @@
           <p:cNvPr id="2" name="Rechteck 1">
             <a:extLst>
               <a:ext uri="{FF2B5EF4-FFF2-40B4-BE49-F238E27FC236}">
-                <a16:creationId xmlns:a16="http://schemas.microsoft.com/office/drawing/2014/main" id="{17CE2839-21F6-AA76-6F59-916EFD25440D}"/>
+                <a16:creationId xmlns:a16="http://schemas.microsoft.com/office/drawing/2014/main" id="{C74F03B0-78BB-3FF2-3496-F9081A420CFB}"/>
               </a:ext>
             </a:extLst>
           </p:cNvPr>
@@ -8881,7 +8881,7 @@
           <p:cNvPr id="3" name="Rechteck 2">
             <a:extLst>
               <a:ext uri="{FF2B5EF4-FFF2-40B4-BE49-F238E27FC236}">
-                <a16:creationId xmlns:a16="http://schemas.microsoft.com/office/drawing/2014/main" id="{54CF58CC-8A11-EDF3-CACC-A6BE19BA0A31}"/>
+                <a16:creationId xmlns:a16="http://schemas.microsoft.com/office/drawing/2014/main" id="{51FF9EF6-1F30-8030-85E8-7372D71927B5}"/>
               </a:ext>
             </a:extLst>
           </p:cNvPr>
@@ -8935,7 +8935,7 @@
           <p:cNvPr id="4" name="Rechteck 3">
             <a:extLst>
               <a:ext uri="{FF2B5EF4-FFF2-40B4-BE49-F238E27FC236}">
-                <a16:creationId xmlns:a16="http://schemas.microsoft.com/office/drawing/2014/main" id="{7E4761C3-4C40-3659-F6A0-B5569A37FED4}"/>
+                <a16:creationId xmlns:a16="http://schemas.microsoft.com/office/drawing/2014/main" id="{B9ED2581-A720-B2FF-ABA0-EEEC6352BF7F}"/>
               </a:ext>
             </a:extLst>
           </p:cNvPr>
@@ -8989,7 +8989,7 @@
           <p:cNvPr id="5" name="Rechteck 4">
             <a:extLst>
               <a:ext uri="{FF2B5EF4-FFF2-40B4-BE49-F238E27FC236}">
-                <a16:creationId xmlns:a16="http://schemas.microsoft.com/office/drawing/2014/main" id="{C0FDDFC1-10BA-1FE2-713D-7FCBE6F0FBD2}"/>
+                <a16:creationId xmlns:a16="http://schemas.microsoft.com/office/drawing/2014/main" id="{2F1932E9-89F0-6FF6-20FF-14D77C7FBCEF}"/>
               </a:ext>
             </a:extLst>
           </p:cNvPr>
@@ -9043,7 +9043,7 @@
           <p:cNvPr id="6" name="Rechteck 5">
             <a:extLst>
               <a:ext uri="{FF2B5EF4-FFF2-40B4-BE49-F238E27FC236}">
-                <a16:creationId xmlns:a16="http://schemas.microsoft.com/office/drawing/2014/main" id="{7B149127-94CA-749B-4DF6-8A27F2ED423C}"/>
+                <a16:creationId xmlns:a16="http://schemas.microsoft.com/office/drawing/2014/main" id="{5CF74D2D-CC05-0FB3-F340-C46AE0A45553}"/>
               </a:ext>
             </a:extLst>
           </p:cNvPr>
@@ -9097,7 +9097,7 @@
           <p:cNvPr id="7" name="Rechteck 6">
             <a:extLst>
               <a:ext uri="{FF2B5EF4-FFF2-40B4-BE49-F238E27FC236}">
-                <a16:creationId xmlns:a16="http://schemas.microsoft.com/office/drawing/2014/main" id="{764294BD-7DDD-B4D1-8354-5DB1C2BD3D82}"/>
+                <a16:creationId xmlns:a16="http://schemas.microsoft.com/office/drawing/2014/main" id="{B67EEED9-F167-397D-D6CF-200BE4C24399}"/>
               </a:ext>
             </a:extLst>
           </p:cNvPr>
@@ -9151,7 +9151,7 @@
           <p:cNvPr id="8" name="Rechteck 7">
             <a:extLst>
               <a:ext uri="{FF2B5EF4-FFF2-40B4-BE49-F238E27FC236}">
-                <a16:creationId xmlns:a16="http://schemas.microsoft.com/office/drawing/2014/main" id="{BB15CF6B-10AE-9A9C-FFE7-262486003C04}"/>
+                <a16:creationId xmlns:a16="http://schemas.microsoft.com/office/drawing/2014/main" id="{EA765C52-63F4-5E80-9656-14B9724713DF}"/>
               </a:ext>
             </a:extLst>
           </p:cNvPr>
@@ -9205,7 +9205,7 @@
           <p:cNvPr id="9" name="Rechteck 8">
             <a:extLst>
               <a:ext uri="{FF2B5EF4-FFF2-40B4-BE49-F238E27FC236}">
-                <a16:creationId xmlns:a16="http://schemas.microsoft.com/office/drawing/2014/main" id="{97C3A57D-2D34-A22D-D0AE-8B127CA55F52}"/>
+                <a16:creationId xmlns:a16="http://schemas.microsoft.com/office/drawing/2014/main" id="{66DB4570-EF53-C584-5648-DE21BB29A59F}"/>
               </a:ext>
             </a:extLst>
           </p:cNvPr>
@@ -9259,7 +9259,7 @@
           <p:cNvPr id="10" name="Rechteck 9">
             <a:extLst>
               <a:ext uri="{FF2B5EF4-FFF2-40B4-BE49-F238E27FC236}">
-                <a16:creationId xmlns:a16="http://schemas.microsoft.com/office/drawing/2014/main" id="{19E15C73-065D-1D4F-A058-79F84BBC0E91}"/>
+                <a16:creationId xmlns:a16="http://schemas.microsoft.com/office/drawing/2014/main" id="{422B2ABB-9571-8CAC-732A-FFE0EA2FC369}"/>
               </a:ext>
             </a:extLst>
           </p:cNvPr>
@@ -9313,7 +9313,7 @@
           <p:cNvPr id="11" name="Rechteck 10">
             <a:extLst>
               <a:ext uri="{FF2B5EF4-FFF2-40B4-BE49-F238E27FC236}">
-                <a16:creationId xmlns:a16="http://schemas.microsoft.com/office/drawing/2014/main" id="{64B2B84F-E64D-04FF-4539-482A3CD9BD9E}"/>
+                <a16:creationId xmlns:a16="http://schemas.microsoft.com/office/drawing/2014/main" id="{08DDADD1-8980-5055-B7EC-F481560E7259}"/>
               </a:ext>
             </a:extLst>
           </p:cNvPr>
@@ -9367,7 +9367,7 @@
           <p:cNvPr id="12" name="Rechteck 11">
             <a:extLst>
               <a:ext uri="{FF2B5EF4-FFF2-40B4-BE49-F238E27FC236}">
-                <a16:creationId xmlns:a16="http://schemas.microsoft.com/office/drawing/2014/main" id="{06BAA078-FF18-01C4-CE7E-AF5CB7C265BE}"/>
+                <a16:creationId xmlns:a16="http://schemas.microsoft.com/office/drawing/2014/main" id="{42367C4D-E723-24D6-451B-BA84EF4341E0}"/>
               </a:ext>
             </a:extLst>
           </p:cNvPr>
@@ -9421,7 +9421,7 @@
           <p:cNvPr id="13" name="Rechteck 12">
             <a:extLst>
               <a:ext uri="{FF2B5EF4-FFF2-40B4-BE49-F238E27FC236}">
-                <a16:creationId xmlns:a16="http://schemas.microsoft.com/office/drawing/2014/main" id="{B7E616DF-5110-6A78-5A3B-8379015D7923}"/>
+                <a16:creationId xmlns:a16="http://schemas.microsoft.com/office/drawing/2014/main" id="{3701D4CE-5A38-28C8-4133-349A15105754}"/>
               </a:ext>
             </a:extLst>
           </p:cNvPr>
@@ -9475,7 +9475,7 @@
           <p:cNvPr id="14" name="Rechteck 13">
             <a:extLst>
               <a:ext uri="{FF2B5EF4-FFF2-40B4-BE49-F238E27FC236}">
-                <a16:creationId xmlns:a16="http://schemas.microsoft.com/office/drawing/2014/main" id="{98DE7CF8-CA06-1F30-7F55-BDE3946B4320}"/>
+                <a16:creationId xmlns:a16="http://schemas.microsoft.com/office/drawing/2014/main" id="{D7DC9BFD-761F-CF1B-3070-2150E9AF6C32}"/>
               </a:ext>
             </a:extLst>
           </p:cNvPr>
@@ -9529,7 +9529,7 @@
           <p:cNvPr id="15" name="Rechteck 14">
             <a:extLst>
               <a:ext uri="{FF2B5EF4-FFF2-40B4-BE49-F238E27FC236}">
-                <a16:creationId xmlns:a16="http://schemas.microsoft.com/office/drawing/2014/main" id="{729322C0-2858-B94C-78C4-8842E7FFF18E}"/>
+                <a16:creationId xmlns:a16="http://schemas.microsoft.com/office/drawing/2014/main" id="{40739CF1-3C0E-8CFA-D8B0-6DA5918327E8}"/>
               </a:ext>
             </a:extLst>
           </p:cNvPr>
@@ -9583,7 +9583,7 @@
           <p:cNvPr id="16" name="Rechteck 15">
             <a:extLst>
               <a:ext uri="{FF2B5EF4-FFF2-40B4-BE49-F238E27FC236}">
-                <a16:creationId xmlns:a16="http://schemas.microsoft.com/office/drawing/2014/main" id="{D579CC05-91FB-A61B-8918-7C3AEAB3BF4D}"/>
+                <a16:creationId xmlns:a16="http://schemas.microsoft.com/office/drawing/2014/main" id="{8F41169F-A060-1E34-669F-AD3E6E321733}"/>
               </a:ext>
             </a:extLst>
           </p:cNvPr>
@@ -9637,7 +9637,7 @@
           <p:cNvPr id="17" name="Rechteck 16">
             <a:extLst>
               <a:ext uri="{FF2B5EF4-FFF2-40B4-BE49-F238E27FC236}">
-                <a16:creationId xmlns:a16="http://schemas.microsoft.com/office/drawing/2014/main" id="{C0F36532-77F0-B18B-38CE-2E89F3065BC3}"/>
+                <a16:creationId xmlns:a16="http://schemas.microsoft.com/office/drawing/2014/main" id="{97FA7818-404A-E7BB-0B96-9990E3826963}"/>
               </a:ext>
             </a:extLst>
           </p:cNvPr>
@@ -9691,7 +9691,7 @@
           <p:cNvPr id="18" name="Rechteck 17">
             <a:extLst>
               <a:ext uri="{FF2B5EF4-FFF2-40B4-BE49-F238E27FC236}">
-                <a16:creationId xmlns:a16="http://schemas.microsoft.com/office/drawing/2014/main" id="{554CEB71-4F4B-A309-BBFF-44C03A70D861}"/>
+                <a16:creationId xmlns:a16="http://schemas.microsoft.com/office/drawing/2014/main" id="{80646D73-11A9-957C-C157-64CCD1FD0729}"/>
               </a:ext>
             </a:extLst>
           </p:cNvPr>
@@ -9745,7 +9745,7 @@
           <p:cNvPr id="19" name="Rechteck 18">
             <a:extLst>
               <a:ext uri="{FF2B5EF4-FFF2-40B4-BE49-F238E27FC236}">
-                <a16:creationId xmlns:a16="http://schemas.microsoft.com/office/drawing/2014/main" id="{0B7C8B6F-6230-314D-F42D-F9F30496EBA3}"/>
+                <a16:creationId xmlns:a16="http://schemas.microsoft.com/office/drawing/2014/main" id="{7E861B8B-BD00-8F39-EF37-560E6094BB40}"/>
               </a:ext>
             </a:extLst>
           </p:cNvPr>
@@ -9799,7 +9799,7 @@
           <p:cNvPr id="20" name="Rechteck 19">
             <a:extLst>
               <a:ext uri="{FF2B5EF4-FFF2-40B4-BE49-F238E27FC236}">
-                <a16:creationId xmlns:a16="http://schemas.microsoft.com/office/drawing/2014/main" id="{114389EB-DAA5-D6B6-1AD7-1DA73F071EDB}"/>
+                <a16:creationId xmlns:a16="http://schemas.microsoft.com/office/drawing/2014/main" id="{434F2AC7-3C32-A221-BA50-2DD7A253AFB5}"/>
               </a:ext>
             </a:extLst>
           </p:cNvPr>
@@ -9853,7 +9853,7 @@
           <p:cNvPr id="21" name="Rechteck 20">
             <a:extLst>
               <a:ext uri="{FF2B5EF4-FFF2-40B4-BE49-F238E27FC236}">
-                <a16:creationId xmlns:a16="http://schemas.microsoft.com/office/drawing/2014/main" id="{81EA858B-02B1-A0F8-E466-BCFBBF10B557}"/>
+                <a16:creationId xmlns:a16="http://schemas.microsoft.com/office/drawing/2014/main" id="{437FCF30-6447-C137-946A-5B35E7196C93}"/>
               </a:ext>
             </a:extLst>
           </p:cNvPr>
@@ -9907,7 +9907,7 @@
           <p:cNvPr id="22" name="Rechteck 21">
             <a:extLst>
               <a:ext uri="{FF2B5EF4-FFF2-40B4-BE49-F238E27FC236}">
-                <a16:creationId xmlns:a16="http://schemas.microsoft.com/office/drawing/2014/main" id="{3511D160-3DA4-552E-78B7-7005AC5B7418}"/>
+                <a16:creationId xmlns:a16="http://schemas.microsoft.com/office/drawing/2014/main" id="{95EADED8-4C1B-83D8-FD59-04BE3B17A7A5}"/>
               </a:ext>
             </a:extLst>
           </p:cNvPr>
@@ -9961,7 +9961,7 @@
           <p:cNvPr id="23" name="Rechteck 22">
             <a:extLst>
               <a:ext uri="{FF2B5EF4-FFF2-40B4-BE49-F238E27FC236}">
-                <a16:creationId xmlns:a16="http://schemas.microsoft.com/office/drawing/2014/main" id="{339F25D2-203B-12ED-D103-48A467723884}"/>
+                <a16:creationId xmlns:a16="http://schemas.microsoft.com/office/drawing/2014/main" id="{0398F505-3CE3-AA72-99FC-6E5416F6EC7C}"/>
               </a:ext>
             </a:extLst>
           </p:cNvPr>
@@ -10015,7 +10015,7 @@
           <p:cNvPr id="24" name="Rechteck 23">
             <a:extLst>
               <a:ext uri="{FF2B5EF4-FFF2-40B4-BE49-F238E27FC236}">
-                <a16:creationId xmlns:a16="http://schemas.microsoft.com/office/drawing/2014/main" id="{02B5316B-907C-7FC3-6A8E-6481DE086563}"/>
+                <a16:creationId xmlns:a16="http://schemas.microsoft.com/office/drawing/2014/main" id="{8FB5CFD0-2496-607B-D897-07166F2F6755}"/>
               </a:ext>
             </a:extLst>
           </p:cNvPr>
@@ -10069,7 +10069,7 @@
           <p:cNvPr id="25" name="Rechteck 24">
             <a:extLst>
               <a:ext uri="{FF2B5EF4-FFF2-40B4-BE49-F238E27FC236}">
-                <a16:creationId xmlns:a16="http://schemas.microsoft.com/office/drawing/2014/main" id="{45BB7BF7-3262-2BF7-AE02-513BB0A5C50E}"/>
+                <a16:creationId xmlns:a16="http://schemas.microsoft.com/office/drawing/2014/main" id="{38633EB8-381B-A67A-445F-78F577E2FCFA}"/>
               </a:ext>
             </a:extLst>
           </p:cNvPr>
@@ -10123,7 +10123,7 @@
           <p:cNvPr id="26" name="Rechteck 25">
             <a:extLst>
               <a:ext uri="{FF2B5EF4-FFF2-40B4-BE49-F238E27FC236}">
-                <a16:creationId xmlns:a16="http://schemas.microsoft.com/office/drawing/2014/main" id="{15D36BC2-D209-A278-1D4F-E598014BD137}"/>
+                <a16:creationId xmlns:a16="http://schemas.microsoft.com/office/drawing/2014/main" id="{922A82FD-00E3-436B-8DAA-2FB14F503545}"/>
               </a:ext>
             </a:extLst>
           </p:cNvPr>
@@ -10177,7 +10177,7 @@
           <p:cNvPr id="27" name="Rechteck 26">
             <a:extLst>
               <a:ext uri="{FF2B5EF4-FFF2-40B4-BE49-F238E27FC236}">
-                <a16:creationId xmlns:a16="http://schemas.microsoft.com/office/drawing/2014/main" id="{FAECDDB4-787D-1E6E-9404-BD7EC60C5857}"/>
+                <a16:creationId xmlns:a16="http://schemas.microsoft.com/office/drawing/2014/main" id="{C816F193-287E-9789-6CE3-FC95F60530D2}"/>
               </a:ext>
             </a:extLst>
           </p:cNvPr>
@@ -10231,7 +10231,7 @@
           <p:cNvPr id="28" name="Rechteck 27">
             <a:extLst>
               <a:ext uri="{FF2B5EF4-FFF2-40B4-BE49-F238E27FC236}">
-                <a16:creationId xmlns:a16="http://schemas.microsoft.com/office/drawing/2014/main" id="{8E4004F9-76B9-16AB-CC11-2479AB1C8D23}"/>
+                <a16:creationId xmlns:a16="http://schemas.microsoft.com/office/drawing/2014/main" id="{E55D2873-F259-E570-0603-2B65AD3C4492}"/>
               </a:ext>
             </a:extLst>
           </p:cNvPr>
@@ -10285,7 +10285,7 @@
           <p:cNvPr id="29" name="Rechteck 28">
             <a:extLst>
               <a:ext uri="{FF2B5EF4-FFF2-40B4-BE49-F238E27FC236}">
-                <a16:creationId xmlns:a16="http://schemas.microsoft.com/office/drawing/2014/main" id="{309462DE-4F61-4207-767A-8CAB3974AD36}"/>
+                <a16:creationId xmlns:a16="http://schemas.microsoft.com/office/drawing/2014/main" id="{101CF128-DAA4-A6B9-57A6-556E96F30254}"/>
               </a:ext>
             </a:extLst>
           </p:cNvPr>
@@ -10339,7 +10339,7 @@
           <p:cNvPr id="30" name="Rechteck 29">
             <a:extLst>
               <a:ext uri="{FF2B5EF4-FFF2-40B4-BE49-F238E27FC236}">
-                <a16:creationId xmlns:a16="http://schemas.microsoft.com/office/drawing/2014/main" id="{A6DD338B-E610-1C6F-1FD7-D81EEAC94D33}"/>
+                <a16:creationId xmlns:a16="http://schemas.microsoft.com/office/drawing/2014/main" id="{965D379B-4F04-4112-8421-3731B7F68544}"/>
               </a:ext>
             </a:extLst>
           </p:cNvPr>
@@ -10393,7 +10393,7 @@
           <p:cNvPr id="31" name="Rechteck 30">
             <a:extLst>
               <a:ext uri="{FF2B5EF4-FFF2-40B4-BE49-F238E27FC236}">
-                <a16:creationId xmlns:a16="http://schemas.microsoft.com/office/drawing/2014/main" id="{1CB9D3AD-C14C-24E3-1C61-ECE22A8A481E}"/>
+                <a16:creationId xmlns:a16="http://schemas.microsoft.com/office/drawing/2014/main" id="{CC82C307-B7A0-0CD8-37C7-24CF7855BF14}"/>
               </a:ext>
             </a:extLst>
           </p:cNvPr>
@@ -10447,7 +10447,7 @@
           <p:cNvPr id="32" name="Rechteck 31">
             <a:extLst>
               <a:ext uri="{FF2B5EF4-FFF2-40B4-BE49-F238E27FC236}">
-                <a16:creationId xmlns:a16="http://schemas.microsoft.com/office/drawing/2014/main" id="{301385C6-3782-CA66-7148-74879B924026}"/>
+                <a16:creationId xmlns:a16="http://schemas.microsoft.com/office/drawing/2014/main" id="{6A2BCF63-4DD0-5E6B-55FA-375A233D9607}"/>
               </a:ext>
             </a:extLst>
           </p:cNvPr>
@@ -10501,7 +10501,7 @@
           <p:cNvPr id="33" name="Rechteck 32">
             <a:extLst>
               <a:ext uri="{FF2B5EF4-FFF2-40B4-BE49-F238E27FC236}">
-                <a16:creationId xmlns:a16="http://schemas.microsoft.com/office/drawing/2014/main" id="{08AA7338-0BAA-FDA7-1BDE-C8AE87765A03}"/>
+                <a16:creationId xmlns:a16="http://schemas.microsoft.com/office/drawing/2014/main" id="{D407FAB2-5B61-596A-0EF9-295395BB94BC}"/>
               </a:ext>
             </a:extLst>
           </p:cNvPr>
@@ -10555,7 +10555,7 @@
           <p:cNvPr id="34" name="Rechteck 33">
             <a:extLst>
               <a:ext uri="{FF2B5EF4-FFF2-40B4-BE49-F238E27FC236}">
-                <a16:creationId xmlns:a16="http://schemas.microsoft.com/office/drawing/2014/main" id="{4B63D2AC-1322-A4C1-9D86-D8A70FDD75E8}"/>
+                <a16:creationId xmlns:a16="http://schemas.microsoft.com/office/drawing/2014/main" id="{5704C63C-2AE0-63F7-CB09-A312D906C2DC}"/>
               </a:ext>
             </a:extLst>
           </p:cNvPr>
@@ -10609,7 +10609,7 @@
           <p:cNvPr id="35" name="Rechteck 34">
             <a:extLst>
               <a:ext uri="{FF2B5EF4-FFF2-40B4-BE49-F238E27FC236}">
-                <a16:creationId xmlns:a16="http://schemas.microsoft.com/office/drawing/2014/main" id="{BDC0A1FE-0580-0888-71C6-DB23B9B97419}"/>
+                <a16:creationId xmlns:a16="http://schemas.microsoft.com/office/drawing/2014/main" id="{3DA4A18E-9E63-59F5-7973-531EA43EB99C}"/>
               </a:ext>
             </a:extLst>
           </p:cNvPr>
@@ -10663,7 +10663,7 @@
           <p:cNvPr id="36" name="Rechteck 35">
             <a:extLst>
               <a:ext uri="{FF2B5EF4-FFF2-40B4-BE49-F238E27FC236}">
-                <a16:creationId xmlns:a16="http://schemas.microsoft.com/office/drawing/2014/main" id="{06839C9C-92EC-99BE-ACD5-70B41FEAB143}"/>
+                <a16:creationId xmlns:a16="http://schemas.microsoft.com/office/drawing/2014/main" id="{EE3EC596-153F-BF6C-4EED-0BE2376BDC22}"/>
               </a:ext>
             </a:extLst>
           </p:cNvPr>
@@ -10717,7 +10717,7 @@
           <p:cNvPr id="37" name="Rechteck 36">
             <a:extLst>
               <a:ext uri="{FF2B5EF4-FFF2-40B4-BE49-F238E27FC236}">
-                <a16:creationId xmlns:a16="http://schemas.microsoft.com/office/drawing/2014/main" id="{DABBB52B-8B88-588E-8FE5-3970EF61E17F}"/>
+                <a16:creationId xmlns:a16="http://schemas.microsoft.com/office/drawing/2014/main" id="{0CF327F5-0DC5-C7C9-81A1-6D10CCC39FED}"/>
               </a:ext>
             </a:extLst>
           </p:cNvPr>
@@ -10771,7 +10771,7 @@
           <p:cNvPr id="38" name="Rechteck 37">
             <a:extLst>
               <a:ext uri="{FF2B5EF4-FFF2-40B4-BE49-F238E27FC236}">
-                <a16:creationId xmlns:a16="http://schemas.microsoft.com/office/drawing/2014/main" id="{3B7394B7-39DF-FEF1-4F74-77720C2330DD}"/>
+                <a16:creationId xmlns:a16="http://schemas.microsoft.com/office/drawing/2014/main" id="{8515C335-E1A6-912F-4380-79D39AED742E}"/>
               </a:ext>
             </a:extLst>
           </p:cNvPr>
@@ -10825,7 +10825,7 @@
           <p:cNvPr id="39" name="Rechteck 38">
             <a:extLst>
               <a:ext uri="{FF2B5EF4-FFF2-40B4-BE49-F238E27FC236}">
-                <a16:creationId xmlns:a16="http://schemas.microsoft.com/office/drawing/2014/main" id="{61B4DEAD-7EBB-033A-769A-38C0416BA911}"/>
+                <a16:creationId xmlns:a16="http://schemas.microsoft.com/office/drawing/2014/main" id="{DD5E70B1-3775-088D-E363-D19F6F4C601B}"/>
               </a:ext>
             </a:extLst>
           </p:cNvPr>
@@ -10879,7 +10879,7 @@
           <p:cNvPr id="40" name="Rechteck 39">
             <a:extLst>
               <a:ext uri="{FF2B5EF4-FFF2-40B4-BE49-F238E27FC236}">
-                <a16:creationId xmlns:a16="http://schemas.microsoft.com/office/drawing/2014/main" id="{8FF61185-5B27-3845-74AC-A4BC790B2337}"/>
+                <a16:creationId xmlns:a16="http://schemas.microsoft.com/office/drawing/2014/main" id="{110EC7FF-B3DB-F9D0-02D8-C49FC005685F}"/>
               </a:ext>
             </a:extLst>
           </p:cNvPr>
@@ -10933,7 +10933,7 @@
           <p:cNvPr id="41" name="Rechteck 40">
             <a:extLst>
               <a:ext uri="{FF2B5EF4-FFF2-40B4-BE49-F238E27FC236}">
-                <a16:creationId xmlns:a16="http://schemas.microsoft.com/office/drawing/2014/main" id="{839C9535-E43E-04B9-2374-B0B466C59491}"/>
+                <a16:creationId xmlns:a16="http://schemas.microsoft.com/office/drawing/2014/main" id="{B55687C5-B32F-CF34-CCFC-35EFA71D2EF2}"/>
               </a:ext>
             </a:extLst>
           </p:cNvPr>
@@ -10987,7 +10987,7 @@
           <p:cNvPr id="42" name="Rechteck 41">
             <a:extLst>
               <a:ext uri="{FF2B5EF4-FFF2-40B4-BE49-F238E27FC236}">
-                <a16:creationId xmlns:a16="http://schemas.microsoft.com/office/drawing/2014/main" id="{D31F4208-9609-52B0-9A1C-6E4EA706A2DD}"/>
+                <a16:creationId xmlns:a16="http://schemas.microsoft.com/office/drawing/2014/main" id="{9AC9317D-A52D-8D58-E9E0-BE1D10C2474C}"/>
               </a:ext>
             </a:extLst>
           </p:cNvPr>
@@ -11041,7 +11041,7 @@
           <p:cNvPr id="43" name="Rechteck 42">
             <a:extLst>
               <a:ext uri="{FF2B5EF4-FFF2-40B4-BE49-F238E27FC236}">
-                <a16:creationId xmlns:a16="http://schemas.microsoft.com/office/drawing/2014/main" id="{73D02342-D992-9720-5628-5A5E6462DB23}"/>
+                <a16:creationId xmlns:a16="http://schemas.microsoft.com/office/drawing/2014/main" id="{B887BDB9-AAA9-D612-578B-55719E2123D4}"/>
               </a:ext>
             </a:extLst>
           </p:cNvPr>
@@ -11095,7 +11095,7 @@
           <p:cNvPr id="44" name="Rechteck 43">
             <a:extLst>
               <a:ext uri="{FF2B5EF4-FFF2-40B4-BE49-F238E27FC236}">
-                <a16:creationId xmlns:a16="http://schemas.microsoft.com/office/drawing/2014/main" id="{A741B15A-2203-DC77-BB5F-017B5FCD1691}"/>
+                <a16:creationId xmlns:a16="http://schemas.microsoft.com/office/drawing/2014/main" id="{A4DF1531-0EF2-0B11-A686-2CEFDAA4AA43}"/>
               </a:ext>
             </a:extLst>
           </p:cNvPr>
@@ -11149,7 +11149,7 @@
           <p:cNvPr id="45" name="Rechteck 44">
             <a:extLst>
               <a:ext uri="{FF2B5EF4-FFF2-40B4-BE49-F238E27FC236}">
-                <a16:creationId xmlns:a16="http://schemas.microsoft.com/office/drawing/2014/main" id="{F17768AD-CC07-F88A-1D42-2FC21181FC1C}"/>
+                <a16:creationId xmlns:a16="http://schemas.microsoft.com/office/drawing/2014/main" id="{69994C33-760F-5FF1-B592-A220F0A4D7F1}"/>
               </a:ext>
             </a:extLst>
           </p:cNvPr>
@@ -11203,7 +11203,7 @@
           <p:cNvPr id="46" name="Rechteck 45">
             <a:extLst>
               <a:ext uri="{FF2B5EF4-FFF2-40B4-BE49-F238E27FC236}">
-                <a16:creationId xmlns:a16="http://schemas.microsoft.com/office/drawing/2014/main" id="{85E9D43C-5D49-7E8C-602E-589882F843ED}"/>
+                <a16:creationId xmlns:a16="http://schemas.microsoft.com/office/drawing/2014/main" id="{763ED991-7DA7-68EF-0A51-CDCDE48A45F5}"/>
               </a:ext>
             </a:extLst>
           </p:cNvPr>
@@ -11257,7 +11257,7 @@
           <p:cNvPr id="47" name="Rechteck 46">
             <a:extLst>
               <a:ext uri="{FF2B5EF4-FFF2-40B4-BE49-F238E27FC236}">
-                <a16:creationId xmlns:a16="http://schemas.microsoft.com/office/drawing/2014/main" id="{F388A2F2-AD77-0C75-D6E5-4196BD49B6FC}"/>
+                <a16:creationId xmlns:a16="http://schemas.microsoft.com/office/drawing/2014/main" id="{D1D466E0-BB34-6B5B-80AA-E6A7ABB15361}"/>
               </a:ext>
             </a:extLst>
           </p:cNvPr>
@@ -11311,7 +11311,7 @@
           <p:cNvPr id="48" name="Rechteck 47">
             <a:extLst>
               <a:ext uri="{FF2B5EF4-FFF2-40B4-BE49-F238E27FC236}">
-                <a16:creationId xmlns:a16="http://schemas.microsoft.com/office/drawing/2014/main" id="{FC553382-AE3C-93E7-90E6-7FD98326DB0E}"/>
+                <a16:creationId xmlns:a16="http://schemas.microsoft.com/office/drawing/2014/main" id="{A0FAE3EA-905D-D47A-4C07-73A2B08A0758}"/>
               </a:ext>
             </a:extLst>
           </p:cNvPr>
@@ -11365,7 +11365,7 @@
           <p:cNvPr id="49" name="Rechteck 48">
             <a:extLst>
               <a:ext uri="{FF2B5EF4-FFF2-40B4-BE49-F238E27FC236}">
-                <a16:creationId xmlns:a16="http://schemas.microsoft.com/office/drawing/2014/main" id="{4006DE0B-E893-E61B-9890-0A5240369E74}"/>
+                <a16:creationId xmlns:a16="http://schemas.microsoft.com/office/drawing/2014/main" id="{5FC300C1-B334-6DBE-39FA-6820892EA1ED}"/>
               </a:ext>
             </a:extLst>
           </p:cNvPr>
@@ -11419,7 +11419,7 @@
           <p:cNvPr id="50" name="Rechteck 49">
             <a:extLst>
               <a:ext uri="{FF2B5EF4-FFF2-40B4-BE49-F238E27FC236}">
-                <a16:creationId xmlns:a16="http://schemas.microsoft.com/office/drawing/2014/main" id="{15AB441F-9802-32C4-B8E8-07F6371F53AB}"/>
+                <a16:creationId xmlns:a16="http://schemas.microsoft.com/office/drawing/2014/main" id="{242986D5-8A79-FFCA-EF86-1CDA98A1BB2C}"/>
               </a:ext>
             </a:extLst>
           </p:cNvPr>
@@ -11473,7 +11473,7 @@
           <p:cNvPr id="51" name="Rechteck 50">
             <a:extLst>
               <a:ext uri="{FF2B5EF4-FFF2-40B4-BE49-F238E27FC236}">
-                <a16:creationId xmlns:a16="http://schemas.microsoft.com/office/drawing/2014/main" id="{4090E9B5-2DB1-785C-284F-A3864B91E931}"/>
+                <a16:creationId xmlns:a16="http://schemas.microsoft.com/office/drawing/2014/main" id="{1BE334F5-8C3C-BB73-E1ED-33905C5236CB}"/>
               </a:ext>
             </a:extLst>
           </p:cNvPr>
@@ -11527,7 +11527,7 @@
           <p:cNvPr id="52" name="Rechteck 51">
             <a:extLst>
               <a:ext uri="{FF2B5EF4-FFF2-40B4-BE49-F238E27FC236}">
-                <a16:creationId xmlns:a16="http://schemas.microsoft.com/office/drawing/2014/main" id="{D19EA74C-4802-2E14-A66E-5DB5B86557B7}"/>
+                <a16:creationId xmlns:a16="http://schemas.microsoft.com/office/drawing/2014/main" id="{F087AD08-D255-C57D-2A5C-1A7810FBCCFA}"/>
               </a:ext>
             </a:extLst>
           </p:cNvPr>
@@ -11581,7 +11581,7 @@
           <p:cNvPr id="53" name="Rechteck 52">
             <a:extLst>
               <a:ext uri="{FF2B5EF4-FFF2-40B4-BE49-F238E27FC236}">
-                <a16:creationId xmlns:a16="http://schemas.microsoft.com/office/drawing/2014/main" id="{B4B14F7B-73D0-246E-BFD5-4198F105D712}"/>
+                <a16:creationId xmlns:a16="http://schemas.microsoft.com/office/drawing/2014/main" id="{D87F67D5-D2FD-364E-C345-F7CE4187FE2B}"/>
               </a:ext>
             </a:extLst>
           </p:cNvPr>
@@ -11635,7 +11635,7 @@
           <p:cNvPr id="54" name="Rechteck 53">
             <a:extLst>
               <a:ext uri="{FF2B5EF4-FFF2-40B4-BE49-F238E27FC236}">
-                <a16:creationId xmlns:a16="http://schemas.microsoft.com/office/drawing/2014/main" id="{FCEDAA9C-F3AB-9BB4-7D06-D91C5314B401}"/>
+                <a16:creationId xmlns:a16="http://schemas.microsoft.com/office/drawing/2014/main" id="{27894CB5-FF25-0300-8487-171C69A4EA04}"/>
               </a:ext>
             </a:extLst>
           </p:cNvPr>
@@ -11689,7 +11689,7 @@
           <p:cNvPr id="55" name="Rechteck 54">
             <a:extLst>
               <a:ext uri="{FF2B5EF4-FFF2-40B4-BE49-F238E27FC236}">
-                <a16:creationId xmlns:a16="http://schemas.microsoft.com/office/drawing/2014/main" id="{278AFE67-CC9E-E138-DC72-B5F254B4E8B9}"/>
+                <a16:creationId xmlns:a16="http://schemas.microsoft.com/office/drawing/2014/main" id="{E1739684-D6C4-27F1-B61C-7B5AD93BF65D}"/>
               </a:ext>
             </a:extLst>
           </p:cNvPr>
@@ -11741,7 +11741,7 @@
     </p:spTree>
     <p:extLst>
       <p:ext uri="{BB962C8B-B14F-4D97-AF65-F5344CB8AC3E}">
-        <p14:creationId xmlns:p14="http://schemas.microsoft.com/office/powerpoint/2010/main" val="707699369"/>
+        <p14:creationId xmlns:p14="http://schemas.microsoft.com/office/powerpoint/2010/main" val="1746839161"/>
       </p:ext>
     </p:extLst>
   </p:cSld>

</xml_diff>